<commit_message>
Route the Network Firewall example's NAT gateways to the IGW through a corridor outside the AZ boxes and move its note below the diagram
Co-Authored-By: Claude Opus 5.5 <noreply@anthropic.com>
</commit_message>
<xml_diff>
--- a/docs/examples/reference-architectures.pptx
+++ b/docs/examples/reference-architectures.pptx
@@ -13697,10 +13697,10 @@
         </p:nvGrpSpPr>
         <p:grpSpPr>
           <a:xfrm>
-            <a:off x="-715791" y="999381"/>
-            <a:ext cx="12691443" cy="5545037"/>
-            <a:chOff x="-715791" y="999381"/>
-            <a:chExt cx="12691443" cy="5545037"/>
+            <a:off x="381000" y="999067"/>
+            <a:ext cx="11657541" cy="5590116"/>
+            <a:chOff x="381000" y="999067"/>
+            <a:chExt cx="11657541" cy="5590116"/>
           </a:xfrm>
         </p:grpSpPr>
         <p:sp>
@@ -13711,14 +13711,14 @@
           </p:nvSpPr>
           <p:spPr>
             <a:xfrm>
-              <a:off x="359755" y="999381"/>
-              <a:ext cx="10580186" cy="5545037"/>
-            </a:xfrm>
-            <a:prstGeom prst="rect">
-              <a:avLst/>
-            </a:prstGeom>
-            <a:noFill/>
-            <a:ln w="21245">
+              <a:off x="381000" y="999067"/>
+              <a:ext cx="10625667" cy="5270500"/>
+            </a:xfrm>
+            <a:prstGeom prst="rect">
+              <a:avLst/>
+            </a:prstGeom>
+            <a:noFill/>
+            <a:ln w="21167">
               <a:solidFill>
                 <a:srgbClr val="232F3E"/>
               </a:solidFill>
@@ -13756,8 +13756,8 @@
           </p:blipFill>
           <p:spPr>
             <a:xfrm>
-              <a:off x="359755" y="999381"/>
-              <a:ext cx="339926" cy="339926"/>
+              <a:off x="381000" y="999067"/>
+              <a:ext cx="338667" cy="338667"/>
             </a:xfrm>
             <a:prstGeom prst="rect">
               <a:avLst/>
@@ -13772,8 +13772,8 @@
           </p:nvSpPr>
           <p:spPr>
             <a:xfrm>
-              <a:off x="805907" y="1081707"/>
-              <a:ext cx="1145257" cy="207142"/>
+              <a:off x="825500" y="1081088"/>
+              <a:ext cx="1141016" cy="206375"/>
             </a:xfrm>
             <a:prstGeom prst="rect">
               <a:avLst/>
@@ -13792,7 +13792,7 @@
                 </a:lnSpc>
               </a:pPr>
               <a:r>
-                <a:rPr sz="1254" b="1" lang="ko-KR">
+                <a:rPr sz="1250" b="1" lang="ko-KR">
                   <a:solidFill>
                     <a:srgbClr val="232F3E"/>
                   </a:solidFill>
@@ -13813,14 +13813,14 @@
           </p:nvSpPr>
           <p:spPr>
             <a:xfrm>
-              <a:off x="572208" y="1381798"/>
-              <a:ext cx="10155279" cy="5035149"/>
-            </a:xfrm>
-            <a:prstGeom prst="rect">
-              <a:avLst/>
-            </a:prstGeom>
-            <a:noFill/>
-            <a:ln w="21245">
+              <a:off x="592667" y="1380067"/>
+              <a:ext cx="10202333" cy="4847167"/>
+            </a:xfrm>
+            <a:prstGeom prst="rect">
+              <a:avLst/>
+            </a:prstGeom>
+            <a:noFill/>
+            <a:ln w="21167">
               <a:solidFill>
                 <a:srgbClr val="00A4A6"/>
               </a:solidFill>
@@ -13860,8 +13860,8 @@
           </p:blipFill>
           <p:spPr>
             <a:xfrm>
-              <a:off x="572208" y="1381798"/>
-              <a:ext cx="254944" cy="254944"/>
+              <a:off x="592667" y="1380067"/>
+              <a:ext cx="254000" cy="254000"/>
             </a:xfrm>
             <a:prstGeom prst="rect">
               <a:avLst/>
@@ -13876,8 +13876,8 @@
           </p:nvSpPr>
           <p:spPr>
             <a:xfrm>
-              <a:off x="912134" y="1431724"/>
-              <a:ext cx="2295826" cy="193333"/>
+              <a:off x="931333" y="1429808"/>
+              <a:ext cx="2287323" cy="192617"/>
             </a:xfrm>
             <a:prstGeom prst="rect">
               <a:avLst/>
@@ -13896,7 +13896,7 @@
                 </a:lnSpc>
               </a:pPr>
               <a:r>
-                <a:rPr sz="1171" b="1" lang="ko-KR">
+                <a:rPr sz="1166" b="1" lang="ko-KR">
                   <a:solidFill>
                     <a:srgbClr val="00A4A6"/>
                   </a:solidFill>
@@ -13917,14 +13917,14 @@
           </p:nvSpPr>
           <p:spPr>
             <a:xfrm>
-              <a:off x="742171" y="1912932"/>
-              <a:ext cx="2124535" cy="1487175"/>
-            </a:xfrm>
-            <a:prstGeom prst="rect">
-              <a:avLst/>
-            </a:prstGeom>
-            <a:noFill/>
-            <a:ln w="21245">
+              <a:off x="762000" y="1909233"/>
+              <a:ext cx="2116667" cy="1481667"/>
+            </a:xfrm>
+            <a:prstGeom prst="rect">
+              <a:avLst/>
+            </a:prstGeom>
+            <a:noFill/>
+            <a:ln w="21167">
               <a:solidFill>
                 <a:srgbClr val="8C4FFF"/>
               </a:solidFill>
@@ -13962,8 +13962,8 @@
           </p:blipFill>
           <p:spPr>
             <a:xfrm>
-              <a:off x="742171" y="1912932"/>
-              <a:ext cx="254944" cy="254944"/>
+              <a:off x="762000" y="1909233"/>
+              <a:ext cx="254000" cy="254000"/>
             </a:xfrm>
             <a:prstGeom prst="rect">
               <a:avLst/>
@@ -13978,8 +13978,8 @@
           </p:nvSpPr>
           <p:spPr>
             <a:xfrm>
-              <a:off x="1082097" y="1962858"/>
-              <a:ext cx="1886853" cy="193333"/>
+              <a:off x="1100667" y="1958975"/>
+              <a:ext cx="1879865" cy="192617"/>
             </a:xfrm>
             <a:prstGeom prst="rect">
               <a:avLst/>
@@ -13998,7 +13998,7 @@
                 </a:lnSpc>
               </a:pPr>
               <a:r>
-                <a:rPr sz="1171" b="1" lang="ko-KR">
+                <a:rPr sz="1166" b="1" lang="ko-KR">
                   <a:solidFill>
                     <a:srgbClr val="8C4FFF"/>
                   </a:solidFill>
@@ -14019,14 +14019,14 @@
           </p:nvSpPr>
           <p:spPr>
             <a:xfrm>
-              <a:off x="869643" y="2210367"/>
-              <a:ext cx="1869591" cy="1104758"/>
-            </a:xfrm>
-            <a:prstGeom prst="rect">
-              <a:avLst/>
-            </a:prstGeom>
-            <a:noFill/>
-            <a:ln w="15934">
+              <a:off x="889000" y="2205567"/>
+              <a:ext cx="1862667" cy="1100667"/>
+            </a:xfrm>
+            <a:prstGeom prst="rect">
+              <a:avLst/>
+            </a:prstGeom>
+            <a:noFill/>
+            <a:ln w="15875">
               <a:solidFill>
                 <a:srgbClr val="00A4A6"/>
               </a:solidFill>
@@ -14064,8 +14064,8 @@
           </p:blipFill>
           <p:spPr>
             <a:xfrm>
-              <a:off x="869643" y="2210367"/>
-              <a:ext cx="254944" cy="254944"/>
+              <a:off x="889000" y="2205567"/>
+              <a:ext cx="254000" cy="254000"/>
             </a:xfrm>
             <a:prstGeom prst="rect">
               <a:avLst/>
@@ -14080,8 +14080,8 @@
           </p:nvSpPr>
           <p:spPr>
             <a:xfrm>
-              <a:off x="1209569" y="2260293"/>
-              <a:ext cx="1171150" cy="193333"/>
+              <a:off x="1227667" y="2255308"/>
+              <a:ext cx="1166813" cy="192617"/>
             </a:xfrm>
             <a:prstGeom prst="rect">
               <a:avLst/>
@@ -14100,7 +14100,7 @@
                 </a:lnSpc>
               </a:pPr>
               <a:r>
-                <a:rPr sz="1171" b="1" lang="ko-KR">
+                <a:rPr sz="1166" b="1" lang="ko-KR">
                   <a:solidFill>
                     <a:srgbClr val="00A4A6"/>
                   </a:solidFill>
@@ -14135,8 +14135,8 @@
           </p:blipFill>
           <p:spPr>
             <a:xfrm>
-              <a:off x="1549494" y="2507801"/>
-              <a:ext cx="509888" cy="509888"/>
+              <a:off x="1566333" y="2501900"/>
+              <a:ext cx="508000" cy="508000"/>
             </a:xfrm>
             <a:prstGeom prst="rect">
               <a:avLst/>
@@ -14151,8 +14151,8 @@
           </p:nvSpPr>
           <p:spPr>
             <a:xfrm>
-              <a:off x="1576715" y="3067617"/>
-              <a:ext cx="455447" cy="193333"/>
+              <a:off x="1593453" y="3059642"/>
+              <a:ext cx="453760" cy="192617"/>
             </a:xfrm>
             <a:prstGeom prst="rect">
               <a:avLst/>
@@ -14171,7 +14171,7 @@
                 </a:lnSpc>
               </a:pPr>
               <a:r>
-                <a:rPr sz="1171" b="0" lang="ko-KR">
+                <a:rPr sz="1166" b="0" lang="ko-KR">
                   <a:solidFill>
                     <a:srgbClr val="232F3E"/>
                   </a:solidFill>
@@ -14192,14 +14192,14 @@
           </p:nvSpPr>
           <p:spPr>
             <a:xfrm>
-              <a:off x="742171" y="4526110"/>
-              <a:ext cx="2124535" cy="1487175"/>
-            </a:xfrm>
-            <a:prstGeom prst="rect">
-              <a:avLst/>
-            </a:prstGeom>
-            <a:noFill/>
-            <a:ln w="21245">
+              <a:off x="762000" y="4512733"/>
+              <a:ext cx="2116667" cy="1481667"/>
+            </a:xfrm>
+            <a:prstGeom prst="rect">
+              <a:avLst/>
+            </a:prstGeom>
+            <a:noFill/>
+            <a:ln w="21167">
               <a:solidFill>
                 <a:srgbClr val="8C4FFF"/>
               </a:solidFill>
@@ -14237,8 +14237,8 @@
           </p:blipFill>
           <p:spPr>
             <a:xfrm>
-              <a:off x="742171" y="4526110"/>
-              <a:ext cx="254944" cy="254944"/>
+              <a:off x="762000" y="4512733"/>
+              <a:ext cx="254000" cy="254000"/>
             </a:xfrm>
             <a:prstGeom prst="rect">
               <a:avLst/>
@@ -14253,8 +14253,8 @@
           </p:nvSpPr>
           <p:spPr>
             <a:xfrm>
-              <a:off x="1082097" y="4576037"/>
-              <a:ext cx="1886853" cy="193333"/>
+              <a:off x="1100667" y="4562475"/>
+              <a:ext cx="1879865" cy="192617"/>
             </a:xfrm>
             <a:prstGeom prst="rect">
               <a:avLst/>
@@ -14273,7 +14273,7 @@
                 </a:lnSpc>
               </a:pPr>
               <a:r>
-                <a:rPr sz="1171" b="1" lang="ko-KR">
+                <a:rPr sz="1166" b="1" lang="ko-KR">
                   <a:solidFill>
                     <a:srgbClr val="8C4FFF"/>
                   </a:solidFill>
@@ -14294,14 +14294,14 @@
           </p:nvSpPr>
           <p:spPr>
             <a:xfrm>
-              <a:off x="869643" y="4823545"/>
-              <a:ext cx="1869591" cy="1104758"/>
-            </a:xfrm>
-            <a:prstGeom prst="rect">
-              <a:avLst/>
-            </a:prstGeom>
-            <a:noFill/>
-            <a:ln w="15934">
+              <a:off x="889000" y="4809067"/>
+              <a:ext cx="1862667" cy="1100667"/>
+            </a:xfrm>
+            <a:prstGeom prst="rect">
+              <a:avLst/>
+            </a:prstGeom>
+            <a:noFill/>
+            <a:ln w="15875">
               <a:solidFill>
                 <a:srgbClr val="00A4A6"/>
               </a:solidFill>
@@ -14339,8 +14339,8 @@
           </p:blipFill>
           <p:spPr>
             <a:xfrm>
-              <a:off x="869643" y="4823545"/>
-              <a:ext cx="254944" cy="254944"/>
+              <a:off x="889000" y="4809067"/>
+              <a:ext cx="254000" cy="254000"/>
             </a:xfrm>
             <a:prstGeom prst="rect">
               <a:avLst/>
@@ -14355,8 +14355,8 @@
           </p:nvSpPr>
           <p:spPr>
             <a:xfrm>
-              <a:off x="1209569" y="4873472"/>
-              <a:ext cx="1171150" cy="193333"/>
+              <a:off x="1227667" y="4858808"/>
+              <a:ext cx="1166813" cy="192617"/>
             </a:xfrm>
             <a:prstGeom prst="rect">
               <a:avLst/>
@@ -14375,7 +14375,7 @@
                 </a:lnSpc>
               </a:pPr>
               <a:r>
-                <a:rPr sz="1171" b="1" lang="ko-KR">
+                <a:rPr sz="1166" b="1" lang="ko-KR">
                   <a:solidFill>
                     <a:srgbClr val="00A4A6"/>
                   </a:solidFill>
@@ -14410,8 +14410,8 @@
           </p:blipFill>
           <p:spPr>
             <a:xfrm>
-              <a:off x="1549494" y="5120980"/>
-              <a:ext cx="509888" cy="509888"/>
+              <a:off x="1566333" y="5105400"/>
+              <a:ext cx="508000" cy="508000"/>
             </a:xfrm>
             <a:prstGeom prst="rect">
               <a:avLst/>
@@ -14426,8 +14426,8 @@
           </p:nvSpPr>
           <p:spPr>
             <a:xfrm>
-              <a:off x="1576715" y="5680795"/>
-              <a:ext cx="455447" cy="193333"/>
+              <a:off x="1593453" y="5663142"/>
+              <a:ext cx="453760" cy="192617"/>
             </a:xfrm>
             <a:prstGeom prst="rect">
               <a:avLst/>
@@ -14446,7 +14446,7 @@
                 </a:lnSpc>
               </a:pPr>
               <a:r>
-                <a:rPr sz="1171" b="0" lang="ko-KR">
+                <a:rPr sz="1166" b="0" lang="ko-KR">
                   <a:solidFill>
                     <a:srgbClr val="232F3E"/>
                   </a:solidFill>
@@ -14481,8 +14481,8 @@
           </p:blipFill>
           <p:spPr>
             <a:xfrm>
-              <a:off x="3525312" y="3740032"/>
-              <a:ext cx="509888" cy="509888"/>
+              <a:off x="3534833" y="3729567"/>
+              <a:ext cx="508000" cy="508000"/>
             </a:xfrm>
             <a:prstGeom prst="rect">
               <a:avLst/>
@@ -14497,8 +14497,8 @@
           </p:nvSpPr>
           <p:spPr>
             <a:xfrm>
-              <a:off x="3552533" y="4299847"/>
-              <a:ext cx="455447" cy="193333"/>
+              <a:off x="3561953" y="4287308"/>
+              <a:ext cx="453760" cy="192617"/>
             </a:xfrm>
             <a:prstGeom prst="rect">
               <a:avLst/>
@@ -14517,7 +14517,7 @@
                 </a:lnSpc>
               </a:pPr>
               <a:r>
-                <a:rPr sz="1171" b="0" lang="ko-KR">
+                <a:rPr sz="1166" b="0" lang="ko-KR">
                   <a:solidFill>
                     <a:srgbClr val="232F3E"/>
                   </a:solidFill>
@@ -14552,8 +14552,8 @@
           </p:blipFill>
           <p:spPr>
             <a:xfrm>
-              <a:off x="3525312" y="2507801"/>
-              <a:ext cx="509888" cy="509888"/>
+              <a:off x="3534833" y="2501900"/>
+              <a:ext cx="508000" cy="508000"/>
             </a:xfrm>
             <a:prstGeom prst="rect">
               <a:avLst/>
@@ -14568,8 +14568,8 @@
           </p:nvSpPr>
           <p:spPr>
             <a:xfrm>
-              <a:off x="3143560" y="3067617"/>
-              <a:ext cx="1273393" cy="193333"/>
+              <a:off x="3154495" y="3059642"/>
+              <a:ext cx="1268677" cy="192617"/>
             </a:xfrm>
             <a:prstGeom prst="rect">
               <a:avLst/>
@@ -14588,7 +14588,7 @@
                 </a:lnSpc>
               </a:pPr>
               <a:r>
-                <a:rPr sz="1171" b="0" lang="ko-KR">
+                <a:rPr sz="1166" b="0" lang="ko-KR">
                   <a:solidFill>
                     <a:srgbClr val="232F3E"/>
                   </a:solidFill>
@@ -14609,8 +14609,8 @@
           </p:nvSpPr>
           <p:spPr>
             <a:xfrm>
-              <a:off x="3118995" y="3257762"/>
-              <a:ext cx="1322523" cy="165714"/>
+              <a:off x="3130021" y="3249083"/>
+              <a:ext cx="1317625" cy="165100"/>
             </a:xfrm>
             <a:prstGeom prst="rect">
               <a:avLst/>
@@ -14629,7 +14629,7 @@
                 </a:lnSpc>
               </a:pPr>
               <a:r>
-                <a:rPr sz="1003" b="0" lang="ko-KR">
+                <a:rPr sz="1000" b="0" lang="ko-KR">
                   <a:solidFill>
                     <a:srgbClr val="545B64"/>
                   </a:solidFill>
@@ -14664,8 +14664,8 @@
           </p:blipFill>
           <p:spPr>
             <a:xfrm>
-              <a:off x="3525312" y="5120980"/>
-              <a:ext cx="509888" cy="509888"/>
+              <a:off x="3534833" y="5105400"/>
+              <a:ext cx="508000" cy="508000"/>
             </a:xfrm>
             <a:prstGeom prst="rect">
               <a:avLst/>
@@ -14680,8 +14680,8 @@
           </p:nvSpPr>
           <p:spPr>
             <a:xfrm>
-              <a:off x="3296925" y="5680795"/>
-              <a:ext cx="966664" cy="193333"/>
+              <a:off x="3307292" y="5663142"/>
+              <a:ext cx="963083" cy="192617"/>
             </a:xfrm>
             <a:prstGeom prst="rect">
               <a:avLst/>
@@ -14700,7 +14700,7 @@
                 </a:lnSpc>
               </a:pPr>
               <a:r>
-                <a:rPr sz="1171" b="0" lang="ko-KR">
+                <a:rPr sz="1166" b="0" lang="ko-KR">
                   <a:solidFill>
                     <a:srgbClr val="232F3E"/>
                   </a:solidFill>
@@ -14721,8 +14721,8 @@
           </p:nvSpPr>
           <p:spPr>
             <a:xfrm>
-              <a:off x="3118995" y="5870941"/>
-              <a:ext cx="1322523" cy="165714"/>
+              <a:off x="3130021" y="5852583"/>
+              <a:ext cx="1317625" cy="165100"/>
             </a:xfrm>
             <a:prstGeom prst="rect">
               <a:avLst/>
@@ -14741,7 +14741,7 @@
                 </a:lnSpc>
               </a:pPr>
               <a:r>
-                <a:rPr sz="1003" b="0" lang="ko-KR">
+                <a:rPr sz="1000" b="0" lang="ko-KR">
                   <a:solidFill>
                     <a:srgbClr val="545B64"/>
                   </a:solidFill>
@@ -14762,8 +14762,8 @@
           </p:nvSpPr>
           <p:spPr>
             <a:xfrm>
-              <a:off x="2909197" y="2762746"/>
-              <a:ext cx="573625" cy="1147249"/>
+              <a:off x="2921000" y="2755900"/>
+              <a:ext cx="571500" cy="1143000"/>
             </a:xfrm>
             <a:custGeom>
               <a:avLst/>
@@ -14772,24 +14772,24 @@
               <a:cxnLst/>
               <a:rect l="l" t="t" r="r" b="b"/>
               <a:pathLst>
-                <a:path w="573625" h="1147249">
+                <a:path w="571500" h="1143000">
                   <a:moveTo>
                     <a:pt x="0" y="0"/>
                   </a:moveTo>
                   <a:lnTo>
-                    <a:pt x="254944" y="0"/>
+                    <a:pt x="254000" y="0"/>
                   </a:lnTo>
                   <a:lnTo>
-                    <a:pt x="254944" y="1147249"/>
+                    <a:pt x="254000" y="1143000"/>
                   </a:lnTo>
                   <a:lnTo>
-                    <a:pt x="573625" y="1147249"/>
+                    <a:pt x="571500" y="1143000"/>
                   </a:lnTo>
                 </a:path>
               </a:pathLst>
             </a:custGeom>
             <a:noFill/>
-            <a:ln w="15934">
+            <a:ln w="15875">
               <a:solidFill>
                 <a:srgbClr val="232F3E"/>
               </a:solidFill>
@@ -14815,8 +14815,8 @@
           </p:nvSpPr>
           <p:spPr>
             <a:xfrm>
-              <a:off x="2909197" y="4079958"/>
-              <a:ext cx="573625" cy="1295966"/>
+              <a:off x="2921000" y="4068233"/>
+              <a:ext cx="571500" cy="1291167"/>
             </a:xfrm>
             <a:custGeom>
               <a:avLst/>
@@ -14825,24 +14825,24 @@
               <a:cxnLst/>
               <a:rect l="l" t="t" r="r" b="b"/>
               <a:pathLst>
-                <a:path w="573625" h="1295966">
+                <a:path w="571500" h="1291167">
                   <a:moveTo>
-                    <a:pt x="0" y="1295966"/>
+                    <a:pt x="0" y="1291167"/>
                   </a:moveTo>
                   <a:lnTo>
-                    <a:pt x="254944" y="1295966"/>
+                    <a:pt x="254000" y="1291167"/>
                   </a:lnTo>
                   <a:lnTo>
-                    <a:pt x="254944" y="0"/>
+                    <a:pt x="254000" y="0"/>
                   </a:lnTo>
                   <a:lnTo>
-                    <a:pt x="573625" y="0"/>
+                    <a:pt x="571500" y="0"/>
                   </a:lnTo>
                 </a:path>
               </a:pathLst>
             </a:custGeom>
             <a:noFill/>
-            <a:ln w="15934">
+            <a:ln w="15875">
               <a:solidFill>
                 <a:srgbClr val="232F3E"/>
               </a:solidFill>
@@ -14868,14 +14868,14 @@
           </p:nvSpPr>
           <p:spPr>
             <a:xfrm>
-              <a:off x="4566335" y="1679233"/>
-              <a:ext cx="5736245" cy="4440279"/>
-            </a:xfrm>
-            <a:prstGeom prst="rect">
-              <a:avLst/>
-            </a:prstGeom>
-            <a:noFill/>
-            <a:ln w="21245">
+              <a:off x="4572000" y="1676400"/>
+              <a:ext cx="5799667" cy="4423833"/>
+            </a:xfrm>
+            <a:prstGeom prst="rect">
+              <a:avLst/>
+            </a:prstGeom>
+            <a:noFill/>
+            <a:ln w="21167">
               <a:solidFill>
                 <a:srgbClr val="8C4FFF"/>
               </a:solidFill>
@@ -14913,8 +14913,8 @@
           </p:blipFill>
           <p:spPr>
             <a:xfrm>
-              <a:off x="4566335" y="1679233"/>
-              <a:ext cx="254944" cy="254944"/>
+              <a:off x="4572000" y="1676400"/>
+              <a:ext cx="254000" cy="254000"/>
             </a:xfrm>
             <a:prstGeom prst="rect">
               <a:avLst/>
@@ -14929,8 +14929,8 @@
           </p:nvSpPr>
           <p:spPr>
             <a:xfrm>
-              <a:off x="4906260" y="1729159"/>
-              <a:ext cx="3011529" cy="193333"/>
+              <a:off x="4910667" y="1726142"/>
+              <a:ext cx="3000375" cy="192617"/>
             </a:xfrm>
             <a:prstGeom prst="rect">
               <a:avLst/>
@@ -14949,7 +14949,7 @@
                 </a:lnSpc>
               </a:pPr>
               <a:r>
-                <a:rPr sz="1171" b="1" lang="ko-KR">
+                <a:rPr sz="1166" b="1" lang="ko-KR">
                   <a:solidFill>
                     <a:srgbClr val="8C4FFF"/>
                   </a:solidFill>
@@ -14970,14 +14970,14 @@
           </p:nvSpPr>
           <p:spPr>
             <a:xfrm>
-              <a:off x="4736297" y="1976668"/>
-              <a:ext cx="5396320" cy="1423439"/>
-            </a:xfrm>
-            <a:prstGeom prst="rect">
-              <a:avLst/>
-            </a:prstGeom>
-            <a:noFill/>
-            <a:ln w="15934">
+              <a:off x="4741333" y="1972733"/>
+              <a:ext cx="5037667" cy="1418167"/>
+            </a:xfrm>
+            <a:prstGeom prst="rect">
+              <a:avLst/>
+            </a:prstGeom>
+            <a:noFill/>
+            <a:ln w="15875">
               <a:solidFill>
                 <a:srgbClr val="00A4A6"/>
               </a:solidFill>
@@ -15003,8 +15003,8 @@
           </p:nvSpPr>
           <p:spPr>
             <a:xfrm>
-              <a:off x="4863770" y="2005349"/>
-              <a:ext cx="2091339" cy="193333"/>
+              <a:off x="4868333" y="2001308"/>
+              <a:ext cx="2083594" cy="192617"/>
             </a:xfrm>
             <a:prstGeom prst="rect">
               <a:avLst/>
@@ -15023,7 +15023,7 @@
                 </a:lnSpc>
               </a:pPr>
               <a:r>
-                <a:rPr sz="1171" b="1" lang="ko-KR">
+                <a:rPr sz="1166" b="1" lang="ko-KR">
                   <a:solidFill>
                     <a:srgbClr val="00A4A6"/>
                   </a:solidFill>
@@ -15044,14 +15044,14 @@
           </p:nvSpPr>
           <p:spPr>
             <a:xfrm>
-              <a:off x="4736297" y="4589846"/>
-              <a:ext cx="5396320" cy="1423439"/>
-            </a:xfrm>
-            <a:prstGeom prst="rect">
-              <a:avLst/>
-            </a:prstGeom>
-            <a:noFill/>
-            <a:ln w="15934">
+              <a:off x="4741333" y="4576233"/>
+              <a:ext cx="5037667" cy="1418167"/>
+            </a:xfrm>
+            <a:prstGeom prst="rect">
+              <a:avLst/>
+            </a:prstGeom>
+            <a:noFill/>
+            <a:ln w="15875">
               <a:solidFill>
                 <a:srgbClr val="00A4A6"/>
               </a:solidFill>
@@ -15077,8 +15077,8 @@
           </p:nvSpPr>
           <p:spPr>
             <a:xfrm>
-              <a:off x="4863770" y="4618527"/>
-              <a:ext cx="2091339" cy="193333"/>
+              <a:off x="4868333" y="4604808"/>
+              <a:ext cx="2083594" cy="192617"/>
             </a:xfrm>
             <a:prstGeom prst="rect">
               <a:avLst/>
@@ -15097,7 +15097,7 @@
                 </a:lnSpc>
               </a:pPr>
               <a:r>
-                <a:rPr sz="1171" b="1" lang="ko-KR">
+                <a:rPr sz="1166" b="1" lang="ko-KR">
                   <a:solidFill>
                     <a:srgbClr val="00A4A6"/>
                   </a:solidFill>
@@ -15118,14 +15118,14 @@
           </p:nvSpPr>
           <p:spPr>
             <a:xfrm>
-              <a:off x="4863770" y="2210367"/>
-              <a:ext cx="1444684" cy="1104758"/>
-            </a:xfrm>
-            <a:prstGeom prst="rect">
-              <a:avLst/>
-            </a:prstGeom>
-            <a:noFill/>
-            <a:ln w="15934">
+              <a:off x="4868333" y="2205567"/>
+              <a:ext cx="1439333" cy="1100667"/>
+            </a:xfrm>
+            <a:prstGeom prst="rect">
+              <a:avLst/>
+            </a:prstGeom>
+            <a:noFill/>
+            <a:ln w="15875">
               <a:solidFill>
                 <a:srgbClr val="00A4A6"/>
               </a:solidFill>
@@ -15163,8 +15163,8 @@
           </p:blipFill>
           <p:spPr>
             <a:xfrm>
-              <a:off x="4863770" y="2210367"/>
-              <a:ext cx="254944" cy="254944"/>
+              <a:off x="4868333" y="2205567"/>
+              <a:ext cx="254000" cy="254000"/>
             </a:xfrm>
             <a:prstGeom prst="rect">
               <a:avLst/>
@@ -15179,8 +15179,8 @@
           </p:nvSpPr>
           <p:spPr>
             <a:xfrm>
-              <a:off x="5203695" y="2260293"/>
-              <a:ext cx="1171150" cy="193333"/>
+              <a:off x="5207000" y="2255308"/>
+              <a:ext cx="1166813" cy="192617"/>
             </a:xfrm>
             <a:prstGeom prst="rect">
               <a:avLst/>
@@ -15199,7 +15199,7 @@
                 </a:lnSpc>
               </a:pPr>
               <a:r>
-                <a:rPr sz="1171" b="1" lang="ko-KR">
+                <a:rPr sz="1166" b="1" lang="ko-KR">
                   <a:solidFill>
                     <a:srgbClr val="00A4A6"/>
                   </a:solidFill>
@@ -15220,14 +15220,14 @@
           </p:nvSpPr>
           <p:spPr>
             <a:xfrm>
-              <a:off x="6478416" y="2210367"/>
-              <a:ext cx="1742119" cy="1104758"/>
-            </a:xfrm>
-            <a:prstGeom prst="rect">
-              <a:avLst/>
-            </a:prstGeom>
-            <a:noFill/>
-            <a:ln w="15934">
+              <a:off x="6434667" y="2205567"/>
+              <a:ext cx="1608667" cy="1100667"/>
+            </a:xfrm>
+            <a:prstGeom prst="rect">
+              <a:avLst/>
+            </a:prstGeom>
+            <a:noFill/>
+            <a:ln w="15875">
               <a:solidFill>
                 <a:srgbClr val="00A4A6"/>
               </a:solidFill>
@@ -15265,8 +15265,8 @@
           </p:blipFill>
           <p:spPr>
             <a:xfrm>
-              <a:off x="6478416" y="2210367"/>
-              <a:ext cx="254944" cy="254944"/>
+              <a:off x="6434667" y="2205567"/>
+              <a:ext cx="254000" cy="254000"/>
             </a:xfrm>
             <a:prstGeom prst="rect">
               <a:avLst/>
@@ -15281,8 +15281,8 @@
           </p:nvSpPr>
           <p:spPr>
             <a:xfrm>
-              <a:off x="6818342" y="2260293"/>
-              <a:ext cx="1682366" cy="193333"/>
+              <a:off x="6773333" y="2255308"/>
+              <a:ext cx="1676135" cy="192617"/>
             </a:xfrm>
             <a:prstGeom prst="rect">
               <a:avLst/>
@@ -15301,7 +15301,7 @@
                 </a:lnSpc>
               </a:pPr>
               <a:r>
-                <a:rPr sz="1171" b="1" lang="ko-KR">
+                <a:rPr sz="1166" b="1" lang="ko-KR">
                   <a:solidFill>
                     <a:srgbClr val="00A4A6"/>
                   </a:solidFill>
@@ -15322,14 +15322,14 @@
           </p:nvSpPr>
           <p:spPr>
             <a:xfrm>
-              <a:off x="8390498" y="2210367"/>
-              <a:ext cx="1572156" cy="1104758"/>
-            </a:xfrm>
-            <a:prstGeom prst="rect">
-              <a:avLst/>
-            </a:prstGeom>
-            <a:noFill/>
-            <a:ln w="15934">
+              <a:off x="8170333" y="2205567"/>
+              <a:ext cx="1481667" cy="1100667"/>
+            </a:xfrm>
+            <a:prstGeom prst="rect">
+              <a:avLst/>
+            </a:prstGeom>
+            <a:noFill/>
+            <a:ln w="15875">
               <a:solidFill>
                 <a:srgbClr val="7AA116"/>
               </a:solidFill>
@@ -15367,8 +15367,8 @@
           </p:blipFill>
           <p:spPr>
             <a:xfrm>
-              <a:off x="8390498" y="2210367"/>
-              <a:ext cx="254944" cy="254944"/>
+              <a:off x="8170333" y="2205567"/>
+              <a:ext cx="254000" cy="254000"/>
             </a:xfrm>
             <a:prstGeom prst="rect">
               <a:avLst/>
@@ -15383,8 +15383,8 @@
           </p:nvSpPr>
           <p:spPr>
             <a:xfrm>
-              <a:off x="8730424" y="2260293"/>
-              <a:ext cx="1477880" cy="193333"/>
+              <a:off x="8509000" y="2255308"/>
+              <a:ext cx="1472406" cy="192617"/>
             </a:xfrm>
             <a:prstGeom prst="rect">
               <a:avLst/>
@@ -15403,7 +15403,7 @@
                 </a:lnSpc>
               </a:pPr>
               <a:r>
-                <a:rPr sz="1171" b="1" lang="ko-KR">
+                <a:rPr sz="1166" b="1" lang="ko-KR">
                   <a:solidFill>
                     <a:srgbClr val="7AA116"/>
                   </a:solidFill>
@@ -15424,14 +15424,14 @@
           </p:nvSpPr>
           <p:spPr>
             <a:xfrm>
-              <a:off x="4863770" y="4823545"/>
-              <a:ext cx="1444684" cy="1104758"/>
-            </a:xfrm>
-            <a:prstGeom prst="rect">
-              <a:avLst/>
-            </a:prstGeom>
-            <a:noFill/>
-            <a:ln w="15934">
+              <a:off x="4868333" y="4809067"/>
+              <a:ext cx="1439333" cy="1100667"/>
+            </a:xfrm>
+            <a:prstGeom prst="rect">
+              <a:avLst/>
+            </a:prstGeom>
+            <a:noFill/>
+            <a:ln w="15875">
               <a:solidFill>
                 <a:srgbClr val="00A4A6"/>
               </a:solidFill>
@@ -15469,8 +15469,8 @@
           </p:blipFill>
           <p:spPr>
             <a:xfrm>
-              <a:off x="4863770" y="4823545"/>
-              <a:ext cx="254944" cy="254944"/>
+              <a:off x="4868333" y="4809067"/>
+              <a:ext cx="254000" cy="254000"/>
             </a:xfrm>
             <a:prstGeom prst="rect">
               <a:avLst/>
@@ -15485,8 +15485,8 @@
           </p:nvSpPr>
           <p:spPr>
             <a:xfrm>
-              <a:off x="5203695" y="4873472"/>
-              <a:ext cx="1171150" cy="193333"/>
+              <a:off x="5207000" y="4858808"/>
+              <a:ext cx="1166813" cy="192617"/>
             </a:xfrm>
             <a:prstGeom prst="rect">
               <a:avLst/>
@@ -15505,7 +15505,7 @@
                 </a:lnSpc>
               </a:pPr>
               <a:r>
-                <a:rPr sz="1171" b="1" lang="ko-KR">
+                <a:rPr sz="1166" b="1" lang="ko-KR">
                   <a:solidFill>
                     <a:srgbClr val="00A4A6"/>
                   </a:solidFill>
@@ -15526,14 +15526,14 @@
           </p:nvSpPr>
           <p:spPr>
             <a:xfrm>
-              <a:off x="6478416" y="4823545"/>
-              <a:ext cx="1742119" cy="1104758"/>
-            </a:xfrm>
-            <a:prstGeom prst="rect">
-              <a:avLst/>
-            </a:prstGeom>
-            <a:noFill/>
-            <a:ln w="15934">
+              <a:off x="6434667" y="4809067"/>
+              <a:ext cx="1608667" cy="1100667"/>
+            </a:xfrm>
+            <a:prstGeom prst="rect">
+              <a:avLst/>
+            </a:prstGeom>
+            <a:noFill/>
+            <a:ln w="15875">
               <a:solidFill>
                 <a:srgbClr val="00A4A6"/>
               </a:solidFill>
@@ -15571,8 +15571,8 @@
           </p:blipFill>
           <p:spPr>
             <a:xfrm>
-              <a:off x="6478416" y="4823545"/>
-              <a:ext cx="254944" cy="254944"/>
+              <a:off x="6434667" y="4809067"/>
+              <a:ext cx="254000" cy="254000"/>
             </a:xfrm>
             <a:prstGeom prst="rect">
               <a:avLst/>
@@ -15587,8 +15587,8 @@
           </p:nvSpPr>
           <p:spPr>
             <a:xfrm>
-              <a:off x="6818342" y="4873472"/>
-              <a:ext cx="1682366" cy="193333"/>
+              <a:off x="6773333" y="4858808"/>
+              <a:ext cx="1676135" cy="192617"/>
             </a:xfrm>
             <a:prstGeom prst="rect">
               <a:avLst/>
@@ -15607,7 +15607,7 @@
                 </a:lnSpc>
               </a:pPr>
               <a:r>
-                <a:rPr sz="1171" b="1" lang="ko-KR">
+                <a:rPr sz="1166" b="1" lang="ko-KR">
                   <a:solidFill>
                     <a:srgbClr val="00A4A6"/>
                   </a:solidFill>
@@ -15628,14 +15628,14 @@
           </p:nvSpPr>
           <p:spPr>
             <a:xfrm>
-              <a:off x="8390498" y="4823545"/>
-              <a:ext cx="1572156" cy="1104758"/>
-            </a:xfrm>
-            <a:prstGeom prst="rect">
-              <a:avLst/>
-            </a:prstGeom>
-            <a:noFill/>
-            <a:ln w="15934">
+              <a:off x="8170333" y="4809067"/>
+              <a:ext cx="1481667" cy="1100667"/>
+            </a:xfrm>
+            <a:prstGeom prst="rect">
+              <a:avLst/>
+            </a:prstGeom>
+            <a:noFill/>
+            <a:ln w="15875">
               <a:solidFill>
                 <a:srgbClr val="7AA116"/>
               </a:solidFill>
@@ -15673,8 +15673,8 @@
           </p:blipFill>
           <p:spPr>
             <a:xfrm>
-              <a:off x="8390498" y="4823545"/>
-              <a:ext cx="254944" cy="254944"/>
+              <a:off x="8170333" y="4809067"/>
+              <a:ext cx="254000" cy="254000"/>
             </a:xfrm>
             <a:prstGeom prst="rect">
               <a:avLst/>
@@ -15689,8 +15689,8 @@
           </p:nvSpPr>
           <p:spPr>
             <a:xfrm>
-              <a:off x="8730424" y="4873472"/>
-              <a:ext cx="1477880" cy="193333"/>
+              <a:off x="8509000" y="4858808"/>
+              <a:ext cx="1472406" cy="192617"/>
             </a:xfrm>
             <a:prstGeom prst="rect">
               <a:avLst/>
@@ -15709,7 +15709,7 @@
                 </a:lnSpc>
               </a:pPr>
               <a:r>
-                <a:rPr sz="1171" b="1" lang="ko-KR">
+                <a:rPr sz="1166" b="1" lang="ko-KR">
                   <a:solidFill>
                     <a:srgbClr val="7AA116"/>
                   </a:solidFill>
@@ -15744,8 +15744,8 @@
           </p:blipFill>
           <p:spPr>
             <a:xfrm>
-              <a:off x="5331167" y="2507801"/>
-              <a:ext cx="509888" cy="509888"/>
+              <a:off x="5334000" y="2501900"/>
+              <a:ext cx="508000" cy="508000"/>
             </a:xfrm>
             <a:prstGeom prst="rect">
               <a:avLst/>
@@ -15760,8 +15760,8 @@
           </p:nvSpPr>
           <p:spPr>
             <a:xfrm>
-              <a:off x="5153901" y="3067617"/>
-              <a:ext cx="864420" cy="193333"/>
+              <a:off x="5157391" y="3059642"/>
+              <a:ext cx="861219" cy="192617"/>
             </a:xfrm>
             <a:prstGeom prst="rect">
               <a:avLst/>
@@ -15780,7 +15780,7 @@
                 </a:lnSpc>
               </a:pPr>
               <a:r>
-                <a:rPr sz="1171" b="0" lang="ko-KR">
+                <a:rPr sz="1166" b="0" lang="ko-KR">
                   <a:solidFill>
                     <a:srgbClr val="232F3E"/>
                   </a:solidFill>
@@ -15815,8 +15815,8 @@
           </p:blipFill>
           <p:spPr>
             <a:xfrm>
-              <a:off x="7094532" y="2507801"/>
-              <a:ext cx="509888" cy="509888"/>
+              <a:off x="6985000" y="2501900"/>
+              <a:ext cx="508000" cy="508000"/>
             </a:xfrm>
             <a:prstGeom prst="rect">
               <a:avLst/>
@@ -15831,8 +15831,8 @@
           </p:nvSpPr>
           <p:spPr>
             <a:xfrm>
-              <a:off x="6406049" y="3067617"/>
-              <a:ext cx="1886853" cy="193333"/>
+              <a:off x="6299068" y="3059642"/>
+              <a:ext cx="1879865" cy="192617"/>
             </a:xfrm>
             <a:prstGeom prst="rect">
               <a:avLst/>
@@ -15851,7 +15851,7 @@
                 </a:lnSpc>
               </a:pPr>
               <a:r>
-                <a:rPr sz="1171" b="0" lang="ko-KR">
+                <a:rPr sz="1166" b="0" lang="ko-KR">
                   <a:solidFill>
                     <a:srgbClr val="232F3E"/>
                   </a:solidFill>
@@ -15886,8 +15886,8 @@
           </p:blipFill>
           <p:spPr>
             <a:xfrm>
-              <a:off x="8921632" y="2507801"/>
-              <a:ext cx="509888" cy="509888"/>
+              <a:off x="8657167" y="2501900"/>
+              <a:ext cx="508000" cy="508000"/>
             </a:xfrm>
             <a:prstGeom prst="rect">
               <a:avLst/>
@@ -15902,8 +15902,8 @@
           </p:nvSpPr>
           <p:spPr>
             <a:xfrm>
-              <a:off x="8539880" y="3067617"/>
-              <a:ext cx="1273393" cy="193333"/>
+              <a:off x="8276828" y="3059642"/>
+              <a:ext cx="1268677" cy="192617"/>
             </a:xfrm>
             <a:prstGeom prst="rect">
               <a:avLst/>
@@ -15922,7 +15922,7 @@
                 </a:lnSpc>
               </a:pPr>
               <a:r>
-                <a:rPr sz="1171" b="0" lang="ko-KR">
+                <a:rPr sz="1166" b="0" lang="ko-KR">
                   <a:solidFill>
                     <a:srgbClr val="232F3E"/>
                   </a:solidFill>
@@ -15957,8 +15957,8 @@
           </p:blipFill>
           <p:spPr>
             <a:xfrm>
-              <a:off x="5331167" y="5120980"/>
-              <a:ext cx="509888" cy="509888"/>
+              <a:off x="5334000" y="5105400"/>
+              <a:ext cx="508000" cy="508000"/>
             </a:xfrm>
             <a:prstGeom prst="rect">
               <a:avLst/>
@@ -15973,8 +15973,8 @@
           </p:nvSpPr>
           <p:spPr>
             <a:xfrm>
-              <a:off x="5153901" y="5680795"/>
-              <a:ext cx="864420" cy="193333"/>
+              <a:off x="5157391" y="5663142"/>
+              <a:ext cx="861219" cy="192617"/>
             </a:xfrm>
             <a:prstGeom prst="rect">
               <a:avLst/>
@@ -15993,7 +15993,7 @@
                 </a:lnSpc>
               </a:pPr>
               <a:r>
-                <a:rPr sz="1171" b="0" lang="ko-KR">
+                <a:rPr sz="1166" b="0" lang="ko-KR">
                   <a:solidFill>
                     <a:srgbClr val="232F3E"/>
                   </a:solidFill>
@@ -16028,8 +16028,8 @@
           </p:blipFill>
           <p:spPr>
             <a:xfrm>
-              <a:off x="7094532" y="5120980"/>
-              <a:ext cx="509888" cy="509888"/>
+              <a:off x="6985000" y="5105400"/>
+              <a:ext cx="508000" cy="508000"/>
             </a:xfrm>
             <a:prstGeom prst="rect">
               <a:avLst/>
@@ -16044,8 +16044,8 @@
           </p:nvSpPr>
           <p:spPr>
             <a:xfrm>
-              <a:off x="6406049" y="5680795"/>
-              <a:ext cx="1886853" cy="193333"/>
+              <a:off x="6299068" y="5663142"/>
+              <a:ext cx="1879865" cy="192617"/>
             </a:xfrm>
             <a:prstGeom prst="rect">
               <a:avLst/>
@@ -16064,7 +16064,7 @@
                 </a:lnSpc>
               </a:pPr>
               <a:r>
-                <a:rPr sz="1171" b="0" lang="ko-KR">
+                <a:rPr sz="1166" b="0" lang="ko-KR">
                   <a:solidFill>
                     <a:srgbClr val="232F3E"/>
                   </a:solidFill>
@@ -16099,8 +16099,8 @@
           </p:blipFill>
           <p:spPr>
             <a:xfrm>
-              <a:off x="8921632" y="5120980"/>
-              <a:ext cx="509888" cy="509888"/>
+              <a:off x="8657167" y="5105400"/>
+              <a:ext cx="508000" cy="508000"/>
             </a:xfrm>
             <a:prstGeom prst="rect">
               <a:avLst/>
@@ -16115,8 +16115,8 @@
           </p:nvSpPr>
           <p:spPr>
             <a:xfrm>
-              <a:off x="8539880" y="5680795"/>
-              <a:ext cx="1273393" cy="193333"/>
+              <a:off x="8276828" y="5663142"/>
+              <a:ext cx="1268677" cy="192617"/>
             </a:xfrm>
             <a:prstGeom prst="rect">
               <a:avLst/>
@@ -16135,7 +16135,7 @@
                 </a:lnSpc>
               </a:pPr>
               <a:r>
-                <a:rPr sz="1171" b="0" lang="ko-KR">
+                <a:rPr sz="1166" b="0" lang="ko-KR">
                   <a:solidFill>
                     <a:srgbClr val="232F3E"/>
                   </a:solidFill>
@@ -16170,8 +16170,8 @@
           </p:blipFill>
           <p:spPr>
             <a:xfrm>
-              <a:off x="7094532" y="3740032"/>
-              <a:ext cx="509888" cy="509888"/>
+              <a:off x="6985000" y="3729567"/>
+              <a:ext cx="508000" cy="508000"/>
             </a:xfrm>
             <a:prstGeom prst="rect">
               <a:avLst/>
@@ -16186,8 +16186,8 @@
           </p:nvSpPr>
           <p:spPr>
             <a:xfrm>
-              <a:off x="6252684" y="4299847"/>
-              <a:ext cx="2193583" cy="193333"/>
+              <a:off x="6146271" y="4287308"/>
+              <a:ext cx="2185458" cy="192617"/>
             </a:xfrm>
             <a:prstGeom prst="rect">
               <a:avLst/>
@@ -16206,7 +16206,7 @@
                 </a:lnSpc>
               </a:pPr>
               <a:r>
-                <a:rPr sz="1171" b="0" lang="ko-KR">
+                <a:rPr sz="1166" b="0" lang="ko-KR">
                   <a:solidFill>
                     <a:srgbClr val="232F3E"/>
                   </a:solidFill>
@@ -16227,8 +16227,8 @@
           </p:nvSpPr>
           <p:spPr>
             <a:xfrm>
-              <a:off x="10047636" y="3740032"/>
-              <a:ext cx="509888" cy="743587"/>
+              <a:off x="10117667" y="3729567"/>
+              <a:ext cx="508000" cy="740833"/>
             </a:xfrm>
             <a:prstGeom prst="rect">
               <a:avLst/>
@@ -16270,8 +16270,8 @@
           </p:blipFill>
           <p:spPr>
             <a:xfrm>
-              <a:off x="10047636" y="3740032"/>
-              <a:ext cx="509888" cy="509888"/>
+              <a:off x="10117667" y="3729567"/>
+              <a:ext cx="508000" cy="508000"/>
             </a:xfrm>
             <a:prstGeom prst="rect">
               <a:avLst/>
@@ -16286,8 +16286,8 @@
           </p:nvSpPr>
           <p:spPr>
             <a:xfrm>
-              <a:off x="10074856" y="4299847"/>
-              <a:ext cx="455447" cy="193333"/>
+              <a:off x="10144786" y="4287308"/>
+              <a:ext cx="453760" cy="192617"/>
             </a:xfrm>
             <a:prstGeom prst="rect">
               <a:avLst/>
@@ -16306,7 +16306,7 @@
                 </a:lnSpc>
               </a:pPr>
               <a:r>
-                <a:rPr sz="1171" b="0" lang="ko-KR">
+                <a:rPr sz="1166" b="0" lang="ko-KR">
                   <a:solidFill>
                     <a:srgbClr val="232F3E"/>
                   </a:solidFill>
@@ -16327,8 +16327,8 @@
           </p:nvSpPr>
           <p:spPr>
             <a:xfrm>
-              <a:off x="4077691" y="2762746"/>
-              <a:ext cx="1210986" cy="1147249"/>
+              <a:off x="4085167" y="2755900"/>
+              <a:ext cx="1206500" cy="1143000"/>
             </a:xfrm>
             <a:custGeom>
               <a:avLst/>
@@ -16337,24 +16337,24 @@
               <a:cxnLst/>
               <a:rect l="l" t="t" r="r" b="b"/>
               <a:pathLst>
-                <a:path w="1210986" h="1147249">
+                <a:path w="1206500" h="1143000">
                   <a:moveTo>
-                    <a:pt x="0" y="1147249"/>
+                    <a:pt x="0" y="1143000"/>
                   </a:moveTo>
                   <a:lnTo>
-                    <a:pt x="318681" y="1147249"/>
+                    <a:pt x="317500" y="1143000"/>
                   </a:lnTo>
                   <a:lnTo>
-                    <a:pt x="318681" y="0"/>
+                    <a:pt x="317500" y="0"/>
                   </a:lnTo>
                   <a:lnTo>
-                    <a:pt x="1210986" y="0"/>
+                    <a:pt x="1206500" y="0"/>
                   </a:lnTo>
                 </a:path>
               </a:pathLst>
             </a:custGeom>
             <a:noFill/>
-            <a:ln w="15934">
+            <a:ln w="15875">
               <a:solidFill>
                 <a:srgbClr val="232F3E"/>
               </a:solidFill>
@@ -16380,8 +16380,8 @@
           </p:nvSpPr>
           <p:spPr>
             <a:xfrm>
-              <a:off x="4077691" y="4079958"/>
-              <a:ext cx="1210986" cy="1295966"/>
+              <a:off x="4085167" y="4068233"/>
+              <a:ext cx="1206500" cy="1291167"/>
             </a:xfrm>
             <a:custGeom>
               <a:avLst/>
@@ -16390,24 +16390,24 @@
               <a:cxnLst/>
               <a:rect l="l" t="t" r="r" b="b"/>
               <a:pathLst>
-                <a:path w="1210986" h="1295966">
+                <a:path w="1206500" h="1291167">
                   <a:moveTo>
                     <a:pt x="0" y="0"/>
                   </a:moveTo>
                   <a:lnTo>
-                    <a:pt x="318681" y="0"/>
+                    <a:pt x="317500" y="0"/>
                   </a:lnTo>
                   <a:lnTo>
-                    <a:pt x="318681" y="1295966"/>
+                    <a:pt x="317500" y="1291167"/>
                   </a:lnTo>
                   <a:lnTo>
-                    <a:pt x="1210986" y="1295966"/>
+                    <a:pt x="1206500" y="1291167"/>
                   </a:lnTo>
                 </a:path>
               </a:pathLst>
             </a:custGeom>
             <a:noFill/>
-            <a:ln w="15934">
+            <a:ln w="15875">
               <a:solidFill>
                 <a:srgbClr val="232F3E"/>
               </a:solidFill>
@@ -16433,13 +16433,13 @@
           </p:nvCxnSpPr>
           <p:spPr>
             <a:xfrm>
-              <a:off x="5883546" y="2762746"/>
-              <a:ext cx="1168495" cy="0"/>
+              <a:off x="5884333" y="2755900"/>
+              <a:ext cx="1058334" cy="0"/>
             </a:xfrm>
             <a:prstGeom prst="line">
               <a:avLst/>
             </a:prstGeom>
-            <a:ln w="15934">
+            <a:ln w="15875">
               <a:solidFill>
                 <a:srgbClr val="232F3E"/>
               </a:solidFill>
@@ -16458,13 +16458,13 @@
           </p:nvCxnSpPr>
           <p:spPr>
             <a:xfrm>
-              <a:off x="5883546" y="5375924"/>
-              <a:ext cx="1168495" cy="0"/>
+              <a:off x="5884333" y="5359400"/>
+              <a:ext cx="1058334" cy="0"/>
             </a:xfrm>
             <a:prstGeom prst="line">
               <a:avLst/>
             </a:prstGeom>
-            <a:ln w="15934">
+            <a:ln w="15875">
               <a:solidFill>
                 <a:srgbClr val="232F3E"/>
               </a:solidFill>
@@ -16483,13 +16483,13 @@
           </p:nvCxnSpPr>
           <p:spPr>
             <a:xfrm>
-              <a:off x="7646911" y="2762746"/>
-              <a:ext cx="1232230" cy="0"/>
+              <a:off x="7535333" y="2755900"/>
+              <a:ext cx="1079500" cy="0"/>
             </a:xfrm>
             <a:prstGeom prst="line">
               <a:avLst/>
             </a:prstGeom>
-            <a:ln w="15934">
+            <a:ln w="15875">
               <a:solidFill>
                 <a:srgbClr val="232F3E"/>
               </a:solidFill>
@@ -16507,13 +16507,13 @@
           </p:nvCxnSpPr>
           <p:spPr>
             <a:xfrm>
-              <a:off x="7646911" y="5375924"/>
-              <a:ext cx="1232230" cy="0"/>
+              <a:off x="7535333" y="5359400"/>
+              <a:ext cx="1079500" cy="0"/>
             </a:xfrm>
             <a:prstGeom prst="line">
               <a:avLst/>
             </a:prstGeom>
-            <a:ln w="15934">
+            <a:ln w="15875">
               <a:solidFill>
                 <a:srgbClr val="232F3E"/>
               </a:solidFill>
@@ -16531,8 +16531,8 @@
           </p:nvSpPr>
           <p:spPr>
             <a:xfrm>
-              <a:off x="9474011" y="2762746"/>
-              <a:ext cx="531134" cy="1232230"/>
+              <a:off x="9207500" y="2755900"/>
+              <a:ext cx="867833" cy="1227667"/>
             </a:xfrm>
             <a:custGeom>
               <a:avLst/>
@@ -16541,24 +16541,24 @@
               <a:cxnLst/>
               <a:rect l="l" t="t" r="r" b="b"/>
               <a:pathLst>
-                <a:path w="531134" h="1232230">
+                <a:path w="867833" h="1227667">
                   <a:moveTo>
                     <a:pt x="0" y="0"/>
                   </a:moveTo>
                   <a:lnTo>
-                    <a:pt x="403662" y="0"/>
+                    <a:pt x="656167" y="0"/>
                   </a:lnTo>
                   <a:lnTo>
-                    <a:pt x="403662" y="1232230"/>
+                    <a:pt x="656167" y="1227667"/>
                   </a:lnTo>
                   <a:lnTo>
-                    <a:pt x="531134" y="1232230"/>
+                    <a:pt x="867833" y="1227667"/>
                   </a:lnTo>
                 </a:path>
               </a:pathLst>
             </a:custGeom>
             <a:noFill/>
-            <a:ln w="15934">
+            <a:ln w="15875">
               <a:solidFill>
                 <a:srgbClr val="232F3E"/>
               </a:solidFill>
@@ -16583,8 +16583,8 @@
           </p:nvSpPr>
           <p:spPr>
             <a:xfrm>
-              <a:off x="9474011" y="3994976"/>
-              <a:ext cx="403662" cy="1380948"/>
+              <a:off x="9207500" y="3983567"/>
+              <a:ext cx="656167" cy="1375833"/>
             </a:xfrm>
             <a:custGeom>
               <a:avLst/>
@@ -16593,21 +16593,21 @@
               <a:cxnLst/>
               <a:rect l="l" t="t" r="r" b="b"/>
               <a:pathLst>
-                <a:path w="403662" h="1380948">
+                <a:path w="656167" h="1375833">
                   <a:moveTo>
-                    <a:pt x="0" y="1380948"/>
+                    <a:pt x="0" y="1375833"/>
                   </a:moveTo>
                   <a:lnTo>
-                    <a:pt x="403662" y="1380948"/>
+                    <a:pt x="656167" y="1375833"/>
                   </a:lnTo>
                   <a:lnTo>
-                    <a:pt x="403662" y="0"/>
+                    <a:pt x="656167" y="0"/>
                   </a:lnTo>
                 </a:path>
               </a:pathLst>
             </a:custGeom>
             <a:noFill/>
-            <a:ln w="15934">
+            <a:ln w="15875">
               <a:solidFill>
                 <a:srgbClr val="232F3E"/>
               </a:solidFill>
@@ -16645,8 +16645,8 @@
           </p:blipFill>
           <p:spPr>
             <a:xfrm>
-              <a:off x="11237375" y="3740032"/>
-              <a:ext cx="509888" cy="509888"/>
+              <a:off x="11303000" y="3729567"/>
+              <a:ext cx="508000" cy="508000"/>
             </a:xfrm>
             <a:prstGeom prst="rect">
               <a:avLst/>
@@ -16661,8 +16661,8 @@
           </p:nvSpPr>
           <p:spPr>
             <a:xfrm>
-              <a:off x="11008988" y="4299847"/>
-              <a:ext cx="966664" cy="193333"/>
+              <a:off x="11075458" y="4287308"/>
+              <a:ext cx="963083" cy="192617"/>
             </a:xfrm>
             <a:prstGeom prst="rect">
               <a:avLst/>
@@ -16681,7 +16681,7 @@
                 </a:lnSpc>
               </a:pPr>
               <a:r>
-                <a:rPr sz="1171" b="0" lang="ko-KR">
+                <a:rPr sz="1166" b="0" lang="ko-KR">
                   <a:solidFill>
                     <a:srgbClr val="232F3E"/>
                   </a:solidFill>
@@ -16702,13 +16702,13 @@
           </p:nvCxnSpPr>
           <p:spPr>
             <a:xfrm>
-              <a:off x="10600015" y="3994976"/>
-              <a:ext cx="594870" cy="0"/>
+              <a:off x="10668000" y="3983567"/>
+              <a:ext cx="592667" cy="0"/>
             </a:xfrm>
             <a:prstGeom prst="line">
               <a:avLst/>
             </a:prstGeom>
-            <a:ln w="15934">
+            <a:ln w="15875">
               <a:solidFill>
                 <a:srgbClr val="232F3E"/>
               </a:solidFill>
@@ -16726,8 +16726,8 @@
           </p:nvSpPr>
           <p:spPr>
             <a:xfrm>
-              <a:off x="3249123" y="3463842"/>
-              <a:ext cx="212454" cy="212454"/>
+              <a:off x="3259667" y="3454400"/>
+              <a:ext cx="211667" cy="211667"/>
             </a:xfrm>
             <a:prstGeom prst="ellipse">
               <a:avLst/>
@@ -16755,8 +16755,8 @@
           </p:nvSpPr>
           <p:spPr>
             <a:xfrm>
-              <a:off x="3247795" y="3491461"/>
-              <a:ext cx="215109" cy="165714"/>
+              <a:off x="3258344" y="3481917"/>
+              <a:ext cx="214312" cy="165100"/>
             </a:xfrm>
             <a:prstGeom prst="rect">
               <a:avLst/>
@@ -16775,7 +16775,7 @@
                 </a:lnSpc>
               </a:pPr>
               <a:r>
-                <a:rPr sz="1003" b="1" lang="ko-KR">
+                <a:rPr sz="1000" b="1" lang="ko-KR">
                   <a:solidFill>
                     <a:srgbClr val="FFFFFF"/>
                   </a:solidFill>
@@ -16796,8 +16796,8 @@
           </p:nvSpPr>
           <p:spPr>
             <a:xfrm>
-              <a:off x="4120182" y="3463842"/>
-              <a:ext cx="212454" cy="212454"/>
+              <a:off x="4127500" y="3454400"/>
+              <a:ext cx="211667" cy="211667"/>
             </a:xfrm>
             <a:prstGeom prst="ellipse">
               <a:avLst/>
@@ -16825,8 +16825,8 @@
           </p:nvSpPr>
           <p:spPr>
             <a:xfrm>
-              <a:off x="4118854" y="3491461"/>
-              <a:ext cx="215109" cy="165714"/>
+              <a:off x="4126177" y="3481917"/>
+              <a:ext cx="214312" cy="165100"/>
             </a:xfrm>
             <a:prstGeom prst="rect">
               <a:avLst/>
@@ -16845,7 +16845,7 @@
                 </a:lnSpc>
               </a:pPr>
               <a:r>
-                <a:rPr sz="1003" b="1" lang="ko-KR">
+                <a:rPr sz="1000" b="1" lang="ko-KR">
                   <a:solidFill>
                     <a:srgbClr val="FFFFFF"/>
                   </a:solidFill>
@@ -16866,8 +16866,8 @@
           </p:nvSpPr>
           <p:spPr>
             <a:xfrm>
-              <a:off x="7731892" y="3463842"/>
-              <a:ext cx="212454" cy="212454"/>
+              <a:off x="8001000" y="3454400"/>
+              <a:ext cx="211667" cy="211667"/>
             </a:xfrm>
             <a:prstGeom prst="ellipse">
               <a:avLst/>
@@ -16895,8 +16895,8 @@
           </p:nvSpPr>
           <p:spPr>
             <a:xfrm>
-              <a:off x="7730564" y="3491461"/>
-              <a:ext cx="215109" cy="165714"/>
+              <a:off x="7999677" y="3481917"/>
+              <a:ext cx="214312" cy="165100"/>
             </a:xfrm>
             <a:prstGeom prst="rect">
               <a:avLst/>
@@ -16915,7 +16915,7 @@
                 </a:lnSpc>
               </a:pPr>
               <a:r>
-                <a:rPr sz="1003" b="1" lang="ko-KR">
+                <a:rPr sz="1000" b="1" lang="ko-KR">
                   <a:solidFill>
                     <a:srgbClr val="FFFFFF"/>
                   </a:solidFill>
@@ -16936,8 +16936,8 @@
           </p:nvSpPr>
           <p:spPr>
             <a:xfrm>
-              <a:off x="9474011" y="3463842"/>
-              <a:ext cx="212454" cy="212454"/>
+              <a:off x="9419167" y="3454400"/>
+              <a:ext cx="211667" cy="211667"/>
             </a:xfrm>
             <a:prstGeom prst="ellipse">
               <a:avLst/>
@@ -16965,8 +16965,8 @@
           </p:nvSpPr>
           <p:spPr>
             <a:xfrm>
-              <a:off x="9472683" y="3491461"/>
-              <a:ext cx="215109" cy="165714"/>
+              <a:off x="9417844" y="3481917"/>
+              <a:ext cx="214312" cy="165100"/>
             </a:xfrm>
             <a:prstGeom prst="rect">
               <a:avLst/>
@@ -16985,7 +16985,7 @@
                 </a:lnSpc>
               </a:pPr>
               <a:r>
-                <a:rPr sz="1003" b="1" lang="ko-KR">
+                <a:rPr sz="1000" b="1" lang="ko-KR">
                   <a:solidFill>
                     <a:srgbClr val="FFFFFF"/>
                   </a:solidFill>
@@ -17006,8 +17006,8 @@
           </p:nvSpPr>
           <p:spPr>
             <a:xfrm>
-              <a:off x="-715791" y="6189621"/>
-              <a:ext cx="11273316" cy="165714"/>
+              <a:off x="381000" y="6424083"/>
+              <a:ext cx="11231563" cy="165100"/>
             </a:xfrm>
             <a:prstGeom prst="rect">
               <a:avLst/>
@@ -17020,13 +17020,13 @@
             </a:bodyPr>
             <a:lstStyle/>
             <a:p>
-              <a:pPr algn="r">
+              <a:pPr algn="l">
                 <a:lnSpc>
                   <a:spcPct val="100000"/>
                 </a:lnSpc>
               </a:pPr>
               <a:r>
-                <a:rPr sz="1003" b="0" lang="ko-KR">
+                <a:rPr sz="1000" b="0" lang="ko-KR">
                   <a:solidFill>
                     <a:srgbClr val="545B64"/>
                   </a:solidFill>

</xml_diff>

<commit_message>
Draw TGW peering with the VPC peering connection icon as the AWS docs do, enforce it in check_layout.py and redraw the Transit Gateway example and the deck
Co-Authored-By: Claude Opus 5.5 <noreply@anthropic.com>
</commit_message>
<xml_diff>
--- a/docs/examples/reference-architectures.pptx
+++ b/docs/examples/reference-architectures.pptx
@@ -11876,10 +11876,10 @@
         </p:nvGrpSpPr>
         <p:grpSpPr>
           <a:xfrm>
-            <a:off x="639792" y="1086928"/>
-            <a:ext cx="12599958" cy="5458364"/>
-            <a:chOff x="639792" y="1086928"/>
-            <a:chExt cx="12599958" cy="5458364"/>
+            <a:off x="398056" y="1134747"/>
+            <a:ext cx="12375554" cy="5361151"/>
+            <a:chOff x="398056" y="1134747"/>
+            <a:chExt cx="12375554" cy="5361151"/>
           </a:xfrm>
         </p:grpSpPr>
         <p:sp>
@@ -11890,14 +11890,14 @@
           </p:nvSpPr>
           <p:spPr>
             <a:xfrm>
-              <a:off x="639792" y="3027872"/>
-              <a:ext cx="1854679" cy="1423358"/>
-            </a:xfrm>
-            <a:prstGeom prst="rect">
-              <a:avLst/>
-            </a:prstGeom>
-            <a:noFill/>
-            <a:ln w="21566">
+              <a:off x="398056" y="3041123"/>
+              <a:ext cx="1821648" cy="1398009"/>
+            </a:xfrm>
+            <a:prstGeom prst="rect">
+              <a:avLst/>
+            </a:prstGeom>
+            <a:noFill/>
+            <a:ln w="21182">
               <a:solidFill>
                 <a:srgbClr val="7D8998"/>
               </a:solidFill>
@@ -11935,8 +11935,8 @@
           </p:blipFill>
           <p:spPr>
             <a:xfrm>
-              <a:off x="639792" y="3027872"/>
-              <a:ext cx="258792" cy="258792"/>
+              <a:off x="398056" y="3041123"/>
+              <a:ext cx="254183" cy="254183"/>
             </a:xfrm>
             <a:prstGeom prst="rect">
               <a:avLst/>
@@ -11951,8 +11951,8 @@
           </p:nvSpPr>
           <p:spPr>
             <a:xfrm>
-              <a:off x="984849" y="3078552"/>
-              <a:ext cx="1292614" cy="196251"/>
+              <a:off x="736967" y="3090900"/>
+              <a:ext cx="1269593" cy="192756"/>
             </a:xfrm>
             <a:prstGeom prst="rect">
               <a:avLst/>
@@ -11971,7 +11971,7 @@
                 </a:lnSpc>
               </a:pPr>
               <a:r>
-                <a:rPr sz="1188" b="1" lang="ko-KR">
+                <a:rPr sz="1167" b="1" lang="ko-KR">
                   <a:solidFill>
                     <a:srgbClr val="7D8998"/>
                   </a:solidFill>
@@ -12006,8 +12006,8 @@
           </p:blipFill>
           <p:spPr>
             <a:xfrm>
-              <a:off x="1308340" y="3394494"/>
-              <a:ext cx="517585" cy="517585"/>
+              <a:off x="1054696" y="3401216"/>
+              <a:ext cx="508367" cy="508367"/>
             </a:xfrm>
             <a:prstGeom prst="rect">
               <a:avLst/>
@@ -12022,8 +12022,8 @@
           </p:nvSpPr>
           <p:spPr>
             <a:xfrm>
-              <a:off x="661358" y="3962759"/>
-              <a:ext cx="1811547" cy="196251"/>
+              <a:off x="419238" y="3959360"/>
+              <a:ext cx="1779284" cy="192756"/>
             </a:xfrm>
             <a:prstGeom prst="rect">
               <a:avLst/>
@@ -12042,7 +12042,7 @@
                 </a:lnSpc>
               </a:pPr>
               <a:r>
-                <a:rPr sz="1188" b="0" lang="ko-KR">
+                <a:rPr sz="1167" b="0" lang="ko-KR">
                   <a:solidFill>
                     <a:srgbClr val="232F3E"/>
                   </a:solidFill>
@@ -12063,8 +12063,8 @@
           </p:nvSpPr>
           <p:spPr>
             <a:xfrm>
-              <a:off x="879715" y="4155775"/>
-              <a:ext cx="1374835" cy="168215"/>
+              <a:off x="633705" y="4148939"/>
+              <a:ext cx="1350349" cy="165219"/>
             </a:xfrm>
             <a:prstGeom prst="rect">
               <a:avLst/>
@@ -12083,7 +12083,7 @@
                 </a:lnSpc>
               </a:pPr>
               <a:r>
-                <a:rPr sz="1018" b="0" lang="ko-KR">
+                <a:rPr sz="1000" b="0" lang="ko-KR">
                   <a:solidFill>
                     <a:srgbClr val="545B64"/>
                   </a:solidFill>
@@ -12118,8 +12118,8 @@
           </p:blipFill>
           <p:spPr>
             <a:xfrm>
-              <a:off x="2861094" y="3394494"/>
-              <a:ext cx="517585" cy="517585"/>
+              <a:off x="2579796" y="3401216"/>
+              <a:ext cx="508367" cy="508367"/>
             </a:xfrm>
             <a:prstGeom prst="rect">
               <a:avLst/>
@@ -12134,8 +12134,8 @@
           </p:nvSpPr>
           <p:spPr>
             <a:xfrm>
-              <a:off x="2629259" y="3962759"/>
-              <a:ext cx="981255" cy="196251"/>
+              <a:off x="2352090" y="3959360"/>
+              <a:ext cx="963779" cy="192756"/>
             </a:xfrm>
             <a:prstGeom prst="rect">
               <a:avLst/>
@@ -12154,7 +12154,7 @@
                 </a:lnSpc>
               </a:pPr>
               <a:r>
-                <a:rPr sz="1188" b="0" lang="ko-KR">
+                <a:rPr sz="1167" b="0" lang="ko-KR">
                   <a:solidFill>
                     <a:srgbClr val="232F3E"/>
                   </a:solidFill>
@@ -12175,13 +12175,13 @@
           </p:nvCxnSpPr>
           <p:spPr>
             <a:xfrm>
-              <a:off x="1869057" y="3653287"/>
-              <a:ext cx="948905" cy="0"/>
+              <a:off x="1605427" y="3655399"/>
+              <a:ext cx="932005" cy="0"/>
             </a:xfrm>
             <a:prstGeom prst="line">
               <a:avLst/>
             </a:prstGeom>
-            <a:ln w="16175">
+            <a:ln w="15886">
               <a:solidFill>
                 <a:srgbClr val="232F3E"/>
               </a:solidFill>
@@ -12198,13 +12198,13 @@
           </p:nvCxnSpPr>
           <p:spPr>
             <a:xfrm>
-              <a:off x="3421811" y="3653287"/>
-              <a:ext cx="539151" cy="0"/>
+              <a:off x="3130527" y="3655399"/>
+              <a:ext cx="529549" cy="0"/>
             </a:xfrm>
             <a:prstGeom prst="line">
               <a:avLst/>
             </a:prstGeom>
-            <a:ln w="16175">
+            <a:ln w="15886">
               <a:solidFill>
                 <a:srgbClr val="232F3E"/>
               </a:solidFill>
@@ -12221,8 +12221,8 @@
           </p:nvSpPr>
           <p:spPr>
             <a:xfrm>
-              <a:off x="3404289" y="3433313"/>
-              <a:ext cx="574196" cy="168215"/>
+              <a:off x="3113317" y="3439343"/>
+              <a:ext cx="563969" cy="165219"/>
             </a:xfrm>
             <a:prstGeom prst="rect">
               <a:avLst/>
@@ -12241,7 +12241,7 @@
                 </a:lnSpc>
               </a:pPr>
               <a:r>
-                <a:rPr sz="1018" b="0" lang="ko-KR">
+                <a:rPr sz="1000" b="0" lang="ko-KR">
                   <a:solidFill>
                     <a:srgbClr val="232F3E"/>
                   </a:solidFill>
@@ -12276,8 +12276,8 @@
           </p:blipFill>
           <p:spPr>
             <a:xfrm>
-              <a:off x="4004094" y="3394494"/>
-              <a:ext cx="517585" cy="517585"/>
+              <a:off x="3702440" y="3401216"/>
+              <a:ext cx="508367" cy="508367"/>
             </a:xfrm>
             <a:prstGeom prst="rect">
               <a:avLst/>
@@ -12292,8 +12292,8 @@
           </p:nvSpPr>
           <p:spPr>
             <a:xfrm>
-              <a:off x="3357113" y="3962759"/>
-              <a:ext cx="1811547" cy="196251"/>
+              <a:off x="3066981" y="3959360"/>
+              <a:ext cx="1779284" cy="192756"/>
             </a:xfrm>
             <a:prstGeom prst="rect">
               <a:avLst/>
@@ -12312,7 +12312,7 @@
                 </a:lnSpc>
               </a:pPr>
               <a:r>
-                <a:rPr sz="1188" b="0" lang="ko-KR">
+                <a:rPr sz="1167" b="0" lang="ko-KR">
                   <a:solidFill>
                     <a:srgbClr val="232F3E"/>
                   </a:solidFill>
@@ -12333,13 +12333,13 @@
           </p:nvCxnSpPr>
           <p:spPr>
             <a:xfrm>
-              <a:off x="4564811" y="3653287"/>
-              <a:ext cx="1854680" cy="0"/>
+              <a:off x="4253170" y="3655399"/>
+              <a:ext cx="1821648" cy="0"/>
             </a:xfrm>
             <a:prstGeom prst="line">
               <a:avLst/>
             </a:prstGeom>
-            <a:ln w="16175">
+            <a:ln w="15886">
               <a:solidFill>
                 <a:srgbClr val="232F3E"/>
               </a:solidFill>
@@ -12356,14 +12356,14 @@
           </p:nvSpPr>
           <p:spPr>
             <a:xfrm>
-              <a:off x="5082396" y="1086928"/>
-              <a:ext cx="6469811" cy="5024887"/>
-            </a:xfrm>
-            <a:prstGeom prst="rect">
-              <a:avLst/>
-            </a:prstGeom>
-            <a:noFill/>
-            <a:ln w="21566">
+              <a:off x="4761537" y="1134747"/>
+              <a:ext cx="7032407" cy="4935394"/>
+            </a:xfrm>
+            <a:prstGeom prst="rect">
+              <a:avLst/>
+            </a:prstGeom>
+            <a:noFill/>
+            <a:ln w="21182">
               <a:solidFill>
                 <a:srgbClr val="232F3E"/>
               </a:solidFill>
@@ -12401,8 +12401,8 @@
           </p:blipFill>
           <p:spPr>
             <a:xfrm>
-              <a:off x="5082396" y="1086928"/>
-              <a:ext cx="345057" cy="345057"/>
+              <a:off x="4761537" y="1134747"/>
+              <a:ext cx="338911" cy="338911"/>
             </a:xfrm>
             <a:prstGeom prst="rect">
               <a:avLst/>
@@ -12417,8 +12417,8 @@
           </p:nvSpPr>
           <p:spPr>
             <a:xfrm>
-              <a:off x="5535283" y="1170497"/>
-              <a:ext cx="1162544" cy="210269"/>
+              <a:off x="5206358" y="1216827"/>
+              <a:ext cx="1141839" cy="206524"/>
             </a:xfrm>
             <a:prstGeom prst="rect">
               <a:avLst/>
@@ -12437,7 +12437,7 @@
                 </a:lnSpc>
               </a:pPr>
               <a:r>
-                <a:rPr sz="1273" b="1" lang="ko-KR">
+                <a:rPr sz="1250" b="1" lang="ko-KR">
                   <a:solidFill>
                     <a:srgbClr val="232F3E"/>
                   </a:solidFill>
@@ -12458,14 +12458,14 @@
           </p:nvSpPr>
           <p:spPr>
             <a:xfrm>
-              <a:off x="5298057" y="1518249"/>
-              <a:ext cx="3105509" cy="4377906"/>
-            </a:xfrm>
-            <a:prstGeom prst="rect">
-              <a:avLst/>
-            </a:prstGeom>
-            <a:noFill/>
-            <a:ln w="21566">
+              <a:off x="4973357" y="1558386"/>
+              <a:ext cx="3050201" cy="4299936"/>
+            </a:xfrm>
+            <a:prstGeom prst="rect">
+              <a:avLst/>
+            </a:prstGeom>
+            <a:noFill/>
+            <a:ln w="21182">
               <a:solidFill>
                 <a:srgbClr val="00A4A6"/>
               </a:solidFill>
@@ -12505,8 +12505,8 @@
           </p:blipFill>
           <p:spPr>
             <a:xfrm>
-              <a:off x="5298057" y="1518249"/>
-              <a:ext cx="258792" cy="258792"/>
+              <a:off x="4973357" y="1558386"/>
+              <a:ext cx="254183" cy="254183"/>
             </a:xfrm>
             <a:prstGeom prst="rect">
               <a:avLst/>
@@ -12521,8 +12521,8 @@
           </p:nvSpPr>
           <p:spPr>
             <a:xfrm>
-              <a:off x="5643113" y="1568929"/>
-              <a:ext cx="2330480" cy="196251"/>
+              <a:off x="5312268" y="1608164"/>
+              <a:ext cx="2288974" cy="192756"/>
             </a:xfrm>
             <a:prstGeom prst="rect">
               <a:avLst/>
@@ -12541,7 +12541,7 @@
                 </a:lnSpc>
               </a:pPr>
               <a:r>
-                <a:rPr sz="1188" b="1" lang="ko-KR">
+                <a:rPr sz="1167" b="1" lang="ko-KR">
                   <a:solidFill>
                     <a:srgbClr val="00A4A6"/>
                   </a:solidFill>
@@ -12576,8 +12576,8 @@
           </p:blipFill>
           <p:spPr>
             <a:xfrm>
-              <a:off x="6462623" y="3394494"/>
-              <a:ext cx="517585" cy="517585"/>
+              <a:off x="6117182" y="3401216"/>
+              <a:ext cx="508367" cy="508367"/>
             </a:xfrm>
             <a:prstGeom prst="rect">
               <a:avLst/>
@@ -12592,8 +12592,8 @@
           </p:nvSpPr>
           <p:spPr>
             <a:xfrm>
-              <a:off x="5763748" y="3962759"/>
-              <a:ext cx="1915334" cy="196251"/>
+              <a:off x="5430754" y="3959360"/>
+              <a:ext cx="1881222" cy="192756"/>
             </a:xfrm>
             <a:prstGeom prst="rect">
               <a:avLst/>
@@ -12612,7 +12612,7 @@
                 </a:lnSpc>
               </a:pPr>
               <a:r>
-                <a:rPr sz="1188" b="0" lang="ko-KR">
+                <a:rPr sz="1167" b="0" lang="ko-KR">
                   <a:solidFill>
                     <a:srgbClr val="232F3E"/>
                   </a:solidFill>
@@ -12647,8 +12647,8 @@
           </p:blipFill>
           <p:spPr>
             <a:xfrm>
-              <a:off x="5815642" y="1949570"/>
-              <a:ext cx="517585" cy="517585"/>
+              <a:off x="5481723" y="1982025"/>
+              <a:ext cx="508367" cy="508367"/>
             </a:xfrm>
             <a:prstGeom prst="rect">
               <a:avLst/>
@@ -12663,8 +12663,8 @@
           </p:nvSpPr>
           <p:spPr>
             <a:xfrm>
-              <a:off x="5376233" y="2517835"/>
-              <a:ext cx="1396401" cy="196251"/>
+              <a:off x="5050141" y="2540170"/>
+              <a:ext cx="1371531" cy="192756"/>
             </a:xfrm>
             <a:prstGeom prst="rect">
               <a:avLst/>
@@ -12683,7 +12683,7 @@
                 </a:lnSpc>
               </a:pPr>
               <a:r>
-                <a:rPr sz="1188" b="0" lang="ko-KR">
+                <a:rPr sz="1167" b="0" lang="ko-KR">
                   <a:solidFill>
                     <a:srgbClr val="232F3E"/>
                   </a:solidFill>
@@ -12704,8 +12704,8 @@
           </p:nvSpPr>
           <p:spPr>
             <a:xfrm>
-              <a:off x="5520456" y="2710851"/>
-              <a:ext cx="1107955" cy="168215"/>
+              <a:off x="5191796" y="2729748"/>
+              <a:ext cx="1088223" cy="165219"/>
             </a:xfrm>
             <a:prstGeom prst="rect">
               <a:avLst/>
@@ -12724,7 +12724,7 @@
                 </a:lnSpc>
               </a:pPr>
               <a:r>
-                <a:rPr sz="1018" b="0" lang="ko-KR">
+                <a:rPr sz="1000" b="0" lang="ko-KR">
                   <a:solidFill>
                     <a:srgbClr val="545B64"/>
                   </a:solidFill>
@@ -12759,8 +12759,8 @@
           </p:blipFill>
           <p:spPr>
             <a:xfrm>
-              <a:off x="7109604" y="1949570"/>
-              <a:ext cx="517585" cy="517585"/>
+              <a:off x="6752640" y="1982025"/>
+              <a:ext cx="508367" cy="508367"/>
             </a:xfrm>
             <a:prstGeom prst="rect">
               <a:avLst/>
@@ -12775,8 +12775,8 @@
           </p:nvSpPr>
           <p:spPr>
             <a:xfrm>
-              <a:off x="6877769" y="2517835"/>
-              <a:ext cx="981255" cy="196251"/>
+              <a:off x="6524934" y="2540170"/>
+              <a:ext cx="963779" cy="192756"/>
             </a:xfrm>
             <a:prstGeom prst="rect">
               <a:avLst/>
@@ -12795,7 +12795,7 @@
                 </a:lnSpc>
               </a:pPr>
               <a:r>
-                <a:rPr sz="1188" b="0" lang="ko-KR">
+                <a:rPr sz="1167" b="0" lang="ko-KR">
                   <a:solidFill>
                     <a:srgbClr val="232F3E"/>
                   </a:solidFill>
@@ -12816,8 +12816,8 @@
           </p:nvSpPr>
           <p:spPr>
             <a:xfrm>
-              <a:off x="6814419" y="2710851"/>
-              <a:ext cx="1107955" cy="168215"/>
+              <a:off x="6462712" y="2729748"/>
+              <a:ext cx="1088223" cy="165219"/>
             </a:xfrm>
             <a:prstGeom prst="rect">
               <a:avLst/>
@@ -12836,7 +12836,7 @@
                 </a:lnSpc>
               </a:pPr>
               <a:r>
-                <a:rPr sz="1018" b="0" lang="ko-KR">
+                <a:rPr sz="1000" b="0" lang="ko-KR">
                   <a:solidFill>
                     <a:srgbClr val="545B64"/>
                   </a:solidFill>
@@ -12871,8 +12871,8 @@
           </p:blipFill>
           <p:spPr>
             <a:xfrm>
-              <a:off x="5815642" y="4839419"/>
-              <a:ext cx="517585" cy="517585"/>
+              <a:off x="5481723" y="4820406"/>
+              <a:ext cx="508367" cy="508367"/>
             </a:xfrm>
             <a:prstGeom prst="rect">
               <a:avLst/>
@@ -12887,8 +12887,8 @@
           </p:nvSpPr>
           <p:spPr>
             <a:xfrm>
-              <a:off x="5635700" y="5407684"/>
-              <a:ext cx="877468" cy="196251"/>
+              <a:off x="5304987" y="5378551"/>
+              <a:ext cx="861841" cy="192756"/>
             </a:xfrm>
             <a:prstGeom prst="rect">
               <a:avLst/>
@@ -12907,7 +12907,7 @@
                 </a:lnSpc>
               </a:pPr>
               <a:r>
-                <a:rPr sz="1188" b="0" lang="ko-KR">
+                <a:rPr sz="1167" b="0" lang="ko-KR">
                   <a:solidFill>
                     <a:srgbClr val="232F3E"/>
                   </a:solidFill>
@@ -12928,8 +12928,8 @@
           </p:nvSpPr>
           <p:spPr>
             <a:xfrm>
-              <a:off x="5520456" y="5600700"/>
-              <a:ext cx="1107955" cy="168215"/>
+              <a:off x="5191796" y="5568129"/>
+              <a:ext cx="1088223" cy="165219"/>
             </a:xfrm>
             <a:prstGeom prst="rect">
               <a:avLst/>
@@ -12948,7 +12948,7 @@
                 </a:lnSpc>
               </a:pPr>
               <a:r>
-                <a:rPr sz="1018" b="0" lang="ko-KR">
+                <a:rPr sz="1000" b="0" lang="ko-KR">
                   <a:solidFill>
                     <a:srgbClr val="545B64"/>
                   </a:solidFill>
@@ -12983,8 +12983,8 @@
           </p:blipFill>
           <p:spPr>
             <a:xfrm>
-              <a:off x="7109604" y="4839419"/>
-              <a:ext cx="517585" cy="517585"/>
+              <a:off x="6752640" y="4820406"/>
+              <a:ext cx="508367" cy="508367"/>
             </a:xfrm>
             <a:prstGeom prst="rect">
               <a:avLst/>
@@ -12999,8 +12999,8 @@
           </p:nvSpPr>
           <p:spPr>
             <a:xfrm>
-              <a:off x="6877769" y="5407684"/>
-              <a:ext cx="981255" cy="196251"/>
+              <a:off x="6524934" y="5378551"/>
+              <a:ext cx="963779" cy="192756"/>
             </a:xfrm>
             <a:prstGeom prst="rect">
               <a:avLst/>
@@ -13019,7 +13019,7 @@
                 </a:lnSpc>
               </a:pPr>
               <a:r>
-                <a:rPr sz="1188" b="0" lang="ko-KR">
+                <a:rPr sz="1167" b="0" lang="ko-KR">
                   <a:solidFill>
                     <a:srgbClr val="232F3E"/>
                   </a:solidFill>
@@ -13040,8 +13040,8 @@
           </p:nvSpPr>
           <p:spPr>
             <a:xfrm>
-              <a:off x="6814419" y="5600700"/>
-              <a:ext cx="1107955" cy="168215"/>
+              <a:off x="6462712" y="5568129"/>
+              <a:ext cx="1088223" cy="165219"/>
             </a:xfrm>
             <a:prstGeom prst="rect">
               <a:avLst/>
@@ -13060,7 +13060,7 @@
                 </a:lnSpc>
               </a:pPr>
               <a:r>
-                <a:rPr sz="1018" b="0" lang="ko-KR">
+                <a:rPr sz="1000" b="0" lang="ko-KR">
                   <a:solidFill>
                     <a:srgbClr val="545B64"/>
                   </a:solidFill>
@@ -13081,8 +13081,8 @@
           </p:nvSpPr>
           <p:spPr>
             <a:xfrm>
-              <a:off x="6074434" y="2920042"/>
-              <a:ext cx="539151" cy="431320"/>
+              <a:off x="5735907" y="2935213"/>
+              <a:ext cx="529549" cy="423639"/>
             </a:xfrm>
             <a:custGeom>
               <a:avLst/>
@@ -13091,15 +13091,15 @@
               <a:cxnLst/>
               <a:rect l="l" t="t" r="r" b="b"/>
               <a:pathLst>
-                <a:path w="539151" h="431320">
+                <a:path w="529549" h="423639">
                   <a:moveTo>
-                    <a:pt x="539151" y="431320"/>
+                    <a:pt x="529549" y="423639"/>
                   </a:moveTo>
                   <a:lnTo>
-                    <a:pt x="539151" y="215660"/>
+                    <a:pt x="529549" y="211819"/>
                   </a:lnTo>
                   <a:lnTo>
-                    <a:pt x="0" y="215660"/>
+                    <a:pt x="0" y="211819"/>
                   </a:lnTo>
                   <a:lnTo>
                     <a:pt x="0" y="0"/>
@@ -13108,7 +13108,7 @@
               </a:pathLst>
             </a:custGeom>
             <a:noFill/>
-            <a:ln w="16175">
+            <a:ln w="15886">
               <a:solidFill>
                 <a:srgbClr val="232F3E"/>
               </a:solidFill>
@@ -13132,8 +13132,8 @@
           </p:nvSpPr>
           <p:spPr>
             <a:xfrm>
-              <a:off x="6829245" y="2920042"/>
-              <a:ext cx="539151" cy="431320"/>
+              <a:off x="6477275" y="2935213"/>
+              <a:ext cx="529549" cy="423639"/>
             </a:xfrm>
             <a:custGeom>
               <a:avLst/>
@@ -13142,24 +13142,24 @@
               <a:cxnLst/>
               <a:rect l="l" t="t" r="r" b="b"/>
               <a:pathLst>
-                <a:path w="539151" h="431320">
+                <a:path w="529549" h="423639">
                   <a:moveTo>
-                    <a:pt x="0" y="431320"/>
+                    <a:pt x="0" y="423639"/>
                   </a:moveTo>
                   <a:lnTo>
-                    <a:pt x="0" y="215660"/>
+                    <a:pt x="0" y="211819"/>
                   </a:lnTo>
                   <a:lnTo>
-                    <a:pt x="539151" y="215660"/>
+                    <a:pt x="529549" y="211819"/>
                   </a:lnTo>
                   <a:lnTo>
-                    <a:pt x="539151" y="0"/>
+                    <a:pt x="529549" y="0"/>
                   </a:lnTo>
                 </a:path>
               </a:pathLst>
             </a:custGeom>
             <a:noFill/>
-            <a:ln w="16175">
+            <a:ln w="15886">
               <a:solidFill>
                 <a:srgbClr val="232F3E"/>
               </a:solidFill>
@@ -13183,8 +13183,8 @@
           </p:nvSpPr>
           <p:spPr>
             <a:xfrm>
-              <a:off x="6074434" y="4192438"/>
-              <a:ext cx="539151" cy="603849"/>
+              <a:off x="5735907" y="4184948"/>
+              <a:ext cx="529549" cy="593095"/>
             </a:xfrm>
             <a:custGeom>
               <a:avLst/>
@@ -13193,24 +13193,24 @@
               <a:cxnLst/>
               <a:rect l="l" t="t" r="r" b="b"/>
               <a:pathLst>
-                <a:path w="539151" h="603849">
+                <a:path w="529549" h="593095">
                   <a:moveTo>
-                    <a:pt x="539151" y="0"/>
+                    <a:pt x="529549" y="0"/>
                   </a:moveTo>
                   <a:lnTo>
-                    <a:pt x="539151" y="301924"/>
+                    <a:pt x="529549" y="296547"/>
                   </a:lnTo>
                   <a:lnTo>
-                    <a:pt x="0" y="301924"/>
+                    <a:pt x="0" y="296547"/>
                   </a:lnTo>
                   <a:lnTo>
-                    <a:pt x="0" y="603849"/>
+                    <a:pt x="0" y="593095"/>
                   </a:lnTo>
                 </a:path>
               </a:pathLst>
             </a:custGeom>
             <a:noFill/>
-            <a:ln w="16175">
+            <a:ln w="15886">
               <a:solidFill>
                 <a:srgbClr val="232F3E"/>
               </a:solidFill>
@@ -13234,8 +13234,8 @@
           </p:nvSpPr>
           <p:spPr>
             <a:xfrm>
-              <a:off x="6829245" y="4192438"/>
-              <a:ext cx="539151" cy="603849"/>
+              <a:off x="6477275" y="4184948"/>
+              <a:ext cx="529549" cy="593095"/>
             </a:xfrm>
             <a:custGeom>
               <a:avLst/>
@@ -13244,24 +13244,24 @@
               <a:cxnLst/>
               <a:rect l="l" t="t" r="r" b="b"/>
               <a:pathLst>
-                <a:path w="539151" h="603849">
+                <a:path w="529549" h="593095">
                   <a:moveTo>
                     <a:pt x="0" y="0"/>
                   </a:moveTo>
                   <a:lnTo>
-                    <a:pt x="0" y="301924"/>
+                    <a:pt x="0" y="296547"/>
                   </a:lnTo>
                   <a:lnTo>
-                    <a:pt x="539151" y="301924"/>
+                    <a:pt x="529549" y="296547"/>
                   </a:lnTo>
                   <a:lnTo>
-                    <a:pt x="539151" y="603849"/>
+                    <a:pt x="529549" y="593095"/>
                   </a:lnTo>
                 </a:path>
               </a:pathLst>
             </a:custGeom>
             <a:noFill/>
-            <a:ln w="16175">
+            <a:ln w="15886">
               <a:solidFill>
                 <a:srgbClr val="232F3E"/>
               </a:solidFill>
@@ -13285,14 +13285,14 @@
           </p:nvSpPr>
           <p:spPr>
             <a:xfrm>
-              <a:off x="8834887" y="1518249"/>
-              <a:ext cx="2501660" cy="4377906"/>
-            </a:xfrm>
-            <a:prstGeom prst="rect">
-              <a:avLst/>
-            </a:prstGeom>
-            <a:noFill/>
-            <a:ln w="21566">
+              <a:off x="9125019" y="1558386"/>
+              <a:ext cx="2457106" cy="4299936"/>
+            </a:xfrm>
+            <a:prstGeom prst="rect">
+              <a:avLst/>
+            </a:prstGeom>
+            <a:noFill/>
+            <a:ln w="21182">
               <a:solidFill>
                 <a:srgbClr val="00A4A6"/>
               </a:solidFill>
@@ -13332,8 +13332,8 @@
           </p:blipFill>
           <p:spPr>
             <a:xfrm>
-              <a:off x="8834887" y="1518249"/>
-              <a:ext cx="258792" cy="258792"/>
+              <a:off x="9125019" y="1558386"/>
+              <a:ext cx="254183" cy="254183"/>
             </a:xfrm>
             <a:prstGeom prst="rect">
               <a:avLst/>
@@ -13348,8 +13348,8 @@
           </p:nvSpPr>
           <p:spPr>
             <a:xfrm>
-              <a:off x="9179943" y="1568929"/>
-              <a:ext cx="2330480" cy="196251"/>
+              <a:off x="9463930" y="1608164"/>
+              <a:ext cx="2288974" cy="192756"/>
             </a:xfrm>
             <a:prstGeom prst="rect">
               <a:avLst/>
@@ -13368,7 +13368,7 @@
                 </a:lnSpc>
               </a:pPr>
               <a:r>
-                <a:rPr sz="1188" b="1" lang="ko-KR">
+                <a:rPr sz="1167" b="1" lang="ko-KR">
                   <a:solidFill>
                     <a:srgbClr val="00A4A6"/>
                   </a:solidFill>
@@ -13403,8 +13403,8 @@
           </p:blipFill>
           <p:spPr>
             <a:xfrm>
-              <a:off x="9783792" y="3394494"/>
-              <a:ext cx="517585" cy="517585"/>
+              <a:off x="10057025" y="3401216"/>
+              <a:ext cx="508367" cy="508367"/>
             </a:xfrm>
             <a:prstGeom prst="rect">
               <a:avLst/>
@@ -13419,8 +13419,8 @@
           </p:nvSpPr>
           <p:spPr>
             <a:xfrm>
-              <a:off x="9084918" y="3962759"/>
-              <a:ext cx="1915334" cy="196251"/>
+              <a:off x="9370597" y="3959360"/>
+              <a:ext cx="1881222" cy="192756"/>
             </a:xfrm>
             <a:prstGeom prst="rect">
               <a:avLst/>
@@ -13439,7 +13439,7 @@
                 </a:lnSpc>
               </a:pPr>
               <a:r>
-                <a:rPr sz="1188" b="0" lang="ko-KR">
+                <a:rPr sz="1167" b="0" lang="ko-KR">
                   <a:solidFill>
                     <a:srgbClr val="232F3E"/>
                   </a:solidFill>
@@ -13474,8 +13474,8 @@
           </p:blipFill>
           <p:spPr>
             <a:xfrm>
-              <a:off x="9783792" y="1949570"/>
-              <a:ext cx="517585" cy="517585"/>
+              <a:off x="10057025" y="1982025"/>
+              <a:ext cx="508367" cy="508367"/>
             </a:xfrm>
             <a:prstGeom prst="rect">
               <a:avLst/>
@@ -13490,8 +13490,8 @@
           </p:nvSpPr>
           <p:spPr>
             <a:xfrm>
-              <a:off x="9655744" y="2517835"/>
-              <a:ext cx="773682" cy="196251"/>
+              <a:off x="9931257" y="2540170"/>
+              <a:ext cx="759902" cy="192756"/>
             </a:xfrm>
             <a:prstGeom prst="rect">
               <a:avLst/>
@@ -13510,7 +13510,7 @@
                 </a:lnSpc>
               </a:pPr>
               <a:r>
-                <a:rPr sz="1188" b="0" lang="ko-KR">
+                <a:rPr sz="1167" b="0" lang="ko-KR">
                   <a:solidFill>
                     <a:srgbClr val="232F3E"/>
                   </a:solidFill>
@@ -13531,8 +13531,8 @@
           </p:nvSpPr>
           <p:spPr>
             <a:xfrm>
-              <a:off x="9444127" y="2710851"/>
-              <a:ext cx="1196915" cy="168215"/>
+              <a:off x="9723409" y="2729748"/>
+              <a:ext cx="1175598" cy="165219"/>
             </a:xfrm>
             <a:prstGeom prst="rect">
               <a:avLst/>
@@ -13551,7 +13551,7 @@
                 </a:lnSpc>
               </a:pPr>
               <a:r>
-                <a:rPr sz="1018" b="0" lang="ko-KR">
+                <a:rPr sz="1000" b="0" lang="ko-KR">
                   <a:solidFill>
                     <a:srgbClr val="545B64"/>
                   </a:solidFill>
@@ -13586,8 +13586,8 @@
           </p:blipFill>
           <p:spPr>
             <a:xfrm>
-              <a:off x="9783792" y="4839419"/>
-              <a:ext cx="517585" cy="517585"/>
+              <a:off x="10057025" y="4820406"/>
+              <a:ext cx="508367" cy="508367"/>
             </a:xfrm>
             <a:prstGeom prst="rect">
               <a:avLst/>
@@ -13602,8 +13602,8 @@
           </p:nvSpPr>
           <p:spPr>
             <a:xfrm>
-              <a:off x="9292491" y="5407684"/>
-              <a:ext cx="1500188" cy="196251"/>
+              <a:off x="9574473" y="5378551"/>
+              <a:ext cx="1473469" cy="192756"/>
             </a:xfrm>
             <a:prstGeom prst="rect">
               <a:avLst/>
@@ -13622,7 +13622,7 @@
                 </a:lnSpc>
               </a:pPr>
               <a:r>
-                <a:rPr sz="1188" b="0" lang="ko-KR">
+                <a:rPr sz="1167" b="0" lang="ko-KR">
                   <a:solidFill>
                     <a:srgbClr val="232F3E"/>
                   </a:solidFill>
@@ -13643,8 +13643,8 @@
           </p:nvSpPr>
           <p:spPr>
             <a:xfrm>
-              <a:off x="9444127" y="5600700"/>
-              <a:ext cx="1196915" cy="168215"/>
+              <a:off x="9723409" y="5568129"/>
+              <a:ext cx="1175598" cy="165219"/>
             </a:xfrm>
             <a:prstGeom prst="rect">
               <a:avLst/>
@@ -13663,7 +13663,7 @@
                 </a:lnSpc>
               </a:pPr>
               <a:r>
-                <a:rPr sz="1018" b="0" lang="ko-KR">
+                <a:rPr sz="1000" b="0" lang="ko-KR">
                   <a:solidFill>
                     <a:srgbClr val="545B64"/>
                   </a:solidFill>
@@ -13684,13 +13684,13 @@
           </p:nvCxnSpPr>
           <p:spPr>
             <a:xfrm flipV="1">
-              <a:off x="10042585" y="2920042"/>
-              <a:ext cx="0" cy="431320"/>
+              <a:off x="10311208" y="2935213"/>
+              <a:ext cx="0" cy="423639"/>
             </a:xfrm>
             <a:prstGeom prst="line">
               <a:avLst/>
             </a:prstGeom>
-            <a:ln w="16175">
+            <a:ln w="15886">
               <a:solidFill>
                 <a:srgbClr val="232F3E"/>
               </a:solidFill>
@@ -13707,13 +13707,13 @@
           </p:nvCxnSpPr>
           <p:spPr>
             <a:xfrm>
-              <a:off x="10042585" y="4192438"/>
-              <a:ext cx="0" cy="603849"/>
+              <a:off x="10311208" y="4184948"/>
+              <a:ext cx="0" cy="593095"/>
             </a:xfrm>
             <a:prstGeom prst="line">
               <a:avLst/>
             </a:prstGeom>
-            <a:ln w="16175">
+            <a:ln w="15886">
               <a:solidFill>
                 <a:srgbClr val="232F3E"/>
               </a:solidFill>
@@ -13730,13 +13730,13 @@
           </p:nvCxnSpPr>
           <p:spPr>
             <a:xfrm>
-              <a:off x="7023340" y="3653287"/>
-              <a:ext cx="2717320" cy="0"/>
+              <a:off x="6667913" y="3655399"/>
+              <a:ext cx="1609828" cy="0"/>
             </a:xfrm>
             <a:prstGeom prst="line">
               <a:avLst/>
             </a:prstGeom>
-            <a:ln w="26958">
+            <a:ln w="26477">
               <a:solidFill>
                 <a:srgbClr val="232F3E"/>
               </a:solidFill>
@@ -13745,16 +13745,69 @@
             </a:ln>
           </p:spPr>
         </p:cxnSp>
-        <p:sp>
-          <p:nvSpPr>
-            <p:cNvPr id="56" name="TextBox 55"/>
+        <p:cxnSp>
+          <p:nvCxnSpPr>
+            <p:cNvPr id="56" name="Connector 55"/>
+            <p:cNvCxnSpPr/>
+            <p:nvPr/>
+          </p:nvCxnSpPr>
+          <p:spPr>
+            <a:xfrm>
+              <a:off x="8870835" y="3655399"/>
+              <a:ext cx="1143826" cy="0"/>
+            </a:xfrm>
+            <a:prstGeom prst="line">
+              <a:avLst/>
+            </a:prstGeom>
+            <a:ln w="26477">
+              <a:solidFill>
+                <a:srgbClr val="232F3E"/>
+              </a:solidFill>
+              <a:prstDash val="solid"/>
+              <a:miter lim="800000"/>
+            </a:ln>
+          </p:spPr>
+        </p:cxnSp>
+        <p:pic>
+          <p:nvPicPr>
+            <p:cNvPr id="57" name="Amazon-VPC_Peering-Connection" descr="Amazon VPC_Peering Connection"/>
+            <p:cNvPicPr>
+              <a:picLocks noChangeAspect="1"/>
+            </p:cNvPicPr>
+            <p:nvPr/>
+          </p:nvPicPr>
+          <p:blipFill>
+            <a:blip r:embed="rId18">
+              <a:extLst>
+                <a:ext uri="{96DAC541-7B7A-43D3-8B79-37D633B846F1}">
+                  <asvg:svgBlip xmlns:asvg="http://schemas.microsoft.com/office/drawing/2016/SVG/main" r:embed="rId19"/>
+                </a:ext>
+              </a:extLst>
+            </a:blip>
+            <a:stretch>
+              <a:fillRect/>
+            </a:stretch>
+          </p:blipFill>
+          <p:spPr>
+            <a:xfrm>
+              <a:off x="8320105" y="3401216"/>
+              <a:ext cx="508367" cy="508367"/>
+            </a:xfrm>
+            <a:prstGeom prst="rect">
+              <a:avLst/>
+            </a:prstGeom>
+          </p:spPr>
+        </p:pic>
+        <p:sp>
+          <p:nvSpPr>
+            <p:cNvPr id="58" name="TextBox 57"/>
             <p:cNvSpPr txBox="1"/>
             <p:nvPr/>
           </p:nvSpPr>
           <p:spPr>
             <a:xfrm>
-              <a:off x="7137909" y="3433313"/>
-              <a:ext cx="1107955" cy="168215"/>
+              <a:off x="7939492" y="3959360"/>
+              <a:ext cx="1269593" cy="192756"/>
             </a:xfrm>
             <a:prstGeom prst="rect">
               <a:avLst/>
@@ -13773,7 +13826,7 @@
                 </a:lnSpc>
               </a:pPr>
               <a:r>
-                <a:rPr sz="1018" b="1" lang="ko-KR">
+                <a:rPr sz="1167" b="0" lang="ko-KR">
                   <a:solidFill>
                     <a:srgbClr val="232F3E"/>
                   </a:solidFill>
@@ -13788,14 +13841,14 @@
         </p:sp>
         <p:sp>
           <p:nvSpPr>
-            <p:cNvPr id="57" name="TextBox 56"/>
+            <p:cNvPr id="59" name="TextBox 58"/>
             <p:cNvSpPr txBox="1"/>
             <p:nvPr/>
           </p:nvSpPr>
           <p:spPr>
             <a:xfrm>
-              <a:off x="6866986" y="3724455"/>
-              <a:ext cx="1649802" cy="168215"/>
+              <a:off x="8177127" y="4148939"/>
+              <a:ext cx="794323" cy="165219"/>
             </a:xfrm>
             <a:prstGeom prst="rect">
               <a:avLst/>
@@ -13814,7 +13867,7 @@
                 </a:lnSpc>
               </a:pPr>
               <a:r>
-                <a:rPr sz="1018" b="0" lang="ko-KR">
+                <a:rPr sz="1000" b="0" lang="ko-KR">
                   <a:solidFill>
                     <a:srgbClr val="545B64"/>
                   </a:solidFill>
@@ -13822,21 +13875,21 @@
                   <a:ea typeface="Malgun Gothic"/>
                   <a:cs typeface="Malgun Gothic"/>
                 </a:rPr>
-                <a:t>리전 간 · AWS 백본</a:t>
+                <a:t>AWS 백본</a:t>
               </a:r>
             </a:p>
           </p:txBody>
         </p:sp>
         <p:sp>
           <p:nvSpPr>
-            <p:cNvPr id="58" name="TextBox 57"/>
+            <p:cNvPr id="60" name="TextBox 59"/>
             <p:cNvSpPr txBox="1"/>
             <p:nvPr/>
           </p:nvSpPr>
           <p:spPr>
             <a:xfrm>
-              <a:off x="639792" y="6204549"/>
-              <a:ext cx="9146696" cy="168215"/>
+              <a:off x="398056" y="6161224"/>
+              <a:ext cx="8983794" cy="165219"/>
             </a:xfrm>
             <a:prstGeom prst="rect">
               <a:avLst/>
@@ -13855,7 +13908,7 @@
                 </a:lnSpc>
               </a:pPr>
               <a:r>
-                <a:rPr sz="1018" b="0" lang="ko-KR">
+                <a:rPr sz="1000" b="0" lang="ko-KR">
                   <a:solidFill>
                     <a:srgbClr val="545B64"/>
                   </a:solidFill>
@@ -13870,14 +13923,14 @@
         </p:sp>
         <p:sp>
           <p:nvSpPr>
-            <p:cNvPr id="59" name="TextBox 58"/>
+            <p:cNvPr id="61" name="TextBox 60"/>
             <p:cNvSpPr txBox="1"/>
             <p:nvPr/>
           </p:nvSpPr>
           <p:spPr>
             <a:xfrm>
-              <a:off x="639792" y="6377077"/>
-              <a:ext cx="12599958" cy="168215"/>
+              <a:off x="398056" y="6330679"/>
+              <a:ext cx="12375554" cy="165219"/>
             </a:xfrm>
             <a:prstGeom prst="rect">
               <a:avLst/>
@@ -13896,7 +13949,7 @@
                 </a:lnSpc>
               </a:pPr>
               <a:r>
-                <a:rPr sz="1018" b="0" lang="ko-KR">
+                <a:rPr sz="1000" b="0" lang="ko-KR">
                   <a:solidFill>
                     <a:srgbClr val="545B64"/>
                   </a:solidFill>

</xml_diff>

<commit_message>
Draw every connector at 1.5px, inter-Region links included, since the TGW peering icon and label already mark the backbone as the AWS docs do
Co-Authored-By: Claude Opus 5.5 <noreply@anthropic.com>
</commit_message>
<xml_diff>
--- a/docs/examples/reference-architectures.pptx
+++ b/docs/examples/reference-architectures.pptx
@@ -13736,7 +13736,7 @@
             <a:prstGeom prst="line">
               <a:avLst/>
             </a:prstGeom>
-            <a:ln w="26477">
+            <a:ln w="15886">
               <a:solidFill>
                 <a:srgbClr val="232F3E"/>
               </a:solidFill>
@@ -13759,7 +13759,7 @@
             <a:prstGeom prst="line">
               <a:avLst/>
             </a:prstGeom>
-            <a:ln w="26477">
+            <a:ln w="15886">
               <a:solidFill>
                 <a:srgbClr val="232F3E"/>
               </a:solidFill>

</xml_diff>

<commit_message>
Join the per-AZ NAT gateway lines into one trunk with one arrowhead into the IGW again and limit separate entries to lines that are separate attachments or endpoints
Co-Authored-By: Claude Opus 5.5 <noreply@anthropic.com>
</commit_message>
<xml_diff>
--- a/docs/examples/reference-architectures.pptx
+++ b/docs/examples/reference-architectures.pptx
@@ -16860,7 +16860,7 @@
           <p:spPr>
             <a:xfrm>
               <a:off x="9207500" y="2861733"/>
-              <a:ext cx="867833" cy="910167"/>
+              <a:ext cx="867833" cy="994834"/>
             </a:xfrm>
             <a:custGeom>
               <a:avLst/>
@@ -16869,7 +16869,7 @@
               <a:cxnLst/>
               <a:rect l="l" t="t" r="r" b="b"/>
               <a:pathLst>
-                <a:path w="867833" h="910167">
+                <a:path w="867833" h="994834">
                   <a:moveTo>
                     <a:pt x="0" y="0"/>
                   </a:moveTo>
@@ -16877,10 +16877,10 @@
                     <a:pt x="656167" y="0"/>
                   </a:lnTo>
                   <a:lnTo>
-                    <a:pt x="656167" y="910167"/>
+                    <a:pt x="656167" y="994834"/>
                   </a:lnTo>
                   <a:lnTo>
-                    <a:pt x="867833" y="910167"/>
+                    <a:pt x="867833" y="994834"/>
                   </a:lnTo>
                 </a:path>
               </a:pathLst>
@@ -16911,8 +16911,8 @@
           </p:nvSpPr>
           <p:spPr>
             <a:xfrm>
-              <a:off x="9207500" y="3941233"/>
-              <a:ext cx="867833" cy="1354667"/>
+              <a:off x="9207500" y="3856567"/>
+              <a:ext cx="656167" cy="1439333"/>
             </a:xfrm>
             <a:custGeom>
               <a:avLst/>
@@ -16921,18 +16921,15 @@
               <a:cxnLst/>
               <a:rect l="l" t="t" r="r" b="b"/>
               <a:pathLst>
-                <a:path w="867833" h="1354667">
+                <a:path w="656167" h="1439333">
                   <a:moveTo>
-                    <a:pt x="0" y="1354667"/>
+                    <a:pt x="0" y="1439333"/>
                   </a:moveTo>
                   <a:lnTo>
-                    <a:pt x="656167" y="1354667"/>
+                    <a:pt x="656167" y="1439333"/>
                   </a:lnTo>
                   <a:lnTo>
                     <a:pt x="656167" y="0"/>
-                  </a:lnTo>
-                  <a:lnTo>
-                    <a:pt x="867833" y="0"/>
                   </a:lnTo>
                 </a:path>
               </a:pathLst>
@@ -16944,7 +16941,6 @@
               </a:solidFill>
               <a:prstDash val="solid"/>
               <a:miter lim="800000"/>
-              <a:tailEnd type="triangle" w="med" len="med"/>
             </a:ln>
           </p:spPr>
           <p:txBody>

</xml_diff>

<commit_message>
Draw the note's step legend with the diagram's own step badges, left-aligned one step per row, and flag circled-digit legends in check_layout.py
Co-Authored-By: Claude Opus 5.5 <noreply@anthropic.com>
</commit_message>
<xml_diff>
--- a/docs/examples/reference-architectures.pptx
+++ b/docs/examples/reference-architectures.pptx
@@ -8903,9 +8903,9 @@
         <p:grpSpPr>
           <a:xfrm>
             <a:off x="242755" y="935567"/>
-            <a:ext cx="12052433" cy="5685366"/>
+            <a:ext cx="12052433" cy="5706533"/>
             <a:chOff x="242755" y="935567"/>
-            <a:chExt cx="12052433" cy="5685366"/>
+            <a:chExt cx="12052433" cy="5706533"/>
           </a:xfrm>
         </p:grpSpPr>
         <p:pic>
@@ -11733,14 +11733,84 @@
         </p:sp>
         <p:sp>
           <p:nvSpPr>
-            <p:cNvPr id="84" name="TextBox 83"/>
+            <p:cNvPr id="84" name="Oval 83"/>
+            <p:cNvSpPr/>
+            <p:nvPr/>
+          </p:nvSpPr>
+          <p:spPr>
+            <a:xfrm>
+              <a:off x="317500" y="6258983"/>
+              <a:ext cx="211667" cy="211667"/>
+            </a:xfrm>
+            <a:prstGeom prst="ellipse">
+              <a:avLst/>
+            </a:prstGeom>
+            <a:solidFill>
+              <a:srgbClr val="232F3E"/>
+            </a:solidFill>
+            <a:ln>
+              <a:noFill/>
+            </a:ln>
+          </p:spPr>
+          <p:txBody>
+            <a:bodyPr rtlCol="0" anchor="ctr"/>
+            <a:lstStyle/>
+            <a:p>
+              <a:pPr algn="ctr"/>
+            </a:p>
+          </p:txBody>
+        </p:sp>
+        <p:sp>
+          <p:nvSpPr>
+            <p:cNvPr id="85" name="TextBox 84"/>
             <p:cNvSpPr txBox="1"/>
             <p:nvPr/>
           </p:nvSpPr>
           <p:spPr>
             <a:xfrm>
-              <a:off x="317500" y="6286500"/>
-              <a:ext cx="9390063" cy="165100"/>
+              <a:off x="316177" y="6286500"/>
+              <a:ext cx="214312" cy="165100"/>
+            </a:xfrm>
+            <a:prstGeom prst="rect">
+              <a:avLst/>
+            </a:prstGeom>
+            <a:noFill/>
+          </p:spPr>
+          <p:txBody>
+            <a:bodyPr wrap="none" lIns="0" rIns="0" tIns="0" bIns="0" anchor="t">
+              <a:noAutofit/>
+            </a:bodyPr>
+            <a:lstStyle/>
+            <a:p>
+              <a:pPr algn="ctr">
+                <a:lnSpc>
+                  <a:spcPct val="100000"/>
+                </a:lnSpc>
+              </a:pPr>
+              <a:r>
+                <a:rPr sz="1000" b="1" lang="ko-KR">
+                  <a:solidFill>
+                    <a:srgbClr val="FFFFFF"/>
+                  </a:solidFill>
+                  <a:latin typeface="Arial"/>
+                  <a:ea typeface="Malgun Gothic"/>
+                  <a:cs typeface="Malgun Gothic"/>
+                </a:rPr>
+                <a:t>1</a:t>
+              </a:r>
+            </a:p>
+          </p:txBody>
+        </p:sp>
+        <p:sp>
+          <p:nvSpPr>
+            <p:cNvPr id="86" name="TextBox 85"/>
+            <p:cNvSpPr txBox="1"/>
+            <p:nvPr/>
+          </p:nvSpPr>
+          <p:spPr>
+            <a:xfrm>
+              <a:off x="613833" y="6286500"/>
+              <a:ext cx="2547938" cy="165100"/>
             </a:xfrm>
             <a:prstGeom prst="rect">
               <a:avLst/>
@@ -11767,20 +11837,353 @@
                   <a:ea typeface="Malgun Gothic"/>
                   <a:cs typeface="Malgun Gothic"/>
                 </a:rPr>
-                <a:t>① IGW → GWLBe (인그레스 라우팅)  ② GWLBe ⇄ GWLB  ③ GWLB ⇄ 방화벽 (검사 후 GWLB → GWLBe로 반환)  ④ GWLBe → EC2</a:t>
+                <a:t>IGW → GWLBe (인그레스 라우팅)</a:t>
               </a:r>
             </a:p>
           </p:txBody>
         </p:sp>
         <p:sp>
           <p:nvSpPr>
-            <p:cNvPr id="85" name="TextBox 84"/>
+            <p:cNvPr id="87" name="Oval 86"/>
+            <p:cNvSpPr/>
+            <p:nvPr/>
+          </p:nvSpPr>
+          <p:spPr>
+            <a:xfrm>
+              <a:off x="2671233" y="6258983"/>
+              <a:ext cx="211667" cy="211667"/>
+            </a:xfrm>
+            <a:prstGeom prst="ellipse">
+              <a:avLst/>
+            </a:prstGeom>
+            <a:solidFill>
+              <a:srgbClr val="232F3E"/>
+            </a:solidFill>
+            <a:ln>
+              <a:noFill/>
+            </a:ln>
+          </p:spPr>
+          <p:txBody>
+            <a:bodyPr rtlCol="0" anchor="ctr"/>
+            <a:lstStyle/>
+            <a:p>
+              <a:pPr algn="ctr"/>
+            </a:p>
+          </p:txBody>
+        </p:sp>
+        <p:sp>
+          <p:nvSpPr>
+            <p:cNvPr id="88" name="TextBox 87"/>
             <p:cNvSpPr txBox="1"/>
             <p:nvPr/>
           </p:nvSpPr>
           <p:spPr>
             <a:xfrm>
-              <a:off x="317500" y="6455833"/>
+              <a:off x="2669910" y="6286500"/>
+              <a:ext cx="214312" cy="165100"/>
+            </a:xfrm>
+            <a:prstGeom prst="rect">
+              <a:avLst/>
+            </a:prstGeom>
+            <a:noFill/>
+          </p:spPr>
+          <p:txBody>
+            <a:bodyPr wrap="none" lIns="0" rIns="0" tIns="0" bIns="0" anchor="t">
+              <a:noAutofit/>
+            </a:bodyPr>
+            <a:lstStyle/>
+            <a:p>
+              <a:pPr algn="ctr">
+                <a:lnSpc>
+                  <a:spcPct val="100000"/>
+                </a:lnSpc>
+              </a:pPr>
+              <a:r>
+                <a:rPr sz="1000" b="1" lang="ko-KR">
+                  <a:solidFill>
+                    <a:srgbClr val="FFFFFF"/>
+                  </a:solidFill>
+                  <a:latin typeface="Arial"/>
+                  <a:ea typeface="Malgun Gothic"/>
+                  <a:cs typeface="Malgun Gothic"/>
+                </a:rPr>
+                <a:t>2</a:t>
+              </a:r>
+            </a:p>
+          </p:txBody>
+        </p:sp>
+        <p:sp>
+          <p:nvSpPr>
+            <p:cNvPr id="89" name="TextBox 88"/>
+            <p:cNvSpPr txBox="1"/>
+            <p:nvPr/>
+          </p:nvSpPr>
+          <p:spPr>
+            <a:xfrm>
+              <a:off x="2967567" y="6286500"/>
+              <a:ext cx="1174750" cy="165100"/>
+            </a:xfrm>
+            <a:prstGeom prst="rect">
+              <a:avLst/>
+            </a:prstGeom>
+            <a:noFill/>
+          </p:spPr>
+          <p:txBody>
+            <a:bodyPr wrap="none" lIns="0" rIns="0" tIns="0" bIns="0" anchor="t">
+              <a:noAutofit/>
+            </a:bodyPr>
+            <a:lstStyle/>
+            <a:p>
+              <a:pPr algn="l">
+                <a:lnSpc>
+                  <a:spcPct val="100000"/>
+                </a:lnSpc>
+              </a:pPr>
+              <a:r>
+                <a:rPr sz="1000" b="0" lang="ko-KR">
+                  <a:solidFill>
+                    <a:srgbClr val="545B64"/>
+                  </a:solidFill>
+                  <a:latin typeface="Arial"/>
+                  <a:ea typeface="Malgun Gothic"/>
+                  <a:cs typeface="Malgun Gothic"/>
+                </a:rPr>
+                <a:t>GWLBe ⇄ GWLB</a:t>
+              </a:r>
+            </a:p>
+          </p:txBody>
+        </p:sp>
+        <p:sp>
+          <p:nvSpPr>
+            <p:cNvPr id="90" name="Oval 89"/>
+            <p:cNvSpPr/>
+            <p:nvPr/>
+          </p:nvSpPr>
+          <p:spPr>
+            <a:xfrm>
+              <a:off x="4163483" y="6258983"/>
+              <a:ext cx="211667" cy="211667"/>
+            </a:xfrm>
+            <a:prstGeom prst="ellipse">
+              <a:avLst/>
+            </a:prstGeom>
+            <a:solidFill>
+              <a:srgbClr val="232F3E"/>
+            </a:solidFill>
+            <a:ln>
+              <a:noFill/>
+            </a:ln>
+          </p:spPr>
+          <p:txBody>
+            <a:bodyPr rtlCol="0" anchor="ctr"/>
+            <a:lstStyle/>
+            <a:p>
+              <a:pPr algn="ctr"/>
+            </a:p>
+          </p:txBody>
+        </p:sp>
+        <p:sp>
+          <p:nvSpPr>
+            <p:cNvPr id="91" name="TextBox 90"/>
+            <p:cNvSpPr txBox="1"/>
+            <p:nvPr/>
+          </p:nvSpPr>
+          <p:spPr>
+            <a:xfrm>
+              <a:off x="4162160" y="6286500"/>
+              <a:ext cx="214312" cy="165100"/>
+            </a:xfrm>
+            <a:prstGeom prst="rect">
+              <a:avLst/>
+            </a:prstGeom>
+            <a:noFill/>
+          </p:spPr>
+          <p:txBody>
+            <a:bodyPr wrap="none" lIns="0" rIns="0" tIns="0" bIns="0" anchor="t">
+              <a:noAutofit/>
+            </a:bodyPr>
+            <a:lstStyle/>
+            <a:p>
+              <a:pPr algn="ctr">
+                <a:lnSpc>
+                  <a:spcPct val="100000"/>
+                </a:lnSpc>
+              </a:pPr>
+              <a:r>
+                <a:rPr sz="1000" b="1" lang="ko-KR">
+                  <a:solidFill>
+                    <a:srgbClr val="FFFFFF"/>
+                  </a:solidFill>
+                  <a:latin typeface="Arial"/>
+                  <a:ea typeface="Malgun Gothic"/>
+                  <a:cs typeface="Malgun Gothic"/>
+                </a:rPr>
+                <a:t>3</a:t>
+              </a:r>
+            </a:p>
+          </p:txBody>
+        </p:sp>
+        <p:sp>
+          <p:nvSpPr>
+            <p:cNvPr id="92" name="TextBox 91"/>
+            <p:cNvSpPr txBox="1"/>
+            <p:nvPr/>
+          </p:nvSpPr>
+          <p:spPr>
+            <a:xfrm>
+              <a:off x="4459817" y="6286500"/>
+              <a:ext cx="3738562" cy="165100"/>
+            </a:xfrm>
+            <a:prstGeom prst="rect">
+              <a:avLst/>
+            </a:prstGeom>
+            <a:noFill/>
+          </p:spPr>
+          <p:txBody>
+            <a:bodyPr wrap="none" lIns="0" rIns="0" tIns="0" bIns="0" anchor="t">
+              <a:noAutofit/>
+            </a:bodyPr>
+            <a:lstStyle/>
+            <a:p>
+              <a:pPr algn="l">
+                <a:lnSpc>
+                  <a:spcPct val="100000"/>
+                </a:lnSpc>
+              </a:pPr>
+              <a:r>
+                <a:rPr sz="1000" b="0" lang="ko-KR">
+                  <a:solidFill>
+                    <a:srgbClr val="545B64"/>
+                  </a:solidFill>
+                  <a:latin typeface="Arial"/>
+                  <a:ea typeface="Malgun Gothic"/>
+                  <a:cs typeface="Malgun Gothic"/>
+                </a:rPr>
+                <a:t>GWLB ⇄ 방화벽 (검사 후 GWLB → GWLBe로 반환)</a:t>
+              </a:r>
+            </a:p>
+          </p:txBody>
+        </p:sp>
+        <p:sp>
+          <p:nvSpPr>
+            <p:cNvPr id="93" name="Oval 92"/>
+            <p:cNvSpPr/>
+            <p:nvPr/>
+          </p:nvSpPr>
+          <p:spPr>
+            <a:xfrm>
+              <a:off x="7526867" y="6258983"/>
+              <a:ext cx="211667" cy="211667"/>
+            </a:xfrm>
+            <a:prstGeom prst="ellipse">
+              <a:avLst/>
+            </a:prstGeom>
+            <a:solidFill>
+              <a:srgbClr val="232F3E"/>
+            </a:solidFill>
+            <a:ln>
+              <a:noFill/>
+            </a:ln>
+          </p:spPr>
+          <p:txBody>
+            <a:bodyPr rtlCol="0" anchor="ctr"/>
+            <a:lstStyle/>
+            <a:p>
+              <a:pPr algn="ctr"/>
+            </a:p>
+          </p:txBody>
+        </p:sp>
+        <p:sp>
+          <p:nvSpPr>
+            <p:cNvPr id="94" name="TextBox 93"/>
+            <p:cNvSpPr txBox="1"/>
+            <p:nvPr/>
+          </p:nvSpPr>
+          <p:spPr>
+            <a:xfrm>
+              <a:off x="7525544" y="6286500"/>
+              <a:ext cx="214312" cy="165100"/>
+            </a:xfrm>
+            <a:prstGeom prst="rect">
+              <a:avLst/>
+            </a:prstGeom>
+            <a:noFill/>
+          </p:spPr>
+          <p:txBody>
+            <a:bodyPr wrap="none" lIns="0" rIns="0" tIns="0" bIns="0" anchor="t">
+              <a:noAutofit/>
+            </a:bodyPr>
+            <a:lstStyle/>
+            <a:p>
+              <a:pPr algn="ctr">
+                <a:lnSpc>
+                  <a:spcPct val="100000"/>
+                </a:lnSpc>
+              </a:pPr>
+              <a:r>
+                <a:rPr sz="1000" b="1" lang="ko-KR">
+                  <a:solidFill>
+                    <a:srgbClr val="FFFFFF"/>
+                  </a:solidFill>
+                  <a:latin typeface="Arial"/>
+                  <a:ea typeface="Malgun Gothic"/>
+                  <a:cs typeface="Malgun Gothic"/>
+                </a:rPr>
+                <a:t>4</a:t>
+              </a:r>
+            </a:p>
+          </p:txBody>
+        </p:sp>
+        <p:sp>
+          <p:nvSpPr>
+            <p:cNvPr id="95" name="TextBox 94"/>
+            <p:cNvSpPr txBox="1"/>
+            <p:nvPr/>
+          </p:nvSpPr>
+          <p:spPr>
+            <a:xfrm>
+              <a:off x="7823200" y="6286500"/>
+              <a:ext cx="1087438" cy="165100"/>
+            </a:xfrm>
+            <a:prstGeom prst="rect">
+              <a:avLst/>
+            </a:prstGeom>
+            <a:noFill/>
+          </p:spPr>
+          <p:txBody>
+            <a:bodyPr wrap="none" lIns="0" rIns="0" tIns="0" bIns="0" anchor="t">
+              <a:noAutofit/>
+            </a:bodyPr>
+            <a:lstStyle/>
+            <a:p>
+              <a:pPr algn="l">
+                <a:lnSpc>
+                  <a:spcPct val="100000"/>
+                </a:lnSpc>
+              </a:pPr>
+              <a:r>
+                <a:rPr sz="1000" b="0" lang="ko-KR">
+                  <a:solidFill>
+                    <a:srgbClr val="545B64"/>
+                  </a:solidFill>
+                  <a:latin typeface="Arial"/>
+                  <a:ea typeface="Malgun Gothic"/>
+                  <a:cs typeface="Malgun Gothic"/>
+                </a:rPr>
+                <a:t>GWLBe → EC2</a:t>
+              </a:r>
+            </a:p>
+          </p:txBody>
+        </p:sp>
+        <p:sp>
+          <p:nvSpPr>
+            <p:cNvPr id="96" name="TextBox 95"/>
+            <p:cNvSpPr txBox="1"/>
+            <p:nvPr/>
+          </p:nvSpPr>
+          <p:spPr>
+            <a:xfrm>
+              <a:off x="317500" y="6477000"/>
               <a:ext cx="11977688" cy="165100"/>
             </a:xfrm>
             <a:prstGeom prst="rect">
@@ -14025,10 +14428,10 @@
         </p:nvGrpSpPr>
         <p:grpSpPr>
           <a:xfrm>
-            <a:off x="381000" y="999067"/>
-            <a:ext cx="14081125" cy="5643033"/>
-            <a:chOff x="381000" y="999067"/>
-            <a:chExt cx="14081125" cy="5643033"/>
+            <a:off x="379677" y="999067"/>
+            <a:ext cx="14082448" cy="5643033"/>
+            <a:chOff x="379677" y="999067"/>
+            <a:chExt cx="14082448" cy="5643033"/>
           </a:xfrm>
         </p:grpSpPr>
         <p:sp>
@@ -17398,14 +17801,84 @@
         </p:sp>
         <p:sp>
           <p:nvSpPr>
-            <p:cNvPr id="99" name="TextBox 98"/>
+            <p:cNvPr id="99" name="Oval 98"/>
+            <p:cNvSpPr/>
+            <p:nvPr/>
+          </p:nvSpPr>
+          <p:spPr>
+            <a:xfrm>
+              <a:off x="381000" y="6280150"/>
+              <a:ext cx="211667" cy="211667"/>
+            </a:xfrm>
+            <a:prstGeom prst="ellipse">
+              <a:avLst/>
+            </a:prstGeom>
+            <a:solidFill>
+              <a:srgbClr val="232F3E"/>
+            </a:solidFill>
+            <a:ln>
+              <a:noFill/>
+            </a:ln>
+          </p:spPr>
+          <p:txBody>
+            <a:bodyPr rtlCol="0" anchor="ctr"/>
+            <a:lstStyle/>
+            <a:p>
+              <a:pPr algn="ctr"/>
+            </a:p>
+          </p:txBody>
+        </p:sp>
+        <p:sp>
+          <p:nvSpPr>
+            <p:cNvPr id="100" name="TextBox 99"/>
             <p:cNvSpPr txBox="1"/>
             <p:nvPr/>
           </p:nvSpPr>
           <p:spPr>
             <a:xfrm>
-              <a:off x="381000" y="6307667"/>
-              <a:ext cx="12858750" cy="165100"/>
+              <a:off x="379677" y="6307667"/>
+              <a:ext cx="214312" cy="165100"/>
+            </a:xfrm>
+            <a:prstGeom prst="rect">
+              <a:avLst/>
+            </a:prstGeom>
+            <a:noFill/>
+          </p:spPr>
+          <p:txBody>
+            <a:bodyPr wrap="none" lIns="0" rIns="0" tIns="0" bIns="0" anchor="t">
+              <a:noAutofit/>
+            </a:bodyPr>
+            <a:lstStyle/>
+            <a:p>
+              <a:pPr algn="ctr">
+                <a:lnSpc>
+                  <a:spcPct val="100000"/>
+                </a:lnSpc>
+              </a:pPr>
+              <a:r>
+                <a:rPr sz="1000" b="1" lang="ko-KR">
+                  <a:solidFill>
+                    <a:srgbClr val="FFFFFF"/>
+                  </a:solidFill>
+                  <a:latin typeface="Arial"/>
+                  <a:ea typeface="Malgun Gothic"/>
+                  <a:cs typeface="Malgun Gothic"/>
+                </a:rPr>
+                <a:t>1</a:t>
+              </a:r>
+            </a:p>
+          </p:txBody>
+        </p:sp>
+        <p:sp>
+          <p:nvSpPr>
+            <p:cNvPr id="101" name="TextBox 100"/>
+            <p:cNvSpPr txBox="1"/>
+            <p:nvPr/>
+          </p:nvSpPr>
+          <p:spPr>
+            <a:xfrm>
+              <a:off x="677333" y="6307667"/>
+              <a:ext cx="912812" cy="165100"/>
             </a:xfrm>
             <a:prstGeom prst="rect">
               <a:avLst/>
@@ -17432,14 +17905,458 @@
                   <a:ea typeface="Malgun Gothic"/>
                   <a:cs typeface="Malgun Gothic"/>
                 </a:rPr>
-                <a:t>① VPC → TGW  ② Spoke RT 0.0.0.0/0 → 검사 VPC (appliance mode)  ③ 같은 AZ 방화벽에서 검사 (VPC 간은 TGW로 반환)  ④ 방화벽 → NAT (인터넷행)  ⑤ NAT → IGW</a:t>
+                <a:t>VPC → TGW</a:t>
               </a:r>
             </a:p>
           </p:txBody>
         </p:sp>
         <p:sp>
           <p:nvSpPr>
-            <p:cNvPr id="100" name="TextBox 99"/>
+            <p:cNvPr id="102" name="Oval 101"/>
+            <p:cNvSpPr/>
+            <p:nvPr/>
+          </p:nvSpPr>
+          <p:spPr>
+            <a:xfrm>
+              <a:off x="1598083" y="6280150"/>
+              <a:ext cx="211667" cy="211667"/>
+            </a:xfrm>
+            <a:prstGeom prst="ellipse">
+              <a:avLst/>
+            </a:prstGeom>
+            <a:solidFill>
+              <a:srgbClr val="232F3E"/>
+            </a:solidFill>
+            <a:ln>
+              <a:noFill/>
+            </a:ln>
+          </p:spPr>
+          <p:txBody>
+            <a:bodyPr rtlCol="0" anchor="ctr"/>
+            <a:lstStyle/>
+            <a:p>
+              <a:pPr algn="ctr"/>
+            </a:p>
+          </p:txBody>
+        </p:sp>
+        <p:sp>
+          <p:nvSpPr>
+            <p:cNvPr id="103" name="TextBox 102"/>
+            <p:cNvSpPr txBox="1"/>
+            <p:nvPr/>
+          </p:nvSpPr>
+          <p:spPr>
+            <a:xfrm>
+              <a:off x="1596760" y="6307667"/>
+              <a:ext cx="214312" cy="165100"/>
+            </a:xfrm>
+            <a:prstGeom prst="rect">
+              <a:avLst/>
+            </a:prstGeom>
+            <a:noFill/>
+          </p:spPr>
+          <p:txBody>
+            <a:bodyPr wrap="none" lIns="0" rIns="0" tIns="0" bIns="0" anchor="t">
+              <a:noAutofit/>
+            </a:bodyPr>
+            <a:lstStyle/>
+            <a:p>
+              <a:pPr algn="ctr">
+                <a:lnSpc>
+                  <a:spcPct val="100000"/>
+                </a:lnSpc>
+              </a:pPr>
+              <a:r>
+                <a:rPr sz="1000" b="1" lang="ko-KR">
+                  <a:solidFill>
+                    <a:srgbClr val="FFFFFF"/>
+                  </a:solidFill>
+                  <a:latin typeface="Arial"/>
+                  <a:ea typeface="Malgun Gothic"/>
+                  <a:cs typeface="Malgun Gothic"/>
+                </a:rPr>
+                <a:t>2</a:t>
+              </a:r>
+            </a:p>
+          </p:txBody>
+        </p:sp>
+        <p:sp>
+          <p:nvSpPr>
+            <p:cNvPr id="104" name="TextBox 103"/>
+            <p:cNvSpPr txBox="1"/>
+            <p:nvPr/>
+          </p:nvSpPr>
+          <p:spPr>
+            <a:xfrm>
+              <a:off x="1894417" y="6307667"/>
+              <a:ext cx="4111625" cy="165100"/>
+            </a:xfrm>
+            <a:prstGeom prst="rect">
+              <a:avLst/>
+            </a:prstGeom>
+            <a:noFill/>
+          </p:spPr>
+          <p:txBody>
+            <a:bodyPr wrap="none" lIns="0" rIns="0" tIns="0" bIns="0" anchor="t">
+              <a:noAutofit/>
+            </a:bodyPr>
+            <a:lstStyle/>
+            <a:p>
+              <a:pPr algn="l">
+                <a:lnSpc>
+                  <a:spcPct val="100000"/>
+                </a:lnSpc>
+              </a:pPr>
+              <a:r>
+                <a:rPr sz="1000" b="0" lang="ko-KR">
+                  <a:solidFill>
+                    <a:srgbClr val="545B64"/>
+                  </a:solidFill>
+                  <a:latin typeface="Arial"/>
+                  <a:ea typeface="Malgun Gothic"/>
+                  <a:cs typeface="Malgun Gothic"/>
+                </a:rPr>
+                <a:t>Spoke RT 0.0.0.0/0 → 검사 VPC (appliance mode)</a:t>
+              </a:r>
+            </a:p>
+          </p:txBody>
+        </p:sp>
+        <p:sp>
+          <p:nvSpPr>
+            <p:cNvPr id="105" name="Oval 104"/>
+            <p:cNvSpPr/>
+            <p:nvPr/>
+          </p:nvSpPr>
+          <p:spPr>
+            <a:xfrm>
+              <a:off x="5202767" y="6280150"/>
+              <a:ext cx="211667" cy="211667"/>
+            </a:xfrm>
+            <a:prstGeom prst="ellipse">
+              <a:avLst/>
+            </a:prstGeom>
+            <a:solidFill>
+              <a:srgbClr val="232F3E"/>
+            </a:solidFill>
+            <a:ln>
+              <a:noFill/>
+            </a:ln>
+          </p:spPr>
+          <p:txBody>
+            <a:bodyPr rtlCol="0" anchor="ctr"/>
+            <a:lstStyle/>
+            <a:p>
+              <a:pPr algn="ctr"/>
+            </a:p>
+          </p:txBody>
+        </p:sp>
+        <p:sp>
+          <p:nvSpPr>
+            <p:cNvPr id="106" name="TextBox 105"/>
+            <p:cNvSpPr txBox="1"/>
+            <p:nvPr/>
+          </p:nvSpPr>
+          <p:spPr>
+            <a:xfrm>
+              <a:off x="5201444" y="6307667"/>
+              <a:ext cx="214312" cy="165100"/>
+            </a:xfrm>
+            <a:prstGeom prst="rect">
+              <a:avLst/>
+            </a:prstGeom>
+            <a:noFill/>
+          </p:spPr>
+          <p:txBody>
+            <a:bodyPr wrap="none" lIns="0" rIns="0" tIns="0" bIns="0" anchor="t">
+              <a:noAutofit/>
+            </a:bodyPr>
+            <a:lstStyle/>
+            <a:p>
+              <a:pPr algn="ctr">
+                <a:lnSpc>
+                  <a:spcPct val="100000"/>
+                </a:lnSpc>
+              </a:pPr>
+              <a:r>
+                <a:rPr sz="1000" b="1" lang="ko-KR">
+                  <a:solidFill>
+                    <a:srgbClr val="FFFFFF"/>
+                  </a:solidFill>
+                  <a:latin typeface="Arial"/>
+                  <a:ea typeface="Malgun Gothic"/>
+                  <a:cs typeface="Malgun Gothic"/>
+                </a:rPr>
+                <a:t>3</a:t>
+              </a:r>
+            </a:p>
+          </p:txBody>
+        </p:sp>
+        <p:sp>
+          <p:nvSpPr>
+            <p:cNvPr id="107" name="TextBox 106"/>
+            <p:cNvSpPr txBox="1"/>
+            <p:nvPr/>
+          </p:nvSpPr>
+          <p:spPr>
+            <a:xfrm>
+              <a:off x="5499100" y="6307667"/>
+              <a:ext cx="3833812" cy="165100"/>
+            </a:xfrm>
+            <a:prstGeom prst="rect">
+              <a:avLst/>
+            </a:prstGeom>
+            <a:noFill/>
+          </p:spPr>
+          <p:txBody>
+            <a:bodyPr wrap="none" lIns="0" rIns="0" tIns="0" bIns="0" anchor="t">
+              <a:noAutofit/>
+            </a:bodyPr>
+            <a:lstStyle/>
+            <a:p>
+              <a:pPr algn="l">
+                <a:lnSpc>
+                  <a:spcPct val="100000"/>
+                </a:lnSpc>
+              </a:pPr>
+              <a:r>
+                <a:rPr sz="1000" b="0" lang="ko-KR">
+                  <a:solidFill>
+                    <a:srgbClr val="545B64"/>
+                  </a:solidFill>
+                  <a:latin typeface="Arial"/>
+                  <a:ea typeface="Malgun Gothic"/>
+                  <a:cs typeface="Malgun Gothic"/>
+                </a:rPr>
+                <a:t>같은 AZ 방화벽에서 검사 (VPC 간은 TGW로 반환)</a:t>
+              </a:r>
+            </a:p>
+          </p:txBody>
+        </p:sp>
+        <p:sp>
+          <p:nvSpPr>
+            <p:cNvPr id="108" name="Oval 107"/>
+            <p:cNvSpPr/>
+            <p:nvPr/>
+          </p:nvSpPr>
+          <p:spPr>
+            <a:xfrm>
+              <a:off x="8528050" y="6280150"/>
+              <a:ext cx="211667" cy="211667"/>
+            </a:xfrm>
+            <a:prstGeom prst="ellipse">
+              <a:avLst/>
+            </a:prstGeom>
+            <a:solidFill>
+              <a:srgbClr val="232F3E"/>
+            </a:solidFill>
+            <a:ln>
+              <a:noFill/>
+            </a:ln>
+          </p:spPr>
+          <p:txBody>
+            <a:bodyPr rtlCol="0" anchor="ctr"/>
+            <a:lstStyle/>
+            <a:p>
+              <a:pPr algn="ctr"/>
+            </a:p>
+          </p:txBody>
+        </p:sp>
+        <p:sp>
+          <p:nvSpPr>
+            <p:cNvPr id="109" name="TextBox 108"/>
+            <p:cNvSpPr txBox="1"/>
+            <p:nvPr/>
+          </p:nvSpPr>
+          <p:spPr>
+            <a:xfrm>
+              <a:off x="8526727" y="6307667"/>
+              <a:ext cx="214312" cy="165100"/>
+            </a:xfrm>
+            <a:prstGeom prst="rect">
+              <a:avLst/>
+            </a:prstGeom>
+            <a:noFill/>
+          </p:spPr>
+          <p:txBody>
+            <a:bodyPr wrap="none" lIns="0" rIns="0" tIns="0" bIns="0" anchor="t">
+              <a:noAutofit/>
+            </a:bodyPr>
+            <a:lstStyle/>
+            <a:p>
+              <a:pPr algn="ctr">
+                <a:lnSpc>
+                  <a:spcPct val="100000"/>
+                </a:lnSpc>
+              </a:pPr>
+              <a:r>
+                <a:rPr sz="1000" b="1" lang="ko-KR">
+                  <a:solidFill>
+                    <a:srgbClr val="FFFFFF"/>
+                  </a:solidFill>
+                  <a:latin typeface="Arial"/>
+                  <a:ea typeface="Malgun Gothic"/>
+                  <a:cs typeface="Malgun Gothic"/>
+                </a:rPr>
+                <a:t>4</a:t>
+              </a:r>
+            </a:p>
+          </p:txBody>
+        </p:sp>
+        <p:sp>
+          <p:nvSpPr>
+            <p:cNvPr id="110" name="TextBox 109"/>
+            <p:cNvSpPr txBox="1"/>
+            <p:nvPr/>
+          </p:nvSpPr>
+          <p:spPr>
+            <a:xfrm>
+              <a:off x="8824383" y="6307667"/>
+              <a:ext cx="2024062" cy="165100"/>
+            </a:xfrm>
+            <a:prstGeom prst="rect">
+              <a:avLst/>
+            </a:prstGeom>
+            <a:noFill/>
+          </p:spPr>
+          <p:txBody>
+            <a:bodyPr wrap="none" lIns="0" rIns="0" tIns="0" bIns="0" anchor="t">
+              <a:noAutofit/>
+            </a:bodyPr>
+            <a:lstStyle/>
+            <a:p>
+              <a:pPr algn="l">
+                <a:lnSpc>
+                  <a:spcPct val="100000"/>
+                </a:lnSpc>
+              </a:pPr>
+              <a:r>
+                <a:rPr sz="1000" b="0" lang="ko-KR">
+                  <a:solidFill>
+                    <a:srgbClr val="545B64"/>
+                  </a:solidFill>
+                  <a:latin typeface="Arial"/>
+                  <a:ea typeface="Malgun Gothic"/>
+                  <a:cs typeface="Malgun Gothic"/>
+                </a:rPr>
+                <a:t>방화벽 → NAT (인터넷행)</a:t>
+              </a:r>
+            </a:p>
+          </p:txBody>
+        </p:sp>
+        <p:sp>
+          <p:nvSpPr>
+            <p:cNvPr id="111" name="Oval 110"/>
+            <p:cNvSpPr/>
+            <p:nvPr/>
+          </p:nvSpPr>
+          <p:spPr>
+            <a:xfrm>
+              <a:off x="10462683" y="6280150"/>
+              <a:ext cx="211667" cy="211667"/>
+            </a:xfrm>
+            <a:prstGeom prst="ellipse">
+              <a:avLst/>
+            </a:prstGeom>
+            <a:solidFill>
+              <a:srgbClr val="232F3E"/>
+            </a:solidFill>
+            <a:ln>
+              <a:noFill/>
+            </a:ln>
+          </p:spPr>
+          <p:txBody>
+            <a:bodyPr rtlCol="0" anchor="ctr"/>
+            <a:lstStyle/>
+            <a:p>
+              <a:pPr algn="ctr"/>
+            </a:p>
+          </p:txBody>
+        </p:sp>
+        <p:sp>
+          <p:nvSpPr>
+            <p:cNvPr id="112" name="TextBox 111"/>
+            <p:cNvSpPr txBox="1"/>
+            <p:nvPr/>
+          </p:nvSpPr>
+          <p:spPr>
+            <a:xfrm>
+              <a:off x="10461360" y="6307667"/>
+              <a:ext cx="214312" cy="165100"/>
+            </a:xfrm>
+            <a:prstGeom prst="rect">
+              <a:avLst/>
+            </a:prstGeom>
+            <a:noFill/>
+          </p:spPr>
+          <p:txBody>
+            <a:bodyPr wrap="none" lIns="0" rIns="0" tIns="0" bIns="0" anchor="t">
+              <a:noAutofit/>
+            </a:bodyPr>
+            <a:lstStyle/>
+            <a:p>
+              <a:pPr algn="ctr">
+                <a:lnSpc>
+                  <a:spcPct val="100000"/>
+                </a:lnSpc>
+              </a:pPr>
+              <a:r>
+                <a:rPr sz="1000" b="1" lang="ko-KR">
+                  <a:solidFill>
+                    <a:srgbClr val="FFFFFF"/>
+                  </a:solidFill>
+                  <a:latin typeface="Arial"/>
+                  <a:ea typeface="Malgun Gothic"/>
+                  <a:cs typeface="Malgun Gothic"/>
+                </a:rPr>
+                <a:t>5</a:t>
+              </a:r>
+            </a:p>
+          </p:txBody>
+        </p:sp>
+        <p:sp>
+          <p:nvSpPr>
+            <p:cNvPr id="113" name="TextBox 112"/>
+            <p:cNvSpPr txBox="1"/>
+            <p:nvPr/>
+          </p:nvSpPr>
+          <p:spPr>
+            <a:xfrm>
+              <a:off x="10759017" y="6307667"/>
+              <a:ext cx="912812" cy="165100"/>
+            </a:xfrm>
+            <a:prstGeom prst="rect">
+              <a:avLst/>
+            </a:prstGeom>
+            <a:noFill/>
+          </p:spPr>
+          <p:txBody>
+            <a:bodyPr wrap="none" lIns="0" rIns="0" tIns="0" bIns="0" anchor="t">
+              <a:noAutofit/>
+            </a:bodyPr>
+            <a:lstStyle/>
+            <a:p>
+              <a:pPr algn="l">
+                <a:lnSpc>
+                  <a:spcPct val="100000"/>
+                </a:lnSpc>
+              </a:pPr>
+              <a:r>
+                <a:rPr sz="1000" b="0" lang="ko-KR">
+                  <a:solidFill>
+                    <a:srgbClr val="545B64"/>
+                  </a:solidFill>
+                  <a:latin typeface="Arial"/>
+                  <a:ea typeface="Malgun Gothic"/>
+                  <a:cs typeface="Malgun Gothic"/>
+                </a:rPr>
+                <a:t>NAT → IGW</a:t>
+              </a:r>
+            </a:p>
+          </p:txBody>
+        </p:sp>
+        <p:sp>
+          <p:nvSpPr>
+            <p:cNvPr id="114" name="TextBox 113"/>
             <p:cNvSpPr txBox="1"/>
             <p:nvPr/>
           </p:nvSpPr>

</xml_diff>

<commit_message>
Left-align every note with the AWS Cloud box's left edge so the legend starts at the same x in every diagram, wrapping a route line that would overflow
Co-Authored-By: Claude Opus 5.5 <noreply@anthropic.com>
</commit_message>
<xml_diff>
--- a/docs/examples/reference-architectures.pptx
+++ b/docs/examples/reference-architectures.pptx
@@ -3137,9 +3137,9 @@
         <p:grpSpPr>
           <a:xfrm>
             <a:off x="750755" y="956733"/>
-            <a:ext cx="10658078" cy="5674784"/>
+            <a:ext cx="11531203" cy="5674784"/>
             <a:chOff x="750755" y="956733"/>
-            <a:chExt cx="10658078" cy="5674784"/>
+            <a:chExt cx="11531203" cy="5674784"/>
           </a:xfrm>
         </p:grpSpPr>
         <p:pic>
@@ -5614,7 +5614,7 @@
           </p:nvSpPr>
           <p:spPr>
             <a:xfrm>
-              <a:off x="825500" y="6466417"/>
+              <a:off x="2137833" y="6466417"/>
               <a:ext cx="10144125" cy="165100"/>
             </a:xfrm>
             <a:prstGeom prst="rect">
@@ -8806,7 +8806,7 @@
           </p:nvSpPr>
           <p:spPr>
             <a:xfrm>
-              <a:off x="402167" y="6413500"/>
+              <a:off x="1778000" y="6413500"/>
               <a:ext cx="7556500" cy="165100"/>
             </a:xfrm>
             <a:prstGeom prst="rect">
@@ -8903,9 +8903,9 @@
         <p:grpSpPr>
           <a:xfrm>
             <a:off x="242755" y="935567"/>
-            <a:ext cx="12052433" cy="5706533"/>
+            <a:ext cx="13449433" cy="5706533"/>
             <a:chOff x="242755" y="935567"/>
-            <a:chExt cx="12052433" cy="5706533"/>
+            <a:chExt cx="13449433" cy="5706533"/>
           </a:xfrm>
         </p:grpSpPr>
         <p:pic>
@@ -11739,7 +11739,7 @@
           </p:nvSpPr>
           <p:spPr>
             <a:xfrm>
-              <a:off x="317500" y="6258983"/>
+              <a:off x="1714500" y="6258983"/>
               <a:ext cx="211667" cy="211667"/>
             </a:xfrm>
             <a:prstGeom prst="ellipse">
@@ -11768,7 +11768,7 @@
           </p:nvSpPr>
           <p:spPr>
             <a:xfrm>
-              <a:off x="316177" y="6286500"/>
+              <a:off x="1713177" y="6286500"/>
               <a:ext cx="214312" cy="165100"/>
             </a:xfrm>
             <a:prstGeom prst="rect">
@@ -11809,7 +11809,7 @@
           </p:nvSpPr>
           <p:spPr>
             <a:xfrm>
-              <a:off x="613833" y="6286500"/>
+              <a:off x="2010833" y="6286500"/>
               <a:ext cx="2547938" cy="165100"/>
             </a:xfrm>
             <a:prstGeom prst="rect">
@@ -11850,7 +11850,7 @@
           </p:nvSpPr>
           <p:spPr>
             <a:xfrm>
-              <a:off x="2671233" y="6258983"/>
+              <a:off x="4068233" y="6258983"/>
               <a:ext cx="211667" cy="211667"/>
             </a:xfrm>
             <a:prstGeom prst="ellipse">
@@ -11879,7 +11879,7 @@
           </p:nvSpPr>
           <p:spPr>
             <a:xfrm>
-              <a:off x="2669910" y="6286500"/>
+              <a:off x="4066910" y="6286500"/>
               <a:ext cx="214312" cy="165100"/>
             </a:xfrm>
             <a:prstGeom prst="rect">
@@ -11920,7 +11920,7 @@
           </p:nvSpPr>
           <p:spPr>
             <a:xfrm>
-              <a:off x="2967567" y="6286500"/>
+              <a:off x="4364567" y="6286500"/>
               <a:ext cx="1174750" cy="165100"/>
             </a:xfrm>
             <a:prstGeom prst="rect">
@@ -11961,7 +11961,7 @@
           </p:nvSpPr>
           <p:spPr>
             <a:xfrm>
-              <a:off x="4163483" y="6258983"/>
+              <a:off x="5560483" y="6258983"/>
               <a:ext cx="211667" cy="211667"/>
             </a:xfrm>
             <a:prstGeom prst="ellipse">
@@ -11990,7 +11990,7 @@
           </p:nvSpPr>
           <p:spPr>
             <a:xfrm>
-              <a:off x="4162160" y="6286500"/>
+              <a:off x="5559160" y="6286500"/>
               <a:ext cx="214312" cy="165100"/>
             </a:xfrm>
             <a:prstGeom prst="rect">
@@ -12031,7 +12031,7 @@
           </p:nvSpPr>
           <p:spPr>
             <a:xfrm>
-              <a:off x="4459817" y="6286500"/>
+              <a:off x="5856817" y="6286500"/>
               <a:ext cx="3738562" cy="165100"/>
             </a:xfrm>
             <a:prstGeom prst="rect">
@@ -12072,7 +12072,7 @@
           </p:nvSpPr>
           <p:spPr>
             <a:xfrm>
-              <a:off x="7526867" y="6258983"/>
+              <a:off x="8923867" y="6258983"/>
               <a:ext cx="211667" cy="211667"/>
             </a:xfrm>
             <a:prstGeom prst="ellipse">
@@ -12101,7 +12101,7 @@
           </p:nvSpPr>
           <p:spPr>
             <a:xfrm>
-              <a:off x="7525544" y="6286500"/>
+              <a:off x="8922544" y="6286500"/>
               <a:ext cx="214312" cy="165100"/>
             </a:xfrm>
             <a:prstGeom prst="rect">
@@ -12142,7 +12142,7 @@
           </p:nvSpPr>
           <p:spPr>
             <a:xfrm>
-              <a:off x="7823200" y="6286500"/>
+              <a:off x="9220200" y="6286500"/>
               <a:ext cx="1087438" cy="165100"/>
             </a:xfrm>
             <a:prstGeom prst="rect">
@@ -12183,7 +12183,7 @@
           </p:nvSpPr>
           <p:spPr>
             <a:xfrm>
-              <a:off x="317500" y="6477000"/>
+              <a:off x="1714500" y="6477000"/>
               <a:ext cx="11977688" cy="165100"/>
             </a:xfrm>
             <a:prstGeom prst="rect">
@@ -12279,10 +12279,10 @@
         </p:nvGrpSpPr>
         <p:grpSpPr>
           <a:xfrm>
-            <a:off x="398056" y="1134747"/>
-            <a:ext cx="12375554" cy="5361151"/>
-            <a:chOff x="398056" y="1134747"/>
-            <a:chExt cx="12375554" cy="5361151"/>
+            <a:off x="402167" y="1083733"/>
+            <a:ext cx="13337646" cy="5526617"/>
+            <a:chOff x="402167" y="1083733"/>
+            <a:chExt cx="13337646" cy="5526617"/>
           </a:xfrm>
         </p:grpSpPr>
         <p:sp>
@@ -12293,14 +12293,14 @@
           </p:nvSpPr>
           <p:spPr>
             <a:xfrm>
-              <a:off x="398056" y="3041123"/>
-              <a:ext cx="1821648" cy="1398009"/>
-            </a:xfrm>
-            <a:prstGeom prst="rect">
-              <a:avLst/>
-            </a:prstGeom>
-            <a:noFill/>
-            <a:ln w="21182">
+              <a:off x="402167" y="2988733"/>
+              <a:ext cx="1820333" cy="1397000"/>
+            </a:xfrm>
+            <a:prstGeom prst="rect">
+              <a:avLst/>
+            </a:prstGeom>
+            <a:noFill/>
+            <a:ln w="21167">
               <a:solidFill>
                 <a:srgbClr val="7D8998"/>
               </a:solidFill>
@@ -12338,8 +12338,8 @@
           </p:blipFill>
           <p:spPr>
             <a:xfrm>
-              <a:off x="398056" y="3041123"/>
-              <a:ext cx="254183" cy="254183"/>
+              <a:off x="402167" y="2988733"/>
+              <a:ext cx="254000" cy="254000"/>
             </a:xfrm>
             <a:prstGeom prst="rect">
               <a:avLst/>
@@ -12354,8 +12354,8 @@
           </p:nvSpPr>
           <p:spPr>
             <a:xfrm>
-              <a:off x="736967" y="3090900"/>
-              <a:ext cx="1269593" cy="192756"/>
+              <a:off x="740833" y="3038475"/>
+              <a:ext cx="1268677" cy="192617"/>
             </a:xfrm>
             <a:prstGeom prst="rect">
               <a:avLst/>
@@ -12374,7 +12374,7 @@
                 </a:lnSpc>
               </a:pPr>
               <a:r>
-                <a:rPr sz="1167" b="1" lang="ko-KR">
+                <a:rPr sz="1166" b="1" lang="ko-KR">
                   <a:solidFill>
                     <a:srgbClr val="7D8998"/>
                   </a:solidFill>
@@ -12409,8 +12409,8 @@
           </p:blipFill>
           <p:spPr>
             <a:xfrm>
-              <a:off x="1054696" y="3401216"/>
-              <a:ext cx="508367" cy="508367"/>
+              <a:off x="1058333" y="3348567"/>
+              <a:ext cx="508000" cy="508000"/>
             </a:xfrm>
             <a:prstGeom prst="rect">
               <a:avLst/>
@@ -12425,8 +12425,8 @@
           </p:nvSpPr>
           <p:spPr>
             <a:xfrm>
-              <a:off x="419238" y="3959360"/>
-              <a:ext cx="1779284" cy="192756"/>
+              <a:off x="423333" y="3906308"/>
+              <a:ext cx="1778000" cy="192617"/>
             </a:xfrm>
             <a:prstGeom prst="rect">
               <a:avLst/>
@@ -12445,7 +12445,7 @@
                 </a:lnSpc>
               </a:pPr>
               <a:r>
-                <a:rPr sz="1167" b="0" lang="ko-KR">
+                <a:rPr sz="1166" b="0" lang="ko-KR">
                   <a:solidFill>
                     <a:srgbClr val="232F3E"/>
                   </a:solidFill>
@@ -12466,8 +12466,8 @@
           </p:nvSpPr>
           <p:spPr>
             <a:xfrm>
-              <a:off x="633705" y="4148939"/>
-              <a:ext cx="1350349" cy="165219"/>
+              <a:off x="637646" y="4095750"/>
+              <a:ext cx="1349375" cy="165100"/>
             </a:xfrm>
             <a:prstGeom prst="rect">
               <a:avLst/>
@@ -12521,8 +12521,8 @@
           </p:blipFill>
           <p:spPr>
             <a:xfrm>
-              <a:off x="2579796" y="3401216"/>
-              <a:ext cx="508367" cy="508367"/>
+              <a:off x="2582333" y="3348567"/>
+              <a:ext cx="508000" cy="508000"/>
             </a:xfrm>
             <a:prstGeom prst="rect">
               <a:avLst/>
@@ -12537,8 +12537,8 @@
           </p:nvSpPr>
           <p:spPr>
             <a:xfrm>
-              <a:off x="2352090" y="3959360"/>
-              <a:ext cx="963779" cy="192756"/>
+              <a:off x="2354792" y="3906308"/>
+              <a:ext cx="963083" cy="192617"/>
             </a:xfrm>
             <a:prstGeom prst="rect">
               <a:avLst/>
@@ -12557,7 +12557,7 @@
                 </a:lnSpc>
               </a:pPr>
               <a:r>
-                <a:rPr sz="1167" b="0" lang="ko-KR">
+                <a:rPr sz="1166" b="0" lang="ko-KR">
                   <a:solidFill>
                     <a:srgbClr val="232F3E"/>
                   </a:solidFill>
@@ -12578,13 +12578,13 @@
           </p:nvCxnSpPr>
           <p:spPr>
             <a:xfrm>
-              <a:off x="1605427" y="3655399"/>
-              <a:ext cx="932005" cy="0"/>
+              <a:off x="1608667" y="3602567"/>
+              <a:ext cx="931333" cy="0"/>
             </a:xfrm>
             <a:prstGeom prst="line">
               <a:avLst/>
             </a:prstGeom>
-            <a:ln w="15886">
+            <a:ln w="15875">
               <a:solidFill>
                 <a:srgbClr val="232F3E"/>
               </a:solidFill>
@@ -12601,13 +12601,13 @@
           </p:nvCxnSpPr>
           <p:spPr>
             <a:xfrm>
-              <a:off x="3130527" y="3655399"/>
-              <a:ext cx="529549" cy="0"/>
+              <a:off x="3132667" y="3602567"/>
+              <a:ext cx="529166" cy="0"/>
             </a:xfrm>
             <a:prstGeom prst="line">
               <a:avLst/>
             </a:prstGeom>
-            <a:ln w="15886">
+            <a:ln w="15875">
               <a:solidFill>
                 <a:srgbClr val="232F3E"/>
               </a:solidFill>
@@ -12624,8 +12624,8 @@
           </p:nvSpPr>
           <p:spPr>
             <a:xfrm>
-              <a:off x="3113317" y="3439343"/>
-              <a:ext cx="563969" cy="165219"/>
+              <a:off x="3115469" y="3386667"/>
+              <a:ext cx="563562" cy="165100"/>
             </a:xfrm>
             <a:prstGeom prst="rect">
               <a:avLst/>
@@ -12679,8 +12679,8 @@
           </p:blipFill>
           <p:spPr>
             <a:xfrm>
-              <a:off x="3702440" y="3401216"/>
-              <a:ext cx="508367" cy="508367"/>
+              <a:off x="3704167" y="3348567"/>
+              <a:ext cx="508000" cy="508000"/>
             </a:xfrm>
             <a:prstGeom prst="rect">
               <a:avLst/>
@@ -12695,8 +12695,8 @@
           </p:nvSpPr>
           <p:spPr>
             <a:xfrm>
-              <a:off x="3066981" y="3959360"/>
-              <a:ext cx="1779284" cy="192756"/>
+              <a:off x="3069167" y="3906308"/>
+              <a:ext cx="1778000" cy="192617"/>
             </a:xfrm>
             <a:prstGeom prst="rect">
               <a:avLst/>
@@ -12715,7 +12715,7 @@
                 </a:lnSpc>
               </a:pPr>
               <a:r>
-                <a:rPr sz="1167" b="0" lang="ko-KR">
+                <a:rPr sz="1166" b="0" lang="ko-KR">
                   <a:solidFill>
                     <a:srgbClr val="232F3E"/>
                   </a:solidFill>
@@ -12736,13 +12736,13 @@
           </p:nvCxnSpPr>
           <p:spPr>
             <a:xfrm>
-              <a:off x="4253170" y="3655399"/>
-              <a:ext cx="1821648" cy="0"/>
+              <a:off x="4254500" y="3602567"/>
+              <a:ext cx="1820333" cy="0"/>
             </a:xfrm>
             <a:prstGeom prst="line">
               <a:avLst/>
             </a:prstGeom>
-            <a:ln w="15886">
+            <a:ln w="15875">
               <a:solidFill>
                 <a:srgbClr val="232F3E"/>
               </a:solidFill>
@@ -12759,14 +12759,14 @@
           </p:nvSpPr>
           <p:spPr>
             <a:xfrm>
-              <a:off x="4761537" y="1134747"/>
-              <a:ext cx="7032407" cy="4935394"/>
-            </a:xfrm>
-            <a:prstGeom prst="rect">
-              <a:avLst/>
-            </a:prstGeom>
-            <a:noFill/>
-            <a:ln w="21182">
+              <a:off x="4762500" y="1083733"/>
+              <a:ext cx="7027333" cy="4931833"/>
+            </a:xfrm>
+            <a:prstGeom prst="rect">
+              <a:avLst/>
+            </a:prstGeom>
+            <a:noFill/>
+            <a:ln w="21167">
               <a:solidFill>
                 <a:srgbClr val="232F3E"/>
               </a:solidFill>
@@ -12804,8 +12804,8 @@
           </p:blipFill>
           <p:spPr>
             <a:xfrm>
-              <a:off x="4761537" y="1134747"/>
-              <a:ext cx="338911" cy="338911"/>
+              <a:off x="4762500" y="1083733"/>
+              <a:ext cx="338667" cy="338667"/>
             </a:xfrm>
             <a:prstGeom prst="rect">
               <a:avLst/>
@@ -12820,8 +12820,8 @@
           </p:nvSpPr>
           <p:spPr>
             <a:xfrm>
-              <a:off x="5206358" y="1216827"/>
-              <a:ext cx="1141839" cy="206524"/>
+              <a:off x="5207000" y="1165754"/>
+              <a:ext cx="1141016" cy="206375"/>
             </a:xfrm>
             <a:prstGeom prst="rect">
               <a:avLst/>
@@ -12861,14 +12861,14 @@
           </p:nvSpPr>
           <p:spPr>
             <a:xfrm>
-              <a:off x="4973357" y="1558386"/>
-              <a:ext cx="3050201" cy="4299936"/>
-            </a:xfrm>
-            <a:prstGeom prst="rect">
-              <a:avLst/>
-            </a:prstGeom>
-            <a:noFill/>
-            <a:ln w="21182">
+              <a:off x="4974167" y="1507067"/>
+              <a:ext cx="3048000" cy="4296833"/>
+            </a:xfrm>
+            <a:prstGeom prst="rect">
+              <a:avLst/>
+            </a:prstGeom>
+            <a:noFill/>
+            <a:ln w="21167">
               <a:solidFill>
                 <a:srgbClr val="00A4A6"/>
               </a:solidFill>
@@ -12908,8 +12908,8 @@
           </p:blipFill>
           <p:spPr>
             <a:xfrm>
-              <a:off x="4973357" y="1558386"/>
-              <a:ext cx="254183" cy="254183"/>
+              <a:off x="4974167" y="1507067"/>
+              <a:ext cx="254000" cy="254000"/>
             </a:xfrm>
             <a:prstGeom prst="rect">
               <a:avLst/>
@@ -12924,8 +12924,8 @@
           </p:nvSpPr>
           <p:spPr>
             <a:xfrm>
-              <a:off x="5312268" y="1608164"/>
-              <a:ext cx="2288974" cy="192756"/>
+              <a:off x="5312833" y="1556808"/>
+              <a:ext cx="2287323" cy="192617"/>
             </a:xfrm>
             <a:prstGeom prst="rect">
               <a:avLst/>
@@ -12944,7 +12944,7 @@
                 </a:lnSpc>
               </a:pPr>
               <a:r>
-                <a:rPr sz="1167" b="1" lang="ko-KR">
+                <a:rPr sz="1166" b="1" lang="ko-KR">
                   <a:solidFill>
                     <a:srgbClr val="00A4A6"/>
                   </a:solidFill>
@@ -12979,8 +12979,8 @@
           </p:blipFill>
           <p:spPr>
             <a:xfrm>
-              <a:off x="6117182" y="3401216"/>
-              <a:ext cx="508367" cy="508367"/>
+              <a:off x="6117167" y="3348567"/>
+              <a:ext cx="508000" cy="508000"/>
             </a:xfrm>
             <a:prstGeom prst="rect">
               <a:avLst/>
@@ -12995,8 +12995,8 @@
           </p:nvSpPr>
           <p:spPr>
             <a:xfrm>
-              <a:off x="5430754" y="3959360"/>
-              <a:ext cx="1881222" cy="192756"/>
+              <a:off x="5431234" y="3906308"/>
+              <a:ext cx="1879865" cy="192617"/>
             </a:xfrm>
             <a:prstGeom prst="rect">
               <a:avLst/>
@@ -13015,7 +13015,7 @@
                 </a:lnSpc>
               </a:pPr>
               <a:r>
-                <a:rPr sz="1167" b="0" lang="ko-KR">
+                <a:rPr sz="1166" b="0" lang="ko-KR">
                   <a:solidFill>
                     <a:srgbClr val="232F3E"/>
                   </a:solidFill>
@@ -13050,8 +13050,8 @@
           </p:blipFill>
           <p:spPr>
             <a:xfrm>
-              <a:off x="5481723" y="1982025"/>
-              <a:ext cx="508367" cy="508367"/>
+              <a:off x="5482167" y="1930400"/>
+              <a:ext cx="508000" cy="508000"/>
             </a:xfrm>
             <a:prstGeom prst="rect">
               <a:avLst/>
@@ -13066,8 +13066,8 @@
           </p:nvSpPr>
           <p:spPr>
             <a:xfrm>
-              <a:off x="5050141" y="2540170"/>
-              <a:ext cx="1371531" cy="192756"/>
+              <a:off x="5050896" y="2488142"/>
+              <a:ext cx="1370542" cy="192617"/>
             </a:xfrm>
             <a:prstGeom prst="rect">
               <a:avLst/>
@@ -13086,7 +13086,7 @@
                 </a:lnSpc>
               </a:pPr>
               <a:r>
-                <a:rPr sz="1167" b="0" lang="ko-KR">
+                <a:rPr sz="1166" b="0" lang="ko-KR">
                   <a:solidFill>
                     <a:srgbClr val="232F3E"/>
                   </a:solidFill>
@@ -13107,8 +13107,8 @@
           </p:nvSpPr>
           <p:spPr>
             <a:xfrm>
-              <a:off x="5191796" y="2729748"/>
-              <a:ext cx="1088223" cy="165219"/>
+              <a:off x="5192448" y="2677583"/>
+              <a:ext cx="1087438" cy="165100"/>
             </a:xfrm>
             <a:prstGeom prst="rect">
               <a:avLst/>
@@ -13162,8 +13162,8 @@
           </p:blipFill>
           <p:spPr>
             <a:xfrm>
-              <a:off x="6752640" y="1982025"/>
-              <a:ext cx="508367" cy="508367"/>
+              <a:off x="6752167" y="1930400"/>
+              <a:ext cx="508000" cy="508000"/>
             </a:xfrm>
             <a:prstGeom prst="rect">
               <a:avLst/>
@@ -13178,8 +13178,8 @@
           </p:nvSpPr>
           <p:spPr>
             <a:xfrm>
-              <a:off x="6524934" y="2540170"/>
-              <a:ext cx="963779" cy="192756"/>
+              <a:off x="6524625" y="2488142"/>
+              <a:ext cx="963083" cy="192617"/>
             </a:xfrm>
             <a:prstGeom prst="rect">
               <a:avLst/>
@@ -13198,7 +13198,7 @@
                 </a:lnSpc>
               </a:pPr>
               <a:r>
-                <a:rPr sz="1167" b="0" lang="ko-KR">
+                <a:rPr sz="1166" b="0" lang="ko-KR">
                   <a:solidFill>
                     <a:srgbClr val="232F3E"/>
                   </a:solidFill>
@@ -13219,8 +13219,8 @@
           </p:nvSpPr>
           <p:spPr>
             <a:xfrm>
-              <a:off x="6462712" y="2729748"/>
-              <a:ext cx="1088223" cy="165219"/>
+              <a:off x="6462448" y="2677583"/>
+              <a:ext cx="1087438" cy="165100"/>
             </a:xfrm>
             <a:prstGeom prst="rect">
               <a:avLst/>
@@ -13274,8 +13274,8 @@
           </p:blipFill>
           <p:spPr>
             <a:xfrm>
-              <a:off x="5481723" y="4820406"/>
-              <a:ext cx="508367" cy="508367"/>
+              <a:off x="5482167" y="4766733"/>
+              <a:ext cx="508000" cy="508000"/>
             </a:xfrm>
             <a:prstGeom prst="rect">
               <a:avLst/>
@@ -13290,8 +13290,8 @@
           </p:nvSpPr>
           <p:spPr>
             <a:xfrm>
-              <a:off x="5304987" y="5378551"/>
-              <a:ext cx="861841" cy="192756"/>
+              <a:off x="5305557" y="5324475"/>
+              <a:ext cx="861219" cy="192617"/>
             </a:xfrm>
             <a:prstGeom prst="rect">
               <a:avLst/>
@@ -13310,7 +13310,7 @@
                 </a:lnSpc>
               </a:pPr>
               <a:r>
-                <a:rPr sz="1167" b="0" lang="ko-KR">
+                <a:rPr sz="1166" b="0" lang="ko-KR">
                   <a:solidFill>
                     <a:srgbClr val="232F3E"/>
                   </a:solidFill>
@@ -13331,8 +13331,8 @@
           </p:nvSpPr>
           <p:spPr>
             <a:xfrm>
-              <a:off x="5191796" y="5568129"/>
-              <a:ext cx="1088223" cy="165219"/>
+              <a:off x="5192448" y="5513917"/>
+              <a:ext cx="1087438" cy="165100"/>
             </a:xfrm>
             <a:prstGeom prst="rect">
               <a:avLst/>
@@ -13386,8 +13386,8 @@
           </p:blipFill>
           <p:spPr>
             <a:xfrm>
-              <a:off x="6752640" y="4820406"/>
-              <a:ext cx="508367" cy="508367"/>
+              <a:off x="6752167" y="4766733"/>
+              <a:ext cx="508000" cy="508000"/>
             </a:xfrm>
             <a:prstGeom prst="rect">
               <a:avLst/>
@@ -13402,8 +13402,8 @@
           </p:nvSpPr>
           <p:spPr>
             <a:xfrm>
-              <a:off x="6524934" y="5378551"/>
-              <a:ext cx="963779" cy="192756"/>
+              <a:off x="6524625" y="5324475"/>
+              <a:ext cx="963083" cy="192617"/>
             </a:xfrm>
             <a:prstGeom prst="rect">
               <a:avLst/>
@@ -13422,7 +13422,7 @@
                 </a:lnSpc>
               </a:pPr>
               <a:r>
-                <a:rPr sz="1167" b="0" lang="ko-KR">
+                <a:rPr sz="1166" b="0" lang="ko-KR">
                   <a:solidFill>
                     <a:srgbClr val="232F3E"/>
                   </a:solidFill>
@@ -13443,8 +13443,8 @@
           </p:nvSpPr>
           <p:spPr>
             <a:xfrm>
-              <a:off x="6462712" y="5568129"/>
-              <a:ext cx="1088223" cy="165219"/>
+              <a:off x="6462448" y="5513917"/>
+              <a:ext cx="1087438" cy="165100"/>
             </a:xfrm>
             <a:prstGeom prst="rect">
               <a:avLst/>
@@ -13484,8 +13484,8 @@
           </p:nvSpPr>
           <p:spPr>
             <a:xfrm>
-              <a:off x="5735907" y="2935213"/>
-              <a:ext cx="529549" cy="423639"/>
+              <a:off x="5736167" y="2882900"/>
+              <a:ext cx="529166" cy="423333"/>
             </a:xfrm>
             <a:custGeom>
               <a:avLst/>
@@ -13494,15 +13494,15 @@
               <a:cxnLst/>
               <a:rect l="l" t="t" r="r" b="b"/>
               <a:pathLst>
-                <a:path w="529549" h="423639">
+                <a:path w="529166" h="423333">
                   <a:moveTo>
-                    <a:pt x="529549" y="423639"/>
+                    <a:pt x="529166" y="423333"/>
                   </a:moveTo>
                   <a:lnTo>
-                    <a:pt x="529549" y="211819"/>
+                    <a:pt x="529166" y="211667"/>
                   </a:lnTo>
                   <a:lnTo>
-                    <a:pt x="0" y="211819"/>
+                    <a:pt x="0" y="211667"/>
                   </a:lnTo>
                   <a:lnTo>
                     <a:pt x="0" y="0"/>
@@ -13511,7 +13511,7 @@
               </a:pathLst>
             </a:custGeom>
             <a:noFill/>
-            <a:ln w="15886">
+            <a:ln w="15875">
               <a:solidFill>
                 <a:srgbClr val="232F3E"/>
               </a:solidFill>
@@ -13535,8 +13535,8 @@
           </p:nvSpPr>
           <p:spPr>
             <a:xfrm>
-              <a:off x="6477275" y="2935213"/>
-              <a:ext cx="529549" cy="423639"/>
+              <a:off x="6477000" y="2882900"/>
+              <a:ext cx="529167" cy="423333"/>
             </a:xfrm>
             <a:custGeom>
               <a:avLst/>
@@ -13545,24 +13545,24 @@
               <a:cxnLst/>
               <a:rect l="l" t="t" r="r" b="b"/>
               <a:pathLst>
-                <a:path w="529549" h="423639">
+                <a:path w="529167" h="423333">
                   <a:moveTo>
-                    <a:pt x="0" y="423639"/>
+                    <a:pt x="0" y="423333"/>
                   </a:moveTo>
                   <a:lnTo>
-                    <a:pt x="0" y="211819"/>
+                    <a:pt x="0" y="211667"/>
                   </a:lnTo>
                   <a:lnTo>
-                    <a:pt x="529549" y="211819"/>
+                    <a:pt x="529167" y="211667"/>
                   </a:lnTo>
                   <a:lnTo>
-                    <a:pt x="529549" y="0"/>
+                    <a:pt x="529167" y="0"/>
                   </a:lnTo>
                 </a:path>
               </a:pathLst>
             </a:custGeom>
             <a:noFill/>
-            <a:ln w="15886">
+            <a:ln w="15875">
               <a:solidFill>
                 <a:srgbClr val="232F3E"/>
               </a:solidFill>
@@ -13586,8 +13586,8 @@
           </p:nvSpPr>
           <p:spPr>
             <a:xfrm>
-              <a:off x="5735907" y="4184948"/>
-              <a:ext cx="529549" cy="593095"/>
+              <a:off x="5736167" y="4131733"/>
+              <a:ext cx="529166" cy="592667"/>
             </a:xfrm>
             <a:custGeom>
               <a:avLst/>
@@ -13596,24 +13596,24 @@
               <a:cxnLst/>
               <a:rect l="l" t="t" r="r" b="b"/>
               <a:pathLst>
-                <a:path w="529549" h="593095">
+                <a:path w="529166" h="592667">
                   <a:moveTo>
-                    <a:pt x="529549" y="0"/>
+                    <a:pt x="529166" y="0"/>
                   </a:moveTo>
                   <a:lnTo>
-                    <a:pt x="529549" y="296547"/>
+                    <a:pt x="529166" y="296334"/>
                   </a:lnTo>
                   <a:lnTo>
-                    <a:pt x="0" y="296547"/>
+                    <a:pt x="0" y="296334"/>
                   </a:lnTo>
                   <a:lnTo>
-                    <a:pt x="0" y="593095"/>
+                    <a:pt x="0" y="592667"/>
                   </a:lnTo>
                 </a:path>
               </a:pathLst>
             </a:custGeom>
             <a:noFill/>
-            <a:ln w="15886">
+            <a:ln w="15875">
               <a:solidFill>
                 <a:srgbClr val="232F3E"/>
               </a:solidFill>
@@ -13637,8 +13637,8 @@
           </p:nvSpPr>
           <p:spPr>
             <a:xfrm>
-              <a:off x="6477275" y="4184948"/>
-              <a:ext cx="529549" cy="593095"/>
+              <a:off x="6477000" y="4131733"/>
+              <a:ext cx="529167" cy="592667"/>
             </a:xfrm>
             <a:custGeom>
               <a:avLst/>
@@ -13647,24 +13647,24 @@
               <a:cxnLst/>
               <a:rect l="l" t="t" r="r" b="b"/>
               <a:pathLst>
-                <a:path w="529549" h="593095">
+                <a:path w="529167" h="592667">
                   <a:moveTo>
                     <a:pt x="0" y="0"/>
                   </a:moveTo>
                   <a:lnTo>
-                    <a:pt x="0" y="296547"/>
+                    <a:pt x="0" y="296334"/>
                   </a:lnTo>
                   <a:lnTo>
-                    <a:pt x="529549" y="296547"/>
+                    <a:pt x="529167" y="296334"/>
                   </a:lnTo>
                   <a:lnTo>
-                    <a:pt x="529549" y="593095"/>
+                    <a:pt x="529167" y="592667"/>
                   </a:lnTo>
                 </a:path>
               </a:pathLst>
             </a:custGeom>
             <a:noFill/>
-            <a:ln w="15886">
+            <a:ln w="15875">
               <a:solidFill>
                 <a:srgbClr val="232F3E"/>
               </a:solidFill>
@@ -13688,14 +13688,14 @@
           </p:nvSpPr>
           <p:spPr>
             <a:xfrm>
-              <a:off x="9125019" y="1558386"/>
-              <a:ext cx="2457106" cy="4299936"/>
-            </a:xfrm>
-            <a:prstGeom prst="rect">
-              <a:avLst/>
-            </a:prstGeom>
-            <a:noFill/>
-            <a:ln w="21182">
+              <a:off x="9122833" y="1507067"/>
+              <a:ext cx="2455333" cy="4296833"/>
+            </a:xfrm>
+            <a:prstGeom prst="rect">
+              <a:avLst/>
+            </a:prstGeom>
+            <a:noFill/>
+            <a:ln w="21167">
               <a:solidFill>
                 <a:srgbClr val="00A4A6"/>
               </a:solidFill>
@@ -13735,8 +13735,8 @@
           </p:blipFill>
           <p:spPr>
             <a:xfrm>
-              <a:off x="9125019" y="1558386"/>
-              <a:ext cx="254183" cy="254183"/>
+              <a:off x="9122833" y="1507067"/>
+              <a:ext cx="254000" cy="254000"/>
             </a:xfrm>
             <a:prstGeom prst="rect">
               <a:avLst/>
@@ -13751,8 +13751,8 @@
           </p:nvSpPr>
           <p:spPr>
             <a:xfrm>
-              <a:off x="9463930" y="1608164"/>
-              <a:ext cx="2288974" cy="192756"/>
+              <a:off x="9461500" y="1556808"/>
+              <a:ext cx="2287323" cy="192617"/>
             </a:xfrm>
             <a:prstGeom prst="rect">
               <a:avLst/>
@@ -13771,7 +13771,7 @@
                 </a:lnSpc>
               </a:pPr>
               <a:r>
-                <a:rPr sz="1167" b="1" lang="ko-KR">
+                <a:rPr sz="1166" b="1" lang="ko-KR">
                   <a:solidFill>
                     <a:srgbClr val="00A4A6"/>
                   </a:solidFill>
@@ -13806,8 +13806,8 @@
           </p:blipFill>
           <p:spPr>
             <a:xfrm>
-              <a:off x="10057025" y="3401216"/>
-              <a:ext cx="508367" cy="508367"/>
+              <a:off x="10054167" y="3348567"/>
+              <a:ext cx="508000" cy="508000"/>
             </a:xfrm>
             <a:prstGeom prst="rect">
               <a:avLst/>
@@ -13822,8 +13822,8 @@
           </p:nvSpPr>
           <p:spPr>
             <a:xfrm>
-              <a:off x="9370597" y="3959360"/>
-              <a:ext cx="1881222" cy="192756"/>
+              <a:off x="9368234" y="3906308"/>
+              <a:ext cx="1879865" cy="192617"/>
             </a:xfrm>
             <a:prstGeom prst="rect">
               <a:avLst/>
@@ -13842,7 +13842,7 @@
                 </a:lnSpc>
               </a:pPr>
               <a:r>
-                <a:rPr sz="1167" b="0" lang="ko-KR">
+                <a:rPr sz="1166" b="0" lang="ko-KR">
                   <a:solidFill>
                     <a:srgbClr val="232F3E"/>
                   </a:solidFill>
@@ -13877,8 +13877,8 @@
           </p:blipFill>
           <p:spPr>
             <a:xfrm>
-              <a:off x="10057025" y="1982025"/>
-              <a:ext cx="508367" cy="508367"/>
+              <a:off x="10054167" y="1930400"/>
+              <a:ext cx="508000" cy="508000"/>
             </a:xfrm>
             <a:prstGeom prst="rect">
               <a:avLst/>
@@ -13893,8 +13893,8 @@
           </p:nvSpPr>
           <p:spPr>
             <a:xfrm>
-              <a:off x="9931257" y="2540170"/>
-              <a:ext cx="759902" cy="192756"/>
+              <a:off x="9928490" y="2488142"/>
+              <a:ext cx="759354" cy="192617"/>
             </a:xfrm>
             <a:prstGeom prst="rect">
               <a:avLst/>
@@ -13913,7 +13913,7 @@
                 </a:lnSpc>
               </a:pPr>
               <a:r>
-                <a:rPr sz="1167" b="0" lang="ko-KR">
+                <a:rPr sz="1166" b="0" lang="ko-KR">
                   <a:solidFill>
                     <a:srgbClr val="232F3E"/>
                   </a:solidFill>
@@ -13934,8 +13934,8 @@
           </p:nvSpPr>
           <p:spPr>
             <a:xfrm>
-              <a:off x="9723409" y="2729748"/>
-              <a:ext cx="1175598" cy="165219"/>
+              <a:off x="9720792" y="2677583"/>
+              <a:ext cx="1174750" cy="165100"/>
             </a:xfrm>
             <a:prstGeom prst="rect">
               <a:avLst/>
@@ -13989,8 +13989,8 @@
           </p:blipFill>
           <p:spPr>
             <a:xfrm>
-              <a:off x="10057025" y="4820406"/>
-              <a:ext cx="508367" cy="508367"/>
+              <a:off x="10054167" y="4766733"/>
+              <a:ext cx="508000" cy="508000"/>
             </a:xfrm>
             <a:prstGeom prst="rect">
               <a:avLst/>
@@ -14005,8 +14005,8 @@
           </p:nvSpPr>
           <p:spPr>
             <a:xfrm>
-              <a:off x="9574473" y="5378551"/>
-              <a:ext cx="1473469" cy="192756"/>
+              <a:off x="9571964" y="5324475"/>
+              <a:ext cx="1472406" cy="192617"/>
             </a:xfrm>
             <a:prstGeom prst="rect">
               <a:avLst/>
@@ -14025,7 +14025,7 @@
                 </a:lnSpc>
               </a:pPr>
               <a:r>
-                <a:rPr sz="1167" b="0" lang="ko-KR">
+                <a:rPr sz="1166" b="0" lang="ko-KR">
                   <a:solidFill>
                     <a:srgbClr val="232F3E"/>
                   </a:solidFill>
@@ -14046,8 +14046,8 @@
           </p:nvSpPr>
           <p:spPr>
             <a:xfrm>
-              <a:off x="9723409" y="5568129"/>
-              <a:ext cx="1175598" cy="165219"/>
+              <a:off x="9720792" y="5513917"/>
+              <a:ext cx="1174750" cy="165100"/>
             </a:xfrm>
             <a:prstGeom prst="rect">
               <a:avLst/>
@@ -14087,13 +14087,13 @@
           </p:nvCxnSpPr>
           <p:spPr>
             <a:xfrm flipV="1">
-              <a:off x="10311208" y="2935213"/>
-              <a:ext cx="0" cy="423639"/>
+              <a:off x="10308167" y="2882900"/>
+              <a:ext cx="0" cy="423333"/>
             </a:xfrm>
             <a:prstGeom prst="line">
               <a:avLst/>
             </a:prstGeom>
-            <a:ln w="15886">
+            <a:ln w="15875">
               <a:solidFill>
                 <a:srgbClr val="232F3E"/>
               </a:solidFill>
@@ -14110,13 +14110,13 @@
           </p:nvCxnSpPr>
           <p:spPr>
             <a:xfrm>
-              <a:off x="10311208" y="4184948"/>
-              <a:ext cx="0" cy="593095"/>
+              <a:off x="10308167" y="4131733"/>
+              <a:ext cx="0" cy="592667"/>
             </a:xfrm>
             <a:prstGeom prst="line">
               <a:avLst/>
             </a:prstGeom>
-            <a:ln w="15886">
+            <a:ln w="15875">
               <a:solidFill>
                 <a:srgbClr val="232F3E"/>
               </a:solidFill>
@@ -14133,13 +14133,13 @@
           </p:nvCxnSpPr>
           <p:spPr>
             <a:xfrm>
-              <a:off x="6667913" y="3655399"/>
-              <a:ext cx="1609828" cy="0"/>
+              <a:off x="6667500" y="3602567"/>
+              <a:ext cx="1608667" cy="0"/>
             </a:xfrm>
             <a:prstGeom prst="line">
               <a:avLst/>
             </a:prstGeom>
-            <a:ln w="15886">
+            <a:ln w="15875">
               <a:solidFill>
                 <a:srgbClr val="232F3E"/>
               </a:solidFill>
@@ -14156,13 +14156,13 @@
           </p:nvCxnSpPr>
           <p:spPr>
             <a:xfrm>
-              <a:off x="8870835" y="3655399"/>
-              <a:ext cx="1143826" cy="0"/>
+              <a:off x="8868833" y="3602567"/>
+              <a:ext cx="1143000" cy="0"/>
             </a:xfrm>
             <a:prstGeom prst="line">
               <a:avLst/>
             </a:prstGeom>
-            <a:ln w="15886">
+            <a:ln w="15875">
               <a:solidFill>
                 <a:srgbClr val="232F3E"/>
               </a:solidFill>
@@ -14193,8 +14193,8 @@
           </p:blipFill>
           <p:spPr>
             <a:xfrm>
-              <a:off x="8320105" y="3401216"/>
-              <a:ext cx="508367" cy="508367"/>
+              <a:off x="8318500" y="3348567"/>
+              <a:ext cx="508000" cy="508000"/>
             </a:xfrm>
             <a:prstGeom prst="rect">
               <a:avLst/>
@@ -14209,8 +14209,8 @@
           </p:nvSpPr>
           <p:spPr>
             <a:xfrm>
-              <a:off x="7939492" y="3959360"/>
-              <a:ext cx="1269593" cy="192756"/>
+              <a:off x="7938161" y="3906308"/>
+              <a:ext cx="1268677" cy="192617"/>
             </a:xfrm>
             <a:prstGeom prst="rect">
               <a:avLst/>
@@ -14229,7 +14229,7 @@
                 </a:lnSpc>
               </a:pPr>
               <a:r>
-                <a:rPr sz="1167" b="0" lang="ko-KR">
+                <a:rPr sz="1166" b="0" lang="ko-KR">
                   <a:solidFill>
                     <a:srgbClr val="232F3E"/>
                   </a:solidFill>
@@ -14250,8 +14250,8 @@
           </p:nvSpPr>
           <p:spPr>
             <a:xfrm>
-              <a:off x="8177127" y="4148939"/>
-              <a:ext cx="794323" cy="165219"/>
+              <a:off x="8175625" y="4095750"/>
+              <a:ext cx="793750" cy="165100"/>
             </a:xfrm>
             <a:prstGeom prst="rect">
               <a:avLst/>
@@ -14291,8 +14291,8 @@
           </p:nvSpPr>
           <p:spPr>
             <a:xfrm>
-              <a:off x="398056" y="6161224"/>
-              <a:ext cx="8983794" cy="165219"/>
+              <a:off x="4762500" y="6106583"/>
+              <a:ext cx="8977313" cy="165100"/>
             </a:xfrm>
             <a:prstGeom prst="rect">
               <a:avLst/>
@@ -14332,8 +14332,8 @@
           </p:nvSpPr>
           <p:spPr>
             <a:xfrm>
-              <a:off x="398056" y="6330679"/>
-              <a:ext cx="12375554" cy="165219"/>
+              <a:off x="4762500" y="6275917"/>
+              <a:ext cx="4572000" cy="165100"/>
             </a:xfrm>
             <a:prstGeom prst="rect">
               <a:avLst/>
@@ -14360,7 +14360,48 @@
                   <a:ea typeface="Malgun Gothic"/>
                   <a:cs typeface="Malgun Gothic"/>
                 </a:rPr>
-                <a:t>라우팅: VPC 서브넷 10.0.0.0/8 · 192.168.0.0/16 → TGW · TGW A 10.16.0.0/13 → peering · TGW B 10.0.0.0/13 · 192.168.0.0/16 → peering (정적 경로)</a:t>
+                <a:t>라우팅: VPC 서브넷 10.0.0.0/8 · 192.168.0.0/16 → TGW</a:t>
+              </a:r>
+            </a:p>
+          </p:txBody>
+        </p:sp>
+        <p:sp>
+          <p:nvSpPr>
+            <p:cNvPr id="62" name="TextBox 61"/>
+            <p:cNvSpPr txBox="1"/>
+            <p:nvPr/>
+          </p:nvSpPr>
+          <p:spPr>
+            <a:xfrm>
+              <a:off x="4762500" y="6445250"/>
+              <a:ext cx="7659688" cy="165100"/>
+            </a:xfrm>
+            <a:prstGeom prst="rect">
+              <a:avLst/>
+            </a:prstGeom>
+            <a:noFill/>
+          </p:spPr>
+          <p:txBody>
+            <a:bodyPr wrap="none" lIns="0" rIns="0" tIns="0" bIns="0" anchor="t">
+              <a:noAutofit/>
+            </a:bodyPr>
+            <a:lstStyle/>
+            <a:p>
+              <a:pPr algn="l">
+                <a:lnSpc>
+                  <a:spcPct val="100000"/>
+                </a:lnSpc>
+              </a:pPr>
+              <a:r>
+                <a:rPr sz="1000" b="0" lang="ko-KR">
+                  <a:solidFill>
+                    <a:srgbClr val="545B64"/>
+                  </a:solidFill>
+                  <a:latin typeface="Arial"/>
+                  <a:ea typeface="Malgun Gothic"/>
+                  <a:cs typeface="Malgun Gothic"/>
+                </a:rPr>
+                <a:t>TGW RT: A 10.16.0.0/13 → peering · B 10.0.0.0/13 · 192.168.0.0/16 → peering (정적 경로)</a:t>
               </a:r>
             </a:p>
           </p:txBody>

</xml_diff>

<commit_message>
Put the note in a panel in an empty corner outside the AWS Cloud when one can hold it, with a bold label column and an aligned text column, as the TGW example now does
Co-Authored-By: Claude Opus 5.5 <noreply@anthropic.com>
</commit_message>
<xml_diff>
--- a/docs/examples/reference-architectures.pptx
+++ b/docs/examples/reference-architectures.pptx
@@ -12279,10 +12279,10 @@
         </p:nvGrpSpPr>
         <p:grpSpPr>
           <a:xfrm>
-            <a:off x="402167" y="1083733"/>
-            <a:ext cx="13337646" cy="5526617"/>
-            <a:chOff x="402167" y="1083733"/>
-            <a:chExt cx="13337646" cy="5526617"/>
+            <a:off x="398056" y="1304203"/>
+            <a:ext cx="11395888" cy="4935394"/>
+            <a:chOff x="398056" y="1304203"/>
+            <a:chExt cx="11395888" cy="4935394"/>
           </a:xfrm>
         </p:grpSpPr>
         <p:sp>
@@ -12293,14 +12293,14 @@
           </p:nvSpPr>
           <p:spPr>
             <a:xfrm>
-              <a:off x="402167" y="2988733"/>
-              <a:ext cx="1820333" cy="1397000"/>
-            </a:xfrm>
-            <a:prstGeom prst="rect">
-              <a:avLst/>
-            </a:prstGeom>
-            <a:noFill/>
-            <a:ln w="21167">
+              <a:off x="398056" y="3210578"/>
+              <a:ext cx="1821648" cy="1398009"/>
+            </a:xfrm>
+            <a:prstGeom prst="rect">
+              <a:avLst/>
+            </a:prstGeom>
+            <a:noFill/>
+            <a:ln w="21182">
               <a:solidFill>
                 <a:srgbClr val="7D8998"/>
               </a:solidFill>
@@ -12338,8 +12338,8 @@
           </p:blipFill>
           <p:spPr>
             <a:xfrm>
-              <a:off x="402167" y="2988733"/>
-              <a:ext cx="254000" cy="254000"/>
+              <a:off x="398056" y="3210578"/>
+              <a:ext cx="254183" cy="254183"/>
             </a:xfrm>
             <a:prstGeom prst="rect">
               <a:avLst/>
@@ -12354,8 +12354,8 @@
           </p:nvSpPr>
           <p:spPr>
             <a:xfrm>
-              <a:off x="740833" y="3038475"/>
-              <a:ext cx="1268677" cy="192617"/>
+              <a:off x="736967" y="3260356"/>
+              <a:ext cx="1269593" cy="192756"/>
             </a:xfrm>
             <a:prstGeom prst="rect">
               <a:avLst/>
@@ -12374,7 +12374,7 @@
                 </a:lnSpc>
               </a:pPr>
               <a:r>
-                <a:rPr sz="1166" b="1" lang="ko-KR">
+                <a:rPr sz="1167" b="1" lang="ko-KR">
                   <a:solidFill>
                     <a:srgbClr val="7D8998"/>
                   </a:solidFill>
@@ -12409,8 +12409,8 @@
           </p:blipFill>
           <p:spPr>
             <a:xfrm>
-              <a:off x="1058333" y="3348567"/>
-              <a:ext cx="508000" cy="508000"/>
+              <a:off x="1054696" y="3570671"/>
+              <a:ext cx="508367" cy="508367"/>
             </a:xfrm>
             <a:prstGeom prst="rect">
               <a:avLst/>
@@ -12425,8 +12425,8 @@
           </p:nvSpPr>
           <p:spPr>
             <a:xfrm>
-              <a:off x="423333" y="3906308"/>
-              <a:ext cx="1778000" cy="192617"/>
+              <a:off x="419238" y="4128816"/>
+              <a:ext cx="1779284" cy="192756"/>
             </a:xfrm>
             <a:prstGeom prst="rect">
               <a:avLst/>
@@ -12445,7 +12445,7 @@
                 </a:lnSpc>
               </a:pPr>
               <a:r>
-                <a:rPr sz="1166" b="0" lang="ko-KR">
+                <a:rPr sz="1167" b="0" lang="ko-KR">
                   <a:solidFill>
                     <a:srgbClr val="232F3E"/>
                   </a:solidFill>
@@ -12466,8 +12466,8 @@
           </p:nvSpPr>
           <p:spPr>
             <a:xfrm>
-              <a:off x="637646" y="4095750"/>
-              <a:ext cx="1349375" cy="165100"/>
+              <a:off x="633705" y="4318394"/>
+              <a:ext cx="1350349" cy="165219"/>
             </a:xfrm>
             <a:prstGeom prst="rect">
               <a:avLst/>
@@ -12521,8 +12521,8 @@
           </p:blipFill>
           <p:spPr>
             <a:xfrm>
-              <a:off x="2582333" y="3348567"/>
-              <a:ext cx="508000" cy="508000"/>
+              <a:off x="2579796" y="3570671"/>
+              <a:ext cx="508367" cy="508367"/>
             </a:xfrm>
             <a:prstGeom prst="rect">
               <a:avLst/>
@@ -12537,8 +12537,8 @@
           </p:nvSpPr>
           <p:spPr>
             <a:xfrm>
-              <a:off x="2354792" y="3906308"/>
-              <a:ext cx="963083" cy="192617"/>
+              <a:off x="2352090" y="4128816"/>
+              <a:ext cx="963779" cy="192756"/>
             </a:xfrm>
             <a:prstGeom prst="rect">
               <a:avLst/>
@@ -12557,7 +12557,7 @@
                 </a:lnSpc>
               </a:pPr>
               <a:r>
-                <a:rPr sz="1166" b="0" lang="ko-KR">
+                <a:rPr sz="1167" b="0" lang="ko-KR">
                   <a:solidFill>
                     <a:srgbClr val="232F3E"/>
                   </a:solidFill>
@@ -12578,13 +12578,13 @@
           </p:nvCxnSpPr>
           <p:spPr>
             <a:xfrm>
-              <a:off x="1608667" y="3602567"/>
-              <a:ext cx="931333" cy="0"/>
+              <a:off x="1605427" y="3824855"/>
+              <a:ext cx="932005" cy="0"/>
             </a:xfrm>
             <a:prstGeom prst="line">
               <a:avLst/>
             </a:prstGeom>
-            <a:ln w="15875">
+            <a:ln w="15886">
               <a:solidFill>
                 <a:srgbClr val="232F3E"/>
               </a:solidFill>
@@ -12601,13 +12601,13 @@
           </p:nvCxnSpPr>
           <p:spPr>
             <a:xfrm>
-              <a:off x="3132667" y="3602567"/>
-              <a:ext cx="529166" cy="0"/>
+              <a:off x="3130527" y="3824855"/>
+              <a:ext cx="529549" cy="0"/>
             </a:xfrm>
             <a:prstGeom prst="line">
               <a:avLst/>
             </a:prstGeom>
-            <a:ln w="15875">
+            <a:ln w="15886">
               <a:solidFill>
                 <a:srgbClr val="232F3E"/>
               </a:solidFill>
@@ -12624,8 +12624,8 @@
           </p:nvSpPr>
           <p:spPr>
             <a:xfrm>
-              <a:off x="3115469" y="3386667"/>
-              <a:ext cx="563562" cy="165100"/>
+              <a:off x="3113317" y="3608799"/>
+              <a:ext cx="563969" cy="165219"/>
             </a:xfrm>
             <a:prstGeom prst="rect">
               <a:avLst/>
@@ -12679,8 +12679,8 @@
           </p:blipFill>
           <p:spPr>
             <a:xfrm>
-              <a:off x="3704167" y="3348567"/>
-              <a:ext cx="508000" cy="508000"/>
+              <a:off x="3702440" y="3570671"/>
+              <a:ext cx="508367" cy="508367"/>
             </a:xfrm>
             <a:prstGeom prst="rect">
               <a:avLst/>
@@ -12695,8 +12695,8 @@
           </p:nvSpPr>
           <p:spPr>
             <a:xfrm>
-              <a:off x="3069167" y="3906308"/>
-              <a:ext cx="1778000" cy="192617"/>
+              <a:off x="3066981" y="4128816"/>
+              <a:ext cx="1779284" cy="192756"/>
             </a:xfrm>
             <a:prstGeom prst="rect">
               <a:avLst/>
@@ -12715,7 +12715,7 @@
                 </a:lnSpc>
               </a:pPr>
               <a:r>
-                <a:rPr sz="1166" b="0" lang="ko-KR">
+                <a:rPr sz="1167" b="0" lang="ko-KR">
                   <a:solidFill>
                     <a:srgbClr val="232F3E"/>
                   </a:solidFill>
@@ -12736,13 +12736,13 @@
           </p:nvCxnSpPr>
           <p:spPr>
             <a:xfrm>
-              <a:off x="4254500" y="3602567"/>
-              <a:ext cx="1820333" cy="0"/>
+              <a:off x="4253170" y="3824855"/>
+              <a:ext cx="1821648" cy="0"/>
             </a:xfrm>
             <a:prstGeom prst="line">
               <a:avLst/>
             </a:prstGeom>
-            <a:ln w="15875">
+            <a:ln w="15886">
               <a:solidFill>
                 <a:srgbClr val="232F3E"/>
               </a:solidFill>
@@ -12759,14 +12759,14 @@
           </p:nvSpPr>
           <p:spPr>
             <a:xfrm>
-              <a:off x="4762500" y="1083733"/>
-              <a:ext cx="7027333" cy="4931833"/>
-            </a:xfrm>
-            <a:prstGeom prst="rect">
-              <a:avLst/>
-            </a:prstGeom>
-            <a:noFill/>
-            <a:ln w="21167">
+              <a:off x="4761537" y="1304203"/>
+              <a:ext cx="7032407" cy="4935394"/>
+            </a:xfrm>
+            <a:prstGeom prst="rect">
+              <a:avLst/>
+            </a:prstGeom>
+            <a:noFill/>
+            <a:ln w="21182">
               <a:solidFill>
                 <a:srgbClr val="232F3E"/>
               </a:solidFill>
@@ -12804,8 +12804,8 @@
           </p:blipFill>
           <p:spPr>
             <a:xfrm>
-              <a:off x="4762500" y="1083733"/>
-              <a:ext cx="338667" cy="338667"/>
+              <a:off x="4761537" y="1304203"/>
+              <a:ext cx="338911" cy="338911"/>
             </a:xfrm>
             <a:prstGeom prst="rect">
               <a:avLst/>
@@ -12820,8 +12820,8 @@
           </p:nvSpPr>
           <p:spPr>
             <a:xfrm>
-              <a:off x="5207000" y="1165754"/>
-              <a:ext cx="1141016" cy="206375"/>
+              <a:off x="5206358" y="1386283"/>
+              <a:ext cx="1141839" cy="206524"/>
             </a:xfrm>
             <a:prstGeom prst="rect">
               <a:avLst/>
@@ -12861,14 +12861,14 @@
           </p:nvSpPr>
           <p:spPr>
             <a:xfrm>
-              <a:off x="4974167" y="1507067"/>
-              <a:ext cx="3048000" cy="4296833"/>
-            </a:xfrm>
-            <a:prstGeom prst="rect">
-              <a:avLst/>
-            </a:prstGeom>
-            <a:noFill/>
-            <a:ln w="21167">
+              <a:off x="4973357" y="1727842"/>
+              <a:ext cx="3050201" cy="4299936"/>
+            </a:xfrm>
+            <a:prstGeom prst="rect">
+              <a:avLst/>
+            </a:prstGeom>
+            <a:noFill/>
+            <a:ln w="21182">
               <a:solidFill>
                 <a:srgbClr val="00A4A6"/>
               </a:solidFill>
@@ -12908,8 +12908,8 @@
           </p:blipFill>
           <p:spPr>
             <a:xfrm>
-              <a:off x="4974167" y="1507067"/>
-              <a:ext cx="254000" cy="254000"/>
+              <a:off x="4973357" y="1727842"/>
+              <a:ext cx="254183" cy="254183"/>
             </a:xfrm>
             <a:prstGeom prst="rect">
               <a:avLst/>
@@ -12924,8 +12924,8 @@
           </p:nvSpPr>
           <p:spPr>
             <a:xfrm>
-              <a:off x="5312833" y="1556808"/>
-              <a:ext cx="2287323" cy="192617"/>
+              <a:off x="5312268" y="1777619"/>
+              <a:ext cx="2288974" cy="192756"/>
             </a:xfrm>
             <a:prstGeom prst="rect">
               <a:avLst/>
@@ -12944,7 +12944,7 @@
                 </a:lnSpc>
               </a:pPr>
               <a:r>
-                <a:rPr sz="1166" b="1" lang="ko-KR">
+                <a:rPr sz="1167" b="1" lang="ko-KR">
                   <a:solidFill>
                     <a:srgbClr val="00A4A6"/>
                   </a:solidFill>
@@ -12979,8 +12979,8 @@
           </p:blipFill>
           <p:spPr>
             <a:xfrm>
-              <a:off x="6117167" y="3348567"/>
-              <a:ext cx="508000" cy="508000"/>
+              <a:off x="6117182" y="3570671"/>
+              <a:ext cx="508367" cy="508367"/>
             </a:xfrm>
             <a:prstGeom prst="rect">
               <a:avLst/>
@@ -12995,8 +12995,8 @@
           </p:nvSpPr>
           <p:spPr>
             <a:xfrm>
-              <a:off x="5431234" y="3906308"/>
-              <a:ext cx="1879865" cy="192617"/>
+              <a:off x="5430754" y="4128816"/>
+              <a:ext cx="1881222" cy="192756"/>
             </a:xfrm>
             <a:prstGeom prst="rect">
               <a:avLst/>
@@ -13015,7 +13015,7 @@
                 </a:lnSpc>
               </a:pPr>
               <a:r>
-                <a:rPr sz="1166" b="0" lang="ko-KR">
+                <a:rPr sz="1167" b="0" lang="ko-KR">
                   <a:solidFill>
                     <a:srgbClr val="232F3E"/>
                   </a:solidFill>
@@ -13050,8 +13050,8 @@
           </p:blipFill>
           <p:spPr>
             <a:xfrm>
-              <a:off x="5482167" y="1930400"/>
-              <a:ext cx="508000" cy="508000"/>
+              <a:off x="5481723" y="2151481"/>
+              <a:ext cx="508367" cy="508367"/>
             </a:xfrm>
             <a:prstGeom prst="rect">
               <a:avLst/>
@@ -13066,8 +13066,8 @@
           </p:nvSpPr>
           <p:spPr>
             <a:xfrm>
-              <a:off x="5050896" y="2488142"/>
-              <a:ext cx="1370542" cy="192617"/>
+              <a:off x="5050141" y="2709625"/>
+              <a:ext cx="1371531" cy="192756"/>
             </a:xfrm>
             <a:prstGeom prst="rect">
               <a:avLst/>
@@ -13086,7 +13086,7 @@
                 </a:lnSpc>
               </a:pPr>
               <a:r>
-                <a:rPr sz="1166" b="0" lang="ko-KR">
+                <a:rPr sz="1167" b="0" lang="ko-KR">
                   <a:solidFill>
                     <a:srgbClr val="232F3E"/>
                   </a:solidFill>
@@ -13107,8 +13107,8 @@
           </p:nvSpPr>
           <p:spPr>
             <a:xfrm>
-              <a:off x="5192448" y="2677583"/>
-              <a:ext cx="1087438" cy="165100"/>
+              <a:off x="5191796" y="2899204"/>
+              <a:ext cx="1088223" cy="165219"/>
             </a:xfrm>
             <a:prstGeom prst="rect">
               <a:avLst/>
@@ -13162,8 +13162,8 @@
           </p:blipFill>
           <p:spPr>
             <a:xfrm>
-              <a:off x="6752167" y="1930400"/>
-              <a:ext cx="508000" cy="508000"/>
+              <a:off x="6752640" y="2151481"/>
+              <a:ext cx="508367" cy="508367"/>
             </a:xfrm>
             <a:prstGeom prst="rect">
               <a:avLst/>
@@ -13178,8 +13178,8 @@
           </p:nvSpPr>
           <p:spPr>
             <a:xfrm>
-              <a:off x="6524625" y="2488142"/>
-              <a:ext cx="963083" cy="192617"/>
+              <a:off x="6524934" y="2709625"/>
+              <a:ext cx="963779" cy="192756"/>
             </a:xfrm>
             <a:prstGeom prst="rect">
               <a:avLst/>
@@ -13198,7 +13198,7 @@
                 </a:lnSpc>
               </a:pPr>
               <a:r>
-                <a:rPr sz="1166" b="0" lang="ko-KR">
+                <a:rPr sz="1167" b="0" lang="ko-KR">
                   <a:solidFill>
                     <a:srgbClr val="232F3E"/>
                   </a:solidFill>
@@ -13219,8 +13219,8 @@
           </p:nvSpPr>
           <p:spPr>
             <a:xfrm>
-              <a:off x="6462448" y="2677583"/>
-              <a:ext cx="1087438" cy="165100"/>
+              <a:off x="6462712" y="2899204"/>
+              <a:ext cx="1088223" cy="165219"/>
             </a:xfrm>
             <a:prstGeom prst="rect">
               <a:avLst/>
@@ -13274,8 +13274,8 @@
           </p:blipFill>
           <p:spPr>
             <a:xfrm>
-              <a:off x="5482167" y="4766733"/>
-              <a:ext cx="508000" cy="508000"/>
+              <a:off x="5481723" y="4989862"/>
+              <a:ext cx="508367" cy="508367"/>
             </a:xfrm>
             <a:prstGeom prst="rect">
               <a:avLst/>
@@ -13290,8 +13290,8 @@
           </p:nvSpPr>
           <p:spPr>
             <a:xfrm>
-              <a:off x="5305557" y="5324475"/>
-              <a:ext cx="861219" cy="192617"/>
+              <a:off x="5304987" y="5548006"/>
+              <a:ext cx="861841" cy="192756"/>
             </a:xfrm>
             <a:prstGeom prst="rect">
               <a:avLst/>
@@ -13310,7 +13310,7 @@
                 </a:lnSpc>
               </a:pPr>
               <a:r>
-                <a:rPr sz="1166" b="0" lang="ko-KR">
+                <a:rPr sz="1167" b="0" lang="ko-KR">
                   <a:solidFill>
                     <a:srgbClr val="232F3E"/>
                   </a:solidFill>
@@ -13331,8 +13331,8 @@
           </p:nvSpPr>
           <p:spPr>
             <a:xfrm>
-              <a:off x="5192448" y="5513917"/>
-              <a:ext cx="1087438" cy="165100"/>
+              <a:off x="5191796" y="5737585"/>
+              <a:ext cx="1088223" cy="165219"/>
             </a:xfrm>
             <a:prstGeom prst="rect">
               <a:avLst/>
@@ -13386,8 +13386,8 @@
           </p:blipFill>
           <p:spPr>
             <a:xfrm>
-              <a:off x="6752167" y="4766733"/>
-              <a:ext cx="508000" cy="508000"/>
+              <a:off x="6752640" y="4989862"/>
+              <a:ext cx="508367" cy="508367"/>
             </a:xfrm>
             <a:prstGeom prst="rect">
               <a:avLst/>
@@ -13402,8 +13402,8 @@
           </p:nvSpPr>
           <p:spPr>
             <a:xfrm>
-              <a:off x="6524625" y="5324475"/>
-              <a:ext cx="963083" cy="192617"/>
+              <a:off x="6524934" y="5548006"/>
+              <a:ext cx="963779" cy="192756"/>
             </a:xfrm>
             <a:prstGeom prst="rect">
               <a:avLst/>
@@ -13422,7 +13422,7 @@
                 </a:lnSpc>
               </a:pPr>
               <a:r>
-                <a:rPr sz="1166" b="0" lang="ko-KR">
+                <a:rPr sz="1167" b="0" lang="ko-KR">
                   <a:solidFill>
                     <a:srgbClr val="232F3E"/>
                   </a:solidFill>
@@ -13443,8 +13443,8 @@
           </p:nvSpPr>
           <p:spPr>
             <a:xfrm>
-              <a:off x="6462448" y="5513917"/>
-              <a:ext cx="1087438" cy="165100"/>
+              <a:off x="6462712" y="5737585"/>
+              <a:ext cx="1088223" cy="165219"/>
             </a:xfrm>
             <a:prstGeom prst="rect">
               <a:avLst/>
@@ -13484,8 +13484,8 @@
           </p:nvSpPr>
           <p:spPr>
             <a:xfrm>
-              <a:off x="5736167" y="2882900"/>
-              <a:ext cx="529166" cy="423333"/>
+              <a:off x="5735907" y="3104669"/>
+              <a:ext cx="529549" cy="423639"/>
             </a:xfrm>
             <a:custGeom>
               <a:avLst/>
@@ -13494,15 +13494,15 @@
               <a:cxnLst/>
               <a:rect l="l" t="t" r="r" b="b"/>
               <a:pathLst>
-                <a:path w="529166" h="423333">
+                <a:path w="529549" h="423639">
                   <a:moveTo>
-                    <a:pt x="529166" y="423333"/>
+                    <a:pt x="529549" y="423639"/>
                   </a:moveTo>
                   <a:lnTo>
-                    <a:pt x="529166" y="211667"/>
+                    <a:pt x="529549" y="211819"/>
                   </a:lnTo>
                   <a:lnTo>
-                    <a:pt x="0" y="211667"/>
+                    <a:pt x="0" y="211819"/>
                   </a:lnTo>
                   <a:lnTo>
                     <a:pt x="0" y="0"/>
@@ -13511,7 +13511,7 @@
               </a:pathLst>
             </a:custGeom>
             <a:noFill/>
-            <a:ln w="15875">
+            <a:ln w="15886">
               <a:solidFill>
                 <a:srgbClr val="232F3E"/>
               </a:solidFill>
@@ -13535,8 +13535,8 @@
           </p:nvSpPr>
           <p:spPr>
             <a:xfrm>
-              <a:off x="6477000" y="2882900"/>
-              <a:ext cx="529167" cy="423333"/>
+              <a:off x="6477275" y="3104669"/>
+              <a:ext cx="529549" cy="423639"/>
             </a:xfrm>
             <a:custGeom>
               <a:avLst/>
@@ -13545,24 +13545,24 @@
               <a:cxnLst/>
               <a:rect l="l" t="t" r="r" b="b"/>
               <a:pathLst>
-                <a:path w="529167" h="423333">
+                <a:path w="529549" h="423639">
                   <a:moveTo>
-                    <a:pt x="0" y="423333"/>
+                    <a:pt x="0" y="423639"/>
                   </a:moveTo>
                   <a:lnTo>
-                    <a:pt x="0" y="211667"/>
+                    <a:pt x="0" y="211819"/>
                   </a:lnTo>
                   <a:lnTo>
-                    <a:pt x="529167" y="211667"/>
+                    <a:pt x="529549" y="211819"/>
                   </a:lnTo>
                   <a:lnTo>
-                    <a:pt x="529167" y="0"/>
+                    <a:pt x="529549" y="0"/>
                   </a:lnTo>
                 </a:path>
               </a:pathLst>
             </a:custGeom>
             <a:noFill/>
-            <a:ln w="15875">
+            <a:ln w="15886">
               <a:solidFill>
                 <a:srgbClr val="232F3E"/>
               </a:solidFill>
@@ -13586,8 +13586,8 @@
           </p:nvSpPr>
           <p:spPr>
             <a:xfrm>
-              <a:off x="5736167" y="4131733"/>
-              <a:ext cx="529166" cy="592667"/>
+              <a:off x="5735907" y="4354404"/>
+              <a:ext cx="529549" cy="593094"/>
             </a:xfrm>
             <a:custGeom>
               <a:avLst/>
@@ -13596,24 +13596,24 @@
               <a:cxnLst/>
               <a:rect l="l" t="t" r="r" b="b"/>
               <a:pathLst>
-                <a:path w="529166" h="592667">
+                <a:path w="529549" h="593094">
                   <a:moveTo>
-                    <a:pt x="529166" y="0"/>
+                    <a:pt x="529549" y="0"/>
                   </a:moveTo>
                   <a:lnTo>
-                    <a:pt x="529166" y="296334"/>
+                    <a:pt x="529549" y="296547"/>
                   </a:lnTo>
                   <a:lnTo>
-                    <a:pt x="0" y="296334"/>
+                    <a:pt x="0" y="296547"/>
                   </a:lnTo>
                   <a:lnTo>
-                    <a:pt x="0" y="592667"/>
+                    <a:pt x="0" y="593094"/>
                   </a:lnTo>
                 </a:path>
               </a:pathLst>
             </a:custGeom>
             <a:noFill/>
-            <a:ln w="15875">
+            <a:ln w="15886">
               <a:solidFill>
                 <a:srgbClr val="232F3E"/>
               </a:solidFill>
@@ -13637,8 +13637,8 @@
           </p:nvSpPr>
           <p:spPr>
             <a:xfrm>
-              <a:off x="6477000" y="4131733"/>
-              <a:ext cx="529167" cy="592667"/>
+              <a:off x="6477275" y="4354404"/>
+              <a:ext cx="529549" cy="593094"/>
             </a:xfrm>
             <a:custGeom>
               <a:avLst/>
@@ -13647,24 +13647,24 @@
               <a:cxnLst/>
               <a:rect l="l" t="t" r="r" b="b"/>
               <a:pathLst>
-                <a:path w="529167" h="592667">
+                <a:path w="529549" h="593094">
                   <a:moveTo>
                     <a:pt x="0" y="0"/>
                   </a:moveTo>
                   <a:lnTo>
-                    <a:pt x="0" y="296334"/>
+                    <a:pt x="0" y="296547"/>
                   </a:lnTo>
                   <a:lnTo>
-                    <a:pt x="529167" y="296334"/>
+                    <a:pt x="529549" y="296547"/>
                   </a:lnTo>
                   <a:lnTo>
-                    <a:pt x="529167" y="592667"/>
+                    <a:pt x="529549" y="593094"/>
                   </a:lnTo>
                 </a:path>
               </a:pathLst>
             </a:custGeom>
             <a:noFill/>
-            <a:ln w="15875">
+            <a:ln w="15886">
               <a:solidFill>
                 <a:srgbClr val="232F3E"/>
               </a:solidFill>
@@ -13688,14 +13688,14 @@
           </p:nvSpPr>
           <p:spPr>
             <a:xfrm>
-              <a:off x="9122833" y="1507067"/>
-              <a:ext cx="2455333" cy="4296833"/>
-            </a:xfrm>
-            <a:prstGeom prst="rect">
-              <a:avLst/>
-            </a:prstGeom>
-            <a:noFill/>
-            <a:ln w="21167">
+              <a:off x="9125019" y="1727842"/>
+              <a:ext cx="2457106" cy="4299936"/>
+            </a:xfrm>
+            <a:prstGeom prst="rect">
+              <a:avLst/>
+            </a:prstGeom>
+            <a:noFill/>
+            <a:ln w="21182">
               <a:solidFill>
                 <a:srgbClr val="00A4A6"/>
               </a:solidFill>
@@ -13735,8 +13735,8 @@
           </p:blipFill>
           <p:spPr>
             <a:xfrm>
-              <a:off x="9122833" y="1507067"/>
-              <a:ext cx="254000" cy="254000"/>
+              <a:off x="9125019" y="1727842"/>
+              <a:ext cx="254183" cy="254183"/>
             </a:xfrm>
             <a:prstGeom prst="rect">
               <a:avLst/>
@@ -13751,8 +13751,8 @@
           </p:nvSpPr>
           <p:spPr>
             <a:xfrm>
-              <a:off x="9461500" y="1556808"/>
-              <a:ext cx="2287323" cy="192617"/>
+              <a:off x="9463930" y="1777619"/>
+              <a:ext cx="2288974" cy="192756"/>
             </a:xfrm>
             <a:prstGeom prst="rect">
               <a:avLst/>
@@ -13771,7 +13771,7 @@
                 </a:lnSpc>
               </a:pPr>
               <a:r>
-                <a:rPr sz="1166" b="1" lang="ko-KR">
+                <a:rPr sz="1167" b="1" lang="ko-KR">
                   <a:solidFill>
                     <a:srgbClr val="00A4A6"/>
                   </a:solidFill>
@@ -13806,8 +13806,8 @@
           </p:blipFill>
           <p:spPr>
             <a:xfrm>
-              <a:off x="10054167" y="3348567"/>
-              <a:ext cx="508000" cy="508000"/>
+              <a:off x="10057025" y="3570671"/>
+              <a:ext cx="508367" cy="508367"/>
             </a:xfrm>
             <a:prstGeom prst="rect">
               <a:avLst/>
@@ -13822,8 +13822,8 @@
           </p:nvSpPr>
           <p:spPr>
             <a:xfrm>
-              <a:off x="9368234" y="3906308"/>
-              <a:ext cx="1879865" cy="192617"/>
+              <a:off x="9370597" y="4128816"/>
+              <a:ext cx="1881222" cy="192756"/>
             </a:xfrm>
             <a:prstGeom prst="rect">
               <a:avLst/>
@@ -13842,7 +13842,7 @@
                 </a:lnSpc>
               </a:pPr>
               <a:r>
-                <a:rPr sz="1166" b="0" lang="ko-KR">
+                <a:rPr sz="1167" b="0" lang="ko-KR">
                   <a:solidFill>
                     <a:srgbClr val="232F3E"/>
                   </a:solidFill>
@@ -13877,8 +13877,8 @@
           </p:blipFill>
           <p:spPr>
             <a:xfrm>
-              <a:off x="10054167" y="1930400"/>
-              <a:ext cx="508000" cy="508000"/>
+              <a:off x="10057025" y="2151481"/>
+              <a:ext cx="508367" cy="508367"/>
             </a:xfrm>
             <a:prstGeom prst="rect">
               <a:avLst/>
@@ -13893,8 +13893,8 @@
           </p:nvSpPr>
           <p:spPr>
             <a:xfrm>
-              <a:off x="9928490" y="2488142"/>
-              <a:ext cx="759354" cy="192617"/>
+              <a:off x="9931257" y="2709625"/>
+              <a:ext cx="759902" cy="192756"/>
             </a:xfrm>
             <a:prstGeom prst="rect">
               <a:avLst/>
@@ -13913,7 +13913,7 @@
                 </a:lnSpc>
               </a:pPr>
               <a:r>
-                <a:rPr sz="1166" b="0" lang="ko-KR">
+                <a:rPr sz="1167" b="0" lang="ko-KR">
                   <a:solidFill>
                     <a:srgbClr val="232F3E"/>
                   </a:solidFill>
@@ -13934,8 +13934,8 @@
           </p:nvSpPr>
           <p:spPr>
             <a:xfrm>
-              <a:off x="9720792" y="2677583"/>
-              <a:ext cx="1174750" cy="165100"/>
+              <a:off x="9723409" y="2899204"/>
+              <a:ext cx="1175598" cy="165219"/>
             </a:xfrm>
             <a:prstGeom prst="rect">
               <a:avLst/>
@@ -13989,8 +13989,8 @@
           </p:blipFill>
           <p:spPr>
             <a:xfrm>
-              <a:off x="10054167" y="4766733"/>
-              <a:ext cx="508000" cy="508000"/>
+              <a:off x="10057025" y="4989862"/>
+              <a:ext cx="508367" cy="508367"/>
             </a:xfrm>
             <a:prstGeom prst="rect">
               <a:avLst/>
@@ -14005,8 +14005,8 @@
           </p:nvSpPr>
           <p:spPr>
             <a:xfrm>
-              <a:off x="9571964" y="5324475"/>
-              <a:ext cx="1472406" cy="192617"/>
+              <a:off x="9574473" y="5548006"/>
+              <a:ext cx="1473469" cy="192756"/>
             </a:xfrm>
             <a:prstGeom prst="rect">
               <a:avLst/>
@@ -14025,7 +14025,7 @@
                 </a:lnSpc>
               </a:pPr>
               <a:r>
-                <a:rPr sz="1166" b="0" lang="ko-KR">
+                <a:rPr sz="1167" b="0" lang="ko-KR">
                   <a:solidFill>
                     <a:srgbClr val="232F3E"/>
                   </a:solidFill>
@@ -14046,8 +14046,8 @@
           </p:nvSpPr>
           <p:spPr>
             <a:xfrm>
-              <a:off x="9720792" y="5513917"/>
-              <a:ext cx="1174750" cy="165100"/>
+              <a:off x="9723409" y="5737585"/>
+              <a:ext cx="1175598" cy="165219"/>
             </a:xfrm>
             <a:prstGeom prst="rect">
               <a:avLst/>
@@ -14087,13 +14087,13 @@
           </p:nvCxnSpPr>
           <p:spPr>
             <a:xfrm flipV="1">
-              <a:off x="10308167" y="2882900"/>
-              <a:ext cx="0" cy="423333"/>
+              <a:off x="10311208" y="3104669"/>
+              <a:ext cx="0" cy="423639"/>
             </a:xfrm>
             <a:prstGeom prst="line">
               <a:avLst/>
             </a:prstGeom>
-            <a:ln w="15875">
+            <a:ln w="15886">
               <a:solidFill>
                 <a:srgbClr val="232F3E"/>
               </a:solidFill>
@@ -14110,13 +14110,13 @@
           </p:nvCxnSpPr>
           <p:spPr>
             <a:xfrm>
-              <a:off x="10308167" y="4131733"/>
-              <a:ext cx="0" cy="592667"/>
+              <a:off x="10311208" y="4354404"/>
+              <a:ext cx="0" cy="593094"/>
             </a:xfrm>
             <a:prstGeom prst="line">
               <a:avLst/>
             </a:prstGeom>
-            <a:ln w="15875">
+            <a:ln w="15886">
               <a:solidFill>
                 <a:srgbClr val="232F3E"/>
               </a:solidFill>
@@ -14133,13 +14133,13 @@
           </p:nvCxnSpPr>
           <p:spPr>
             <a:xfrm>
-              <a:off x="6667500" y="3602567"/>
-              <a:ext cx="1608667" cy="0"/>
+              <a:off x="6667913" y="3824855"/>
+              <a:ext cx="1609828" cy="0"/>
             </a:xfrm>
             <a:prstGeom prst="line">
               <a:avLst/>
             </a:prstGeom>
-            <a:ln w="15875">
+            <a:ln w="15886">
               <a:solidFill>
                 <a:srgbClr val="232F3E"/>
               </a:solidFill>
@@ -14156,13 +14156,13 @@
           </p:nvCxnSpPr>
           <p:spPr>
             <a:xfrm>
-              <a:off x="8868833" y="3602567"/>
-              <a:ext cx="1143000" cy="0"/>
+              <a:off x="8870835" y="3824855"/>
+              <a:ext cx="1143826" cy="0"/>
             </a:xfrm>
             <a:prstGeom prst="line">
               <a:avLst/>
             </a:prstGeom>
-            <a:ln w="15875">
+            <a:ln w="15886">
               <a:solidFill>
                 <a:srgbClr val="232F3E"/>
               </a:solidFill>
@@ -14193,8 +14193,8 @@
           </p:blipFill>
           <p:spPr>
             <a:xfrm>
-              <a:off x="8318500" y="3348567"/>
-              <a:ext cx="508000" cy="508000"/>
+              <a:off x="8320105" y="3570671"/>
+              <a:ext cx="508367" cy="508367"/>
             </a:xfrm>
             <a:prstGeom prst="rect">
               <a:avLst/>
@@ -14209,8 +14209,8 @@
           </p:nvSpPr>
           <p:spPr>
             <a:xfrm>
-              <a:off x="7938161" y="3906308"/>
-              <a:ext cx="1268677" cy="192617"/>
+              <a:off x="7939492" y="4128816"/>
+              <a:ext cx="1269593" cy="192756"/>
             </a:xfrm>
             <a:prstGeom prst="rect">
               <a:avLst/>
@@ -14229,7 +14229,7 @@
                 </a:lnSpc>
               </a:pPr>
               <a:r>
-                <a:rPr sz="1166" b="0" lang="ko-KR">
+                <a:rPr sz="1167" b="0" lang="ko-KR">
                   <a:solidFill>
                     <a:srgbClr val="232F3E"/>
                   </a:solidFill>
@@ -14250,8 +14250,8 @@
           </p:nvSpPr>
           <p:spPr>
             <a:xfrm>
-              <a:off x="8175625" y="4095750"/>
-              <a:ext cx="793750" cy="165100"/>
+              <a:off x="8177127" y="4318394"/>
+              <a:ext cx="794323" cy="165219"/>
             </a:xfrm>
             <a:prstGeom prst="rect">
               <a:avLst/>
@@ -14285,14 +14285,47 @@
         </p:sp>
         <p:sp>
           <p:nvSpPr>
-            <p:cNvPr id="60" name="TextBox 59"/>
-            <p:cNvSpPr txBox="1"/>
-            <p:nvPr/>
-          </p:nvSpPr>
-          <p:spPr>
-            <a:xfrm>
-              <a:off x="4762500" y="6106583"/>
-              <a:ext cx="8977313" cy="165100"/>
+            <p:cNvPr id="60" name="Rectangle 59"/>
+            <p:cNvSpPr/>
+            <p:nvPr/>
+          </p:nvSpPr>
+          <p:spPr>
+            <a:xfrm>
+              <a:off x="398056" y="4820406"/>
+              <a:ext cx="4194026" cy="1419191"/>
+            </a:xfrm>
+            <a:prstGeom prst="rect">
+              <a:avLst/>
+            </a:prstGeom>
+            <a:solidFill>
+              <a:srgbClr val="F8F9F9"/>
+            </a:solidFill>
+            <a:ln w="10591">
+              <a:solidFill>
+                <a:srgbClr val="D5DBDB"/>
+              </a:solidFill>
+              <a:prstDash val="solid"/>
+              <a:miter lim="800000"/>
+            </a:ln>
+          </p:spPr>
+          <p:txBody>
+            <a:bodyPr rtlCol="0" anchor="ctr"/>
+            <a:lstStyle/>
+            <a:p>
+              <a:pPr algn="ctr"/>
+            </a:p>
+          </p:txBody>
+        </p:sp>
+        <p:sp>
+          <p:nvSpPr>
+            <p:cNvPr id="61" name="TextBox 60"/>
+            <p:cNvSpPr txBox="1"/>
+            <p:nvPr/>
+          </p:nvSpPr>
+          <p:spPr>
+            <a:xfrm>
+              <a:off x="525147" y="4932671"/>
+              <a:ext cx="1088223" cy="165219"/>
             </a:xfrm>
             <a:prstGeom prst="rect">
               <a:avLst/>
@@ -14311,6 +14344,47 @@
                 </a:lnSpc>
               </a:pPr>
               <a:r>
+                <a:rPr sz="1000" b="1" lang="ko-KR">
+                  <a:solidFill>
+                    <a:srgbClr val="232F3E"/>
+                  </a:solidFill>
+                  <a:latin typeface="Arial"/>
+                  <a:ea typeface="Malgun Gothic"/>
+                  <a:cs typeface="Malgun Gothic"/>
+                </a:rPr>
+                <a:t>Hub &amp; spoke</a:t>
+              </a:r>
+            </a:p>
+          </p:txBody>
+        </p:sp>
+        <p:sp>
+          <p:nvSpPr>
+            <p:cNvPr id="62" name="TextBox 61"/>
+            <p:cNvSpPr txBox="1"/>
+            <p:nvPr/>
+          </p:nvSpPr>
+          <p:spPr>
+            <a:xfrm>
+              <a:off x="1565181" y="4932671"/>
+              <a:ext cx="3336157" cy="165219"/>
+            </a:xfrm>
+            <a:prstGeom prst="rect">
+              <a:avLst/>
+            </a:prstGeom>
+            <a:noFill/>
+          </p:spPr>
+          <p:txBody>
+            <a:bodyPr wrap="none" lIns="0" rIns="0" tIns="0" bIns="0" anchor="t">
+              <a:noAutofit/>
+            </a:bodyPr>
+            <a:lstStyle/>
+            <a:p>
+              <a:pPr algn="l">
+                <a:lnSpc>
+                  <a:spcPct val="100000"/>
+                </a:lnSpc>
+              </a:pPr>
+              <a:r>
                 <a:rPr sz="1000" b="0" lang="ko-KR">
                   <a:solidFill>
                     <a:srgbClr val="545B64"/>
@@ -14319,21 +14393,21 @@
                   <a:ea typeface="Malgun Gothic"/>
                   <a:cs typeface="Malgun Gothic"/>
                 </a:rPr>
-                <a:t>Hub &amp; spoke: VPC·VPN은 리전 TGW에 attachment로 연결 · VPC CIDR과 VPN(BGP) 경로는 TGW 라우팅 테이블에 전파</a:t>
-              </a:r>
-            </a:p>
-          </p:txBody>
-        </p:sp>
-        <p:sp>
-          <p:nvSpPr>
-            <p:cNvPr id="61" name="TextBox 60"/>
-            <p:cNvSpPr txBox="1"/>
-            <p:nvPr/>
-          </p:nvSpPr>
-          <p:spPr>
-            <a:xfrm>
-              <a:off x="4762500" y="6275917"/>
-              <a:ext cx="4572000" cy="165100"/>
+                <a:t>VPC·VPN은 리전 TGW에 attachment로 연결</a:t>
+              </a:r>
+            </a:p>
+          </p:txBody>
+        </p:sp>
+        <p:sp>
+          <p:nvSpPr>
+            <p:cNvPr id="63" name="TextBox 62"/>
+            <p:cNvSpPr txBox="1"/>
+            <p:nvPr/>
+          </p:nvSpPr>
+          <p:spPr>
+            <a:xfrm>
+              <a:off x="1565181" y="5102126"/>
+              <a:ext cx="3352044" cy="165219"/>
             </a:xfrm>
             <a:prstGeom prst="rect">
               <a:avLst/>
@@ -14360,21 +14434,21 @@
                   <a:ea typeface="Malgun Gothic"/>
                   <a:cs typeface="Malgun Gothic"/>
                 </a:rPr>
-                <a:t>라우팅: VPC 서브넷 10.0.0.0/8 · 192.168.0.0/16 → TGW</a:t>
-              </a:r>
-            </a:p>
-          </p:txBody>
-        </p:sp>
-        <p:sp>
-          <p:nvSpPr>
-            <p:cNvPr id="62" name="TextBox 61"/>
-            <p:cNvSpPr txBox="1"/>
-            <p:nvPr/>
-          </p:nvSpPr>
-          <p:spPr>
-            <a:xfrm>
-              <a:off x="4762500" y="6445250"/>
-              <a:ext cx="7659688" cy="165100"/>
+                <a:t>VPC CIDR·VPN(BGP) 경로는 TGW RT에 전파</a:t>
+              </a:r>
+            </a:p>
+          </p:txBody>
+        </p:sp>
+        <p:sp>
+          <p:nvSpPr>
+            <p:cNvPr id="64" name="TextBox 63"/>
+            <p:cNvSpPr txBox="1"/>
+            <p:nvPr/>
+          </p:nvSpPr>
+          <p:spPr>
+            <a:xfrm>
+              <a:off x="525147" y="5335128"/>
+              <a:ext cx="1215314" cy="165219"/>
             </a:xfrm>
             <a:prstGeom prst="rect">
               <a:avLst/>
@@ -14393,6 +14467,47 @@
                 </a:lnSpc>
               </a:pPr>
               <a:r>
+                <a:rPr sz="1000" b="1" lang="ko-KR">
+                  <a:solidFill>
+                    <a:srgbClr val="232F3E"/>
+                  </a:solidFill>
+                  <a:latin typeface="Arial"/>
+                  <a:ea typeface="Malgun Gothic"/>
+                  <a:cs typeface="Malgun Gothic"/>
+                </a:rPr>
+                <a:t>VPC 서브넷 RT</a:t>
+              </a:r>
+            </a:p>
+          </p:txBody>
+        </p:sp>
+        <p:sp>
+          <p:nvSpPr>
+            <p:cNvPr id="65" name="TextBox 64"/>
+            <p:cNvSpPr txBox="1"/>
+            <p:nvPr/>
+          </p:nvSpPr>
+          <p:spPr>
+            <a:xfrm>
+              <a:off x="1565181" y="5335128"/>
+              <a:ext cx="3010485" cy="165219"/>
+            </a:xfrm>
+            <a:prstGeom prst="rect">
+              <a:avLst/>
+            </a:prstGeom>
+            <a:noFill/>
+          </p:spPr>
+          <p:txBody>
+            <a:bodyPr wrap="none" lIns="0" rIns="0" tIns="0" bIns="0" anchor="t">
+              <a:noAutofit/>
+            </a:bodyPr>
+            <a:lstStyle/>
+            <a:p>
+              <a:pPr algn="l">
+                <a:lnSpc>
+                  <a:spcPct val="100000"/>
+                </a:lnSpc>
+              </a:pPr>
+              <a:r>
                 <a:rPr sz="1000" b="0" lang="ko-KR">
                   <a:solidFill>
                     <a:srgbClr val="545B64"/>
@@ -14401,7 +14516,212 @@
                   <a:ea typeface="Malgun Gothic"/>
                   <a:cs typeface="Malgun Gothic"/>
                 </a:rPr>
-                <a:t>TGW RT: A 10.16.0.0/13 → peering · B 10.0.0.0/13 · 192.168.0.0/16 → peering (정적 경로)</a:t>
+                <a:t>10.0.0.0/8 · 192.168.0.0/16 → TGW</a:t>
+              </a:r>
+            </a:p>
+          </p:txBody>
+        </p:sp>
+        <p:sp>
+          <p:nvSpPr>
+            <p:cNvPr id="66" name="TextBox 65"/>
+            <p:cNvSpPr txBox="1"/>
+            <p:nvPr/>
+          </p:nvSpPr>
+          <p:spPr>
+            <a:xfrm>
+              <a:off x="525147" y="5568129"/>
+              <a:ext cx="826096" cy="165219"/>
+            </a:xfrm>
+            <a:prstGeom prst="rect">
+              <a:avLst/>
+            </a:prstGeom>
+            <a:noFill/>
+          </p:spPr>
+          <p:txBody>
+            <a:bodyPr wrap="none" lIns="0" rIns="0" tIns="0" bIns="0" anchor="t">
+              <a:noAutofit/>
+            </a:bodyPr>
+            <a:lstStyle/>
+            <a:p>
+              <a:pPr algn="l">
+                <a:lnSpc>
+                  <a:spcPct val="100000"/>
+                </a:lnSpc>
+              </a:pPr>
+              <a:r>
+                <a:rPr sz="1000" b="1" lang="ko-KR">
+                  <a:solidFill>
+                    <a:srgbClr val="232F3E"/>
+                  </a:solidFill>
+                  <a:latin typeface="Arial"/>
+                  <a:ea typeface="Malgun Gothic"/>
+                  <a:cs typeface="Malgun Gothic"/>
+                </a:rPr>
+                <a:t>TGW A RT</a:t>
+              </a:r>
+            </a:p>
+          </p:txBody>
+        </p:sp>
+        <p:sp>
+          <p:nvSpPr>
+            <p:cNvPr id="67" name="TextBox 66"/>
+            <p:cNvSpPr txBox="1"/>
+            <p:nvPr/>
+          </p:nvSpPr>
+          <p:spPr>
+            <a:xfrm>
+              <a:off x="1565181" y="5568129"/>
+              <a:ext cx="2629209" cy="165219"/>
+            </a:xfrm>
+            <a:prstGeom prst="rect">
+              <a:avLst/>
+            </a:prstGeom>
+            <a:noFill/>
+          </p:spPr>
+          <p:txBody>
+            <a:bodyPr wrap="none" lIns="0" rIns="0" tIns="0" bIns="0" anchor="t">
+              <a:noAutofit/>
+            </a:bodyPr>
+            <a:lstStyle/>
+            <a:p>
+              <a:pPr algn="l">
+                <a:lnSpc>
+                  <a:spcPct val="100000"/>
+                </a:lnSpc>
+              </a:pPr>
+              <a:r>
+                <a:rPr sz="1000" b="0" lang="ko-KR">
+                  <a:solidFill>
+                    <a:srgbClr val="545B64"/>
+                  </a:solidFill>
+                  <a:latin typeface="Arial"/>
+                  <a:ea typeface="Malgun Gothic"/>
+                  <a:cs typeface="Malgun Gothic"/>
+                </a:rPr>
+                <a:t>10.16.0.0/13 → peering (정적)</a:t>
+              </a:r>
+            </a:p>
+          </p:txBody>
+        </p:sp>
+        <p:sp>
+          <p:nvSpPr>
+            <p:cNvPr id="68" name="TextBox 67"/>
+            <p:cNvSpPr txBox="1"/>
+            <p:nvPr/>
+          </p:nvSpPr>
+          <p:spPr>
+            <a:xfrm>
+              <a:off x="525147" y="5801131"/>
+              <a:ext cx="826096" cy="165219"/>
+            </a:xfrm>
+            <a:prstGeom prst="rect">
+              <a:avLst/>
+            </a:prstGeom>
+            <a:noFill/>
+          </p:spPr>
+          <p:txBody>
+            <a:bodyPr wrap="none" lIns="0" rIns="0" tIns="0" bIns="0" anchor="t">
+              <a:noAutofit/>
+            </a:bodyPr>
+            <a:lstStyle/>
+            <a:p>
+              <a:pPr algn="l">
+                <a:lnSpc>
+                  <a:spcPct val="100000"/>
+                </a:lnSpc>
+              </a:pPr>
+              <a:r>
+                <a:rPr sz="1000" b="1" lang="ko-KR">
+                  <a:solidFill>
+                    <a:srgbClr val="232F3E"/>
+                  </a:solidFill>
+                  <a:latin typeface="Arial"/>
+                  <a:ea typeface="Malgun Gothic"/>
+                  <a:cs typeface="Malgun Gothic"/>
+                </a:rPr>
+                <a:t>TGW B RT</a:t>
+              </a:r>
+            </a:p>
+          </p:txBody>
+        </p:sp>
+        <p:sp>
+          <p:nvSpPr>
+            <p:cNvPr id="69" name="TextBox 68"/>
+            <p:cNvSpPr txBox="1"/>
+            <p:nvPr/>
+          </p:nvSpPr>
+          <p:spPr>
+            <a:xfrm>
+              <a:off x="1565181" y="5801131"/>
+              <a:ext cx="2573607" cy="165219"/>
+            </a:xfrm>
+            <a:prstGeom prst="rect">
+              <a:avLst/>
+            </a:prstGeom>
+            <a:noFill/>
+          </p:spPr>
+          <p:txBody>
+            <a:bodyPr wrap="none" lIns="0" rIns="0" tIns="0" bIns="0" anchor="t">
+              <a:noAutofit/>
+            </a:bodyPr>
+            <a:lstStyle/>
+            <a:p>
+              <a:pPr algn="l">
+                <a:lnSpc>
+                  <a:spcPct val="100000"/>
+                </a:lnSpc>
+              </a:pPr>
+              <a:r>
+                <a:rPr sz="1000" b="0" lang="ko-KR">
+                  <a:solidFill>
+                    <a:srgbClr val="545B64"/>
+                  </a:solidFill>
+                  <a:latin typeface="Arial"/>
+                  <a:ea typeface="Malgun Gothic"/>
+                  <a:cs typeface="Malgun Gothic"/>
+                </a:rPr>
+                <a:t>10.0.0.0/13 · 192.168.0.0/16</a:t>
+              </a:r>
+            </a:p>
+          </p:txBody>
+        </p:sp>
+        <p:sp>
+          <p:nvSpPr>
+            <p:cNvPr id="70" name="TextBox 69"/>
+            <p:cNvSpPr txBox="1"/>
+            <p:nvPr/>
+          </p:nvSpPr>
+          <p:spPr>
+            <a:xfrm>
+              <a:off x="1565181" y="5970586"/>
+              <a:ext cx="1493327" cy="165219"/>
+            </a:xfrm>
+            <a:prstGeom prst="rect">
+              <a:avLst/>
+            </a:prstGeom>
+            <a:noFill/>
+          </p:spPr>
+          <p:txBody>
+            <a:bodyPr wrap="none" lIns="0" rIns="0" tIns="0" bIns="0" anchor="t">
+              <a:noAutofit/>
+            </a:bodyPr>
+            <a:lstStyle/>
+            <a:p>
+              <a:pPr algn="l">
+                <a:lnSpc>
+                  <a:spcPct val="100000"/>
+                </a:lnSpc>
+              </a:pPr>
+              <a:r>
+                <a:rPr sz="1000" b="0" lang="ko-KR">
+                  <a:solidFill>
+                    <a:srgbClr val="545B64"/>
+                  </a:solidFill>
+                  <a:latin typeface="Arial"/>
+                  <a:ea typeface="Malgun Gothic"/>
+                  <a:cs typeface="Malgun Gothic"/>
+                </a:rPr>
+                <a:t>→ peering (정적)</a:t>
               </a:r>
             </a:p>
           </p:txBody>

</xml_diff>

<commit_message>
Place the note panel at the bottom of every document diagram across the full canvas width with a 16px margin each side, so it sits in the same place everywhere
Co-Authored-By: Claude Opus 5.5 <noreply@anthropic.com>
</commit_message>
<xml_diff>
--- a/docs/examples/reference-architectures.pptx
+++ b/docs/examples/reference-architectures.pptx
@@ -12279,10 +12279,10 @@
         </p:nvGrpSpPr>
         <p:grpSpPr>
           <a:xfrm>
-            <a:off x="398056" y="1304203"/>
-            <a:ext cx="11395888" cy="4935394"/>
-            <a:chOff x="398056" y="1304203"/>
-            <a:chExt cx="11395888" cy="4935394"/>
+            <a:off x="402167" y="1083733"/>
+            <a:ext cx="13337646" cy="5526617"/>
+            <a:chOff x="402167" y="1083733"/>
+            <a:chExt cx="13337646" cy="5526617"/>
           </a:xfrm>
         </p:grpSpPr>
         <p:sp>
@@ -12293,14 +12293,14 @@
           </p:nvSpPr>
           <p:spPr>
             <a:xfrm>
-              <a:off x="398056" y="3210578"/>
-              <a:ext cx="1821648" cy="1398009"/>
-            </a:xfrm>
-            <a:prstGeom prst="rect">
-              <a:avLst/>
-            </a:prstGeom>
-            <a:noFill/>
-            <a:ln w="21182">
+              <a:off x="402167" y="2988733"/>
+              <a:ext cx="1820333" cy="1397000"/>
+            </a:xfrm>
+            <a:prstGeom prst="rect">
+              <a:avLst/>
+            </a:prstGeom>
+            <a:noFill/>
+            <a:ln w="21167">
               <a:solidFill>
                 <a:srgbClr val="7D8998"/>
               </a:solidFill>
@@ -12338,8 +12338,8 @@
           </p:blipFill>
           <p:spPr>
             <a:xfrm>
-              <a:off x="398056" y="3210578"/>
-              <a:ext cx="254183" cy="254183"/>
+              <a:off x="402167" y="2988733"/>
+              <a:ext cx="254000" cy="254000"/>
             </a:xfrm>
             <a:prstGeom prst="rect">
               <a:avLst/>
@@ -12354,8 +12354,8 @@
           </p:nvSpPr>
           <p:spPr>
             <a:xfrm>
-              <a:off x="736967" y="3260356"/>
-              <a:ext cx="1269593" cy="192756"/>
+              <a:off x="740833" y="3038475"/>
+              <a:ext cx="1268677" cy="192617"/>
             </a:xfrm>
             <a:prstGeom prst="rect">
               <a:avLst/>
@@ -12374,7 +12374,7 @@
                 </a:lnSpc>
               </a:pPr>
               <a:r>
-                <a:rPr sz="1167" b="1" lang="ko-KR">
+                <a:rPr sz="1166" b="1" lang="ko-KR">
                   <a:solidFill>
                     <a:srgbClr val="7D8998"/>
                   </a:solidFill>
@@ -12409,8 +12409,8 @@
           </p:blipFill>
           <p:spPr>
             <a:xfrm>
-              <a:off x="1054696" y="3570671"/>
-              <a:ext cx="508367" cy="508367"/>
+              <a:off x="1058333" y="3348567"/>
+              <a:ext cx="508000" cy="508000"/>
             </a:xfrm>
             <a:prstGeom prst="rect">
               <a:avLst/>
@@ -12425,8 +12425,8 @@
           </p:nvSpPr>
           <p:spPr>
             <a:xfrm>
-              <a:off x="419238" y="4128816"/>
-              <a:ext cx="1779284" cy="192756"/>
+              <a:off x="423333" y="3906308"/>
+              <a:ext cx="1778000" cy="192617"/>
             </a:xfrm>
             <a:prstGeom prst="rect">
               <a:avLst/>
@@ -12445,7 +12445,7 @@
                 </a:lnSpc>
               </a:pPr>
               <a:r>
-                <a:rPr sz="1167" b="0" lang="ko-KR">
+                <a:rPr sz="1166" b="0" lang="ko-KR">
                   <a:solidFill>
                     <a:srgbClr val="232F3E"/>
                   </a:solidFill>
@@ -12466,8 +12466,8 @@
           </p:nvSpPr>
           <p:spPr>
             <a:xfrm>
-              <a:off x="633705" y="4318394"/>
-              <a:ext cx="1350349" cy="165219"/>
+              <a:off x="637646" y="4095750"/>
+              <a:ext cx="1349375" cy="165100"/>
             </a:xfrm>
             <a:prstGeom prst="rect">
               <a:avLst/>
@@ -12521,8 +12521,8 @@
           </p:blipFill>
           <p:spPr>
             <a:xfrm>
-              <a:off x="2579796" y="3570671"/>
-              <a:ext cx="508367" cy="508367"/>
+              <a:off x="2582333" y="3348567"/>
+              <a:ext cx="508000" cy="508000"/>
             </a:xfrm>
             <a:prstGeom prst="rect">
               <a:avLst/>
@@ -12537,8 +12537,8 @@
           </p:nvSpPr>
           <p:spPr>
             <a:xfrm>
-              <a:off x="2352090" y="4128816"/>
-              <a:ext cx="963779" cy="192756"/>
+              <a:off x="2354792" y="3906308"/>
+              <a:ext cx="963083" cy="192617"/>
             </a:xfrm>
             <a:prstGeom prst="rect">
               <a:avLst/>
@@ -12557,7 +12557,7 @@
                 </a:lnSpc>
               </a:pPr>
               <a:r>
-                <a:rPr sz="1167" b="0" lang="ko-KR">
+                <a:rPr sz="1166" b="0" lang="ko-KR">
                   <a:solidFill>
                     <a:srgbClr val="232F3E"/>
                   </a:solidFill>
@@ -12578,13 +12578,13 @@
           </p:nvCxnSpPr>
           <p:spPr>
             <a:xfrm>
-              <a:off x="1605427" y="3824855"/>
-              <a:ext cx="932005" cy="0"/>
+              <a:off x="1608667" y="3602567"/>
+              <a:ext cx="931333" cy="0"/>
             </a:xfrm>
             <a:prstGeom prst="line">
               <a:avLst/>
             </a:prstGeom>
-            <a:ln w="15886">
+            <a:ln w="15875">
               <a:solidFill>
                 <a:srgbClr val="232F3E"/>
               </a:solidFill>
@@ -12601,13 +12601,13 @@
           </p:nvCxnSpPr>
           <p:spPr>
             <a:xfrm>
-              <a:off x="3130527" y="3824855"/>
-              <a:ext cx="529549" cy="0"/>
+              <a:off x="3132667" y="3602567"/>
+              <a:ext cx="529166" cy="0"/>
             </a:xfrm>
             <a:prstGeom prst="line">
               <a:avLst/>
             </a:prstGeom>
-            <a:ln w="15886">
+            <a:ln w="15875">
               <a:solidFill>
                 <a:srgbClr val="232F3E"/>
               </a:solidFill>
@@ -12624,8 +12624,8 @@
           </p:nvSpPr>
           <p:spPr>
             <a:xfrm>
-              <a:off x="3113317" y="3608799"/>
-              <a:ext cx="563969" cy="165219"/>
+              <a:off x="3115469" y="3386667"/>
+              <a:ext cx="563562" cy="165100"/>
             </a:xfrm>
             <a:prstGeom prst="rect">
               <a:avLst/>
@@ -12679,8 +12679,8 @@
           </p:blipFill>
           <p:spPr>
             <a:xfrm>
-              <a:off x="3702440" y="3570671"/>
-              <a:ext cx="508367" cy="508367"/>
+              <a:off x="3704167" y="3348567"/>
+              <a:ext cx="508000" cy="508000"/>
             </a:xfrm>
             <a:prstGeom prst="rect">
               <a:avLst/>
@@ -12695,8 +12695,8 @@
           </p:nvSpPr>
           <p:spPr>
             <a:xfrm>
-              <a:off x="3066981" y="4128816"/>
-              <a:ext cx="1779284" cy="192756"/>
+              <a:off x="3069167" y="3906308"/>
+              <a:ext cx="1778000" cy="192617"/>
             </a:xfrm>
             <a:prstGeom prst="rect">
               <a:avLst/>
@@ -12715,7 +12715,7 @@
                 </a:lnSpc>
               </a:pPr>
               <a:r>
-                <a:rPr sz="1167" b="0" lang="ko-KR">
+                <a:rPr sz="1166" b="0" lang="ko-KR">
                   <a:solidFill>
                     <a:srgbClr val="232F3E"/>
                   </a:solidFill>
@@ -12736,13 +12736,13 @@
           </p:nvCxnSpPr>
           <p:spPr>
             <a:xfrm>
-              <a:off x="4253170" y="3824855"/>
-              <a:ext cx="1821648" cy="0"/>
+              <a:off x="4254500" y="3602567"/>
+              <a:ext cx="1820333" cy="0"/>
             </a:xfrm>
             <a:prstGeom prst="line">
               <a:avLst/>
             </a:prstGeom>
-            <a:ln w="15886">
+            <a:ln w="15875">
               <a:solidFill>
                 <a:srgbClr val="232F3E"/>
               </a:solidFill>
@@ -12759,14 +12759,14 @@
           </p:nvSpPr>
           <p:spPr>
             <a:xfrm>
-              <a:off x="4761537" y="1304203"/>
-              <a:ext cx="7032407" cy="4935394"/>
-            </a:xfrm>
-            <a:prstGeom prst="rect">
-              <a:avLst/>
-            </a:prstGeom>
-            <a:noFill/>
-            <a:ln w="21182">
+              <a:off x="4762500" y="1083733"/>
+              <a:ext cx="7027333" cy="4931833"/>
+            </a:xfrm>
+            <a:prstGeom prst="rect">
+              <a:avLst/>
+            </a:prstGeom>
+            <a:noFill/>
+            <a:ln w="21167">
               <a:solidFill>
                 <a:srgbClr val="232F3E"/>
               </a:solidFill>
@@ -12804,8 +12804,8 @@
           </p:blipFill>
           <p:spPr>
             <a:xfrm>
-              <a:off x="4761537" y="1304203"/>
-              <a:ext cx="338911" cy="338911"/>
+              <a:off x="4762500" y="1083733"/>
+              <a:ext cx="338667" cy="338667"/>
             </a:xfrm>
             <a:prstGeom prst="rect">
               <a:avLst/>
@@ -12820,8 +12820,8 @@
           </p:nvSpPr>
           <p:spPr>
             <a:xfrm>
-              <a:off x="5206358" y="1386283"/>
-              <a:ext cx="1141839" cy="206524"/>
+              <a:off x="5207000" y="1165754"/>
+              <a:ext cx="1141016" cy="206375"/>
             </a:xfrm>
             <a:prstGeom prst="rect">
               <a:avLst/>
@@ -12861,14 +12861,14 @@
           </p:nvSpPr>
           <p:spPr>
             <a:xfrm>
-              <a:off x="4973357" y="1727842"/>
-              <a:ext cx="3050201" cy="4299936"/>
-            </a:xfrm>
-            <a:prstGeom prst="rect">
-              <a:avLst/>
-            </a:prstGeom>
-            <a:noFill/>
-            <a:ln w="21182">
+              <a:off x="4974167" y="1507067"/>
+              <a:ext cx="3048000" cy="4296833"/>
+            </a:xfrm>
+            <a:prstGeom prst="rect">
+              <a:avLst/>
+            </a:prstGeom>
+            <a:noFill/>
+            <a:ln w="21167">
               <a:solidFill>
                 <a:srgbClr val="00A4A6"/>
               </a:solidFill>
@@ -12908,8 +12908,8 @@
           </p:blipFill>
           <p:spPr>
             <a:xfrm>
-              <a:off x="4973357" y="1727842"/>
-              <a:ext cx="254183" cy="254183"/>
+              <a:off x="4974167" y="1507067"/>
+              <a:ext cx="254000" cy="254000"/>
             </a:xfrm>
             <a:prstGeom prst="rect">
               <a:avLst/>
@@ -12924,8 +12924,8 @@
           </p:nvSpPr>
           <p:spPr>
             <a:xfrm>
-              <a:off x="5312268" y="1777619"/>
-              <a:ext cx="2288974" cy="192756"/>
+              <a:off x="5312833" y="1556808"/>
+              <a:ext cx="2287323" cy="192617"/>
             </a:xfrm>
             <a:prstGeom prst="rect">
               <a:avLst/>
@@ -12944,7 +12944,7 @@
                 </a:lnSpc>
               </a:pPr>
               <a:r>
-                <a:rPr sz="1167" b="1" lang="ko-KR">
+                <a:rPr sz="1166" b="1" lang="ko-KR">
                   <a:solidFill>
                     <a:srgbClr val="00A4A6"/>
                   </a:solidFill>
@@ -12979,8 +12979,8 @@
           </p:blipFill>
           <p:spPr>
             <a:xfrm>
-              <a:off x="6117182" y="3570671"/>
-              <a:ext cx="508367" cy="508367"/>
+              <a:off x="6117167" y="3348567"/>
+              <a:ext cx="508000" cy="508000"/>
             </a:xfrm>
             <a:prstGeom prst="rect">
               <a:avLst/>
@@ -12995,8 +12995,8 @@
           </p:nvSpPr>
           <p:spPr>
             <a:xfrm>
-              <a:off x="5430754" y="4128816"/>
-              <a:ext cx="1881222" cy="192756"/>
+              <a:off x="5431234" y="3906308"/>
+              <a:ext cx="1879865" cy="192617"/>
             </a:xfrm>
             <a:prstGeom prst="rect">
               <a:avLst/>
@@ -13015,7 +13015,7 @@
                 </a:lnSpc>
               </a:pPr>
               <a:r>
-                <a:rPr sz="1167" b="0" lang="ko-KR">
+                <a:rPr sz="1166" b="0" lang="ko-KR">
                   <a:solidFill>
                     <a:srgbClr val="232F3E"/>
                   </a:solidFill>
@@ -13050,8 +13050,8 @@
           </p:blipFill>
           <p:spPr>
             <a:xfrm>
-              <a:off x="5481723" y="2151481"/>
-              <a:ext cx="508367" cy="508367"/>
+              <a:off x="5482167" y="1930400"/>
+              <a:ext cx="508000" cy="508000"/>
             </a:xfrm>
             <a:prstGeom prst="rect">
               <a:avLst/>
@@ -13066,8 +13066,8 @@
           </p:nvSpPr>
           <p:spPr>
             <a:xfrm>
-              <a:off x="5050141" y="2709625"/>
-              <a:ext cx="1371531" cy="192756"/>
+              <a:off x="5050896" y="2488142"/>
+              <a:ext cx="1370542" cy="192617"/>
             </a:xfrm>
             <a:prstGeom prst="rect">
               <a:avLst/>
@@ -13086,7 +13086,7 @@
                 </a:lnSpc>
               </a:pPr>
               <a:r>
-                <a:rPr sz="1167" b="0" lang="ko-KR">
+                <a:rPr sz="1166" b="0" lang="ko-KR">
                   <a:solidFill>
                     <a:srgbClr val="232F3E"/>
                   </a:solidFill>
@@ -13107,8 +13107,8 @@
           </p:nvSpPr>
           <p:spPr>
             <a:xfrm>
-              <a:off x="5191796" y="2899204"/>
-              <a:ext cx="1088223" cy="165219"/>
+              <a:off x="5192448" y="2677583"/>
+              <a:ext cx="1087438" cy="165100"/>
             </a:xfrm>
             <a:prstGeom prst="rect">
               <a:avLst/>
@@ -13162,8 +13162,8 @@
           </p:blipFill>
           <p:spPr>
             <a:xfrm>
-              <a:off x="6752640" y="2151481"/>
-              <a:ext cx="508367" cy="508367"/>
+              <a:off x="6752167" y="1930400"/>
+              <a:ext cx="508000" cy="508000"/>
             </a:xfrm>
             <a:prstGeom prst="rect">
               <a:avLst/>
@@ -13178,8 +13178,8 @@
           </p:nvSpPr>
           <p:spPr>
             <a:xfrm>
-              <a:off x="6524934" y="2709625"/>
-              <a:ext cx="963779" cy="192756"/>
+              <a:off x="6524625" y="2488142"/>
+              <a:ext cx="963083" cy="192617"/>
             </a:xfrm>
             <a:prstGeom prst="rect">
               <a:avLst/>
@@ -13198,7 +13198,7 @@
                 </a:lnSpc>
               </a:pPr>
               <a:r>
-                <a:rPr sz="1167" b="0" lang="ko-KR">
+                <a:rPr sz="1166" b="0" lang="ko-KR">
                   <a:solidFill>
                     <a:srgbClr val="232F3E"/>
                   </a:solidFill>
@@ -13219,8 +13219,8 @@
           </p:nvSpPr>
           <p:spPr>
             <a:xfrm>
-              <a:off x="6462712" y="2899204"/>
-              <a:ext cx="1088223" cy="165219"/>
+              <a:off x="6462448" y="2677583"/>
+              <a:ext cx="1087438" cy="165100"/>
             </a:xfrm>
             <a:prstGeom prst="rect">
               <a:avLst/>
@@ -13274,8 +13274,8 @@
           </p:blipFill>
           <p:spPr>
             <a:xfrm>
-              <a:off x="5481723" y="4989862"/>
-              <a:ext cx="508367" cy="508367"/>
+              <a:off x="5482167" y="4766733"/>
+              <a:ext cx="508000" cy="508000"/>
             </a:xfrm>
             <a:prstGeom prst="rect">
               <a:avLst/>
@@ -13290,8 +13290,8 @@
           </p:nvSpPr>
           <p:spPr>
             <a:xfrm>
-              <a:off x="5304987" y="5548006"/>
-              <a:ext cx="861841" cy="192756"/>
+              <a:off x="5305557" y="5324475"/>
+              <a:ext cx="861219" cy="192617"/>
             </a:xfrm>
             <a:prstGeom prst="rect">
               <a:avLst/>
@@ -13310,7 +13310,7 @@
                 </a:lnSpc>
               </a:pPr>
               <a:r>
-                <a:rPr sz="1167" b="0" lang="ko-KR">
+                <a:rPr sz="1166" b="0" lang="ko-KR">
                   <a:solidFill>
                     <a:srgbClr val="232F3E"/>
                   </a:solidFill>
@@ -13331,8 +13331,8 @@
           </p:nvSpPr>
           <p:spPr>
             <a:xfrm>
-              <a:off x="5191796" y="5737585"/>
-              <a:ext cx="1088223" cy="165219"/>
+              <a:off x="5192448" y="5513917"/>
+              <a:ext cx="1087438" cy="165100"/>
             </a:xfrm>
             <a:prstGeom prst="rect">
               <a:avLst/>
@@ -13386,8 +13386,8 @@
           </p:blipFill>
           <p:spPr>
             <a:xfrm>
-              <a:off x="6752640" y="4989862"/>
-              <a:ext cx="508367" cy="508367"/>
+              <a:off x="6752167" y="4766733"/>
+              <a:ext cx="508000" cy="508000"/>
             </a:xfrm>
             <a:prstGeom prst="rect">
               <a:avLst/>
@@ -13402,8 +13402,8 @@
           </p:nvSpPr>
           <p:spPr>
             <a:xfrm>
-              <a:off x="6524934" y="5548006"/>
-              <a:ext cx="963779" cy="192756"/>
+              <a:off x="6524625" y="5324475"/>
+              <a:ext cx="963083" cy="192617"/>
             </a:xfrm>
             <a:prstGeom prst="rect">
               <a:avLst/>
@@ -13422,7 +13422,7 @@
                 </a:lnSpc>
               </a:pPr>
               <a:r>
-                <a:rPr sz="1167" b="0" lang="ko-KR">
+                <a:rPr sz="1166" b="0" lang="ko-KR">
                   <a:solidFill>
                     <a:srgbClr val="232F3E"/>
                   </a:solidFill>
@@ -13443,8 +13443,8 @@
           </p:nvSpPr>
           <p:spPr>
             <a:xfrm>
-              <a:off x="6462712" y="5737585"/>
-              <a:ext cx="1088223" cy="165219"/>
+              <a:off x="6462448" y="5513917"/>
+              <a:ext cx="1087438" cy="165100"/>
             </a:xfrm>
             <a:prstGeom prst="rect">
               <a:avLst/>
@@ -13484,8 +13484,8 @@
           </p:nvSpPr>
           <p:spPr>
             <a:xfrm>
-              <a:off x="5735907" y="3104669"/>
-              <a:ext cx="529549" cy="423639"/>
+              <a:off x="5736167" y="2882900"/>
+              <a:ext cx="529166" cy="423333"/>
             </a:xfrm>
             <a:custGeom>
               <a:avLst/>
@@ -13494,15 +13494,15 @@
               <a:cxnLst/>
               <a:rect l="l" t="t" r="r" b="b"/>
               <a:pathLst>
-                <a:path w="529549" h="423639">
+                <a:path w="529166" h="423333">
                   <a:moveTo>
-                    <a:pt x="529549" y="423639"/>
+                    <a:pt x="529166" y="423333"/>
                   </a:moveTo>
                   <a:lnTo>
-                    <a:pt x="529549" y="211819"/>
+                    <a:pt x="529166" y="211667"/>
                   </a:lnTo>
                   <a:lnTo>
-                    <a:pt x="0" y="211819"/>
+                    <a:pt x="0" y="211667"/>
                   </a:lnTo>
                   <a:lnTo>
                     <a:pt x="0" y="0"/>
@@ -13511,7 +13511,7 @@
               </a:pathLst>
             </a:custGeom>
             <a:noFill/>
-            <a:ln w="15886">
+            <a:ln w="15875">
               <a:solidFill>
                 <a:srgbClr val="232F3E"/>
               </a:solidFill>
@@ -13535,8 +13535,8 @@
           </p:nvSpPr>
           <p:spPr>
             <a:xfrm>
-              <a:off x="6477275" y="3104669"/>
-              <a:ext cx="529549" cy="423639"/>
+              <a:off x="6477000" y="2882900"/>
+              <a:ext cx="529167" cy="423333"/>
             </a:xfrm>
             <a:custGeom>
               <a:avLst/>
@@ -13545,24 +13545,24 @@
               <a:cxnLst/>
               <a:rect l="l" t="t" r="r" b="b"/>
               <a:pathLst>
-                <a:path w="529549" h="423639">
+                <a:path w="529167" h="423333">
                   <a:moveTo>
-                    <a:pt x="0" y="423639"/>
+                    <a:pt x="0" y="423333"/>
                   </a:moveTo>
                   <a:lnTo>
-                    <a:pt x="0" y="211819"/>
+                    <a:pt x="0" y="211667"/>
                   </a:lnTo>
                   <a:lnTo>
-                    <a:pt x="529549" y="211819"/>
+                    <a:pt x="529167" y="211667"/>
                   </a:lnTo>
                   <a:lnTo>
-                    <a:pt x="529549" y="0"/>
+                    <a:pt x="529167" y="0"/>
                   </a:lnTo>
                 </a:path>
               </a:pathLst>
             </a:custGeom>
             <a:noFill/>
-            <a:ln w="15886">
+            <a:ln w="15875">
               <a:solidFill>
                 <a:srgbClr val="232F3E"/>
               </a:solidFill>
@@ -13586,8 +13586,8 @@
           </p:nvSpPr>
           <p:spPr>
             <a:xfrm>
-              <a:off x="5735907" y="4354404"/>
-              <a:ext cx="529549" cy="593094"/>
+              <a:off x="5736167" y="4131733"/>
+              <a:ext cx="529166" cy="592667"/>
             </a:xfrm>
             <a:custGeom>
               <a:avLst/>
@@ -13596,24 +13596,24 @@
               <a:cxnLst/>
               <a:rect l="l" t="t" r="r" b="b"/>
               <a:pathLst>
-                <a:path w="529549" h="593094">
+                <a:path w="529166" h="592667">
                   <a:moveTo>
-                    <a:pt x="529549" y="0"/>
+                    <a:pt x="529166" y="0"/>
                   </a:moveTo>
                   <a:lnTo>
-                    <a:pt x="529549" y="296547"/>
+                    <a:pt x="529166" y="296334"/>
                   </a:lnTo>
                   <a:lnTo>
-                    <a:pt x="0" y="296547"/>
+                    <a:pt x="0" y="296334"/>
                   </a:lnTo>
                   <a:lnTo>
-                    <a:pt x="0" y="593094"/>
+                    <a:pt x="0" y="592667"/>
                   </a:lnTo>
                 </a:path>
               </a:pathLst>
             </a:custGeom>
             <a:noFill/>
-            <a:ln w="15886">
+            <a:ln w="15875">
               <a:solidFill>
                 <a:srgbClr val="232F3E"/>
               </a:solidFill>
@@ -13637,8 +13637,8 @@
           </p:nvSpPr>
           <p:spPr>
             <a:xfrm>
-              <a:off x="6477275" y="4354404"/>
-              <a:ext cx="529549" cy="593094"/>
+              <a:off x="6477000" y="4131733"/>
+              <a:ext cx="529167" cy="592667"/>
             </a:xfrm>
             <a:custGeom>
               <a:avLst/>
@@ -13647,24 +13647,24 @@
               <a:cxnLst/>
               <a:rect l="l" t="t" r="r" b="b"/>
               <a:pathLst>
-                <a:path w="529549" h="593094">
+                <a:path w="529167" h="592667">
                   <a:moveTo>
                     <a:pt x="0" y="0"/>
                   </a:moveTo>
                   <a:lnTo>
-                    <a:pt x="0" y="296547"/>
+                    <a:pt x="0" y="296334"/>
                   </a:lnTo>
                   <a:lnTo>
-                    <a:pt x="529549" y="296547"/>
+                    <a:pt x="529167" y="296334"/>
                   </a:lnTo>
                   <a:lnTo>
-                    <a:pt x="529549" y="593094"/>
+                    <a:pt x="529167" y="592667"/>
                   </a:lnTo>
                 </a:path>
               </a:pathLst>
             </a:custGeom>
             <a:noFill/>
-            <a:ln w="15886">
+            <a:ln w="15875">
               <a:solidFill>
                 <a:srgbClr val="232F3E"/>
               </a:solidFill>
@@ -13688,14 +13688,14 @@
           </p:nvSpPr>
           <p:spPr>
             <a:xfrm>
-              <a:off x="9125019" y="1727842"/>
-              <a:ext cx="2457106" cy="4299936"/>
-            </a:xfrm>
-            <a:prstGeom prst="rect">
-              <a:avLst/>
-            </a:prstGeom>
-            <a:noFill/>
-            <a:ln w="21182">
+              <a:off x="9122833" y="1507067"/>
+              <a:ext cx="2455333" cy="4296833"/>
+            </a:xfrm>
+            <a:prstGeom prst="rect">
+              <a:avLst/>
+            </a:prstGeom>
+            <a:noFill/>
+            <a:ln w="21167">
               <a:solidFill>
                 <a:srgbClr val="00A4A6"/>
               </a:solidFill>
@@ -13735,8 +13735,8 @@
           </p:blipFill>
           <p:spPr>
             <a:xfrm>
-              <a:off x="9125019" y="1727842"/>
-              <a:ext cx="254183" cy="254183"/>
+              <a:off x="9122833" y="1507067"/>
+              <a:ext cx="254000" cy="254000"/>
             </a:xfrm>
             <a:prstGeom prst="rect">
               <a:avLst/>
@@ -13751,8 +13751,8 @@
           </p:nvSpPr>
           <p:spPr>
             <a:xfrm>
-              <a:off x="9463930" y="1777619"/>
-              <a:ext cx="2288974" cy="192756"/>
+              <a:off x="9461500" y="1556808"/>
+              <a:ext cx="2287323" cy="192617"/>
             </a:xfrm>
             <a:prstGeom prst="rect">
               <a:avLst/>
@@ -13771,7 +13771,7 @@
                 </a:lnSpc>
               </a:pPr>
               <a:r>
-                <a:rPr sz="1167" b="1" lang="ko-KR">
+                <a:rPr sz="1166" b="1" lang="ko-KR">
                   <a:solidFill>
                     <a:srgbClr val="00A4A6"/>
                   </a:solidFill>
@@ -13806,8 +13806,8 @@
           </p:blipFill>
           <p:spPr>
             <a:xfrm>
-              <a:off x="10057025" y="3570671"/>
-              <a:ext cx="508367" cy="508367"/>
+              <a:off x="10054167" y="3348567"/>
+              <a:ext cx="508000" cy="508000"/>
             </a:xfrm>
             <a:prstGeom prst="rect">
               <a:avLst/>
@@ -13822,8 +13822,8 @@
           </p:nvSpPr>
           <p:spPr>
             <a:xfrm>
-              <a:off x="9370597" y="4128816"/>
-              <a:ext cx="1881222" cy="192756"/>
+              <a:off x="9368234" y="3906308"/>
+              <a:ext cx="1879865" cy="192617"/>
             </a:xfrm>
             <a:prstGeom prst="rect">
               <a:avLst/>
@@ -13842,7 +13842,7 @@
                 </a:lnSpc>
               </a:pPr>
               <a:r>
-                <a:rPr sz="1167" b="0" lang="ko-KR">
+                <a:rPr sz="1166" b="0" lang="ko-KR">
                   <a:solidFill>
                     <a:srgbClr val="232F3E"/>
                   </a:solidFill>
@@ -13877,8 +13877,8 @@
           </p:blipFill>
           <p:spPr>
             <a:xfrm>
-              <a:off x="10057025" y="2151481"/>
-              <a:ext cx="508367" cy="508367"/>
+              <a:off x="10054167" y="1930400"/>
+              <a:ext cx="508000" cy="508000"/>
             </a:xfrm>
             <a:prstGeom prst="rect">
               <a:avLst/>
@@ -13893,8 +13893,8 @@
           </p:nvSpPr>
           <p:spPr>
             <a:xfrm>
-              <a:off x="9931257" y="2709625"/>
-              <a:ext cx="759902" cy="192756"/>
+              <a:off x="9928490" y="2488142"/>
+              <a:ext cx="759354" cy="192617"/>
             </a:xfrm>
             <a:prstGeom prst="rect">
               <a:avLst/>
@@ -13913,7 +13913,7 @@
                 </a:lnSpc>
               </a:pPr>
               <a:r>
-                <a:rPr sz="1167" b="0" lang="ko-KR">
+                <a:rPr sz="1166" b="0" lang="ko-KR">
                   <a:solidFill>
                     <a:srgbClr val="232F3E"/>
                   </a:solidFill>
@@ -13934,8 +13934,8 @@
           </p:nvSpPr>
           <p:spPr>
             <a:xfrm>
-              <a:off x="9723409" y="2899204"/>
-              <a:ext cx="1175598" cy="165219"/>
+              <a:off x="9720792" y="2677583"/>
+              <a:ext cx="1174750" cy="165100"/>
             </a:xfrm>
             <a:prstGeom prst="rect">
               <a:avLst/>
@@ -13989,8 +13989,8 @@
           </p:blipFill>
           <p:spPr>
             <a:xfrm>
-              <a:off x="10057025" y="4989862"/>
-              <a:ext cx="508367" cy="508367"/>
+              <a:off x="10054167" y="4766733"/>
+              <a:ext cx="508000" cy="508000"/>
             </a:xfrm>
             <a:prstGeom prst="rect">
               <a:avLst/>
@@ -14005,8 +14005,8 @@
           </p:nvSpPr>
           <p:spPr>
             <a:xfrm>
-              <a:off x="9574473" y="5548006"/>
-              <a:ext cx="1473469" cy="192756"/>
+              <a:off x="9571964" y="5324475"/>
+              <a:ext cx="1472406" cy="192617"/>
             </a:xfrm>
             <a:prstGeom prst="rect">
               <a:avLst/>
@@ -14025,7 +14025,7 @@
                 </a:lnSpc>
               </a:pPr>
               <a:r>
-                <a:rPr sz="1167" b="0" lang="ko-KR">
+                <a:rPr sz="1166" b="0" lang="ko-KR">
                   <a:solidFill>
                     <a:srgbClr val="232F3E"/>
                   </a:solidFill>
@@ -14046,8 +14046,8 @@
           </p:nvSpPr>
           <p:spPr>
             <a:xfrm>
-              <a:off x="9723409" y="5737585"/>
-              <a:ext cx="1175598" cy="165219"/>
+              <a:off x="9720792" y="5513917"/>
+              <a:ext cx="1174750" cy="165100"/>
             </a:xfrm>
             <a:prstGeom prst="rect">
               <a:avLst/>
@@ -14087,13 +14087,13 @@
           </p:nvCxnSpPr>
           <p:spPr>
             <a:xfrm flipV="1">
-              <a:off x="10311208" y="3104669"/>
-              <a:ext cx="0" cy="423639"/>
+              <a:off x="10308167" y="2882900"/>
+              <a:ext cx="0" cy="423333"/>
             </a:xfrm>
             <a:prstGeom prst="line">
               <a:avLst/>
             </a:prstGeom>
-            <a:ln w="15886">
+            <a:ln w="15875">
               <a:solidFill>
                 <a:srgbClr val="232F3E"/>
               </a:solidFill>
@@ -14110,13 +14110,13 @@
           </p:nvCxnSpPr>
           <p:spPr>
             <a:xfrm>
-              <a:off x="10311208" y="4354404"/>
-              <a:ext cx="0" cy="593094"/>
+              <a:off x="10308167" y="4131733"/>
+              <a:ext cx="0" cy="592667"/>
             </a:xfrm>
             <a:prstGeom prst="line">
               <a:avLst/>
             </a:prstGeom>
-            <a:ln w="15886">
+            <a:ln w="15875">
               <a:solidFill>
                 <a:srgbClr val="232F3E"/>
               </a:solidFill>
@@ -14133,13 +14133,13 @@
           </p:nvCxnSpPr>
           <p:spPr>
             <a:xfrm>
-              <a:off x="6667913" y="3824855"/>
-              <a:ext cx="1609828" cy="0"/>
+              <a:off x="6667500" y="3602567"/>
+              <a:ext cx="1608667" cy="0"/>
             </a:xfrm>
             <a:prstGeom prst="line">
               <a:avLst/>
             </a:prstGeom>
-            <a:ln w="15886">
+            <a:ln w="15875">
               <a:solidFill>
                 <a:srgbClr val="232F3E"/>
               </a:solidFill>
@@ -14156,13 +14156,13 @@
           </p:nvCxnSpPr>
           <p:spPr>
             <a:xfrm>
-              <a:off x="8870835" y="3824855"/>
-              <a:ext cx="1143826" cy="0"/>
+              <a:off x="8868833" y="3602567"/>
+              <a:ext cx="1143000" cy="0"/>
             </a:xfrm>
             <a:prstGeom prst="line">
               <a:avLst/>
             </a:prstGeom>
-            <a:ln w="15886">
+            <a:ln w="15875">
               <a:solidFill>
                 <a:srgbClr val="232F3E"/>
               </a:solidFill>
@@ -14193,8 +14193,8 @@
           </p:blipFill>
           <p:spPr>
             <a:xfrm>
-              <a:off x="8320105" y="3570671"/>
-              <a:ext cx="508367" cy="508367"/>
+              <a:off x="8318500" y="3348567"/>
+              <a:ext cx="508000" cy="508000"/>
             </a:xfrm>
             <a:prstGeom prst="rect">
               <a:avLst/>
@@ -14209,8 +14209,8 @@
           </p:nvSpPr>
           <p:spPr>
             <a:xfrm>
-              <a:off x="7939492" y="4128816"/>
-              <a:ext cx="1269593" cy="192756"/>
+              <a:off x="7938161" y="3906308"/>
+              <a:ext cx="1268677" cy="192617"/>
             </a:xfrm>
             <a:prstGeom prst="rect">
               <a:avLst/>
@@ -14229,7 +14229,7 @@
                 </a:lnSpc>
               </a:pPr>
               <a:r>
-                <a:rPr sz="1167" b="0" lang="ko-KR">
+                <a:rPr sz="1166" b="0" lang="ko-KR">
                   <a:solidFill>
                     <a:srgbClr val="232F3E"/>
                   </a:solidFill>
@@ -14250,8 +14250,8 @@
           </p:nvSpPr>
           <p:spPr>
             <a:xfrm>
-              <a:off x="8177127" y="4318394"/>
-              <a:ext cx="794323" cy="165219"/>
+              <a:off x="8175625" y="4095750"/>
+              <a:ext cx="793750" cy="165100"/>
             </a:xfrm>
             <a:prstGeom prst="rect">
               <a:avLst/>
@@ -14285,34 +14285,42 @@
         </p:sp>
         <p:sp>
           <p:nvSpPr>
-            <p:cNvPr id="60" name="Rectangle 59"/>
-            <p:cNvSpPr/>
-            <p:nvPr/>
-          </p:nvSpPr>
-          <p:spPr>
-            <a:xfrm>
-              <a:off x="398056" y="4820406"/>
-              <a:ext cx="4194026" cy="1419191"/>
-            </a:xfrm>
-            <a:prstGeom prst="rect">
-              <a:avLst/>
-            </a:prstGeom>
-            <a:solidFill>
-              <a:srgbClr val="F8F9F9"/>
-            </a:solidFill>
-            <a:ln w="10591">
-              <a:solidFill>
-                <a:srgbClr val="D5DBDB"/>
-              </a:solidFill>
-              <a:prstDash val="solid"/>
-              <a:miter lim="800000"/>
-            </a:ln>
-          </p:spPr>
-          <p:txBody>
-            <a:bodyPr rtlCol="0" anchor="ctr"/>
-            <a:lstStyle/>
-            <a:p>
-              <a:pPr algn="ctr"/>
+            <p:cNvPr id="60" name="TextBox 59"/>
+            <p:cNvSpPr txBox="1"/>
+            <p:nvPr/>
+          </p:nvSpPr>
+          <p:spPr>
+            <a:xfrm>
+              <a:off x="4762500" y="6106583"/>
+              <a:ext cx="8977313" cy="165100"/>
+            </a:xfrm>
+            <a:prstGeom prst="rect">
+              <a:avLst/>
+            </a:prstGeom>
+            <a:noFill/>
+          </p:spPr>
+          <p:txBody>
+            <a:bodyPr wrap="none" lIns="0" rIns="0" tIns="0" bIns="0" anchor="t">
+              <a:noAutofit/>
+            </a:bodyPr>
+            <a:lstStyle/>
+            <a:p>
+              <a:pPr algn="l">
+                <a:lnSpc>
+                  <a:spcPct val="100000"/>
+                </a:lnSpc>
+              </a:pPr>
+              <a:r>
+                <a:rPr sz="1000" b="0" lang="ko-KR">
+                  <a:solidFill>
+                    <a:srgbClr val="545B64"/>
+                  </a:solidFill>
+                  <a:latin typeface="Arial"/>
+                  <a:ea typeface="Malgun Gothic"/>
+                  <a:cs typeface="Malgun Gothic"/>
+                </a:rPr>
+                <a:t>Hub &amp; spoke: VPC·VPN은 리전 TGW에 attachment로 연결 · VPC CIDR과 VPN(BGP) 경로는 TGW 라우팅 테이블에 전파</a:t>
+              </a:r>
             </a:p>
           </p:txBody>
         </p:sp>
@@ -14324,8 +14332,8 @@
           </p:nvSpPr>
           <p:spPr>
             <a:xfrm>
-              <a:off x="525147" y="4932671"/>
-              <a:ext cx="1088223" cy="165219"/>
+              <a:off x="4762500" y="6275917"/>
+              <a:ext cx="4572000" cy="165100"/>
             </a:xfrm>
             <a:prstGeom prst="rect">
               <a:avLst/>
@@ -14344,15 +14352,15 @@
                 </a:lnSpc>
               </a:pPr>
               <a:r>
-                <a:rPr sz="1000" b="1" lang="ko-KR">
-                  <a:solidFill>
-                    <a:srgbClr val="232F3E"/>
-                  </a:solidFill>
-                  <a:latin typeface="Arial"/>
-                  <a:ea typeface="Malgun Gothic"/>
-                  <a:cs typeface="Malgun Gothic"/>
-                </a:rPr>
-                <a:t>Hub &amp; spoke</a:t>
+                <a:rPr sz="1000" b="0" lang="ko-KR">
+                  <a:solidFill>
+                    <a:srgbClr val="545B64"/>
+                  </a:solidFill>
+                  <a:latin typeface="Arial"/>
+                  <a:ea typeface="Malgun Gothic"/>
+                  <a:cs typeface="Malgun Gothic"/>
+                </a:rPr>
+                <a:t>라우팅: VPC 서브넷 10.0.0.0/8 · 192.168.0.0/16 → TGW</a:t>
               </a:r>
             </a:p>
           </p:txBody>
@@ -14365,8 +14373,8 @@
           </p:nvSpPr>
           <p:spPr>
             <a:xfrm>
-              <a:off x="1565181" y="4932671"/>
-              <a:ext cx="3336157" cy="165219"/>
+              <a:off x="4762500" y="6445250"/>
+              <a:ext cx="7659688" cy="165100"/>
             </a:xfrm>
             <a:prstGeom prst="rect">
               <a:avLst/>
@@ -14393,335 +14401,7 @@
                   <a:ea typeface="Malgun Gothic"/>
                   <a:cs typeface="Malgun Gothic"/>
                 </a:rPr>
-                <a:t>VPC·VPN은 리전 TGW에 attachment로 연결</a:t>
-              </a:r>
-            </a:p>
-          </p:txBody>
-        </p:sp>
-        <p:sp>
-          <p:nvSpPr>
-            <p:cNvPr id="63" name="TextBox 62"/>
-            <p:cNvSpPr txBox="1"/>
-            <p:nvPr/>
-          </p:nvSpPr>
-          <p:spPr>
-            <a:xfrm>
-              <a:off x="1565181" y="5102126"/>
-              <a:ext cx="3352044" cy="165219"/>
-            </a:xfrm>
-            <a:prstGeom prst="rect">
-              <a:avLst/>
-            </a:prstGeom>
-            <a:noFill/>
-          </p:spPr>
-          <p:txBody>
-            <a:bodyPr wrap="none" lIns="0" rIns="0" tIns="0" bIns="0" anchor="t">
-              <a:noAutofit/>
-            </a:bodyPr>
-            <a:lstStyle/>
-            <a:p>
-              <a:pPr algn="l">
-                <a:lnSpc>
-                  <a:spcPct val="100000"/>
-                </a:lnSpc>
-              </a:pPr>
-              <a:r>
-                <a:rPr sz="1000" b="0" lang="ko-KR">
-                  <a:solidFill>
-                    <a:srgbClr val="545B64"/>
-                  </a:solidFill>
-                  <a:latin typeface="Arial"/>
-                  <a:ea typeface="Malgun Gothic"/>
-                  <a:cs typeface="Malgun Gothic"/>
-                </a:rPr>
-                <a:t>VPC CIDR·VPN(BGP) 경로는 TGW RT에 전파</a:t>
-              </a:r>
-            </a:p>
-          </p:txBody>
-        </p:sp>
-        <p:sp>
-          <p:nvSpPr>
-            <p:cNvPr id="64" name="TextBox 63"/>
-            <p:cNvSpPr txBox="1"/>
-            <p:nvPr/>
-          </p:nvSpPr>
-          <p:spPr>
-            <a:xfrm>
-              <a:off x="525147" y="5335128"/>
-              <a:ext cx="1215314" cy="165219"/>
-            </a:xfrm>
-            <a:prstGeom prst="rect">
-              <a:avLst/>
-            </a:prstGeom>
-            <a:noFill/>
-          </p:spPr>
-          <p:txBody>
-            <a:bodyPr wrap="none" lIns="0" rIns="0" tIns="0" bIns="0" anchor="t">
-              <a:noAutofit/>
-            </a:bodyPr>
-            <a:lstStyle/>
-            <a:p>
-              <a:pPr algn="l">
-                <a:lnSpc>
-                  <a:spcPct val="100000"/>
-                </a:lnSpc>
-              </a:pPr>
-              <a:r>
-                <a:rPr sz="1000" b="1" lang="ko-KR">
-                  <a:solidFill>
-                    <a:srgbClr val="232F3E"/>
-                  </a:solidFill>
-                  <a:latin typeface="Arial"/>
-                  <a:ea typeface="Malgun Gothic"/>
-                  <a:cs typeface="Malgun Gothic"/>
-                </a:rPr>
-                <a:t>VPC 서브넷 RT</a:t>
-              </a:r>
-            </a:p>
-          </p:txBody>
-        </p:sp>
-        <p:sp>
-          <p:nvSpPr>
-            <p:cNvPr id="65" name="TextBox 64"/>
-            <p:cNvSpPr txBox="1"/>
-            <p:nvPr/>
-          </p:nvSpPr>
-          <p:spPr>
-            <a:xfrm>
-              <a:off x="1565181" y="5335128"/>
-              <a:ext cx="3010485" cy="165219"/>
-            </a:xfrm>
-            <a:prstGeom prst="rect">
-              <a:avLst/>
-            </a:prstGeom>
-            <a:noFill/>
-          </p:spPr>
-          <p:txBody>
-            <a:bodyPr wrap="none" lIns="0" rIns="0" tIns="0" bIns="0" anchor="t">
-              <a:noAutofit/>
-            </a:bodyPr>
-            <a:lstStyle/>
-            <a:p>
-              <a:pPr algn="l">
-                <a:lnSpc>
-                  <a:spcPct val="100000"/>
-                </a:lnSpc>
-              </a:pPr>
-              <a:r>
-                <a:rPr sz="1000" b="0" lang="ko-KR">
-                  <a:solidFill>
-                    <a:srgbClr val="545B64"/>
-                  </a:solidFill>
-                  <a:latin typeface="Arial"/>
-                  <a:ea typeface="Malgun Gothic"/>
-                  <a:cs typeface="Malgun Gothic"/>
-                </a:rPr>
-                <a:t>10.0.0.0/8 · 192.168.0.0/16 → TGW</a:t>
-              </a:r>
-            </a:p>
-          </p:txBody>
-        </p:sp>
-        <p:sp>
-          <p:nvSpPr>
-            <p:cNvPr id="66" name="TextBox 65"/>
-            <p:cNvSpPr txBox="1"/>
-            <p:nvPr/>
-          </p:nvSpPr>
-          <p:spPr>
-            <a:xfrm>
-              <a:off x="525147" y="5568129"/>
-              <a:ext cx="826096" cy="165219"/>
-            </a:xfrm>
-            <a:prstGeom prst="rect">
-              <a:avLst/>
-            </a:prstGeom>
-            <a:noFill/>
-          </p:spPr>
-          <p:txBody>
-            <a:bodyPr wrap="none" lIns="0" rIns="0" tIns="0" bIns="0" anchor="t">
-              <a:noAutofit/>
-            </a:bodyPr>
-            <a:lstStyle/>
-            <a:p>
-              <a:pPr algn="l">
-                <a:lnSpc>
-                  <a:spcPct val="100000"/>
-                </a:lnSpc>
-              </a:pPr>
-              <a:r>
-                <a:rPr sz="1000" b="1" lang="ko-KR">
-                  <a:solidFill>
-                    <a:srgbClr val="232F3E"/>
-                  </a:solidFill>
-                  <a:latin typeface="Arial"/>
-                  <a:ea typeface="Malgun Gothic"/>
-                  <a:cs typeface="Malgun Gothic"/>
-                </a:rPr>
-                <a:t>TGW A RT</a:t>
-              </a:r>
-            </a:p>
-          </p:txBody>
-        </p:sp>
-        <p:sp>
-          <p:nvSpPr>
-            <p:cNvPr id="67" name="TextBox 66"/>
-            <p:cNvSpPr txBox="1"/>
-            <p:nvPr/>
-          </p:nvSpPr>
-          <p:spPr>
-            <a:xfrm>
-              <a:off x="1565181" y="5568129"/>
-              <a:ext cx="2629209" cy="165219"/>
-            </a:xfrm>
-            <a:prstGeom prst="rect">
-              <a:avLst/>
-            </a:prstGeom>
-            <a:noFill/>
-          </p:spPr>
-          <p:txBody>
-            <a:bodyPr wrap="none" lIns="0" rIns="0" tIns="0" bIns="0" anchor="t">
-              <a:noAutofit/>
-            </a:bodyPr>
-            <a:lstStyle/>
-            <a:p>
-              <a:pPr algn="l">
-                <a:lnSpc>
-                  <a:spcPct val="100000"/>
-                </a:lnSpc>
-              </a:pPr>
-              <a:r>
-                <a:rPr sz="1000" b="0" lang="ko-KR">
-                  <a:solidFill>
-                    <a:srgbClr val="545B64"/>
-                  </a:solidFill>
-                  <a:latin typeface="Arial"/>
-                  <a:ea typeface="Malgun Gothic"/>
-                  <a:cs typeface="Malgun Gothic"/>
-                </a:rPr>
-                <a:t>10.16.0.0/13 → peering (정적)</a:t>
-              </a:r>
-            </a:p>
-          </p:txBody>
-        </p:sp>
-        <p:sp>
-          <p:nvSpPr>
-            <p:cNvPr id="68" name="TextBox 67"/>
-            <p:cNvSpPr txBox="1"/>
-            <p:nvPr/>
-          </p:nvSpPr>
-          <p:spPr>
-            <a:xfrm>
-              <a:off x="525147" y="5801131"/>
-              <a:ext cx="826096" cy="165219"/>
-            </a:xfrm>
-            <a:prstGeom prst="rect">
-              <a:avLst/>
-            </a:prstGeom>
-            <a:noFill/>
-          </p:spPr>
-          <p:txBody>
-            <a:bodyPr wrap="none" lIns="0" rIns="0" tIns="0" bIns="0" anchor="t">
-              <a:noAutofit/>
-            </a:bodyPr>
-            <a:lstStyle/>
-            <a:p>
-              <a:pPr algn="l">
-                <a:lnSpc>
-                  <a:spcPct val="100000"/>
-                </a:lnSpc>
-              </a:pPr>
-              <a:r>
-                <a:rPr sz="1000" b="1" lang="ko-KR">
-                  <a:solidFill>
-                    <a:srgbClr val="232F3E"/>
-                  </a:solidFill>
-                  <a:latin typeface="Arial"/>
-                  <a:ea typeface="Malgun Gothic"/>
-                  <a:cs typeface="Malgun Gothic"/>
-                </a:rPr>
-                <a:t>TGW B RT</a:t>
-              </a:r>
-            </a:p>
-          </p:txBody>
-        </p:sp>
-        <p:sp>
-          <p:nvSpPr>
-            <p:cNvPr id="69" name="TextBox 68"/>
-            <p:cNvSpPr txBox="1"/>
-            <p:nvPr/>
-          </p:nvSpPr>
-          <p:spPr>
-            <a:xfrm>
-              <a:off x="1565181" y="5801131"/>
-              <a:ext cx="2573607" cy="165219"/>
-            </a:xfrm>
-            <a:prstGeom prst="rect">
-              <a:avLst/>
-            </a:prstGeom>
-            <a:noFill/>
-          </p:spPr>
-          <p:txBody>
-            <a:bodyPr wrap="none" lIns="0" rIns="0" tIns="0" bIns="0" anchor="t">
-              <a:noAutofit/>
-            </a:bodyPr>
-            <a:lstStyle/>
-            <a:p>
-              <a:pPr algn="l">
-                <a:lnSpc>
-                  <a:spcPct val="100000"/>
-                </a:lnSpc>
-              </a:pPr>
-              <a:r>
-                <a:rPr sz="1000" b="0" lang="ko-KR">
-                  <a:solidFill>
-                    <a:srgbClr val="545B64"/>
-                  </a:solidFill>
-                  <a:latin typeface="Arial"/>
-                  <a:ea typeface="Malgun Gothic"/>
-                  <a:cs typeface="Malgun Gothic"/>
-                </a:rPr>
-                <a:t>10.0.0.0/13 · 192.168.0.0/16</a:t>
-              </a:r>
-            </a:p>
-          </p:txBody>
-        </p:sp>
-        <p:sp>
-          <p:nvSpPr>
-            <p:cNvPr id="70" name="TextBox 69"/>
-            <p:cNvSpPr txBox="1"/>
-            <p:nvPr/>
-          </p:nvSpPr>
-          <p:spPr>
-            <a:xfrm>
-              <a:off x="1565181" y="5970586"/>
-              <a:ext cx="1493327" cy="165219"/>
-            </a:xfrm>
-            <a:prstGeom prst="rect">
-              <a:avLst/>
-            </a:prstGeom>
-            <a:noFill/>
-          </p:spPr>
-          <p:txBody>
-            <a:bodyPr wrap="none" lIns="0" rIns="0" tIns="0" bIns="0" anchor="t">
-              <a:noAutofit/>
-            </a:bodyPr>
-            <a:lstStyle/>
-            <a:p>
-              <a:pPr algn="l">
-                <a:lnSpc>
-                  <a:spcPct val="100000"/>
-                </a:lnSpc>
-              </a:pPr>
-              <a:r>
-                <a:rPr sz="1000" b="0" lang="ko-KR">
-                  <a:solidFill>
-                    <a:srgbClr val="545B64"/>
-                  </a:solidFill>
-                  <a:latin typeface="Arial"/>
-                  <a:ea typeface="Malgun Gothic"/>
-                  <a:cs typeface="Malgun Gothic"/>
-                </a:rPr>
-                <a:t>→ peering (정적)</a:t>
+                <a:t>TGW RT: A 10.16.0.0/13 → peering · B 10.0.0.0/13 · 192.168.0.0/16 → peering (정적 경로)</a:t>
               </a:r>
             </a:p>
           </p:txBody>

</xml_diff>

<commit_message>
Widen the NAT-to-IGW corridor in the Network Firewall example so the trunk clears the AZ boxes and the arrow into the IGW has a shaft, and flag short arrows and border-hugging trunks in check_layout.py
Co-Authored-By: Claude Opus 5.5 <noreply@anthropic.com>
</commit_message>
<xml_diff>
--- a/docs/examples/reference-architectures.pptx
+++ b/docs/examples/reference-architectures.pptx
@@ -14469,9 +14469,9 @@
         </p:nvGrpSpPr>
         <p:grpSpPr>
           <a:xfrm>
-            <a:off x="379677" y="999067"/>
+            <a:off x="316177" y="999067"/>
             <a:ext cx="14082448" cy="5643033"/>
-            <a:chOff x="379677" y="999067"/>
+            <a:chOff x="316177" y="999067"/>
             <a:chExt cx="14082448" cy="5643033"/>
           </a:xfrm>
         </p:grpSpPr>
@@ -14483,8 +14483,8 @@
           </p:nvSpPr>
           <p:spPr>
             <a:xfrm>
-              <a:off x="381000" y="999067"/>
-              <a:ext cx="10625667" cy="5249333"/>
+              <a:off x="317500" y="999067"/>
+              <a:ext cx="10752667" cy="5249333"/>
             </a:xfrm>
             <a:prstGeom prst="rect">
               <a:avLst/>
@@ -14528,7 +14528,7 @@
           </p:blipFill>
           <p:spPr>
             <a:xfrm>
-              <a:off x="381000" y="999067"/>
+              <a:off x="317500" y="999067"/>
               <a:ext cx="338667" cy="338667"/>
             </a:xfrm>
             <a:prstGeom prst="rect">
@@ -14544,7 +14544,7 @@
           </p:nvSpPr>
           <p:spPr>
             <a:xfrm>
-              <a:off x="825500" y="1081088"/>
+              <a:off x="762000" y="1081088"/>
               <a:ext cx="1141016" cy="206375"/>
             </a:xfrm>
             <a:prstGeom prst="rect">
@@ -14585,8 +14585,8 @@
           </p:nvSpPr>
           <p:spPr>
             <a:xfrm>
-              <a:off x="592667" y="1358900"/>
-              <a:ext cx="10202333" cy="4804833"/>
+              <a:off x="529167" y="1358900"/>
+              <a:ext cx="10329333" cy="4804833"/>
             </a:xfrm>
             <a:prstGeom prst="rect">
               <a:avLst/>
@@ -14632,7 +14632,7 @@
           </p:blipFill>
           <p:spPr>
             <a:xfrm>
-              <a:off x="592667" y="1358900"/>
+              <a:off x="529167" y="1358900"/>
               <a:ext cx="254000" cy="254000"/>
             </a:xfrm>
             <a:prstGeom prst="rect">
@@ -14648,7 +14648,7 @@
           </p:nvSpPr>
           <p:spPr>
             <a:xfrm>
-              <a:off x="931333" y="1408642"/>
+              <a:off x="867833" y="1408642"/>
               <a:ext cx="2287323" cy="192617"/>
             </a:xfrm>
             <a:prstGeom prst="rect">
@@ -14689,7 +14689,7 @@
           </p:nvSpPr>
           <p:spPr>
             <a:xfrm>
-              <a:off x="762000" y="1993900"/>
+              <a:off x="698500" y="1993900"/>
               <a:ext cx="2116667" cy="1524000"/>
             </a:xfrm>
             <a:prstGeom prst="rect">
@@ -14734,7 +14734,7 @@
           </p:blipFill>
           <p:spPr>
             <a:xfrm>
-              <a:off x="762000" y="1993900"/>
+              <a:off x="698500" y="1993900"/>
               <a:ext cx="254000" cy="254000"/>
             </a:xfrm>
             <a:prstGeom prst="rect">
@@ -14750,7 +14750,7 @@
           </p:nvSpPr>
           <p:spPr>
             <a:xfrm>
-              <a:off x="1100667" y="2043642"/>
+              <a:off x="1037167" y="2043642"/>
               <a:ext cx="1879865" cy="192617"/>
             </a:xfrm>
             <a:prstGeom prst="rect">
@@ -14791,7 +14791,7 @@
           </p:nvSpPr>
           <p:spPr>
             <a:xfrm>
-              <a:off x="889000" y="2311400"/>
+              <a:off x="825500" y="2311400"/>
               <a:ext cx="1862667" cy="1121833"/>
             </a:xfrm>
             <a:prstGeom prst="rect">
@@ -14836,7 +14836,7 @@
           </p:blipFill>
           <p:spPr>
             <a:xfrm>
-              <a:off x="889000" y="2311400"/>
+              <a:off x="825500" y="2311400"/>
               <a:ext cx="254000" cy="254000"/>
             </a:xfrm>
             <a:prstGeom prst="rect">
@@ -14852,7 +14852,7 @@
           </p:nvSpPr>
           <p:spPr>
             <a:xfrm>
-              <a:off x="1227667" y="2361142"/>
+              <a:off x="1164167" y="2361142"/>
               <a:ext cx="1166813" cy="192617"/>
             </a:xfrm>
             <a:prstGeom prst="rect">
@@ -14907,7 +14907,7 @@
           </p:blipFill>
           <p:spPr>
             <a:xfrm>
-              <a:off x="1566333" y="2607733"/>
+              <a:off x="1502833" y="2607733"/>
               <a:ext cx="508000" cy="508000"/>
             </a:xfrm>
             <a:prstGeom prst="rect">
@@ -14923,7 +14923,7 @@
           </p:nvSpPr>
           <p:spPr>
             <a:xfrm>
-              <a:off x="1593453" y="3165475"/>
+              <a:off x="1529953" y="3165475"/>
               <a:ext cx="453760" cy="192617"/>
             </a:xfrm>
             <a:prstGeom prst="rect">
@@ -14964,7 +14964,7 @@
           </p:nvSpPr>
           <p:spPr>
             <a:xfrm>
-              <a:off x="762000" y="4428067"/>
+              <a:off x="698500" y="4428067"/>
               <a:ext cx="2116667" cy="1524000"/>
             </a:xfrm>
             <a:prstGeom prst="rect">
@@ -15009,7 +15009,7 @@
           </p:blipFill>
           <p:spPr>
             <a:xfrm>
-              <a:off x="762000" y="4428067"/>
+              <a:off x="698500" y="4428067"/>
               <a:ext cx="254000" cy="254000"/>
             </a:xfrm>
             <a:prstGeom prst="rect">
@@ -15025,7 +15025,7 @@
           </p:nvSpPr>
           <p:spPr>
             <a:xfrm>
-              <a:off x="1100667" y="4477808"/>
+              <a:off x="1037167" y="4477808"/>
               <a:ext cx="1879865" cy="192617"/>
             </a:xfrm>
             <a:prstGeom prst="rect">
@@ -15066,7 +15066,7 @@
           </p:nvSpPr>
           <p:spPr>
             <a:xfrm>
-              <a:off x="889000" y="4745567"/>
+              <a:off x="825500" y="4745567"/>
               <a:ext cx="1862667" cy="1121833"/>
             </a:xfrm>
             <a:prstGeom prst="rect">
@@ -15111,7 +15111,7 @@
           </p:blipFill>
           <p:spPr>
             <a:xfrm>
-              <a:off x="889000" y="4745567"/>
+              <a:off x="825500" y="4745567"/>
               <a:ext cx="254000" cy="254000"/>
             </a:xfrm>
             <a:prstGeom prst="rect">
@@ -15127,7 +15127,7 @@
           </p:nvSpPr>
           <p:spPr>
             <a:xfrm>
-              <a:off x="1227667" y="4795308"/>
+              <a:off x="1164167" y="4795308"/>
               <a:ext cx="1166813" cy="192617"/>
             </a:xfrm>
             <a:prstGeom prst="rect">
@@ -15182,7 +15182,7 @@
           </p:blipFill>
           <p:spPr>
             <a:xfrm>
-              <a:off x="1566333" y="5041900"/>
+              <a:off x="1502833" y="5041900"/>
               <a:ext cx="508000" cy="508000"/>
             </a:xfrm>
             <a:prstGeom prst="rect">
@@ -15198,7 +15198,7 @@
           </p:nvSpPr>
           <p:spPr>
             <a:xfrm>
-              <a:off x="1593453" y="5599642"/>
+              <a:off x="1529953" y="5599642"/>
               <a:ext cx="453760" cy="192617"/>
             </a:xfrm>
             <a:prstGeom prst="rect">
@@ -15253,7 +15253,7 @@
           </p:blipFill>
           <p:spPr>
             <a:xfrm>
-              <a:off x="3492500" y="3602567"/>
+              <a:off x="3429000" y="3602567"/>
               <a:ext cx="508000" cy="508000"/>
             </a:xfrm>
             <a:prstGeom prst="rect">
@@ -15269,7 +15269,7 @@
           </p:nvSpPr>
           <p:spPr>
             <a:xfrm>
-              <a:off x="3519620" y="4160308"/>
+              <a:off x="3456120" y="4160308"/>
               <a:ext cx="453760" cy="192617"/>
             </a:xfrm>
             <a:prstGeom prst="rect">
@@ -15324,7 +15324,7 @@
           </p:blipFill>
           <p:spPr>
             <a:xfrm>
-              <a:off x="3492500" y="2607733"/>
+              <a:off x="3429000" y="2607733"/>
               <a:ext cx="508000" cy="508000"/>
             </a:xfrm>
             <a:prstGeom prst="rect">
@@ -15340,7 +15340,7 @@
           </p:nvSpPr>
           <p:spPr>
             <a:xfrm>
-              <a:off x="3112161" y="3165475"/>
+              <a:off x="3048661" y="3165475"/>
               <a:ext cx="1268677" cy="192617"/>
             </a:xfrm>
             <a:prstGeom prst="rect">
@@ -15381,7 +15381,7 @@
           </p:nvSpPr>
           <p:spPr>
             <a:xfrm>
-              <a:off x="3087688" y="3354917"/>
+              <a:off x="3024188" y="3354917"/>
               <a:ext cx="1317625" cy="165100"/>
             </a:xfrm>
             <a:prstGeom prst="rect">
@@ -15436,7 +15436,7 @@
           </p:blipFill>
           <p:spPr>
             <a:xfrm>
-              <a:off x="3492500" y="5041900"/>
+              <a:off x="3429000" y="5041900"/>
               <a:ext cx="508000" cy="508000"/>
             </a:xfrm>
             <a:prstGeom prst="rect">
@@ -15452,7 +15452,7 @@
           </p:nvSpPr>
           <p:spPr>
             <a:xfrm>
-              <a:off x="3264958" y="5599642"/>
+              <a:off x="3201458" y="5599642"/>
               <a:ext cx="963083" cy="192617"/>
             </a:xfrm>
             <a:prstGeom prst="rect">
@@ -15493,7 +15493,7 @@
           </p:nvSpPr>
           <p:spPr>
             <a:xfrm>
-              <a:off x="2825750" y="5789083"/>
+              <a:off x="2762250" y="5789083"/>
               <a:ext cx="1841500" cy="165100"/>
             </a:xfrm>
             <a:prstGeom prst="rect">
@@ -15534,7 +15534,7 @@
           </p:nvSpPr>
           <p:spPr>
             <a:xfrm>
-              <a:off x="2921000" y="2861733"/>
+              <a:off x="2857500" y="2861733"/>
               <a:ext cx="529167" cy="910167"/>
             </a:xfrm>
             <a:custGeom>
@@ -15587,7 +15587,7 @@
           </p:nvSpPr>
           <p:spPr>
             <a:xfrm>
-              <a:off x="2921000" y="3941233"/>
+              <a:off x="2857500" y="3941233"/>
               <a:ext cx="529167" cy="1354667"/>
             </a:xfrm>
             <a:custGeom>
@@ -15640,8 +15640,8 @@
           </p:nvSpPr>
           <p:spPr>
             <a:xfrm>
-              <a:off x="4572000" y="1676400"/>
-              <a:ext cx="5799667" cy="4360333"/>
+              <a:off x="4508500" y="1676400"/>
+              <a:ext cx="5926667" cy="4360333"/>
             </a:xfrm>
             <a:prstGeom prst="rect">
               <a:avLst/>
@@ -15685,7 +15685,7 @@
           </p:blipFill>
           <p:spPr>
             <a:xfrm>
-              <a:off x="4572000" y="1676400"/>
+              <a:off x="4508500" y="1676400"/>
               <a:ext cx="254000" cy="254000"/>
             </a:xfrm>
             <a:prstGeom prst="rect">
@@ -15701,7 +15701,7 @@
           </p:nvSpPr>
           <p:spPr>
             <a:xfrm>
-              <a:off x="4910667" y="1726142"/>
+              <a:off x="4847167" y="1726142"/>
               <a:ext cx="3000375" cy="192617"/>
             </a:xfrm>
             <a:prstGeom prst="rect">
@@ -15742,7 +15742,7 @@
           </p:nvSpPr>
           <p:spPr>
             <a:xfrm>
-              <a:off x="4741333" y="1993900"/>
+              <a:off x="4677833" y="1993900"/>
               <a:ext cx="5037667" cy="1524000"/>
             </a:xfrm>
             <a:prstGeom prst="rect">
@@ -15775,7 +15775,7 @@
           </p:nvSpPr>
           <p:spPr>
             <a:xfrm>
-              <a:off x="4868333" y="2043642"/>
+              <a:off x="4804833" y="2043642"/>
               <a:ext cx="2083594" cy="192617"/>
             </a:xfrm>
             <a:prstGeom prst="rect">
@@ -15816,7 +15816,7 @@
           </p:nvSpPr>
           <p:spPr>
             <a:xfrm>
-              <a:off x="4741333" y="4428067"/>
+              <a:off x="4677833" y="4428067"/>
               <a:ext cx="5037667" cy="1524000"/>
             </a:xfrm>
             <a:prstGeom prst="rect">
@@ -15849,7 +15849,7 @@
           </p:nvSpPr>
           <p:spPr>
             <a:xfrm>
-              <a:off x="4868333" y="4477808"/>
+              <a:off x="4804833" y="4477808"/>
               <a:ext cx="2083594" cy="192617"/>
             </a:xfrm>
             <a:prstGeom prst="rect">
@@ -15890,7 +15890,7 @@
           </p:nvSpPr>
           <p:spPr>
             <a:xfrm>
-              <a:off x="4868333" y="2311400"/>
+              <a:off x="4804833" y="2311400"/>
               <a:ext cx="1439333" cy="1121833"/>
             </a:xfrm>
             <a:prstGeom prst="rect">
@@ -15935,7 +15935,7 @@
           </p:blipFill>
           <p:spPr>
             <a:xfrm>
-              <a:off x="4868333" y="2311400"/>
+              <a:off x="4804833" y="2311400"/>
               <a:ext cx="254000" cy="254000"/>
             </a:xfrm>
             <a:prstGeom prst="rect">
@@ -15951,7 +15951,7 @@
           </p:nvSpPr>
           <p:spPr>
             <a:xfrm>
-              <a:off x="5207000" y="2361142"/>
+              <a:off x="5143500" y="2361142"/>
               <a:ext cx="1166813" cy="192617"/>
             </a:xfrm>
             <a:prstGeom prst="rect">
@@ -15992,7 +15992,7 @@
           </p:nvSpPr>
           <p:spPr>
             <a:xfrm>
-              <a:off x="6434667" y="2311400"/>
+              <a:off x="6371167" y="2311400"/>
               <a:ext cx="1608667" cy="1121833"/>
             </a:xfrm>
             <a:prstGeom prst="rect">
@@ -16037,7 +16037,7 @@
           </p:blipFill>
           <p:spPr>
             <a:xfrm>
-              <a:off x="6434667" y="2311400"/>
+              <a:off x="6371167" y="2311400"/>
               <a:ext cx="254000" cy="254000"/>
             </a:xfrm>
             <a:prstGeom prst="rect">
@@ -16053,7 +16053,7 @@
           </p:nvSpPr>
           <p:spPr>
             <a:xfrm>
-              <a:off x="6773333" y="2361142"/>
+              <a:off x="6709833" y="2361142"/>
               <a:ext cx="1676135" cy="192617"/>
             </a:xfrm>
             <a:prstGeom prst="rect">
@@ -16094,7 +16094,7 @@
           </p:nvSpPr>
           <p:spPr>
             <a:xfrm>
-              <a:off x="8170333" y="2311400"/>
+              <a:off x="8106833" y="2311400"/>
               <a:ext cx="1481667" cy="1121833"/>
             </a:xfrm>
             <a:prstGeom prst="rect">
@@ -16139,7 +16139,7 @@
           </p:blipFill>
           <p:spPr>
             <a:xfrm>
-              <a:off x="8170333" y="2311400"/>
+              <a:off x="8106833" y="2311400"/>
               <a:ext cx="254000" cy="254000"/>
             </a:xfrm>
             <a:prstGeom prst="rect">
@@ -16155,7 +16155,7 @@
           </p:nvSpPr>
           <p:spPr>
             <a:xfrm>
-              <a:off x="8509000" y="2361142"/>
+              <a:off x="8445500" y="2361142"/>
               <a:ext cx="1472406" cy="192617"/>
             </a:xfrm>
             <a:prstGeom prst="rect">
@@ -16196,7 +16196,7 @@
           </p:nvSpPr>
           <p:spPr>
             <a:xfrm>
-              <a:off x="4868333" y="4745567"/>
+              <a:off x="4804833" y="4745567"/>
               <a:ext cx="1439333" cy="1121833"/>
             </a:xfrm>
             <a:prstGeom prst="rect">
@@ -16241,7 +16241,7 @@
           </p:blipFill>
           <p:spPr>
             <a:xfrm>
-              <a:off x="4868333" y="4745567"/>
+              <a:off x="4804833" y="4745567"/>
               <a:ext cx="254000" cy="254000"/>
             </a:xfrm>
             <a:prstGeom prst="rect">
@@ -16257,7 +16257,7 @@
           </p:nvSpPr>
           <p:spPr>
             <a:xfrm>
-              <a:off x="5207000" y="4795308"/>
+              <a:off x="5143500" y="4795308"/>
               <a:ext cx="1166813" cy="192617"/>
             </a:xfrm>
             <a:prstGeom prst="rect">
@@ -16298,7 +16298,7 @@
           </p:nvSpPr>
           <p:spPr>
             <a:xfrm>
-              <a:off x="6434667" y="4745567"/>
+              <a:off x="6371167" y="4745567"/>
               <a:ext cx="1608667" cy="1121833"/>
             </a:xfrm>
             <a:prstGeom prst="rect">
@@ -16343,7 +16343,7 @@
           </p:blipFill>
           <p:spPr>
             <a:xfrm>
-              <a:off x="6434667" y="4745567"/>
+              <a:off x="6371167" y="4745567"/>
               <a:ext cx="254000" cy="254000"/>
             </a:xfrm>
             <a:prstGeom prst="rect">
@@ -16359,7 +16359,7 @@
           </p:nvSpPr>
           <p:spPr>
             <a:xfrm>
-              <a:off x="6773333" y="4795308"/>
+              <a:off x="6709833" y="4795308"/>
               <a:ext cx="1676135" cy="192617"/>
             </a:xfrm>
             <a:prstGeom prst="rect">
@@ -16400,7 +16400,7 @@
           </p:nvSpPr>
           <p:spPr>
             <a:xfrm>
-              <a:off x="8170333" y="4745567"/>
+              <a:off x="8106833" y="4745567"/>
               <a:ext cx="1481667" cy="1121833"/>
             </a:xfrm>
             <a:prstGeom prst="rect">
@@ -16445,7 +16445,7 @@
           </p:blipFill>
           <p:spPr>
             <a:xfrm>
-              <a:off x="8170333" y="4745567"/>
+              <a:off x="8106833" y="4745567"/>
               <a:ext cx="254000" cy="254000"/>
             </a:xfrm>
             <a:prstGeom prst="rect">
@@ -16461,7 +16461,7 @@
           </p:nvSpPr>
           <p:spPr>
             <a:xfrm>
-              <a:off x="8509000" y="4795308"/>
+              <a:off x="8445500" y="4795308"/>
               <a:ext cx="1472406" cy="192617"/>
             </a:xfrm>
             <a:prstGeom prst="rect">
@@ -16516,7 +16516,7 @@
           </p:blipFill>
           <p:spPr>
             <a:xfrm>
-              <a:off x="5334000" y="2607733"/>
+              <a:off x="5270500" y="2607733"/>
               <a:ext cx="508000" cy="508000"/>
             </a:xfrm>
             <a:prstGeom prst="rect">
@@ -16532,7 +16532,7 @@
           </p:nvSpPr>
           <p:spPr>
             <a:xfrm>
-              <a:off x="5157391" y="3165475"/>
+              <a:off x="5093891" y="3165475"/>
               <a:ext cx="861219" cy="192617"/>
             </a:xfrm>
             <a:prstGeom prst="rect">
@@ -16587,7 +16587,7 @@
           </p:blipFill>
           <p:spPr>
             <a:xfrm>
-              <a:off x="6985000" y="2607733"/>
+              <a:off x="6921500" y="2607733"/>
               <a:ext cx="508000" cy="508000"/>
             </a:xfrm>
             <a:prstGeom prst="rect">
@@ -16603,7 +16603,7 @@
           </p:nvSpPr>
           <p:spPr>
             <a:xfrm>
-              <a:off x="6299068" y="3165475"/>
+              <a:off x="6235568" y="3165475"/>
               <a:ext cx="1879865" cy="192617"/>
             </a:xfrm>
             <a:prstGeom prst="rect">
@@ -16658,7 +16658,7 @@
           </p:blipFill>
           <p:spPr>
             <a:xfrm>
-              <a:off x="8657167" y="2607733"/>
+              <a:off x="8593667" y="2607733"/>
               <a:ext cx="508000" cy="508000"/>
             </a:xfrm>
             <a:prstGeom prst="rect">
@@ -16674,7 +16674,7 @@
           </p:nvSpPr>
           <p:spPr>
             <a:xfrm>
-              <a:off x="8276828" y="3165475"/>
+              <a:off x="8213328" y="3165475"/>
               <a:ext cx="1268677" cy="192617"/>
             </a:xfrm>
             <a:prstGeom prst="rect">
@@ -16729,7 +16729,7 @@
           </p:blipFill>
           <p:spPr>
             <a:xfrm>
-              <a:off x="5334000" y="5041900"/>
+              <a:off x="5270500" y="5041900"/>
               <a:ext cx="508000" cy="508000"/>
             </a:xfrm>
             <a:prstGeom prst="rect">
@@ -16745,7 +16745,7 @@
           </p:nvSpPr>
           <p:spPr>
             <a:xfrm>
-              <a:off x="5157391" y="5599642"/>
+              <a:off x="5093891" y="5599642"/>
               <a:ext cx="861219" cy="192617"/>
             </a:xfrm>
             <a:prstGeom prst="rect">
@@ -16800,7 +16800,7 @@
           </p:blipFill>
           <p:spPr>
             <a:xfrm>
-              <a:off x="6985000" y="5041900"/>
+              <a:off x="6921500" y="5041900"/>
               <a:ext cx="508000" cy="508000"/>
             </a:xfrm>
             <a:prstGeom prst="rect">
@@ -16816,7 +16816,7 @@
           </p:nvSpPr>
           <p:spPr>
             <a:xfrm>
-              <a:off x="6299068" y="5599642"/>
+              <a:off x="6235568" y="5599642"/>
               <a:ext cx="1879865" cy="192617"/>
             </a:xfrm>
             <a:prstGeom prst="rect">
@@ -16871,7 +16871,7 @@
           </p:blipFill>
           <p:spPr>
             <a:xfrm>
-              <a:off x="8657167" y="5041900"/>
+              <a:off x="8593667" y="5041900"/>
               <a:ext cx="508000" cy="508000"/>
             </a:xfrm>
             <a:prstGeom prst="rect">
@@ -16887,7 +16887,7 @@
           </p:nvSpPr>
           <p:spPr>
             <a:xfrm>
-              <a:off x="8276828" y="5599642"/>
+              <a:off x="8213328" y="5599642"/>
               <a:ext cx="1268677" cy="192617"/>
             </a:xfrm>
             <a:prstGeom prst="rect">
@@ -16942,7 +16942,7 @@
           </p:blipFill>
           <p:spPr>
             <a:xfrm>
-              <a:off x="6985000" y="3602567"/>
+              <a:off x="6921500" y="3602567"/>
               <a:ext cx="508000" cy="508000"/>
             </a:xfrm>
             <a:prstGeom prst="rect">
@@ -16958,7 +16958,7 @@
           </p:nvSpPr>
           <p:spPr>
             <a:xfrm>
-              <a:off x="6146271" y="4160308"/>
+              <a:off x="6082771" y="4160308"/>
               <a:ext cx="2185458" cy="192617"/>
             </a:xfrm>
             <a:prstGeom prst="rect">
@@ -16999,7 +16999,7 @@
           </p:nvSpPr>
           <p:spPr>
             <a:xfrm>
-              <a:off x="10117667" y="3602567"/>
+              <a:off x="10181167" y="3602567"/>
               <a:ext cx="508000" cy="740833"/>
             </a:xfrm>
             <a:prstGeom prst="rect">
@@ -17042,7 +17042,7 @@
           </p:blipFill>
           <p:spPr>
             <a:xfrm>
-              <a:off x="10117667" y="3602567"/>
+              <a:off x="10181167" y="3602567"/>
               <a:ext cx="508000" cy="508000"/>
             </a:xfrm>
             <a:prstGeom prst="rect">
@@ -17058,7 +17058,7 @@
           </p:nvSpPr>
           <p:spPr>
             <a:xfrm>
-              <a:off x="10144786" y="4160308"/>
+              <a:off x="10208286" y="4160308"/>
               <a:ext cx="453760" cy="192617"/>
             </a:xfrm>
             <a:prstGeom prst="rect">
@@ -17099,7 +17099,7 @@
           </p:nvSpPr>
           <p:spPr>
             <a:xfrm>
-              <a:off x="4042833" y="2861733"/>
+              <a:off x="3979333" y="2861733"/>
               <a:ext cx="1248834" cy="910167"/>
             </a:xfrm>
             <a:custGeom>
@@ -17152,7 +17152,7 @@
           </p:nvSpPr>
           <p:spPr>
             <a:xfrm>
-              <a:off x="4042833" y="3941233"/>
+              <a:off x="3979333" y="3941233"/>
               <a:ext cx="1248834" cy="1354667"/>
             </a:xfrm>
             <a:custGeom>
@@ -17205,7 +17205,7 @@
           </p:nvCxnSpPr>
           <p:spPr>
             <a:xfrm>
-              <a:off x="5884333" y="2861733"/>
+              <a:off x="5820833" y="2861733"/>
               <a:ext cx="1058334" cy="0"/>
             </a:xfrm>
             <a:prstGeom prst="line">
@@ -17230,7 +17230,7 @@
           </p:nvCxnSpPr>
           <p:spPr>
             <a:xfrm>
-              <a:off x="5884333" y="5295900"/>
+              <a:off x="5820833" y="5295900"/>
               <a:ext cx="1058334" cy="0"/>
             </a:xfrm>
             <a:prstGeom prst="line">
@@ -17255,7 +17255,7 @@
           </p:nvCxnSpPr>
           <p:spPr>
             <a:xfrm>
-              <a:off x="7535333" y="2861733"/>
+              <a:off x="7471833" y="2861733"/>
               <a:ext cx="1079500" cy="0"/>
             </a:xfrm>
             <a:prstGeom prst="line">
@@ -17279,7 +17279,7 @@
           </p:nvCxnSpPr>
           <p:spPr>
             <a:xfrm>
-              <a:off x="7535333" y="5295900"/>
+              <a:off x="7471833" y="5295900"/>
               <a:ext cx="1079500" cy="0"/>
             </a:xfrm>
             <a:prstGeom prst="line">
@@ -17303,8 +17303,8 @@
           </p:nvSpPr>
           <p:spPr>
             <a:xfrm>
-              <a:off x="9207500" y="2861733"/>
-              <a:ext cx="867833" cy="994834"/>
+              <a:off x="9144000" y="2861733"/>
+              <a:ext cx="994833" cy="994834"/>
             </a:xfrm>
             <a:custGeom>
               <a:avLst/>
@@ -17313,18 +17313,18 @@
               <a:cxnLst/>
               <a:rect l="l" t="t" r="r" b="b"/>
               <a:pathLst>
-                <a:path w="867833" h="994834">
+                <a:path w="994833" h="994834">
                   <a:moveTo>
                     <a:pt x="0" y="0"/>
                   </a:moveTo>
                   <a:lnTo>
-                    <a:pt x="656167" y="0"/>
+                    <a:pt x="698500" y="0"/>
                   </a:lnTo>
                   <a:lnTo>
-                    <a:pt x="656167" y="994834"/>
+                    <a:pt x="698500" y="994834"/>
                   </a:lnTo>
                   <a:lnTo>
-                    <a:pt x="867833" y="994834"/>
+                    <a:pt x="994833" y="994834"/>
                   </a:lnTo>
                 </a:path>
               </a:pathLst>
@@ -17355,8 +17355,8 @@
           </p:nvSpPr>
           <p:spPr>
             <a:xfrm>
-              <a:off x="9207500" y="3856567"/>
-              <a:ext cx="656167" cy="1439333"/>
+              <a:off x="9144000" y="3856567"/>
+              <a:ext cx="698500" cy="1439333"/>
             </a:xfrm>
             <a:custGeom>
               <a:avLst/>
@@ -17365,15 +17365,15 @@
               <a:cxnLst/>
               <a:rect l="l" t="t" r="r" b="b"/>
               <a:pathLst>
-                <a:path w="656167" h="1439333">
+                <a:path w="698500" h="1439333">
                   <a:moveTo>
                     <a:pt x="0" y="1439333"/>
                   </a:moveTo>
                   <a:lnTo>
-                    <a:pt x="656167" y="1439333"/>
+                    <a:pt x="698500" y="1439333"/>
                   </a:lnTo>
                   <a:lnTo>
-                    <a:pt x="656167" y="0"/>
+                    <a:pt x="698500" y="0"/>
                   </a:lnTo>
                 </a:path>
               </a:pathLst>
@@ -17417,7 +17417,7 @@
           </p:blipFill>
           <p:spPr>
             <a:xfrm>
-              <a:off x="11303000" y="3602567"/>
+              <a:off x="11366500" y="3602567"/>
               <a:ext cx="508000" cy="508000"/>
             </a:xfrm>
             <a:prstGeom prst="rect">
@@ -17433,7 +17433,7 @@
           </p:nvSpPr>
           <p:spPr>
             <a:xfrm>
-              <a:off x="11075458" y="4160308"/>
+              <a:off x="11138958" y="4160308"/>
               <a:ext cx="963083" cy="192617"/>
             </a:xfrm>
             <a:prstGeom prst="rect">
@@ -17474,7 +17474,7 @@
           </p:nvCxnSpPr>
           <p:spPr>
             <a:xfrm>
-              <a:off x="10668000" y="3856567"/>
+              <a:off x="10731500" y="3856567"/>
               <a:ext cx="592667" cy="0"/>
             </a:xfrm>
             <a:prstGeom prst="line">
@@ -17498,7 +17498,7 @@
           </p:nvSpPr>
           <p:spPr>
             <a:xfrm>
-              <a:off x="3227917" y="3517900"/>
+              <a:off x="3164417" y="3517900"/>
               <a:ext cx="211667" cy="211667"/>
             </a:xfrm>
             <a:prstGeom prst="ellipse">
@@ -17527,7 +17527,7 @@
           </p:nvSpPr>
           <p:spPr>
             <a:xfrm>
-              <a:off x="3226594" y="3545417"/>
+              <a:off x="3163094" y="3545417"/>
               <a:ext cx="214312" cy="165100"/>
             </a:xfrm>
             <a:prstGeom prst="rect">
@@ -17568,7 +17568,7 @@
           </p:nvSpPr>
           <p:spPr>
             <a:xfrm>
-              <a:off x="4116917" y="3517900"/>
+              <a:off x="4053417" y="3517900"/>
               <a:ext cx="211667" cy="211667"/>
             </a:xfrm>
             <a:prstGeom prst="ellipse">
@@ -17597,7 +17597,7 @@
           </p:nvSpPr>
           <p:spPr>
             <a:xfrm>
-              <a:off x="4115594" y="3545417"/>
+              <a:off x="4052094" y="3545417"/>
               <a:ext cx="214312" cy="165100"/>
             </a:xfrm>
             <a:prstGeom prst="rect">
@@ -17638,7 +17638,7 @@
           </p:nvSpPr>
           <p:spPr>
             <a:xfrm>
-              <a:off x="6582833" y="2607733"/>
+              <a:off x="6519333" y="2607733"/>
               <a:ext cx="211667" cy="211667"/>
             </a:xfrm>
             <a:prstGeom prst="ellipse">
@@ -17667,7 +17667,7 @@
           </p:nvSpPr>
           <p:spPr>
             <a:xfrm>
-              <a:off x="6581510" y="2635250"/>
+              <a:off x="6518010" y="2635250"/>
               <a:ext cx="214312" cy="165100"/>
             </a:xfrm>
             <a:prstGeom prst="rect">
@@ -17708,7 +17708,7 @@
           </p:nvSpPr>
           <p:spPr>
             <a:xfrm>
-              <a:off x="7683500" y="2607733"/>
+              <a:off x="7620000" y="2607733"/>
               <a:ext cx="211667" cy="211667"/>
             </a:xfrm>
             <a:prstGeom prst="ellipse">
@@ -17737,7 +17737,7 @@
           </p:nvSpPr>
           <p:spPr>
             <a:xfrm>
-              <a:off x="7682177" y="2635250"/>
+              <a:off x="7618677" y="2635250"/>
               <a:ext cx="214312" cy="165100"/>
             </a:xfrm>
             <a:prstGeom prst="rect">
@@ -17778,7 +17778,7 @@
           </p:nvSpPr>
           <p:spPr>
             <a:xfrm>
-              <a:off x="9323917" y="2607733"/>
+              <a:off x="9260417" y="2607733"/>
               <a:ext cx="211667" cy="211667"/>
             </a:xfrm>
             <a:prstGeom prst="ellipse">
@@ -17807,7 +17807,7 @@
           </p:nvSpPr>
           <p:spPr>
             <a:xfrm>
-              <a:off x="9322594" y="2635250"/>
+              <a:off x="9259094" y="2635250"/>
               <a:ext cx="214312" cy="165100"/>
             </a:xfrm>
             <a:prstGeom prst="rect">
@@ -17848,7 +17848,7 @@
           </p:nvSpPr>
           <p:spPr>
             <a:xfrm>
-              <a:off x="381000" y="6280150"/>
+              <a:off x="317500" y="6280150"/>
               <a:ext cx="211667" cy="211667"/>
             </a:xfrm>
             <a:prstGeom prst="ellipse">
@@ -17877,7 +17877,7 @@
           </p:nvSpPr>
           <p:spPr>
             <a:xfrm>
-              <a:off x="379677" y="6307667"/>
+              <a:off x="316177" y="6307667"/>
               <a:ext cx="214312" cy="165100"/>
             </a:xfrm>
             <a:prstGeom prst="rect">
@@ -17918,7 +17918,7 @@
           </p:nvSpPr>
           <p:spPr>
             <a:xfrm>
-              <a:off x="677333" y="6307667"/>
+              <a:off x="613833" y="6307667"/>
               <a:ext cx="912812" cy="165100"/>
             </a:xfrm>
             <a:prstGeom prst="rect">
@@ -17959,7 +17959,7 @@
           </p:nvSpPr>
           <p:spPr>
             <a:xfrm>
-              <a:off x="1598083" y="6280150"/>
+              <a:off x="1534583" y="6280150"/>
               <a:ext cx="211667" cy="211667"/>
             </a:xfrm>
             <a:prstGeom prst="ellipse">
@@ -17988,7 +17988,7 @@
           </p:nvSpPr>
           <p:spPr>
             <a:xfrm>
-              <a:off x="1596760" y="6307667"/>
+              <a:off x="1533260" y="6307667"/>
               <a:ext cx="214312" cy="165100"/>
             </a:xfrm>
             <a:prstGeom prst="rect">
@@ -18029,7 +18029,7 @@
           </p:nvSpPr>
           <p:spPr>
             <a:xfrm>
-              <a:off x="1894417" y="6307667"/>
+              <a:off x="1830917" y="6307667"/>
               <a:ext cx="4111625" cy="165100"/>
             </a:xfrm>
             <a:prstGeom prst="rect">
@@ -18070,7 +18070,7 @@
           </p:nvSpPr>
           <p:spPr>
             <a:xfrm>
-              <a:off x="5202767" y="6280150"/>
+              <a:off x="5139267" y="6280150"/>
               <a:ext cx="211667" cy="211667"/>
             </a:xfrm>
             <a:prstGeom prst="ellipse">
@@ -18099,7 +18099,7 @@
           </p:nvSpPr>
           <p:spPr>
             <a:xfrm>
-              <a:off x="5201444" y="6307667"/>
+              <a:off x="5137944" y="6307667"/>
               <a:ext cx="214312" cy="165100"/>
             </a:xfrm>
             <a:prstGeom prst="rect">
@@ -18140,7 +18140,7 @@
           </p:nvSpPr>
           <p:spPr>
             <a:xfrm>
-              <a:off x="5499100" y="6307667"/>
+              <a:off x="5435600" y="6307667"/>
               <a:ext cx="3833812" cy="165100"/>
             </a:xfrm>
             <a:prstGeom prst="rect">
@@ -18181,7 +18181,7 @@
           </p:nvSpPr>
           <p:spPr>
             <a:xfrm>
-              <a:off x="8528050" y="6280150"/>
+              <a:off x="8464550" y="6280150"/>
               <a:ext cx="211667" cy="211667"/>
             </a:xfrm>
             <a:prstGeom prst="ellipse">
@@ -18210,7 +18210,7 @@
           </p:nvSpPr>
           <p:spPr>
             <a:xfrm>
-              <a:off x="8526727" y="6307667"/>
+              <a:off x="8463227" y="6307667"/>
               <a:ext cx="214312" cy="165100"/>
             </a:xfrm>
             <a:prstGeom prst="rect">
@@ -18251,7 +18251,7 @@
           </p:nvSpPr>
           <p:spPr>
             <a:xfrm>
-              <a:off x="8824383" y="6307667"/>
+              <a:off x="8760883" y="6307667"/>
               <a:ext cx="2024062" cy="165100"/>
             </a:xfrm>
             <a:prstGeom prst="rect">
@@ -18292,7 +18292,7 @@
           </p:nvSpPr>
           <p:spPr>
             <a:xfrm>
-              <a:off x="10462683" y="6280150"/>
+              <a:off x="10399183" y="6280150"/>
               <a:ext cx="211667" cy="211667"/>
             </a:xfrm>
             <a:prstGeom prst="ellipse">
@@ -18321,7 +18321,7 @@
           </p:nvSpPr>
           <p:spPr>
             <a:xfrm>
-              <a:off x="10461360" y="6307667"/>
+              <a:off x="10397860" y="6307667"/>
               <a:ext cx="214312" cy="165100"/>
             </a:xfrm>
             <a:prstGeom prst="rect">
@@ -18362,7 +18362,7 @@
           </p:nvSpPr>
           <p:spPr>
             <a:xfrm>
-              <a:off x="10759017" y="6307667"/>
+              <a:off x="10695517" y="6307667"/>
               <a:ext cx="912812" cy="165100"/>
             </a:xfrm>
             <a:prstGeom prst="rect">
@@ -18403,7 +18403,7 @@
           </p:nvSpPr>
           <p:spPr>
             <a:xfrm>
-              <a:off x="381000" y="6477000"/>
+              <a:off x="317500" y="6477000"/>
               <a:ext cx="14081125" cy="165100"/>
             </a:xfrm>
             <a:prstGeom prst="rect">

</xml_diff>

<commit_message>
Reconcile the note, CIDR, header and trunk rules after review, make check_layout distinguish titles from bold legend text, fix the drifted example geometry and add the left-pane NLB mTLS example
Co-Authored-By: Claude Fable 5.1 <noreply@anthropic.com>
</commit_message>
<xml_diff>
--- a/docs/examples/reference-architectures.pptx
+++ b/docs/examples/reference-architectures.pptx
@@ -3394,8 +3394,8 @@
           </p:nvSpPr>
           <p:spPr>
             <a:xfrm>
-              <a:off x="2151003" y="3597688"/>
-              <a:ext cx="1091480" cy="165714"/>
+              <a:off x="2115152" y="3597688"/>
+              <a:ext cx="1163183" cy="165714"/>
             </a:xfrm>
             <a:prstGeom prst="rect">
               <a:avLst/>
@@ -4018,8 +4018,8 @@
           </p:nvSpPr>
           <p:spPr>
             <a:xfrm>
-              <a:off x="3780257" y="2125385"/>
-              <a:ext cx="5693755" cy="1635892"/>
+              <a:off x="3780257" y="2146630"/>
+              <a:ext cx="5693755" cy="1614647"/>
             </a:xfrm>
             <a:prstGeom prst="rect">
               <a:avLst/>
@@ -4051,7 +4051,7 @@
           </p:nvSpPr>
           <p:spPr>
             <a:xfrm>
-              <a:off x="3907729" y="2175312"/>
+              <a:off x="3907729" y="2196557"/>
               <a:ext cx="2091339" cy="193333"/>
             </a:xfrm>
             <a:prstGeom prst="rect">
@@ -4166,8 +4166,8 @@
           </p:nvSpPr>
           <p:spPr>
             <a:xfrm>
-              <a:off x="3907729" y="2444065"/>
-              <a:ext cx="1699628" cy="1232230"/>
+              <a:off x="3907729" y="2465311"/>
+              <a:ext cx="1699628" cy="1210985"/>
             </a:xfrm>
             <a:prstGeom prst="rect">
               <a:avLst/>
@@ -4211,7 +4211,7 @@
           </p:blipFill>
           <p:spPr>
             <a:xfrm>
-              <a:off x="3907729" y="2444065"/>
+              <a:off x="3907729" y="2465311"/>
               <a:ext cx="254944" cy="254944"/>
             </a:xfrm>
             <a:prstGeom prst="rect">
@@ -4227,7 +4227,7 @@
           </p:nvSpPr>
           <p:spPr>
             <a:xfrm>
-              <a:off x="4247654" y="2493992"/>
+              <a:off x="4247654" y="2515237"/>
               <a:ext cx="1477880" cy="193333"/>
             </a:xfrm>
             <a:prstGeom prst="rect">
@@ -4268,8 +4268,8 @@
           </p:nvSpPr>
           <p:spPr>
             <a:xfrm>
-              <a:off x="5862301" y="2444065"/>
-              <a:ext cx="3484238" cy="1232230"/>
+              <a:off x="5862301" y="2465311"/>
+              <a:ext cx="3484238" cy="1210985"/>
             </a:xfrm>
             <a:prstGeom prst="rect">
               <a:avLst/>
@@ -4313,7 +4313,7 @@
           </p:blipFill>
           <p:spPr>
             <a:xfrm>
-              <a:off x="5862301" y="2444065"/>
+              <a:off x="5862301" y="2465311"/>
               <a:ext cx="254944" cy="254944"/>
             </a:xfrm>
             <a:prstGeom prst="rect">
@@ -4329,7 +4329,7 @@
           </p:nvSpPr>
           <p:spPr>
             <a:xfrm>
-              <a:off x="6202227" y="2493992"/>
+              <a:off x="6202227" y="2515237"/>
               <a:ext cx="1171150" cy="193333"/>
             </a:xfrm>
             <a:prstGeom prst="rect">
@@ -4716,8 +4716,8 @@
           </p:nvSpPr>
           <p:spPr>
             <a:xfrm>
-              <a:off x="7179513" y="2529047"/>
-              <a:ext cx="2039554" cy="3590465"/>
+              <a:off x="7179513" y="2550292"/>
+              <a:ext cx="2039554" cy="3569219"/>
             </a:xfrm>
             <a:prstGeom prst="rect">
               <a:avLst/>
@@ -4763,7 +4763,7 @@
           </p:blipFill>
           <p:spPr>
             <a:xfrm>
-              <a:off x="7179513" y="2529047"/>
+              <a:off x="7179513" y="2550292"/>
               <a:ext cx="254944" cy="254944"/>
             </a:xfrm>
             <a:prstGeom prst="rect">
@@ -4779,7 +4779,7 @@
           </p:nvSpPr>
           <p:spPr>
             <a:xfrm>
-              <a:off x="7519439" y="2578973"/>
+              <a:off x="7519439" y="2600219"/>
               <a:ext cx="1989096" cy="193333"/>
             </a:xfrm>
             <a:prstGeom prst="rect">
@@ -5754,7 +5754,7 @@
           </p:nvSpPr>
           <p:spPr>
             <a:xfrm>
-              <a:off x="323257" y="4361817"/>
+              <a:off x="323257" y="4382999"/>
               <a:ext cx="657964" cy="192756"/>
             </a:xfrm>
             <a:prstGeom prst="rect">
@@ -5927,7 +5927,7 @@
           </p:nvSpPr>
           <p:spPr>
             <a:xfrm>
-              <a:off x="1790769" y="2095349"/>
+              <a:off x="1790769" y="1947075"/>
               <a:ext cx="963779" cy="192756"/>
             </a:xfrm>
             <a:prstGeom prst="rect">
@@ -5968,8 +5968,8 @@
           </p:nvSpPr>
           <p:spPr>
             <a:xfrm>
-              <a:off x="1728547" y="2284927"/>
-              <a:ext cx="1088223" cy="165219"/>
+              <a:off x="1692802" y="2136654"/>
+              <a:ext cx="1159712" cy="165219"/>
             </a:xfrm>
             <a:prstGeom prst="rect">
               <a:avLst/>
@@ -6127,7 +6127,7 @@
           </p:blipFill>
           <p:spPr>
             <a:xfrm>
-              <a:off x="10067616" y="2850485"/>
+              <a:off x="10067616" y="2829303"/>
               <a:ext cx="508367" cy="508367"/>
             </a:xfrm>
             <a:prstGeom prst="rect">
@@ -6239,7 +6239,7 @@
           </p:blipFill>
           <p:spPr>
             <a:xfrm>
-              <a:off x="10067616" y="5286409"/>
+              <a:off x="10067616" y="5265227"/>
               <a:ext cx="508367" cy="508367"/>
             </a:xfrm>
             <a:prstGeom prst="rect">
@@ -6351,7 +6351,7 @@
           </p:blipFill>
           <p:spPr>
             <a:xfrm>
-              <a:off x="11084349" y="2850485"/>
+              <a:off x="11084349" y="2829303"/>
               <a:ext cx="508367" cy="508367"/>
             </a:xfrm>
             <a:prstGeom prst="rect">
@@ -6463,7 +6463,7 @@
           </p:blipFill>
           <p:spPr>
             <a:xfrm>
-              <a:off x="11084349" y="5286409"/>
+              <a:off x="11084349" y="5265227"/>
               <a:ext cx="508367" cy="508367"/>
             </a:xfrm>
             <a:prstGeom prst="rect">
@@ -7478,7 +7478,7 @@
           </p:blipFill>
           <p:spPr>
             <a:xfrm>
-              <a:off x="3861304" y="2850485"/>
+              <a:off x="3861304" y="2829303"/>
               <a:ext cx="508367" cy="508367"/>
             </a:xfrm>
             <a:prstGeom prst="rect">
@@ -7549,7 +7549,7 @@
           </p:blipFill>
           <p:spPr>
             <a:xfrm>
-              <a:off x="3861304" y="5286409"/>
+              <a:off x="3861304" y="5265227"/>
               <a:ext cx="508367" cy="508367"/>
             </a:xfrm>
             <a:prstGeom prst="rect">
@@ -7724,7 +7724,7 @@
           </p:blipFill>
           <p:spPr>
             <a:xfrm>
-              <a:off x="6625549" y="2850485"/>
+              <a:off x="6625549" y="2829303"/>
               <a:ext cx="508367" cy="508367"/>
             </a:xfrm>
             <a:prstGeom prst="rect">
@@ -7795,7 +7795,7 @@
           </p:blipFill>
           <p:spPr>
             <a:xfrm>
-              <a:off x="7642282" y="2850485"/>
+              <a:off x="7642282" y="2829303"/>
               <a:ext cx="508367" cy="508367"/>
             </a:xfrm>
             <a:prstGeom prst="rect">
@@ -7866,7 +7866,7 @@
           </p:blipFill>
           <p:spPr>
             <a:xfrm>
-              <a:off x="6625549" y="5286409"/>
+              <a:off x="6625549" y="5265227"/>
               <a:ext cx="508367" cy="508367"/>
             </a:xfrm>
             <a:prstGeom prst="rect">
@@ -7937,7 +7937,7 @@
           </p:blipFill>
           <p:spPr>
             <a:xfrm>
-              <a:off x="7642282" y="5286409"/>
+              <a:off x="7642282" y="5265227"/>
               <a:ext cx="508367" cy="508367"/>
             </a:xfrm>
             <a:prstGeom prst="rect">
@@ -8008,7 +8008,7 @@
           </p:blipFill>
           <p:spPr>
             <a:xfrm>
-              <a:off x="8828471" y="2850485"/>
+              <a:off x="8828471" y="2829303"/>
               <a:ext cx="508367" cy="508367"/>
             </a:xfrm>
             <a:prstGeom prst="rect">
@@ -8079,7 +8079,7 @@
           </p:blipFill>
           <p:spPr>
             <a:xfrm>
-              <a:off x="8828471" y="5286409"/>
+              <a:off x="8828471" y="5265227"/>
               <a:ext cx="508367" cy="508367"/>
             </a:xfrm>
             <a:prstGeom prst="rect">
@@ -8166,7 +8166,7 @@
           </p:nvSpPr>
           <p:spPr>
             <a:xfrm>
-              <a:off x="3888444" y="4361817"/>
+              <a:off x="3888444" y="4382999"/>
               <a:ext cx="454088" cy="192756"/>
             </a:xfrm>
             <a:prstGeom prst="rect">
@@ -8266,7 +8266,7 @@
           </p:nvSpPr>
           <p:spPr>
             <a:xfrm>
-              <a:off x="2882301" y="4361817"/>
+              <a:off x="2882301" y="4382999"/>
               <a:ext cx="454088" cy="192756"/>
             </a:xfrm>
             <a:prstGeom prst="rect">
@@ -8461,7 +8461,7 @@
           </p:nvCxnSpPr>
           <p:spPr>
             <a:xfrm>
-              <a:off x="8235377" y="3104669"/>
+              <a:off x="8235377" y="3083487"/>
               <a:ext cx="550731" cy="0"/>
             </a:xfrm>
             <a:prstGeom prst="line">
@@ -8485,7 +8485,7 @@
           </p:nvSpPr>
           <p:spPr>
             <a:xfrm>
-              <a:off x="8443225" y="2899204"/>
+              <a:off x="8443225" y="2878022"/>
               <a:ext cx="389218" cy="165219"/>
             </a:xfrm>
             <a:prstGeom prst="rect">
@@ -8618,7 +8618,7 @@
           </p:nvCxnSpPr>
           <p:spPr>
             <a:xfrm flipH="1">
-              <a:off x="4412035" y="3104669"/>
+              <a:off x="4412035" y="3083487"/>
               <a:ext cx="1832239" cy="0"/>
             </a:xfrm>
             <a:prstGeom prst="line">
@@ -8644,7 +8644,7 @@
           </p:nvSpPr>
           <p:spPr>
             <a:xfrm>
-              <a:off x="5169290" y="2899204"/>
+              <a:off x="5169290" y="2878022"/>
               <a:ext cx="921415" cy="165219"/>
             </a:xfrm>
             <a:prstGeom prst="rect">
@@ -8685,7 +8685,7 @@
           </p:nvCxnSpPr>
           <p:spPr>
             <a:xfrm flipH="1">
-              <a:off x="4412035" y="5540593"/>
+              <a:off x="4412035" y="5519411"/>
               <a:ext cx="1832239" cy="0"/>
             </a:xfrm>
             <a:prstGeom prst="line">
@@ -8711,7 +8711,7 @@
           </p:nvSpPr>
           <p:spPr>
             <a:xfrm>
-              <a:off x="5169290" y="5335128"/>
+              <a:off x="5169290" y="5313946"/>
               <a:ext cx="921415" cy="165219"/>
             </a:xfrm>
             <a:prstGeom prst="rect">
@@ -8752,7 +8752,7 @@
           </p:nvSpPr>
           <p:spPr>
             <a:xfrm>
-              <a:off x="9379202" y="3231760"/>
+              <a:off x="9379202" y="3210578"/>
               <a:ext cx="211820" cy="2181741"/>
             </a:xfrm>
             <a:custGeom>
@@ -8902,10 +8902,10 @@
         </p:nvGrpSpPr>
         <p:grpSpPr>
           <a:xfrm>
-            <a:off x="238529" y="944110"/>
-            <a:ext cx="11682507" cy="5666171"/>
-            <a:chOff x="238529" y="944110"/>
-            <a:chExt cx="11682507" cy="5666171"/>
+            <a:off x="285794" y="935411"/>
+            <a:ext cx="11588239" cy="5715000"/>
+            <a:chOff x="285794" y="935411"/>
+            <a:chExt cx="11588239" cy="5715000"/>
           </a:xfrm>
         </p:grpSpPr>
         <p:pic>
@@ -8930,8 +8930,8 @@
           </p:blipFill>
           <p:spPr>
             <a:xfrm>
-              <a:off x="313328" y="3718945"/>
-              <a:ext cx="508367" cy="508367"/>
+              <a:off x="359989" y="3687856"/>
+              <a:ext cx="504265" cy="504265"/>
             </a:xfrm>
             <a:prstGeom prst="rect">
               <a:avLst/>
@@ -8946,8 +8946,8 @@
           </p:nvSpPr>
           <p:spPr>
             <a:xfrm>
-              <a:off x="238529" y="4277089"/>
-              <a:ext cx="657964" cy="192756"/>
+              <a:off x="285794" y="4241497"/>
+              <a:ext cx="652655" cy="191200"/>
             </a:xfrm>
             <a:prstGeom prst="rect">
               <a:avLst/>
@@ -8966,7 +8966,7 @@
                 </a:lnSpc>
               </a:pPr>
               <a:r>
-                <a:rPr sz="1167" b="0" lang="ko-KR">
+                <a:rPr sz="1158" b="0" lang="ko-KR">
                   <a:solidFill>
                     <a:srgbClr val="232F3E"/>
                   </a:solidFill>
@@ -8987,14 +8987,14 @@
           </p:nvSpPr>
           <p:spPr>
             <a:xfrm>
-              <a:off x="1711336" y="944110"/>
-              <a:ext cx="10209700" cy="5422579"/>
-            </a:xfrm>
-            <a:prstGeom prst="rect">
-              <a:avLst/>
-            </a:prstGeom>
-            <a:noFill/>
-            <a:ln w="21182">
+              <a:off x="1746717" y="935411"/>
+              <a:ext cx="10127316" cy="5420846"/>
+            </a:xfrm>
+            <a:prstGeom prst="rect">
+              <a:avLst/>
+            </a:prstGeom>
+            <a:noFill/>
+            <a:ln w="21011">
               <a:solidFill>
                 <a:srgbClr val="232F3E"/>
               </a:solidFill>
@@ -9032,8 +9032,8 @@
           </p:blipFill>
           <p:spPr>
             <a:xfrm>
-              <a:off x="1711336" y="944110"/>
-              <a:ext cx="254183" cy="254183"/>
+              <a:off x="1746717" y="935411"/>
+              <a:ext cx="336176" cy="336176"/>
             </a:xfrm>
             <a:prstGeom prst="rect">
               <a:avLst/>
@@ -9048,8 +9048,8 @@
           </p:nvSpPr>
           <p:spPr>
             <a:xfrm>
-              <a:off x="2050248" y="1026190"/>
-              <a:ext cx="1141839" cy="206524"/>
+              <a:off x="2187949" y="1016829"/>
+              <a:ext cx="1132626" cy="204858"/>
             </a:xfrm>
             <a:prstGeom prst="rect">
               <a:avLst/>
@@ -9068,7 +9068,7 @@
                 </a:lnSpc>
               </a:pPr>
               <a:r>
-                <a:rPr sz="1250" b="1" lang="ko-KR">
+                <a:rPr sz="1240" b="1" lang="ko-KR">
                   <a:solidFill>
                     <a:srgbClr val="232F3E"/>
                   </a:solidFill>
@@ -9089,14 +9089,14 @@
           </p:nvSpPr>
           <p:spPr>
             <a:xfrm>
-              <a:off x="1923156" y="1304203"/>
-              <a:ext cx="9913152" cy="4977758"/>
-            </a:xfrm>
-            <a:prstGeom prst="rect">
-              <a:avLst/>
-            </a:prstGeom>
-            <a:noFill/>
-            <a:ln w="21182">
+              <a:off x="1956827" y="1292599"/>
+              <a:ext cx="9833162" cy="4979614"/>
+            </a:xfrm>
+            <a:prstGeom prst="rect">
+              <a:avLst/>
+            </a:prstGeom>
+            <a:noFill/>
+            <a:ln w="21011">
               <a:solidFill>
                 <a:srgbClr val="00A4A6"/>
               </a:solidFill>
@@ -9136,8 +9136,8 @@
           </p:blipFill>
           <p:spPr>
             <a:xfrm>
-              <a:off x="1923156" y="1304203"/>
-              <a:ext cx="254183" cy="254183"/>
+              <a:off x="1956827" y="1292599"/>
+              <a:ext cx="252132" cy="252132"/>
             </a:xfrm>
             <a:prstGeom prst="rect">
               <a:avLst/>
@@ -9152,8 +9152,8 @@
           </p:nvSpPr>
           <p:spPr>
             <a:xfrm>
-              <a:off x="2262067" y="1353980"/>
-              <a:ext cx="759902" cy="192756"/>
+              <a:off x="2293004" y="1341974"/>
+              <a:ext cx="753771" cy="191200"/>
             </a:xfrm>
             <a:prstGeom prst="rect">
               <a:avLst/>
@@ -9172,7 +9172,7 @@
                 </a:lnSpc>
               </a:pPr>
               <a:r>
-                <a:rPr sz="1167" b="1" lang="ko-KR">
+                <a:rPr sz="1158" b="1" lang="ko-KR">
                   <a:solidFill>
                     <a:srgbClr val="00A4A6"/>
                   </a:solidFill>
@@ -9193,14 +9193,14 @@
           </p:nvSpPr>
           <p:spPr>
             <a:xfrm>
-              <a:off x="2558614" y="1621932"/>
-              <a:ext cx="5104850" cy="4575301"/>
-            </a:xfrm>
-            <a:prstGeom prst="rect">
-              <a:avLst/>
-            </a:prstGeom>
-            <a:noFill/>
-            <a:ln w="21182">
+              <a:off x="2587158" y="1607764"/>
+              <a:ext cx="5063658" cy="4580404"/>
+            </a:xfrm>
+            <a:prstGeom prst="rect">
+              <a:avLst/>
+            </a:prstGeom>
+            <a:noFill/>
+            <a:ln w="21011">
               <a:solidFill>
                 <a:srgbClr val="8C4FFF"/>
               </a:solidFill>
@@ -9238,8 +9238,8 @@
           </p:blipFill>
           <p:spPr>
             <a:xfrm>
-              <a:off x="2558614" y="1621932"/>
-              <a:ext cx="254183" cy="254183"/>
+              <a:off x="2587158" y="1607764"/>
+              <a:ext cx="252132" cy="252132"/>
             </a:xfrm>
             <a:prstGeom prst="rect">
               <a:avLst/>
@@ -9254,8 +9254,8 @@
           </p:nvSpPr>
           <p:spPr>
             <a:xfrm>
-              <a:off x="2897526" y="1671710"/>
-              <a:ext cx="1677346" cy="192756"/>
+              <a:off x="2923335" y="1657140"/>
+              <a:ext cx="1663811" cy="191200"/>
             </a:xfrm>
             <a:prstGeom prst="rect">
               <a:avLst/>
@@ -9274,7 +9274,7 @@
                 </a:lnSpc>
               </a:pPr>
               <a:r>
-                <a:rPr sz="1167" b="1" lang="ko-KR">
+                <a:rPr sz="1158" b="1" lang="ko-KR">
                   <a:solidFill>
                     <a:srgbClr val="8C4FFF"/>
                   </a:solidFill>
@@ -9295,8 +9295,8 @@
           </p:nvSpPr>
           <p:spPr>
             <a:xfrm>
-              <a:off x="2897526" y="1861288"/>
-              <a:ext cx="1088223" cy="165219"/>
+              <a:off x="2923335" y="1845189"/>
+              <a:ext cx="1079442" cy="163886"/>
             </a:xfrm>
             <a:prstGeom prst="rect">
               <a:avLst/>
@@ -9315,7 +9315,7 @@
                 </a:lnSpc>
               </a:pPr>
               <a:r>
-                <a:rPr sz="1000" b="0" lang="ko-KR">
+                <a:rPr sz="992" b="0" lang="ko-KR">
                   <a:solidFill>
                     <a:srgbClr val="232F3E"/>
                   </a:solidFill>
@@ -9336,14 +9336,14 @@
           </p:nvSpPr>
           <p:spPr>
             <a:xfrm>
-              <a:off x="2770434" y="2109117"/>
-              <a:ext cx="4681211" cy="1525100"/>
-            </a:xfrm>
-            <a:prstGeom prst="rect">
-              <a:avLst/>
-            </a:prstGeom>
-            <a:noFill/>
-            <a:ln w="15886">
+              <a:off x="2797268" y="2091018"/>
+              <a:ext cx="4643438" cy="1512794"/>
+            </a:xfrm>
+            <a:prstGeom prst="rect">
+              <a:avLst/>
+            </a:prstGeom>
+            <a:noFill/>
+            <a:ln w="15758">
               <a:solidFill>
                 <a:srgbClr val="00A4A6"/>
               </a:solidFill>
@@ -9369,8 +9369,8 @@
           </p:nvSpPr>
           <p:spPr>
             <a:xfrm>
-              <a:off x="2897526" y="2158895"/>
-              <a:ext cx="2085098" cy="192756"/>
+              <a:off x="2923335" y="2140394"/>
+              <a:ext cx="2068273" cy="191200"/>
             </a:xfrm>
             <a:prstGeom prst="rect">
               <a:avLst/>
@@ -9389,7 +9389,7 @@
                 </a:lnSpc>
               </a:pPr>
               <a:r>
-                <a:rPr sz="1167" b="1" lang="ko-KR">
+                <a:rPr sz="1158" b="1" lang="ko-KR">
                   <a:solidFill>
                     <a:srgbClr val="00A4A6"/>
                   </a:solidFill>
@@ -9410,14 +9410,14 @@
           </p:nvSpPr>
           <p:spPr>
             <a:xfrm>
-              <a:off x="2770434" y="4545041"/>
-              <a:ext cx="4681211" cy="1567464"/>
-            </a:xfrm>
-            <a:prstGeom prst="rect">
-              <a:avLst/>
-            </a:prstGeom>
-            <a:noFill/>
-            <a:ln w="15886">
+              <a:off x="2797268" y="4507286"/>
+              <a:ext cx="4643438" cy="1596838"/>
+            </a:xfrm>
+            <a:prstGeom prst="rect">
+              <a:avLst/>
+            </a:prstGeom>
+            <a:noFill/>
+            <a:ln w="15758">
               <a:solidFill>
                 <a:srgbClr val="00A4A6"/>
               </a:solidFill>
@@ -9443,8 +9443,8 @@
           </p:nvSpPr>
           <p:spPr>
             <a:xfrm>
-              <a:off x="2897526" y="4594819"/>
-              <a:ext cx="2085098" cy="192756"/>
+              <a:off x="2923335" y="4556662"/>
+              <a:ext cx="2068273" cy="191200"/>
             </a:xfrm>
             <a:prstGeom prst="rect">
               <a:avLst/>
@@ -9463,7 +9463,7 @@
                 </a:lnSpc>
               </a:pPr>
               <a:r>
-                <a:rPr sz="1167" b="1" lang="ko-KR">
+                <a:rPr sz="1158" b="1" lang="ko-KR">
                   <a:solidFill>
                     <a:srgbClr val="00A4A6"/>
                   </a:solidFill>
@@ -9484,14 +9484,14 @@
           </p:nvSpPr>
           <p:spPr>
             <a:xfrm>
-              <a:off x="2897526" y="2426846"/>
-              <a:ext cx="2584198" cy="1122643"/>
-            </a:xfrm>
-            <a:prstGeom prst="rect">
-              <a:avLst/>
-            </a:prstGeom>
-            <a:noFill/>
-            <a:ln w="15886">
+              <a:off x="2923335" y="2406183"/>
+              <a:ext cx="2563346" cy="1113585"/>
+            </a:xfrm>
+            <a:prstGeom prst="rect">
+              <a:avLst/>
+            </a:prstGeom>
+            <a:noFill/>
+            <a:ln w="15758">
               <a:solidFill>
                 <a:srgbClr val="7AA116"/>
               </a:solidFill>
@@ -9529,8 +9529,8 @@
           </p:blipFill>
           <p:spPr>
             <a:xfrm>
-              <a:off x="2897526" y="2426846"/>
-              <a:ext cx="254183" cy="254183"/>
+              <a:off x="2923335" y="2406183"/>
+              <a:ext cx="252132" cy="252132"/>
             </a:xfrm>
             <a:prstGeom prst="rect">
               <a:avLst/>
@@ -9545,8 +9545,8 @@
           </p:nvSpPr>
           <p:spPr>
             <a:xfrm>
-              <a:off x="3236437" y="2476624"/>
-              <a:ext cx="1371531" cy="192756"/>
+              <a:off x="3259511" y="2455559"/>
+              <a:ext cx="1360464" cy="191200"/>
             </a:xfrm>
             <a:prstGeom prst="rect">
               <a:avLst/>
@@ -9565,7 +9565,7 @@
                 </a:lnSpc>
               </a:pPr>
               <a:r>
-                <a:rPr sz="1167" b="1" lang="ko-KR">
+                <a:rPr sz="1158" b="1" lang="ko-KR">
                   <a:solidFill>
                     <a:srgbClr val="7AA116"/>
                   </a:solidFill>
@@ -9586,14 +9586,14 @@
           </p:nvSpPr>
           <p:spPr>
             <a:xfrm>
-              <a:off x="5735907" y="2426846"/>
-              <a:ext cx="1588646" cy="1122643"/>
-            </a:xfrm>
-            <a:prstGeom prst="rect">
-              <a:avLst/>
-            </a:prstGeom>
-            <a:noFill/>
-            <a:ln w="15886">
+              <a:off x="5738812" y="2406183"/>
+              <a:ext cx="1575827" cy="1113585"/>
+            </a:xfrm>
+            <a:prstGeom prst="rect">
+              <a:avLst/>
+            </a:prstGeom>
+            <a:noFill/>
+            <a:ln w="15758">
               <a:solidFill>
                 <a:srgbClr val="00A4A6"/>
               </a:solidFill>
@@ -9631,8 +9631,8 @@
           </p:blipFill>
           <p:spPr>
             <a:xfrm>
-              <a:off x="5735907" y="2426846"/>
-              <a:ext cx="254183" cy="254183"/>
+              <a:off x="5738812" y="2406183"/>
+              <a:ext cx="252132" cy="252132"/>
             </a:xfrm>
             <a:prstGeom prst="rect">
               <a:avLst/>
@@ -9647,8 +9647,8 @@
           </p:nvSpPr>
           <p:spPr>
             <a:xfrm>
-              <a:off x="6074818" y="2476624"/>
-              <a:ext cx="1167655" cy="192756"/>
+              <a:off x="6074989" y="2455559"/>
+              <a:ext cx="1158233" cy="191200"/>
             </a:xfrm>
             <a:prstGeom prst="rect">
               <a:avLst/>
@@ -9667,7 +9667,7 @@
                 </a:lnSpc>
               </a:pPr>
               <a:r>
-                <a:rPr sz="1167" b="1" lang="ko-KR">
+                <a:rPr sz="1158" b="1" lang="ko-KR">
                   <a:solidFill>
                     <a:srgbClr val="00A4A6"/>
                   </a:solidFill>
@@ -9688,14 +9688,14 @@
           </p:nvSpPr>
           <p:spPr>
             <a:xfrm>
-              <a:off x="2897526" y="4862770"/>
-              <a:ext cx="2584198" cy="1165007"/>
-            </a:xfrm>
-            <a:prstGeom prst="rect">
-              <a:avLst/>
-            </a:prstGeom>
-            <a:noFill/>
-            <a:ln w="15886">
+              <a:off x="2923335" y="4822451"/>
+              <a:ext cx="2563346" cy="1197629"/>
+            </a:xfrm>
+            <a:prstGeom prst="rect">
+              <a:avLst/>
+            </a:prstGeom>
+            <a:noFill/>
+            <a:ln w="15758">
               <a:solidFill>
                 <a:srgbClr val="7AA116"/>
               </a:solidFill>
@@ -9733,8 +9733,8 @@
           </p:blipFill>
           <p:spPr>
             <a:xfrm>
-              <a:off x="2897526" y="4862770"/>
-              <a:ext cx="254183" cy="254183"/>
+              <a:off x="2923335" y="4822451"/>
+              <a:ext cx="252132" cy="252132"/>
             </a:xfrm>
             <a:prstGeom prst="rect">
               <a:avLst/>
@@ -9749,8 +9749,8 @@
           </p:nvSpPr>
           <p:spPr>
             <a:xfrm>
-              <a:off x="3236437" y="4912548"/>
-              <a:ext cx="1371531" cy="192756"/>
+              <a:off x="3259511" y="4871827"/>
+              <a:ext cx="1360464" cy="191200"/>
             </a:xfrm>
             <a:prstGeom prst="rect">
               <a:avLst/>
@@ -9769,7 +9769,7 @@
                 </a:lnSpc>
               </a:pPr>
               <a:r>
-                <a:rPr sz="1167" b="1" lang="ko-KR">
+                <a:rPr sz="1158" b="1" lang="ko-KR">
                   <a:solidFill>
                     <a:srgbClr val="7AA116"/>
                   </a:solidFill>
@@ -9790,14 +9790,14 @@
           </p:nvSpPr>
           <p:spPr>
             <a:xfrm>
-              <a:off x="5735907" y="4862770"/>
-              <a:ext cx="1588646" cy="1165007"/>
-            </a:xfrm>
-            <a:prstGeom prst="rect">
-              <a:avLst/>
-            </a:prstGeom>
-            <a:noFill/>
-            <a:ln w="15886">
+              <a:off x="5738812" y="4822451"/>
+              <a:ext cx="1575827" cy="1197629"/>
+            </a:xfrm>
+            <a:prstGeom prst="rect">
+              <a:avLst/>
+            </a:prstGeom>
+            <a:noFill/>
+            <a:ln w="15758">
               <a:solidFill>
                 <a:srgbClr val="00A4A6"/>
               </a:solidFill>
@@ -9835,8 +9835,8 @@
           </p:blipFill>
           <p:spPr>
             <a:xfrm>
-              <a:off x="5735907" y="4862770"/>
-              <a:ext cx="254183" cy="254183"/>
+              <a:off x="5738812" y="4822451"/>
+              <a:ext cx="252132" cy="252132"/>
             </a:xfrm>
             <a:prstGeom prst="rect">
               <a:avLst/>
@@ -9851,8 +9851,8 @@
           </p:nvSpPr>
           <p:spPr>
             <a:xfrm>
-              <a:off x="6074818" y="4912548"/>
-              <a:ext cx="1167655" cy="192756"/>
+              <a:off x="6074989" y="4871827"/>
+              <a:ext cx="1158233" cy="191200"/>
             </a:xfrm>
             <a:prstGeom prst="rect">
               <a:avLst/>
@@ -9871,7 +9871,7 @@
                 </a:lnSpc>
               </a:pPr>
               <a:r>
-                <a:rPr sz="1167" b="1" lang="ko-KR">
+                <a:rPr sz="1158" b="1" lang="ko-KR">
                   <a:solidFill>
                     <a:srgbClr val="00A4A6"/>
                   </a:solidFill>
@@ -9906,8 +9906,8 @@
           </p:blipFill>
           <p:spPr>
             <a:xfrm>
-              <a:off x="4761537" y="2723394"/>
-              <a:ext cx="508367" cy="508367"/>
+              <a:off x="4772305" y="2700338"/>
+              <a:ext cx="504265" cy="504265"/>
             </a:xfrm>
             <a:prstGeom prst="rect">
               <a:avLst/>
@@ -9922,8 +9922,8 @@
           </p:nvSpPr>
           <p:spPr>
             <a:xfrm>
-              <a:off x="4686738" y="3281538"/>
-              <a:ext cx="657964" cy="192756"/>
+              <a:off x="4698110" y="3253978"/>
+              <a:ext cx="652655" cy="191200"/>
             </a:xfrm>
             <a:prstGeom prst="rect">
               <a:avLst/>
@@ -9942,7 +9942,7 @@
                 </a:lnSpc>
               </a:pPr>
               <a:r>
-                <a:rPr sz="1167" b="0" lang="ko-KR">
+                <a:rPr sz="1158" b="0" lang="ko-KR">
                   <a:solidFill>
                     <a:srgbClr val="232F3E"/>
                   </a:solidFill>
@@ -9977,8 +9977,8 @@
           </p:blipFill>
           <p:spPr>
             <a:xfrm>
-              <a:off x="4761537" y="5159318"/>
-              <a:ext cx="508367" cy="508367"/>
+              <a:off x="4772305" y="5116606"/>
+              <a:ext cx="504265" cy="504265"/>
             </a:xfrm>
             <a:prstGeom prst="rect">
               <a:avLst/>
@@ -9993,8 +9993,8 @@
           </p:nvSpPr>
           <p:spPr>
             <a:xfrm>
-              <a:off x="4686738" y="5717462"/>
-              <a:ext cx="657964" cy="192756"/>
+              <a:off x="4698110" y="5670247"/>
+              <a:ext cx="652655" cy="191200"/>
             </a:xfrm>
             <a:prstGeom prst="rect">
               <a:avLst/>
@@ -10013,7 +10013,7 @@
                 </a:lnSpc>
               </a:pPr>
               <a:r>
-                <a:rPr sz="1167" b="0" lang="ko-KR">
+                <a:rPr sz="1158" b="0" lang="ko-KR">
                   <a:solidFill>
                     <a:srgbClr val="232F3E"/>
                   </a:solidFill>
@@ -10048,8 +10048,8 @@
           </p:blipFill>
           <p:spPr>
             <a:xfrm>
-              <a:off x="6276047" y="2723394"/>
-              <a:ext cx="508367" cy="508367"/>
+              <a:off x="6274594" y="2700338"/>
+              <a:ext cx="504265" cy="504265"/>
             </a:xfrm>
             <a:prstGeom prst="rect">
               <a:avLst/>
@@ -10064,8 +10064,8 @@
           </p:nvSpPr>
           <p:spPr>
             <a:xfrm>
-              <a:off x="6303186" y="3281538"/>
-              <a:ext cx="454088" cy="192756"/>
+              <a:off x="6301514" y="3253978"/>
+              <a:ext cx="450424" cy="191200"/>
             </a:xfrm>
             <a:prstGeom prst="rect">
               <a:avLst/>
@@ -10084,7 +10084,7 @@
                 </a:lnSpc>
               </a:pPr>
               <a:r>
-                <a:rPr sz="1167" b="0" lang="ko-KR">
+                <a:rPr sz="1158" b="0" lang="ko-KR">
                   <a:solidFill>
                     <a:srgbClr val="232F3E"/>
                   </a:solidFill>
@@ -10119,8 +10119,8 @@
           </p:blipFill>
           <p:spPr>
             <a:xfrm>
-              <a:off x="6276047" y="5159318"/>
-              <a:ext cx="508367" cy="508367"/>
+              <a:off x="6274594" y="5116606"/>
+              <a:ext cx="504265" cy="504265"/>
             </a:xfrm>
             <a:prstGeom prst="rect">
               <a:avLst/>
@@ -10135,8 +10135,8 @@
           </p:nvSpPr>
           <p:spPr>
             <a:xfrm>
-              <a:off x="6303186" y="5717462"/>
-              <a:ext cx="454088" cy="192756"/>
+              <a:off x="6301514" y="5670247"/>
+              <a:ext cx="450424" cy="191200"/>
             </a:xfrm>
             <a:prstGeom prst="rect">
               <a:avLst/>
@@ -10155,7 +10155,7 @@
                 </a:lnSpc>
               </a:pPr>
               <a:r>
-                <a:rPr sz="1167" b="0" lang="ko-KR">
+                <a:rPr sz="1158" b="0" lang="ko-KR">
                   <a:solidFill>
                     <a:srgbClr val="232F3E"/>
                   </a:solidFill>
@@ -10176,8 +10176,8 @@
           </p:nvSpPr>
           <p:spPr>
             <a:xfrm>
-              <a:off x="2304431" y="3718945"/>
-              <a:ext cx="508367" cy="741368"/>
+              <a:off x="2335026" y="3687856"/>
+              <a:ext cx="504265" cy="735386"/>
             </a:xfrm>
             <a:prstGeom prst="rect">
               <a:avLst/>
@@ -10219,8 +10219,8 @@
           </p:blipFill>
           <p:spPr>
             <a:xfrm>
-              <a:off x="2304431" y="3718945"/>
-              <a:ext cx="508367" cy="508367"/>
+              <a:off x="2335026" y="3687856"/>
+              <a:ext cx="504265" cy="504265"/>
             </a:xfrm>
             <a:prstGeom prst="rect">
               <a:avLst/>
@@ -10235,8 +10235,8 @@
           </p:nvSpPr>
           <p:spPr>
             <a:xfrm>
-              <a:off x="2331570" y="4277089"/>
-              <a:ext cx="454088" cy="192756"/>
+              <a:off x="2361946" y="4241497"/>
+              <a:ext cx="450424" cy="191200"/>
             </a:xfrm>
             <a:prstGeom prst="rect">
               <a:avLst/>
@@ -10255,7 +10255,7 @@
                 </a:lnSpc>
               </a:pPr>
               <a:r>
-                <a:rPr sz="1167" b="0" lang="ko-KR">
+                <a:rPr sz="1158" b="0" lang="ko-KR">
                   <a:solidFill>
                     <a:srgbClr val="232F3E"/>
                   </a:solidFill>
@@ -10276,14 +10276,14 @@
           </p:nvSpPr>
           <p:spPr>
             <a:xfrm>
-              <a:off x="8002375" y="1621932"/>
-              <a:ext cx="3749205" cy="4575301"/>
-            </a:xfrm>
-            <a:prstGeom prst="rect">
-              <a:avLst/>
-            </a:prstGeom>
-            <a:noFill/>
-            <a:ln w="21182">
+              <a:off x="7986993" y="1607764"/>
+              <a:ext cx="3718952" cy="4580404"/>
+            </a:xfrm>
+            <a:prstGeom prst="rect">
+              <a:avLst/>
+            </a:prstGeom>
+            <a:noFill/>
+            <a:ln w="21011">
               <a:solidFill>
                 <a:srgbClr val="8C4FFF"/>
               </a:solidFill>
@@ -10321,8 +10321,8 @@
           </p:blipFill>
           <p:spPr>
             <a:xfrm>
-              <a:off x="8002375" y="1621932"/>
-              <a:ext cx="254183" cy="254183"/>
+              <a:off x="7986993" y="1607764"/>
+              <a:ext cx="252132" cy="252132"/>
             </a:xfrm>
             <a:prstGeom prst="rect">
               <a:avLst/>
@@ -10337,8 +10337,8 @@
           </p:nvSpPr>
           <p:spPr>
             <a:xfrm>
-              <a:off x="8341287" y="1671710"/>
-              <a:ext cx="1371531" cy="192756"/>
+              <a:off x="8323169" y="1657140"/>
+              <a:ext cx="1360464" cy="191200"/>
             </a:xfrm>
             <a:prstGeom prst="rect">
               <a:avLst/>
@@ -10357,7 +10357,7 @@
                 </a:lnSpc>
               </a:pPr>
               <a:r>
-                <a:rPr sz="1167" b="1" lang="ko-KR">
+                <a:rPr sz="1158" b="1" lang="ko-KR">
                   <a:solidFill>
                     <a:srgbClr val="8C4FFF"/>
                   </a:solidFill>
@@ -10378,8 +10378,8 @@
           </p:nvSpPr>
           <p:spPr>
             <a:xfrm>
-              <a:off x="8341287" y="1861288"/>
-              <a:ext cx="1088223" cy="165219"/>
+              <a:off x="8323169" y="1845189"/>
+              <a:ext cx="1079442" cy="163886"/>
             </a:xfrm>
             <a:prstGeom prst="rect">
               <a:avLst/>
@@ -10398,7 +10398,7 @@
                 </a:lnSpc>
               </a:pPr>
               <a:r>
-                <a:rPr sz="1000" b="0" lang="ko-KR">
+                <a:rPr sz="992" b="0" lang="ko-KR">
                   <a:solidFill>
                     <a:srgbClr val="232F3E"/>
                   </a:solidFill>
@@ -10419,14 +10419,14 @@
           </p:nvSpPr>
           <p:spPr>
             <a:xfrm>
-              <a:off x="8214195" y="2109117"/>
-              <a:ext cx="3325566" cy="1525100"/>
-            </a:xfrm>
-            <a:prstGeom prst="rect">
-              <a:avLst/>
-            </a:prstGeom>
-            <a:noFill/>
-            <a:ln w="15886">
+              <a:off x="8197103" y="2091018"/>
+              <a:ext cx="3298732" cy="1512794"/>
+            </a:xfrm>
+            <a:prstGeom prst="rect">
+              <a:avLst/>
+            </a:prstGeom>
+            <a:noFill/>
+            <a:ln w="15758">
               <a:solidFill>
                 <a:srgbClr val="00A4A6"/>
               </a:solidFill>
@@ -10452,8 +10452,8 @@
           </p:nvSpPr>
           <p:spPr>
             <a:xfrm>
-              <a:off x="8341287" y="2158895"/>
-              <a:ext cx="2085098" cy="192756"/>
+              <a:off x="8323169" y="2140394"/>
+              <a:ext cx="2068273" cy="191200"/>
             </a:xfrm>
             <a:prstGeom prst="rect">
               <a:avLst/>
@@ -10472,7 +10472,7 @@
                 </a:lnSpc>
               </a:pPr>
               <a:r>
-                <a:rPr sz="1167" b="1" lang="ko-KR">
+                <a:rPr sz="1158" b="1" lang="ko-KR">
                   <a:solidFill>
                     <a:srgbClr val="00A4A6"/>
                   </a:solidFill>
@@ -10493,14 +10493,14 @@
           </p:nvSpPr>
           <p:spPr>
             <a:xfrm>
-              <a:off x="8214195" y="4545041"/>
-              <a:ext cx="3325566" cy="1567464"/>
-            </a:xfrm>
-            <a:prstGeom prst="rect">
-              <a:avLst/>
-            </a:prstGeom>
-            <a:noFill/>
-            <a:ln w="15886">
+              <a:off x="8197103" y="4507286"/>
+              <a:ext cx="3298732" cy="1596838"/>
+            </a:xfrm>
+            <a:prstGeom prst="rect">
+              <a:avLst/>
+            </a:prstGeom>
+            <a:noFill/>
+            <a:ln w="15758">
               <a:solidFill>
                 <a:srgbClr val="00A4A6"/>
               </a:solidFill>
@@ -10526,8 +10526,8 @@
           </p:nvSpPr>
           <p:spPr>
             <a:xfrm>
-              <a:off x="8341287" y="4594819"/>
-              <a:ext cx="2085098" cy="192756"/>
+              <a:off x="8323169" y="4556662"/>
+              <a:ext cx="2068273" cy="191200"/>
             </a:xfrm>
             <a:prstGeom prst="rect">
               <a:avLst/>
@@ -10546,7 +10546,7 @@
                 </a:lnSpc>
               </a:pPr>
               <a:r>
-                <a:rPr sz="1167" b="1" lang="ko-KR">
+                <a:rPr sz="1158" b="1" lang="ko-KR">
                   <a:solidFill>
                     <a:srgbClr val="00A4A6"/>
                   </a:solidFill>
@@ -10567,14 +10567,14 @@
           </p:nvSpPr>
           <p:spPr>
             <a:xfrm>
-              <a:off x="8341287" y="2426846"/>
-              <a:ext cx="3113747" cy="1122643"/>
-            </a:xfrm>
-            <a:prstGeom prst="rect">
-              <a:avLst/>
-            </a:prstGeom>
-            <a:noFill/>
-            <a:ln w="15886">
+              <a:off x="8323169" y="2406183"/>
+              <a:ext cx="3088621" cy="1113585"/>
+            </a:xfrm>
+            <a:prstGeom prst="rect">
+              <a:avLst/>
+            </a:prstGeom>
+            <a:noFill/>
+            <a:ln w="15758">
               <a:solidFill>
                 <a:srgbClr val="00A4A6"/>
               </a:solidFill>
@@ -10612,8 +10612,8 @@
           </p:blipFill>
           <p:spPr>
             <a:xfrm>
-              <a:off x="8341287" y="2426846"/>
-              <a:ext cx="254183" cy="254183"/>
+              <a:off x="8323169" y="2406183"/>
+              <a:ext cx="252132" cy="252132"/>
             </a:xfrm>
             <a:prstGeom prst="rect">
               <a:avLst/>
@@ -10628,8 +10628,8 @@
           </p:nvSpPr>
           <p:spPr>
             <a:xfrm>
-              <a:off x="8680198" y="2476624"/>
-              <a:ext cx="1779284" cy="192756"/>
+              <a:off x="8659346" y="2455559"/>
+              <a:ext cx="1764926" cy="191200"/>
             </a:xfrm>
             <a:prstGeom prst="rect">
               <a:avLst/>
@@ -10648,7 +10648,7 @@
                 </a:lnSpc>
               </a:pPr>
               <a:r>
-                <a:rPr sz="1167" b="1" lang="ko-KR">
+                <a:rPr sz="1158" b="1" lang="ko-KR">
                   <a:solidFill>
                     <a:srgbClr val="00A4A6"/>
                   </a:solidFill>
@@ -10669,14 +10669,14 @@
           </p:nvSpPr>
           <p:spPr>
             <a:xfrm>
-              <a:off x="8341287" y="4862770"/>
-              <a:ext cx="3113747" cy="1165007"/>
-            </a:xfrm>
-            <a:prstGeom prst="rect">
-              <a:avLst/>
-            </a:prstGeom>
-            <a:noFill/>
-            <a:ln w="15886">
+              <a:off x="8323169" y="4822451"/>
+              <a:ext cx="3088621" cy="1197629"/>
+            </a:xfrm>
+            <a:prstGeom prst="rect">
+              <a:avLst/>
+            </a:prstGeom>
+            <a:noFill/>
+            <a:ln w="15758">
               <a:solidFill>
                 <a:srgbClr val="00A4A6"/>
               </a:solidFill>
@@ -10714,8 +10714,8 @@
           </p:blipFill>
           <p:spPr>
             <a:xfrm>
-              <a:off x="8341287" y="4862770"/>
-              <a:ext cx="254183" cy="254183"/>
+              <a:off x="8323169" y="4822451"/>
+              <a:ext cx="252132" cy="252132"/>
             </a:xfrm>
             <a:prstGeom prst="rect">
               <a:avLst/>
@@ -10730,8 +10730,8 @@
           </p:nvSpPr>
           <p:spPr>
             <a:xfrm>
-              <a:off x="8680198" y="4912548"/>
-              <a:ext cx="1779284" cy="192756"/>
+              <a:off x="8659346" y="4871827"/>
+              <a:ext cx="1764926" cy="191200"/>
             </a:xfrm>
             <a:prstGeom prst="rect">
               <a:avLst/>
@@ -10750,7 +10750,7 @@
                 </a:lnSpc>
               </a:pPr>
               <a:r>
-                <a:rPr sz="1167" b="1" lang="ko-KR">
+                <a:rPr sz="1158" b="1" lang="ko-KR">
                   <a:solidFill>
                     <a:srgbClr val="00A4A6"/>
                   </a:solidFill>
@@ -10771,14 +10771,14 @@
           </p:nvSpPr>
           <p:spPr>
             <a:xfrm>
-              <a:off x="10078206" y="2511574"/>
-              <a:ext cx="1292099" cy="3473840"/>
-            </a:xfrm>
-            <a:prstGeom prst="rect">
-              <a:avLst/>
-            </a:prstGeom>
-            <a:noFill/>
-            <a:ln w="15886">
+              <a:off x="10025062" y="2490227"/>
+              <a:ext cx="1302684" cy="3445809"/>
+            </a:xfrm>
+            <a:prstGeom prst="rect">
+              <a:avLst/>
+            </a:prstGeom>
+            <a:noFill/>
+            <a:ln w="15758">
               <a:solidFill>
                 <a:srgbClr val="ED7100"/>
               </a:solidFill>
@@ -10818,8 +10818,8 @@
           </p:blipFill>
           <p:spPr>
             <a:xfrm>
-              <a:off x="10078206" y="2511574"/>
-              <a:ext cx="254183" cy="254183"/>
+              <a:off x="10025062" y="2490227"/>
+              <a:ext cx="252132" cy="252132"/>
             </a:xfrm>
             <a:prstGeom prst="rect">
               <a:avLst/>
@@ -10834,8 +10834,8 @@
           </p:nvSpPr>
           <p:spPr>
             <a:xfrm>
-              <a:off x="10417118" y="2561352"/>
-              <a:ext cx="454088" cy="192756"/>
+              <a:off x="10361239" y="2539603"/>
+              <a:ext cx="450424" cy="191200"/>
             </a:xfrm>
             <a:prstGeom prst="rect">
               <a:avLst/>
@@ -10854,7 +10854,7 @@
                 </a:lnSpc>
               </a:pPr>
               <a:r>
-                <a:rPr sz="1167" b="1" lang="ko-KR">
+                <a:rPr sz="1158" b="1" lang="ko-KR">
                   <a:solidFill>
                     <a:srgbClr val="ED7100"/>
                   </a:solidFill>
@@ -10889,8 +10889,8 @@
           </p:blipFill>
           <p:spPr>
             <a:xfrm>
-              <a:off x="10777211" y="2723394"/>
-              <a:ext cx="508367" cy="508367"/>
+              <a:off x="10739438" y="2700338"/>
+              <a:ext cx="504265" cy="504265"/>
             </a:xfrm>
             <a:prstGeom prst="rect">
               <a:avLst/>
@@ -10905,8 +10905,8 @@
           </p:nvSpPr>
           <p:spPr>
             <a:xfrm>
-              <a:off x="10679244" y="3281538"/>
-              <a:ext cx="704300" cy="192756"/>
+              <a:off x="10642261" y="3253978"/>
+              <a:ext cx="698617" cy="191200"/>
             </a:xfrm>
             <a:prstGeom prst="rect">
               <a:avLst/>
@@ -10925,7 +10925,7 @@
                 </a:lnSpc>
               </a:pPr>
               <a:r>
-                <a:rPr sz="1167" b="0" lang="ko-KR">
+                <a:rPr sz="1158" b="0" lang="ko-KR">
                   <a:solidFill>
                     <a:srgbClr val="232F3E"/>
                   </a:solidFill>
@@ -10960,8 +10960,8 @@
           </p:blipFill>
           <p:spPr>
             <a:xfrm>
-              <a:off x="10777211" y="5159318"/>
-              <a:ext cx="508367" cy="508367"/>
+              <a:off x="10739438" y="5116606"/>
+              <a:ext cx="504265" cy="504265"/>
             </a:xfrm>
             <a:prstGeom prst="rect">
               <a:avLst/>
@@ -10976,8 +10976,8 @@
           </p:nvSpPr>
           <p:spPr>
             <a:xfrm>
-              <a:off x="10679244" y="5717462"/>
-              <a:ext cx="704300" cy="192756"/>
+              <a:off x="10642261" y="5670247"/>
+              <a:ext cx="698617" cy="191200"/>
             </a:xfrm>
             <a:prstGeom prst="rect">
               <a:avLst/>
@@ -10996,7 +10996,7 @@
                 </a:lnSpc>
               </a:pPr>
               <a:r>
-                <a:rPr sz="1167" b="0" lang="ko-KR">
+                <a:rPr sz="1158" b="0" lang="ko-KR">
                   <a:solidFill>
                     <a:srgbClr val="232F3E"/>
                   </a:solidFill>
@@ -11031,8 +11031,8 @@
           </p:blipFill>
           <p:spPr>
             <a:xfrm>
-              <a:off x="8510742" y="3718945"/>
-              <a:ext cx="508367" cy="508367"/>
+              <a:off x="8491257" y="3687856"/>
+              <a:ext cx="504265" cy="504265"/>
             </a:xfrm>
             <a:prstGeom prst="rect">
               <a:avLst/>
@@ -11047,8 +11047,8 @@
           </p:nvSpPr>
           <p:spPr>
             <a:xfrm>
-              <a:off x="8486913" y="4277089"/>
-              <a:ext cx="556026" cy="192756"/>
+              <a:off x="8467620" y="4241497"/>
+              <a:ext cx="551540" cy="191200"/>
             </a:xfrm>
             <a:prstGeom prst="rect">
               <a:avLst/>
@@ -11067,7 +11067,7 @@
                 </a:lnSpc>
               </a:pPr>
               <a:r>
-                <a:rPr sz="1167" b="0" lang="ko-KR">
+                <a:rPr sz="1158" b="0" lang="ko-KR">
                   <a:solidFill>
                     <a:srgbClr val="232F3E"/>
                   </a:solidFill>
@@ -11088,8 +11088,8 @@
           </p:nvSpPr>
           <p:spPr>
             <a:xfrm>
-              <a:off x="2855162" y="2977577"/>
-              <a:ext cx="1864011" cy="995552"/>
+              <a:off x="2881312" y="2952470"/>
+              <a:ext cx="1848971" cy="987518"/>
             </a:xfrm>
             <a:custGeom>
               <a:avLst/>
@@ -11098,24 +11098,24 @@
               <a:cxnLst/>
               <a:rect l="l" t="t" r="r" b="b"/>
               <a:pathLst>
-                <a:path w="1864011" h="995552">
+                <a:path w="1848971" h="987518">
                   <a:moveTo>
-                    <a:pt x="0" y="995552"/>
+                    <a:pt x="0" y="987518"/>
                   </a:moveTo>
                   <a:lnTo>
-                    <a:pt x="1652192" y="995552"/>
+                    <a:pt x="1638861" y="987518"/>
                   </a:lnTo>
                   <a:lnTo>
-                    <a:pt x="1652192" y="0"/>
+                    <a:pt x="1638861" y="0"/>
                   </a:lnTo>
                   <a:lnTo>
-                    <a:pt x="1864011" y="0"/>
+                    <a:pt x="1848971" y="0"/>
                   </a:lnTo>
                 </a:path>
               </a:pathLst>
             </a:custGeom>
             <a:noFill/>
-            <a:ln w="15886">
+            <a:ln w="15758">
               <a:solidFill>
                 <a:srgbClr val="232F3E"/>
               </a:solidFill>
@@ -11140,8 +11140,8 @@
           </p:nvSpPr>
           <p:spPr>
             <a:xfrm>
-              <a:off x="2855162" y="3973129"/>
-              <a:ext cx="1864011" cy="1440372"/>
+              <a:off x="2881312" y="3939988"/>
+              <a:ext cx="1848971" cy="1428750"/>
             </a:xfrm>
             <a:custGeom>
               <a:avLst/>
@@ -11150,24 +11150,24 @@
               <a:cxnLst/>
               <a:rect l="l" t="t" r="r" b="b"/>
               <a:pathLst>
-                <a:path w="1864011" h="1440372">
+                <a:path w="1848971" h="1428750">
                   <a:moveTo>
                     <a:pt x="0" y="0"/>
                   </a:moveTo>
                   <a:lnTo>
-                    <a:pt x="1652192" y="0"/>
+                    <a:pt x="1638861" y="0"/>
                   </a:lnTo>
                   <a:lnTo>
-                    <a:pt x="1652192" y="1440372"/>
+                    <a:pt x="1638861" y="1428750"/>
                   </a:lnTo>
                   <a:lnTo>
-                    <a:pt x="1864011" y="1440372"/>
+                    <a:pt x="1848971" y="1428750"/>
                   </a:lnTo>
                 </a:path>
               </a:pathLst>
             </a:custGeom>
             <a:noFill/>
-            <a:ln w="15886">
+            <a:ln w="15758">
               <a:solidFill>
                 <a:srgbClr val="232F3E"/>
               </a:solidFill>
@@ -11192,13 +11192,13 @@
           </p:nvCxnSpPr>
           <p:spPr>
             <a:xfrm>
-              <a:off x="5312268" y="2977577"/>
-              <a:ext cx="921415" cy="0"/>
+              <a:off x="5318592" y="2952470"/>
+              <a:ext cx="913980" cy="0"/>
             </a:xfrm>
             <a:prstGeom prst="line">
               <a:avLst/>
             </a:prstGeom>
-            <a:ln w="15886">
+            <a:ln w="15758">
               <a:solidFill>
                 <a:srgbClr val="232F3E"/>
               </a:solidFill>
@@ -11216,13 +11216,13 @@
           </p:nvCxnSpPr>
           <p:spPr>
             <a:xfrm>
-              <a:off x="5312268" y="5413501"/>
-              <a:ext cx="921415" cy="0"/>
+              <a:off x="5318592" y="5368738"/>
+              <a:ext cx="913980" cy="0"/>
             </a:xfrm>
             <a:prstGeom prst="line">
               <a:avLst/>
             </a:prstGeom>
-            <a:ln w="15886">
+            <a:ln w="15758">
               <a:solidFill>
                 <a:srgbClr val="232F3E"/>
               </a:solidFill>
@@ -11240,8 +11240,8 @@
           </p:nvSpPr>
           <p:spPr>
             <a:xfrm>
-              <a:off x="5015721" y="3507126"/>
-              <a:ext cx="3452657" cy="381275"/>
+              <a:off x="5024438" y="3477746"/>
+              <a:ext cx="3424797" cy="378198"/>
             </a:xfrm>
             <a:custGeom>
               <a:avLst/>
@@ -11250,12 +11250,12 @@
               <a:cxnLst/>
               <a:rect l="l" t="t" r="r" b="b"/>
               <a:pathLst>
-                <a:path w="3452657" h="381275">
+                <a:path w="3424797" h="378198">
                   <a:moveTo>
-                    <a:pt x="3452657" y="381275"/>
+                    <a:pt x="3424797" y="378198"/>
                   </a:moveTo>
                   <a:lnTo>
-                    <a:pt x="0" y="381275"/>
+                    <a:pt x="0" y="378198"/>
                   </a:lnTo>
                   <a:lnTo>
                     <a:pt x="0" y="0"/>
@@ -11264,7 +11264,7 @@
               </a:pathLst>
             </a:custGeom>
             <a:noFill/>
-            <a:ln w="15886">
+            <a:ln w="15758">
               <a:solidFill>
                 <a:srgbClr val="232F3E"/>
               </a:solidFill>
@@ -11290,8 +11290,8 @@
           </p:nvSpPr>
           <p:spPr>
             <a:xfrm>
-              <a:off x="5015721" y="4057856"/>
-              <a:ext cx="3452657" cy="1059098"/>
+              <a:off x="5024438" y="4024032"/>
+              <a:ext cx="3424797" cy="1050552"/>
             </a:xfrm>
             <a:custGeom>
               <a:avLst/>
@@ -11300,21 +11300,21 @@
               <a:cxnLst/>
               <a:rect l="l" t="t" r="r" b="b"/>
               <a:pathLst>
-                <a:path w="3452657" h="1059098">
+                <a:path w="3424797" h="1050552">
                   <a:moveTo>
-                    <a:pt x="3452657" y="0"/>
+                    <a:pt x="3424797" y="0"/>
                   </a:moveTo>
                   <a:lnTo>
                     <a:pt x="0" y="0"/>
                   </a:lnTo>
                   <a:lnTo>
-                    <a:pt x="0" y="1059098"/>
+                    <a:pt x="0" y="1050552"/>
                   </a:lnTo>
                 </a:path>
               </a:pathLst>
             </a:custGeom>
             <a:noFill/>
-            <a:ln w="15886">
+            <a:ln w="15758">
               <a:solidFill>
                 <a:srgbClr val="232F3E"/>
               </a:solidFill>
@@ -11340,13 +11340,13 @@
           </p:nvCxnSpPr>
           <p:spPr>
             <a:xfrm>
-              <a:off x="9061473" y="3973129"/>
-              <a:ext cx="974370" cy="0"/>
+              <a:off x="9037544" y="3939988"/>
+              <a:ext cx="966507" cy="0"/>
             </a:xfrm>
             <a:prstGeom prst="line">
               <a:avLst/>
             </a:prstGeom>
-            <a:ln w="15886">
+            <a:ln w="15758">
               <a:solidFill>
                 <a:srgbClr val="232F3E"/>
               </a:solidFill>
@@ -11365,8 +11365,8 @@
           </p:nvSpPr>
           <p:spPr>
             <a:xfrm>
-              <a:off x="8960859" y="4021847"/>
-              <a:ext cx="1175598" cy="165219"/>
+              <a:off x="8937742" y="3988314"/>
+              <a:ext cx="1166112" cy="163886"/>
             </a:xfrm>
             <a:prstGeom prst="rect">
               <a:avLst/>
@@ -11385,7 +11385,7 @@
                 </a:lnSpc>
               </a:pPr>
               <a:r>
-                <a:rPr sz="1000" b="0" lang="ko-KR">
+                <a:rPr sz="992" b="0" lang="ko-KR">
                   <a:solidFill>
                     <a:srgbClr val="232F3E"/>
                   </a:solidFill>
@@ -11406,8 +11406,8 @@
           </p:nvSpPr>
           <p:spPr>
             <a:xfrm>
-              <a:off x="3575348" y="3718945"/>
-              <a:ext cx="211819" cy="211819"/>
+              <a:off x="3595687" y="3687856"/>
+              <a:ext cx="210110" cy="210110"/>
             </a:xfrm>
             <a:prstGeom prst="ellipse">
               <a:avLst/>
@@ -11435,8 +11435,8 @@
           </p:nvSpPr>
           <p:spPr>
             <a:xfrm>
-              <a:off x="3574024" y="3746482"/>
-              <a:ext cx="214467" cy="165219"/>
+              <a:off x="3594374" y="3715170"/>
+              <a:ext cx="212737" cy="163886"/>
             </a:xfrm>
             <a:prstGeom prst="rect">
               <a:avLst/>
@@ -11455,7 +11455,7 @@
                 </a:lnSpc>
               </a:pPr>
               <a:r>
-                <a:rPr sz="1000" b="1" lang="ko-KR">
+                <a:rPr sz="992" b="1" lang="ko-KR">
                   <a:solidFill>
                     <a:srgbClr val="FFFFFF"/>
                   </a:solidFill>
@@ -11476,8 +11476,8 @@
           </p:nvSpPr>
           <p:spPr>
             <a:xfrm>
-              <a:off x="7727010" y="3634217"/>
-              <a:ext cx="211819" cy="211819"/>
+              <a:off x="7713849" y="3603812"/>
+              <a:ext cx="210110" cy="210110"/>
             </a:xfrm>
             <a:prstGeom prst="ellipse">
               <a:avLst/>
@@ -11505,8 +11505,8 @@
           </p:nvSpPr>
           <p:spPr>
             <a:xfrm>
-              <a:off x="7725686" y="3661754"/>
-              <a:ext cx="214467" cy="165219"/>
+              <a:off x="7712536" y="3631126"/>
+              <a:ext cx="212737" cy="163886"/>
             </a:xfrm>
             <a:prstGeom prst="rect">
               <a:avLst/>
@@ -11525,7 +11525,7 @@
                 </a:lnSpc>
               </a:pPr>
               <a:r>
-                <a:rPr sz="1000" b="1" lang="ko-KR">
+                <a:rPr sz="992" b="1" lang="ko-KR">
                   <a:solidFill>
                     <a:srgbClr val="FFFFFF"/>
                   </a:solidFill>
@@ -11546,8 +11546,8 @@
           </p:nvSpPr>
           <p:spPr>
             <a:xfrm>
-              <a:off x="9442748" y="3718945"/>
-              <a:ext cx="211819" cy="211819"/>
+              <a:off x="9415743" y="3687856"/>
+              <a:ext cx="210110" cy="210110"/>
             </a:xfrm>
             <a:prstGeom prst="ellipse">
               <a:avLst/>
@@ -11575,8 +11575,8 @@
           </p:nvSpPr>
           <p:spPr>
             <a:xfrm>
-              <a:off x="9441424" y="3746482"/>
-              <a:ext cx="214467" cy="165219"/>
+              <a:off x="9414429" y="3715170"/>
+              <a:ext cx="212737" cy="163886"/>
             </a:xfrm>
             <a:prstGeom prst="rect">
               <a:avLst/>
@@ -11595,7 +11595,7 @@
                 </a:lnSpc>
               </a:pPr>
               <a:r>
-                <a:rPr sz="1000" b="1" lang="ko-KR">
+                <a:rPr sz="992" b="1" lang="ko-KR">
                   <a:solidFill>
                     <a:srgbClr val="FFFFFF"/>
                   </a:solidFill>
@@ -11616,8 +11616,8 @@
           </p:nvSpPr>
           <p:spPr>
             <a:xfrm>
-              <a:off x="5884181" y="2723394"/>
-              <a:ext cx="211819" cy="211819"/>
+              <a:off x="5885890" y="2700338"/>
+              <a:ext cx="210110" cy="210110"/>
             </a:xfrm>
             <a:prstGeom prst="ellipse">
               <a:avLst/>
@@ -11645,8 +11645,8 @@
           </p:nvSpPr>
           <p:spPr>
             <a:xfrm>
-              <a:off x="5882857" y="2750930"/>
-              <a:ext cx="214467" cy="165219"/>
+              <a:off x="5884577" y="2727652"/>
+              <a:ext cx="212737" cy="163886"/>
             </a:xfrm>
             <a:prstGeom prst="rect">
               <a:avLst/>
@@ -11665,7 +11665,7 @@
                 </a:lnSpc>
               </a:pPr>
               <a:r>
-                <a:rPr sz="1000" b="1" lang="ko-KR">
+                <a:rPr sz="992" b="1" lang="ko-KR">
                   <a:solidFill>
                     <a:srgbClr val="FFFFFF"/>
                   </a:solidFill>
@@ -11686,8 +11686,8 @@
           </p:nvSpPr>
           <p:spPr>
             <a:xfrm>
-              <a:off x="5884181" y="5159318"/>
-              <a:ext cx="211819" cy="211819"/>
+              <a:off x="5885890" y="5116606"/>
+              <a:ext cx="210110" cy="210110"/>
             </a:xfrm>
             <a:prstGeom prst="ellipse">
               <a:avLst/>
@@ -11715,8 +11715,8 @@
           </p:nvSpPr>
           <p:spPr>
             <a:xfrm>
-              <a:off x="5882857" y="5186854"/>
-              <a:ext cx="214467" cy="165219"/>
+              <a:off x="5884577" y="5143920"/>
+              <a:ext cx="212737" cy="163886"/>
             </a:xfrm>
             <a:prstGeom prst="rect">
               <a:avLst/>
@@ -11735,7 +11735,7 @@
                 </a:lnSpc>
               </a:pPr>
               <a:r>
-                <a:rPr sz="1000" b="1" lang="ko-KR">
+                <a:rPr sz="992" b="1" lang="ko-KR">
                   <a:solidFill>
                     <a:srgbClr val="FFFFFF"/>
                   </a:solidFill>
@@ -11756,13 +11756,13 @@
           </p:nvCxnSpPr>
           <p:spPr>
             <a:xfrm>
-              <a:off x="864058" y="3973129"/>
-              <a:ext cx="1398009" cy="0"/>
+              <a:off x="906276" y="3939988"/>
+              <a:ext cx="1386728" cy="0"/>
             </a:xfrm>
             <a:prstGeom prst="line">
               <a:avLst/>
             </a:prstGeom>
-            <a:ln w="15886">
+            <a:ln w="15758">
               <a:solidFill>
                 <a:srgbClr val="232F3E"/>
               </a:solidFill>
@@ -11780,8 +11780,8 @@
           </p:nvSpPr>
           <p:spPr>
             <a:xfrm>
-              <a:off x="766092" y="3757073"/>
-              <a:ext cx="1000847" cy="165219"/>
+              <a:off x="809100" y="3725676"/>
+              <a:ext cx="992771" cy="163886"/>
             </a:xfrm>
             <a:prstGeom prst="rect">
               <a:avLst/>
@@ -11800,7 +11800,7 @@
                 </a:lnSpc>
               </a:pPr>
               <a:r>
-                <a:rPr sz="1000" b="0" lang="ko-KR">
+                <a:rPr sz="992" b="0" lang="ko-KR">
                   <a:solidFill>
                     <a:srgbClr val="232F3E"/>
                   </a:solidFill>
@@ -11821,8 +11821,8 @@
           </p:nvSpPr>
           <p:spPr>
             <a:xfrm>
-              <a:off x="1711336" y="6398462"/>
-              <a:ext cx="211819" cy="211819"/>
+              <a:off x="1746717" y="6440301"/>
+              <a:ext cx="210110" cy="210110"/>
             </a:xfrm>
             <a:prstGeom prst="ellipse">
               <a:avLst/>
@@ -11850,8 +11850,8 @@
           </p:nvSpPr>
           <p:spPr>
             <a:xfrm>
-              <a:off x="1710013" y="6425998"/>
-              <a:ext cx="214467" cy="165219"/>
+              <a:off x="1745404" y="6467615"/>
+              <a:ext cx="212737" cy="163886"/>
             </a:xfrm>
             <a:prstGeom prst="rect">
               <a:avLst/>
@@ -11870,7 +11870,7 @@
                 </a:lnSpc>
               </a:pPr>
               <a:r>
-                <a:rPr sz="1000" b="1" lang="ko-KR">
+                <a:rPr sz="992" b="1" lang="ko-KR">
                   <a:solidFill>
                     <a:srgbClr val="FFFFFF"/>
                   </a:solidFill>
@@ -11891,8 +11891,8 @@
           </p:nvSpPr>
           <p:spPr>
             <a:xfrm>
-              <a:off x="2007884" y="6425998"/>
-              <a:ext cx="2549777" cy="165219"/>
+              <a:off x="2040871" y="6467615"/>
+              <a:ext cx="2600115" cy="163886"/>
             </a:xfrm>
             <a:prstGeom prst="rect">
               <a:avLst/>
@@ -11911,7 +11911,7 @@
                 </a:lnSpc>
               </a:pPr>
               <a:r>
-                <a:rPr sz="1000" b="0" lang="ko-KR">
+                <a:rPr sz="992" b="0" lang="ko-KR">
                   <a:solidFill>
                     <a:srgbClr val="545B64"/>
                   </a:solidFill>
@@ -11932,8 +11932,8 @@
           </p:nvSpPr>
           <p:spPr>
             <a:xfrm>
-              <a:off x="4066769" y="6398462"/>
-              <a:ext cx="211819" cy="211819"/>
+              <a:off x="4230221" y="6440301"/>
+              <a:ext cx="210110" cy="210110"/>
             </a:xfrm>
             <a:prstGeom prst="ellipse">
               <a:avLst/>
@@ -11961,8 +11961,8 @@
           </p:nvSpPr>
           <p:spPr>
             <a:xfrm>
-              <a:off x="4065445" y="6425998"/>
-              <a:ext cx="214467" cy="165219"/>
+              <a:off x="4228907" y="6467615"/>
+              <a:ext cx="212737" cy="163886"/>
             </a:xfrm>
             <a:prstGeom prst="rect">
               <a:avLst/>
@@ -11981,7 +11981,7 @@
                 </a:lnSpc>
               </a:pPr>
               <a:r>
-                <a:rPr sz="1000" b="1" lang="ko-KR">
+                <a:rPr sz="992" b="1" lang="ko-KR">
                   <a:solidFill>
                     <a:srgbClr val="FFFFFF"/>
                   </a:solidFill>
@@ -12002,8 +12002,8 @@
           </p:nvSpPr>
           <p:spPr>
             <a:xfrm>
-              <a:off x="4363317" y="6425998"/>
-              <a:ext cx="1175598" cy="165219"/>
+              <a:off x="4524375" y="6467615"/>
+              <a:ext cx="1237024" cy="163886"/>
             </a:xfrm>
             <a:prstGeom prst="rect">
               <a:avLst/>
@@ -12022,7 +12022,7 @@
                 </a:lnSpc>
               </a:pPr>
               <a:r>
-                <a:rPr sz="1000" b="0" lang="ko-KR">
+                <a:rPr sz="992" b="0" lang="ko-KR">
                   <a:solidFill>
                     <a:srgbClr val="545B64"/>
                   </a:solidFill>
@@ -12043,8 +12043,8 @@
           </p:nvSpPr>
           <p:spPr>
             <a:xfrm>
-              <a:off x="5560097" y="6398462"/>
-              <a:ext cx="211819" cy="211819"/>
+              <a:off x="5623252" y="6440301"/>
+              <a:ext cx="210110" cy="210110"/>
             </a:xfrm>
             <a:prstGeom prst="ellipse">
               <a:avLst/>
@@ -12072,8 +12072,8 @@
           </p:nvSpPr>
           <p:spPr>
             <a:xfrm>
-              <a:off x="5558773" y="6425998"/>
-              <a:ext cx="214467" cy="165219"/>
+              <a:off x="5621939" y="6467615"/>
+              <a:ext cx="212737" cy="163886"/>
             </a:xfrm>
             <a:prstGeom prst="rect">
               <a:avLst/>
@@ -12092,7 +12092,7 @@
                 </a:lnSpc>
               </a:pPr>
               <a:r>
-                <a:rPr sz="1000" b="1" lang="ko-KR">
+                <a:rPr sz="992" b="1" lang="ko-KR">
                   <a:solidFill>
                     <a:srgbClr val="FFFFFF"/>
                   </a:solidFill>
@@ -12113,8 +12113,8 @@
           </p:nvSpPr>
           <p:spPr>
             <a:xfrm>
-              <a:off x="5856644" y="6425998"/>
-              <a:ext cx="3741262" cy="165219"/>
+              <a:off x="5917406" y="6467615"/>
+              <a:ext cx="3852898" cy="163886"/>
             </a:xfrm>
             <a:prstGeom prst="rect">
               <a:avLst/>
@@ -12133,7 +12133,7 @@
                 </a:lnSpc>
               </a:pPr>
               <a:r>
-                <a:rPr sz="1000" b="0" lang="ko-KR">
+                <a:rPr sz="992" b="0" lang="ko-KR">
                   <a:solidFill>
                     <a:srgbClr val="545B64"/>
                   </a:solidFill>
@@ -12154,8 +12154,8 @@
           </p:nvSpPr>
           <p:spPr>
             <a:xfrm>
-              <a:off x="8925908" y="6398462"/>
-              <a:ext cx="211819" cy="211819"/>
+              <a:off x="9108982" y="6440301"/>
+              <a:ext cx="210110" cy="210110"/>
             </a:xfrm>
             <a:prstGeom prst="ellipse">
               <a:avLst/>
@@ -12183,8 +12183,8 @@
           </p:nvSpPr>
           <p:spPr>
             <a:xfrm>
-              <a:off x="8924585" y="6425998"/>
-              <a:ext cx="214467" cy="165219"/>
+              <a:off x="9107668" y="6467615"/>
+              <a:ext cx="212737" cy="163886"/>
             </a:xfrm>
             <a:prstGeom prst="rect">
               <a:avLst/>
@@ -12203,7 +12203,7 @@
                 </a:lnSpc>
               </a:pPr>
               <a:r>
-                <a:rPr sz="1000" b="1" lang="ko-KR">
+                <a:rPr sz="992" b="1" lang="ko-KR">
                   <a:solidFill>
                     <a:srgbClr val="FFFFFF"/>
                   </a:solidFill>
@@ -12224,8 +12224,8 @@
           </p:nvSpPr>
           <p:spPr>
             <a:xfrm>
-              <a:off x="9222456" y="6425998"/>
-              <a:ext cx="1088223" cy="165219"/>
+              <a:off x="9403136" y="6467615"/>
+              <a:ext cx="1150354" cy="163886"/>
             </a:xfrm>
             <a:prstGeom prst="rect">
               <a:avLst/>
@@ -12244,7 +12244,7 @@
                 </a:lnSpc>
               </a:pPr>
               <a:r>
-                <a:rPr sz="1000" b="0" lang="ko-KR">
+                <a:rPr sz="992" b="0" lang="ko-KR">
                   <a:solidFill>
                     <a:srgbClr val="545B64"/>
                   </a:solidFill>
@@ -12320,10 +12320,10 @@
         </p:nvGrpSpPr>
         <p:grpSpPr>
           <a:xfrm>
-            <a:off x="402167" y="1083733"/>
-            <a:ext cx="13337646" cy="5526617"/>
-            <a:chOff x="402167" y="1083733"/>
-            <a:chExt cx="13337646" cy="5526617"/>
+            <a:off x="592667" y="1083733"/>
+            <a:ext cx="12472458" cy="5547784"/>
+            <a:chOff x="592667" y="1083733"/>
+            <a:chExt cx="12472458" cy="5547784"/>
           </a:xfrm>
         </p:grpSpPr>
         <p:sp>
@@ -12334,7 +12334,7 @@
           </p:nvSpPr>
           <p:spPr>
             <a:xfrm>
-              <a:off x="402167" y="2988733"/>
+              <a:off x="592667" y="2988733"/>
               <a:ext cx="1820333" cy="1397000"/>
             </a:xfrm>
             <a:prstGeom prst="rect">
@@ -12379,7 +12379,7 @@
           </p:blipFill>
           <p:spPr>
             <a:xfrm>
-              <a:off x="402167" y="2988733"/>
+              <a:off x="592667" y="2988733"/>
               <a:ext cx="254000" cy="254000"/>
             </a:xfrm>
             <a:prstGeom prst="rect">
@@ -12395,7 +12395,7 @@
           </p:nvSpPr>
           <p:spPr>
             <a:xfrm>
-              <a:off x="740833" y="3038475"/>
+              <a:off x="931333" y="3038475"/>
               <a:ext cx="1268677" cy="192617"/>
             </a:xfrm>
             <a:prstGeom prst="rect">
@@ -12450,7 +12450,7 @@
           </p:blipFill>
           <p:spPr>
             <a:xfrm>
-              <a:off x="1058333" y="3348567"/>
+              <a:off x="1248833" y="3348567"/>
               <a:ext cx="508000" cy="508000"/>
             </a:xfrm>
             <a:prstGeom prst="rect">
@@ -12466,7 +12466,7 @@
           </p:nvSpPr>
           <p:spPr>
             <a:xfrm>
-              <a:off x="423333" y="3906308"/>
+              <a:off x="613833" y="3906308"/>
               <a:ext cx="1778000" cy="192617"/>
             </a:xfrm>
             <a:prstGeom prst="rect">
@@ -12507,7 +12507,7 @@
           </p:nvSpPr>
           <p:spPr>
             <a:xfrm>
-              <a:off x="637646" y="4095750"/>
+              <a:off x="828146" y="4095750"/>
               <a:ext cx="1349375" cy="165100"/>
             </a:xfrm>
             <a:prstGeom prst="rect">
@@ -12562,7 +12562,7 @@
           </p:blipFill>
           <p:spPr>
             <a:xfrm>
-              <a:off x="2582333" y="3348567"/>
+              <a:off x="2772833" y="3348567"/>
               <a:ext cx="508000" cy="508000"/>
             </a:xfrm>
             <a:prstGeom prst="rect">
@@ -12578,7 +12578,7 @@
           </p:nvSpPr>
           <p:spPr>
             <a:xfrm>
-              <a:off x="2354792" y="3906308"/>
+              <a:off x="2545292" y="3906308"/>
               <a:ext cx="963083" cy="192617"/>
             </a:xfrm>
             <a:prstGeom prst="rect">
@@ -12619,7 +12619,7 @@
           </p:nvCxnSpPr>
           <p:spPr>
             <a:xfrm>
-              <a:off x="1608667" y="3602567"/>
+              <a:off x="1799167" y="3602567"/>
               <a:ext cx="931333" cy="0"/>
             </a:xfrm>
             <a:prstGeom prst="line">
@@ -12642,7 +12642,7 @@
           </p:nvCxnSpPr>
           <p:spPr>
             <a:xfrm>
-              <a:off x="3132667" y="3602567"/>
+              <a:off x="3323167" y="3602567"/>
               <a:ext cx="529166" cy="0"/>
             </a:xfrm>
             <a:prstGeom prst="line">
@@ -12665,7 +12665,7 @@
           </p:nvSpPr>
           <p:spPr>
             <a:xfrm>
-              <a:off x="3115469" y="3386667"/>
+              <a:off x="3305969" y="3386667"/>
               <a:ext cx="563562" cy="165100"/>
             </a:xfrm>
             <a:prstGeom prst="rect">
@@ -12720,7 +12720,7 @@
           </p:blipFill>
           <p:spPr>
             <a:xfrm>
-              <a:off x="3704167" y="3348567"/>
+              <a:off x="3894667" y="3348567"/>
               <a:ext cx="508000" cy="508000"/>
             </a:xfrm>
             <a:prstGeom prst="rect">
@@ -12736,7 +12736,7 @@
           </p:nvSpPr>
           <p:spPr>
             <a:xfrm>
-              <a:off x="3069167" y="3906308"/>
+              <a:off x="3259667" y="3906308"/>
               <a:ext cx="1778000" cy="192617"/>
             </a:xfrm>
             <a:prstGeom prst="rect">
@@ -12777,7 +12777,7 @@
           </p:nvCxnSpPr>
           <p:spPr>
             <a:xfrm>
-              <a:off x="4254500" y="3602567"/>
+              <a:off x="4445000" y="3602567"/>
               <a:ext cx="1820333" cy="0"/>
             </a:xfrm>
             <a:prstGeom prst="line">
@@ -12800,8 +12800,8 @@
           </p:nvSpPr>
           <p:spPr>
             <a:xfrm>
-              <a:off x="4762500" y="1083733"/>
-              <a:ext cx="7027333" cy="4931833"/>
+              <a:off x="4953000" y="1083733"/>
+              <a:ext cx="6646333" cy="4931833"/>
             </a:xfrm>
             <a:prstGeom prst="rect">
               <a:avLst/>
@@ -12845,7 +12845,7 @@
           </p:blipFill>
           <p:spPr>
             <a:xfrm>
-              <a:off x="4762500" y="1083733"/>
+              <a:off x="4953000" y="1083733"/>
               <a:ext cx="338667" cy="338667"/>
             </a:xfrm>
             <a:prstGeom prst="rect">
@@ -12861,7 +12861,7 @@
           </p:nvSpPr>
           <p:spPr>
             <a:xfrm>
-              <a:off x="5207000" y="1165754"/>
+              <a:off x="5397500" y="1165754"/>
               <a:ext cx="1141016" cy="206375"/>
             </a:xfrm>
             <a:prstGeom prst="rect">
@@ -12902,8 +12902,8 @@
           </p:nvSpPr>
           <p:spPr>
             <a:xfrm>
-              <a:off x="4974167" y="1507067"/>
-              <a:ext cx="3048000" cy="4296833"/>
+              <a:off x="5164667" y="1507067"/>
+              <a:ext cx="2667000" cy="4296833"/>
             </a:xfrm>
             <a:prstGeom prst="rect">
               <a:avLst/>
@@ -12949,7 +12949,7 @@
           </p:blipFill>
           <p:spPr>
             <a:xfrm>
-              <a:off x="4974167" y="1507067"/>
+              <a:off x="5164667" y="1507067"/>
               <a:ext cx="254000" cy="254000"/>
             </a:xfrm>
             <a:prstGeom prst="rect">
@@ -12965,7 +12965,7 @@
           </p:nvSpPr>
           <p:spPr>
             <a:xfrm>
-              <a:off x="5312833" y="1556808"/>
+              <a:off x="5503333" y="1556808"/>
               <a:ext cx="2287323" cy="192617"/>
             </a:xfrm>
             <a:prstGeom prst="rect">
@@ -13020,7 +13020,7 @@
           </p:blipFill>
           <p:spPr>
             <a:xfrm>
-              <a:off x="6117167" y="3348567"/>
+              <a:off x="6307667" y="3348567"/>
               <a:ext cx="508000" cy="508000"/>
             </a:xfrm>
             <a:prstGeom prst="rect">
@@ -13036,7 +13036,7 @@
           </p:nvSpPr>
           <p:spPr>
             <a:xfrm>
-              <a:off x="5431234" y="3906308"/>
+              <a:off x="5621734" y="3906308"/>
               <a:ext cx="1879865" cy="192617"/>
             </a:xfrm>
             <a:prstGeom prst="rect">
@@ -13091,7 +13091,7 @@
           </p:blipFill>
           <p:spPr>
             <a:xfrm>
-              <a:off x="5482167" y="1930400"/>
+              <a:off x="5672667" y="1930400"/>
               <a:ext cx="508000" cy="508000"/>
             </a:xfrm>
             <a:prstGeom prst="rect">
@@ -13107,7 +13107,7 @@
           </p:nvSpPr>
           <p:spPr>
             <a:xfrm>
-              <a:off x="5050896" y="2488142"/>
+              <a:off x="5241396" y="2488142"/>
               <a:ext cx="1370542" cy="192617"/>
             </a:xfrm>
             <a:prstGeom prst="rect">
@@ -13148,7 +13148,7 @@
           </p:nvSpPr>
           <p:spPr>
             <a:xfrm>
-              <a:off x="5192448" y="2677583"/>
+              <a:off x="5382948" y="2677583"/>
               <a:ext cx="1087438" cy="165100"/>
             </a:xfrm>
             <a:prstGeom prst="rect">
@@ -13203,7 +13203,7 @@
           </p:blipFill>
           <p:spPr>
             <a:xfrm>
-              <a:off x="6752167" y="1930400"/>
+              <a:off x="6942667" y="1930400"/>
               <a:ext cx="508000" cy="508000"/>
             </a:xfrm>
             <a:prstGeom prst="rect">
@@ -13219,7 +13219,7 @@
           </p:nvSpPr>
           <p:spPr>
             <a:xfrm>
-              <a:off x="6524625" y="2488142"/>
+              <a:off x="6715125" y="2488142"/>
               <a:ext cx="963083" cy="192617"/>
             </a:xfrm>
             <a:prstGeom prst="rect">
@@ -13260,7 +13260,7 @@
           </p:nvSpPr>
           <p:spPr>
             <a:xfrm>
-              <a:off x="6462448" y="2677583"/>
+              <a:off x="6652948" y="2677583"/>
               <a:ext cx="1087438" cy="165100"/>
             </a:xfrm>
             <a:prstGeom prst="rect">
@@ -13315,7 +13315,7 @@
           </p:blipFill>
           <p:spPr>
             <a:xfrm>
-              <a:off x="5482167" y="4766733"/>
+              <a:off x="5672667" y="4766733"/>
               <a:ext cx="508000" cy="508000"/>
             </a:xfrm>
             <a:prstGeom prst="rect">
@@ -13331,7 +13331,7 @@
           </p:nvSpPr>
           <p:spPr>
             <a:xfrm>
-              <a:off x="5305557" y="5324475"/>
+              <a:off x="5496057" y="5324475"/>
               <a:ext cx="861219" cy="192617"/>
             </a:xfrm>
             <a:prstGeom prst="rect">
@@ -13372,7 +13372,7 @@
           </p:nvSpPr>
           <p:spPr>
             <a:xfrm>
-              <a:off x="5192448" y="5513917"/>
+              <a:off x="5382948" y="5513917"/>
               <a:ext cx="1087438" cy="165100"/>
             </a:xfrm>
             <a:prstGeom prst="rect">
@@ -13427,7 +13427,7 @@
           </p:blipFill>
           <p:spPr>
             <a:xfrm>
-              <a:off x="6752167" y="4766733"/>
+              <a:off x="6942667" y="4766733"/>
               <a:ext cx="508000" cy="508000"/>
             </a:xfrm>
             <a:prstGeom prst="rect">
@@ -13443,7 +13443,7 @@
           </p:nvSpPr>
           <p:spPr>
             <a:xfrm>
-              <a:off x="6524625" y="5324475"/>
+              <a:off x="6715125" y="5324475"/>
               <a:ext cx="963083" cy="192617"/>
             </a:xfrm>
             <a:prstGeom prst="rect">
@@ -13484,7 +13484,7 @@
           </p:nvSpPr>
           <p:spPr>
             <a:xfrm>
-              <a:off x="6462448" y="5513917"/>
+              <a:off x="6652948" y="5513917"/>
               <a:ext cx="1087438" cy="165100"/>
             </a:xfrm>
             <a:prstGeom prst="rect">
@@ -13525,7 +13525,7 @@
           </p:nvSpPr>
           <p:spPr>
             <a:xfrm>
-              <a:off x="5736167" y="2882900"/>
+              <a:off x="5926667" y="2882900"/>
               <a:ext cx="529166" cy="423333"/>
             </a:xfrm>
             <a:custGeom>
@@ -13576,7 +13576,7 @@
           </p:nvSpPr>
           <p:spPr>
             <a:xfrm>
-              <a:off x="6477000" y="2882900"/>
+              <a:off x="6667500" y="2882900"/>
               <a:ext cx="529167" cy="423333"/>
             </a:xfrm>
             <a:custGeom>
@@ -13627,7 +13627,7 @@
           </p:nvSpPr>
           <p:spPr>
             <a:xfrm>
-              <a:off x="5736167" y="4131733"/>
+              <a:off x="5926667" y="4131733"/>
               <a:ext cx="529166" cy="592667"/>
             </a:xfrm>
             <a:custGeom>
@@ -13678,7 +13678,7 @@
           </p:nvSpPr>
           <p:spPr>
             <a:xfrm>
-              <a:off x="6477000" y="4131733"/>
+              <a:off x="6667500" y="4131733"/>
               <a:ext cx="529167" cy="592667"/>
             </a:xfrm>
             <a:custGeom>
@@ -13729,7 +13729,7 @@
           </p:nvSpPr>
           <p:spPr>
             <a:xfrm>
-              <a:off x="9122833" y="1507067"/>
+              <a:off x="8932333" y="1507067"/>
               <a:ext cx="2455333" cy="4296833"/>
             </a:xfrm>
             <a:prstGeom prst="rect">
@@ -13776,7 +13776,7 @@
           </p:blipFill>
           <p:spPr>
             <a:xfrm>
-              <a:off x="9122833" y="1507067"/>
+              <a:off x="8932333" y="1507067"/>
               <a:ext cx="254000" cy="254000"/>
             </a:xfrm>
             <a:prstGeom prst="rect">
@@ -13792,7 +13792,7 @@
           </p:nvSpPr>
           <p:spPr>
             <a:xfrm>
-              <a:off x="9461500" y="1556808"/>
+              <a:off x="9271000" y="1556808"/>
               <a:ext cx="2287323" cy="192617"/>
             </a:xfrm>
             <a:prstGeom prst="rect">
@@ -13847,7 +13847,7 @@
           </p:blipFill>
           <p:spPr>
             <a:xfrm>
-              <a:off x="10054167" y="3348567"/>
+              <a:off x="9863667" y="3348567"/>
               <a:ext cx="508000" cy="508000"/>
             </a:xfrm>
             <a:prstGeom prst="rect">
@@ -13863,7 +13863,7 @@
           </p:nvSpPr>
           <p:spPr>
             <a:xfrm>
-              <a:off x="9368234" y="3906308"/>
+              <a:off x="9177734" y="3906308"/>
               <a:ext cx="1879865" cy="192617"/>
             </a:xfrm>
             <a:prstGeom prst="rect">
@@ -13918,7 +13918,7 @@
           </p:blipFill>
           <p:spPr>
             <a:xfrm>
-              <a:off x="10054167" y="1930400"/>
+              <a:off x="9863667" y="1930400"/>
               <a:ext cx="508000" cy="508000"/>
             </a:xfrm>
             <a:prstGeom prst="rect">
@@ -13934,7 +13934,7 @@
           </p:nvSpPr>
           <p:spPr>
             <a:xfrm>
-              <a:off x="9928490" y="2488142"/>
+              <a:off x="9737990" y="2488142"/>
               <a:ext cx="759354" cy="192617"/>
             </a:xfrm>
             <a:prstGeom prst="rect">
@@ -13975,7 +13975,7 @@
           </p:nvSpPr>
           <p:spPr>
             <a:xfrm>
-              <a:off x="9720792" y="2677583"/>
+              <a:off x="9530292" y="2677583"/>
               <a:ext cx="1174750" cy="165100"/>
             </a:xfrm>
             <a:prstGeom prst="rect">
@@ -14030,7 +14030,7 @@
           </p:blipFill>
           <p:spPr>
             <a:xfrm>
-              <a:off x="10054167" y="4766733"/>
+              <a:off x="9863667" y="4766733"/>
               <a:ext cx="508000" cy="508000"/>
             </a:xfrm>
             <a:prstGeom prst="rect">
@@ -14046,7 +14046,7 @@
           </p:nvSpPr>
           <p:spPr>
             <a:xfrm>
-              <a:off x="9571964" y="5324475"/>
+              <a:off x="9381464" y="5324475"/>
               <a:ext cx="1472406" cy="192617"/>
             </a:xfrm>
             <a:prstGeom prst="rect">
@@ -14087,7 +14087,7 @@
           </p:nvSpPr>
           <p:spPr>
             <a:xfrm>
-              <a:off x="9720792" y="5513917"/>
+              <a:off x="9530292" y="5513917"/>
               <a:ext cx="1174750" cy="165100"/>
             </a:xfrm>
             <a:prstGeom prst="rect">
@@ -14128,7 +14128,7 @@
           </p:nvCxnSpPr>
           <p:spPr>
             <a:xfrm flipV="1">
-              <a:off x="10308167" y="2882900"/>
+              <a:off x="10117667" y="2882900"/>
               <a:ext cx="0" cy="423333"/>
             </a:xfrm>
             <a:prstGeom prst="line">
@@ -14151,7 +14151,7 @@
           </p:nvCxnSpPr>
           <p:spPr>
             <a:xfrm>
-              <a:off x="10308167" y="4131733"/>
+              <a:off x="10117667" y="4131733"/>
               <a:ext cx="0" cy="592667"/>
             </a:xfrm>
             <a:prstGeom prst="line">
@@ -14174,8 +14174,8 @@
           </p:nvCxnSpPr>
           <p:spPr>
             <a:xfrm>
-              <a:off x="6667500" y="3602567"/>
-              <a:ext cx="1608667" cy="0"/>
+              <a:off x="6858000" y="3602567"/>
+              <a:ext cx="1227667" cy="0"/>
             </a:xfrm>
             <a:prstGeom prst="line">
               <a:avLst/>
@@ -14197,7 +14197,7 @@
           </p:nvCxnSpPr>
           <p:spPr>
             <a:xfrm>
-              <a:off x="8868833" y="3602567"/>
+              <a:off x="8678333" y="3602567"/>
               <a:ext cx="1143000" cy="0"/>
             </a:xfrm>
             <a:prstGeom prst="line">
@@ -14234,7 +14234,7 @@
           </p:blipFill>
           <p:spPr>
             <a:xfrm>
-              <a:off x="8318500" y="3348567"/>
+              <a:off x="8128000" y="3348567"/>
               <a:ext cx="508000" cy="508000"/>
             </a:xfrm>
             <a:prstGeom prst="rect">
@@ -14250,7 +14250,7 @@
           </p:nvSpPr>
           <p:spPr>
             <a:xfrm>
-              <a:off x="7938161" y="3906308"/>
+              <a:off x="7747661" y="3906308"/>
               <a:ext cx="1268677" cy="192617"/>
             </a:xfrm>
             <a:prstGeom prst="rect">
@@ -14291,7 +14291,7 @@
           </p:nvSpPr>
           <p:spPr>
             <a:xfrm>
-              <a:off x="8175625" y="4095750"/>
+              <a:off x="7985125" y="4095750"/>
               <a:ext cx="793750" cy="165100"/>
             </a:xfrm>
             <a:prstGeom prst="rect">
@@ -14332,8 +14332,8 @@
           </p:nvSpPr>
           <p:spPr>
             <a:xfrm>
-              <a:off x="4762500" y="6106583"/>
-              <a:ext cx="8977313" cy="165100"/>
+              <a:off x="4953000" y="6127750"/>
+              <a:ext cx="8112125" cy="165100"/>
             </a:xfrm>
             <a:prstGeom prst="rect">
               <a:avLst/>
@@ -14360,7 +14360,7 @@
                   <a:ea typeface="Malgun Gothic"/>
                   <a:cs typeface="Malgun Gothic"/>
                 </a:rPr>
-                <a:t>Hub &amp; spoke: VPC·VPN은 리전 TGW에 attachment로 연결 · VPC CIDR과 VPN(BGP) 경로는 TGW 라우팅 테이블에 전파</a:t>
+                <a:t>Hub &amp; spoke: VPC·VPN은 리전 TGW에 attachment로 연결 · VPC CIDR과 VPN(BGP) 경로는 TGW RT에 전파</a:t>
               </a:r>
             </a:p>
           </p:txBody>
@@ -14373,8 +14373,8 @@
           </p:nvSpPr>
           <p:spPr>
             <a:xfrm>
-              <a:off x="4762500" y="6275917"/>
-              <a:ext cx="4572000" cy="165100"/>
+              <a:off x="4953000" y="6297083"/>
+              <a:ext cx="4643438" cy="165100"/>
             </a:xfrm>
             <a:prstGeom prst="rect">
               <a:avLst/>
@@ -14414,8 +14414,8 @@
           </p:nvSpPr>
           <p:spPr>
             <a:xfrm>
-              <a:off x="4762500" y="6445250"/>
-              <a:ext cx="7659688" cy="165100"/>
+              <a:off x="4953000" y="6466417"/>
+              <a:ext cx="7802563" cy="165100"/>
             </a:xfrm>
             <a:prstGeom prst="rect">
               <a:avLst/>
@@ -14510,10 +14510,10 @@
         </p:nvGrpSpPr>
         <p:grpSpPr>
           <a:xfrm>
-            <a:off x="316177" y="999067"/>
-            <a:ext cx="11785864" cy="5619750"/>
-            <a:chOff x="316177" y="999067"/>
-            <a:chExt cx="11785864" cy="5619750"/>
+            <a:off x="316177" y="935567"/>
+            <a:ext cx="11785864" cy="5715000"/>
+            <a:chOff x="316177" y="935567"/>
+            <a:chExt cx="11785864" cy="5715000"/>
           </a:xfrm>
         </p:grpSpPr>
         <p:sp>
@@ -14524,7 +14524,7 @@
           </p:nvSpPr>
           <p:spPr>
             <a:xfrm>
-              <a:off x="317500" y="999067"/>
+              <a:off x="317500" y="935567"/>
               <a:ext cx="10752667" cy="5376333"/>
             </a:xfrm>
             <a:prstGeom prst="rect">
@@ -14569,7 +14569,7 @@
           </p:blipFill>
           <p:spPr>
             <a:xfrm>
-              <a:off x="317500" y="999067"/>
+              <a:off x="317500" y="935567"/>
               <a:ext cx="338667" cy="338667"/>
             </a:xfrm>
             <a:prstGeom prst="rect">
@@ -14585,7 +14585,7 @@
           </p:nvSpPr>
           <p:spPr>
             <a:xfrm>
-              <a:off x="762000" y="1081088"/>
+              <a:off x="762000" y="1017588"/>
               <a:ext cx="1141016" cy="206375"/>
             </a:xfrm>
             <a:prstGeom prst="rect">
@@ -14626,7 +14626,7 @@
           </p:nvSpPr>
           <p:spPr>
             <a:xfrm>
-              <a:off x="529167" y="1358900"/>
+              <a:off x="529167" y="1295400"/>
               <a:ext cx="10329333" cy="4931833"/>
             </a:xfrm>
             <a:prstGeom prst="rect">
@@ -14673,7 +14673,7 @@
           </p:blipFill>
           <p:spPr>
             <a:xfrm>
-              <a:off x="529167" y="1358900"/>
+              <a:off x="529167" y="1295400"/>
               <a:ext cx="254000" cy="254000"/>
             </a:xfrm>
             <a:prstGeom prst="rect">
@@ -14689,7 +14689,7 @@
           </p:nvSpPr>
           <p:spPr>
             <a:xfrm>
-              <a:off x="867833" y="1408642"/>
+              <a:off x="867833" y="1345142"/>
               <a:ext cx="2287323" cy="192617"/>
             </a:xfrm>
             <a:prstGeom prst="rect">
@@ -14730,8 +14730,8 @@
           </p:nvSpPr>
           <p:spPr>
             <a:xfrm>
-              <a:off x="698500" y="1993900"/>
-              <a:ext cx="2116667" cy="1693333"/>
+              <a:off x="698500" y="1930400"/>
+              <a:ext cx="1735667" cy="1693333"/>
             </a:xfrm>
             <a:prstGeom prst="rect">
               <a:avLst/>
@@ -14775,7 +14775,7 @@
           </p:blipFill>
           <p:spPr>
             <a:xfrm>
-              <a:off x="698500" y="1993900"/>
+              <a:off x="698500" y="1930400"/>
               <a:ext cx="254000" cy="254000"/>
             </a:xfrm>
             <a:prstGeom prst="rect">
@@ -14791,7 +14791,7 @@
           </p:nvSpPr>
           <p:spPr>
             <a:xfrm>
-              <a:off x="1037167" y="2043642"/>
+              <a:off x="1037167" y="1980142"/>
               <a:ext cx="657490" cy="192617"/>
             </a:xfrm>
             <a:prstGeom prst="rect">
@@ -14832,7 +14832,7 @@
           </p:nvSpPr>
           <p:spPr>
             <a:xfrm>
-              <a:off x="1037167" y="2233083"/>
+              <a:off x="1037167" y="2169583"/>
               <a:ext cx="1087438" cy="165100"/>
             </a:xfrm>
             <a:prstGeom prst="rect">
@@ -14873,8 +14873,8 @@
           </p:nvSpPr>
           <p:spPr>
             <a:xfrm>
-              <a:off x="825500" y="2480733"/>
-              <a:ext cx="1862667" cy="1121833"/>
+              <a:off x="825500" y="2417233"/>
+              <a:ext cx="1481667" cy="1121833"/>
             </a:xfrm>
             <a:prstGeom prst="rect">
               <a:avLst/>
@@ -14918,7 +14918,7 @@
           </p:blipFill>
           <p:spPr>
             <a:xfrm>
-              <a:off x="825500" y="2480733"/>
+              <a:off x="825500" y="2417233"/>
               <a:ext cx="254000" cy="254000"/>
             </a:xfrm>
             <a:prstGeom prst="rect">
@@ -14934,7 +14934,7 @@
           </p:nvSpPr>
           <p:spPr>
             <a:xfrm>
-              <a:off x="1164167" y="2530475"/>
+              <a:off x="1164167" y="2466975"/>
               <a:ext cx="1166813" cy="192617"/>
             </a:xfrm>
             <a:prstGeom prst="rect">
@@ -14989,7 +14989,7 @@
           </p:blipFill>
           <p:spPr>
             <a:xfrm>
-              <a:off x="1502833" y="2777067"/>
+              <a:off x="1312333" y="2713567"/>
               <a:ext cx="508000" cy="508000"/>
             </a:xfrm>
             <a:prstGeom prst="rect">
@@ -15005,7 +15005,7 @@
           </p:nvSpPr>
           <p:spPr>
             <a:xfrm>
-              <a:off x="1529953" y="3334808"/>
+              <a:off x="1339453" y="3271308"/>
               <a:ext cx="453760" cy="192617"/>
             </a:xfrm>
             <a:prstGeom prst="rect">
@@ -15046,8 +15046,8 @@
           </p:nvSpPr>
           <p:spPr>
             <a:xfrm>
-              <a:off x="698500" y="4428067"/>
-              <a:ext cx="2116667" cy="1693333"/>
+              <a:off x="698500" y="4364567"/>
+              <a:ext cx="1735667" cy="1693333"/>
             </a:xfrm>
             <a:prstGeom prst="rect">
               <a:avLst/>
@@ -15091,7 +15091,7 @@
           </p:blipFill>
           <p:spPr>
             <a:xfrm>
-              <a:off x="698500" y="4428067"/>
+              <a:off x="698500" y="4364567"/>
               <a:ext cx="254000" cy="254000"/>
             </a:xfrm>
             <a:prstGeom prst="rect">
@@ -15107,7 +15107,7 @@
           </p:nvSpPr>
           <p:spPr>
             <a:xfrm>
-              <a:off x="1037167" y="4477808"/>
+              <a:off x="1037167" y="4414308"/>
               <a:ext cx="657490" cy="192617"/>
             </a:xfrm>
             <a:prstGeom prst="rect">
@@ -15148,7 +15148,7 @@
           </p:nvSpPr>
           <p:spPr>
             <a:xfrm>
-              <a:off x="1037167" y="4667250"/>
+              <a:off x="1037167" y="4603750"/>
               <a:ext cx="1087438" cy="165100"/>
             </a:xfrm>
             <a:prstGeom prst="rect">
@@ -15189,8 +15189,8 @@
           </p:nvSpPr>
           <p:spPr>
             <a:xfrm>
-              <a:off x="825500" y="4914900"/>
-              <a:ext cx="1862667" cy="1121833"/>
+              <a:off x="825500" y="4851400"/>
+              <a:ext cx="1481667" cy="1121833"/>
             </a:xfrm>
             <a:prstGeom prst="rect">
               <a:avLst/>
@@ -15234,7 +15234,7 @@
           </p:blipFill>
           <p:spPr>
             <a:xfrm>
-              <a:off x="825500" y="4914900"/>
+              <a:off x="825500" y="4851400"/>
               <a:ext cx="254000" cy="254000"/>
             </a:xfrm>
             <a:prstGeom prst="rect">
@@ -15250,7 +15250,7 @@
           </p:nvSpPr>
           <p:spPr>
             <a:xfrm>
-              <a:off x="1164167" y="4964642"/>
+              <a:off x="1164167" y="4901142"/>
               <a:ext cx="1166813" cy="192617"/>
             </a:xfrm>
             <a:prstGeom prst="rect">
@@ -15305,7 +15305,7 @@
           </p:blipFill>
           <p:spPr>
             <a:xfrm>
-              <a:off x="1502833" y="5211233"/>
+              <a:off x="1312333" y="5147733"/>
               <a:ext cx="508000" cy="508000"/>
             </a:xfrm>
             <a:prstGeom prst="rect">
@@ -15321,7 +15321,7 @@
           </p:nvSpPr>
           <p:spPr>
             <a:xfrm>
-              <a:off x="1529953" y="5768975"/>
+              <a:off x="1339453" y="5705475"/>
               <a:ext cx="453760" cy="192617"/>
             </a:xfrm>
             <a:prstGeom prst="rect">
@@ -15376,7 +15376,7 @@
           </p:blipFill>
           <p:spPr>
             <a:xfrm>
-              <a:off x="3429000" y="3771900"/>
+              <a:off x="3429000" y="3708400"/>
               <a:ext cx="508000" cy="508000"/>
             </a:xfrm>
             <a:prstGeom prst="rect">
@@ -15392,7 +15392,7 @@
           </p:nvSpPr>
           <p:spPr>
             <a:xfrm>
-              <a:off x="3456120" y="4329642"/>
+              <a:off x="3456120" y="4266142"/>
               <a:ext cx="453760" cy="192617"/>
             </a:xfrm>
             <a:prstGeom prst="rect">
@@ -15447,7 +15447,7 @@
           </p:blipFill>
           <p:spPr>
             <a:xfrm>
-              <a:off x="3429000" y="2777067"/>
+              <a:off x="3429000" y="2713567"/>
               <a:ext cx="508000" cy="508000"/>
             </a:xfrm>
             <a:prstGeom prst="rect">
@@ -15463,7 +15463,7 @@
           </p:nvSpPr>
           <p:spPr>
             <a:xfrm>
-              <a:off x="3048661" y="3334808"/>
+              <a:off x="3048661" y="3271308"/>
               <a:ext cx="1268677" cy="192617"/>
             </a:xfrm>
             <a:prstGeom prst="rect">
@@ -15504,7 +15504,7 @@
           </p:nvSpPr>
           <p:spPr>
             <a:xfrm>
-              <a:off x="3024188" y="3524250"/>
+              <a:off x="3024188" y="3460750"/>
               <a:ext cx="1317625" cy="165100"/>
             </a:xfrm>
             <a:prstGeom prst="rect">
@@ -15559,7 +15559,7 @@
           </p:blipFill>
           <p:spPr>
             <a:xfrm>
-              <a:off x="3429000" y="5211233"/>
+              <a:off x="3429000" y="5147733"/>
               <a:ext cx="508000" cy="508000"/>
             </a:xfrm>
             <a:prstGeom prst="rect">
@@ -15575,7 +15575,7 @@
           </p:nvSpPr>
           <p:spPr>
             <a:xfrm>
-              <a:off x="3201458" y="5768975"/>
+              <a:off x="3201458" y="5705475"/>
               <a:ext cx="963083" cy="192617"/>
             </a:xfrm>
             <a:prstGeom prst="rect">
@@ -15616,8 +15616,8 @@
           </p:nvSpPr>
           <p:spPr>
             <a:xfrm>
-              <a:off x="2762250" y="5958417"/>
-              <a:ext cx="1841500" cy="165100"/>
+              <a:off x="2726531" y="5894917"/>
+              <a:ext cx="1912937" cy="165100"/>
             </a:xfrm>
             <a:prstGeom prst="rect">
               <a:avLst/>
@@ -15657,8 +15657,8 @@
           </p:nvSpPr>
           <p:spPr>
             <a:xfrm>
-              <a:off x="2857500" y="3031067"/>
-              <a:ext cx="529167" cy="910166"/>
+              <a:off x="2476500" y="2967567"/>
+              <a:ext cx="910167" cy="910166"/>
             </a:xfrm>
             <a:custGeom>
               <a:avLst/>
@@ -15667,18 +15667,18 @@
               <a:cxnLst/>
               <a:rect l="l" t="t" r="r" b="b"/>
               <a:pathLst>
-                <a:path w="529167" h="910166">
+                <a:path w="910167" h="910166">
                   <a:moveTo>
                     <a:pt x="0" y="0"/>
                   </a:moveTo>
                   <a:lnTo>
-                    <a:pt x="254000" y="0"/>
+                    <a:pt x="635000" y="0"/>
                   </a:lnTo>
                   <a:lnTo>
-                    <a:pt x="254000" y="910166"/>
+                    <a:pt x="635000" y="910166"/>
                   </a:lnTo>
                   <a:lnTo>
-                    <a:pt x="529167" y="910166"/>
+                    <a:pt x="910167" y="910166"/>
                   </a:lnTo>
                 </a:path>
               </a:pathLst>
@@ -15710,8 +15710,8 @@
           </p:nvSpPr>
           <p:spPr>
             <a:xfrm>
-              <a:off x="2857500" y="4110567"/>
-              <a:ext cx="529167" cy="1354666"/>
+              <a:off x="2476500" y="4047067"/>
+              <a:ext cx="910167" cy="1354666"/>
             </a:xfrm>
             <a:custGeom>
               <a:avLst/>
@@ -15720,18 +15720,18 @@
               <a:cxnLst/>
               <a:rect l="l" t="t" r="r" b="b"/>
               <a:pathLst>
-                <a:path w="529167" h="1354666">
+                <a:path w="910167" h="1354666">
                   <a:moveTo>
                     <a:pt x="0" y="1354666"/>
                   </a:moveTo>
                   <a:lnTo>
-                    <a:pt x="254000" y="1354666"/>
+                    <a:pt x="635000" y="1354666"/>
                   </a:lnTo>
                   <a:lnTo>
-                    <a:pt x="254000" y="0"/>
+                    <a:pt x="635000" y="0"/>
                   </a:lnTo>
                   <a:lnTo>
-                    <a:pt x="529167" y="0"/>
+                    <a:pt x="910167" y="0"/>
                   </a:lnTo>
                 </a:path>
               </a:pathLst>
@@ -15763,7 +15763,7 @@
           </p:nvSpPr>
           <p:spPr>
             <a:xfrm>
-              <a:off x="4508500" y="1676400"/>
+              <a:off x="4508500" y="1612900"/>
               <a:ext cx="5926667" cy="4529667"/>
             </a:xfrm>
             <a:prstGeom prst="rect">
@@ -15808,7 +15808,7 @@
           </p:blipFill>
           <p:spPr>
             <a:xfrm>
-              <a:off x="4508500" y="1676400"/>
+              <a:off x="4508500" y="1612900"/>
               <a:ext cx="254000" cy="254000"/>
             </a:xfrm>
             <a:prstGeom prst="rect">
@@ -15824,7 +15824,7 @@
           </p:nvSpPr>
           <p:spPr>
             <a:xfrm>
-              <a:off x="4847167" y="1726142"/>
+              <a:off x="4847167" y="1662642"/>
               <a:ext cx="1574271" cy="192617"/>
             </a:xfrm>
             <a:prstGeom prst="rect">
@@ -15865,7 +15865,7 @@
           </p:nvSpPr>
           <p:spPr>
             <a:xfrm>
-              <a:off x="4847167" y="1915583"/>
+              <a:off x="4847167" y="1852083"/>
               <a:ext cx="1262062" cy="165100"/>
             </a:xfrm>
             <a:prstGeom prst="rect">
@@ -15906,7 +15906,7 @@
           </p:nvSpPr>
           <p:spPr>
             <a:xfrm>
-              <a:off x="4677833" y="2163233"/>
+              <a:off x="4677833" y="2099733"/>
               <a:ext cx="5037667" cy="1524000"/>
             </a:xfrm>
             <a:prstGeom prst="rect">
@@ -15939,7 +15939,7 @@
           </p:nvSpPr>
           <p:spPr>
             <a:xfrm>
-              <a:off x="4804833" y="2212975"/>
+              <a:off x="4804833" y="2149475"/>
               <a:ext cx="2083594" cy="192617"/>
             </a:xfrm>
             <a:prstGeom prst="rect">
@@ -15980,7 +15980,7 @@
           </p:nvSpPr>
           <p:spPr>
             <a:xfrm>
-              <a:off x="4677833" y="4597400"/>
+              <a:off x="4677833" y="4533900"/>
               <a:ext cx="5037667" cy="1524000"/>
             </a:xfrm>
             <a:prstGeom prst="rect">
@@ -16013,7 +16013,7 @@
           </p:nvSpPr>
           <p:spPr>
             <a:xfrm>
-              <a:off x="4804833" y="4647142"/>
+              <a:off x="4804833" y="4583642"/>
               <a:ext cx="2083594" cy="192617"/>
             </a:xfrm>
             <a:prstGeom prst="rect">
@@ -16054,7 +16054,7 @@
           </p:nvSpPr>
           <p:spPr>
             <a:xfrm>
-              <a:off x="4804833" y="2480733"/>
+              <a:off x="4804833" y="2417233"/>
               <a:ext cx="1439333" cy="1121833"/>
             </a:xfrm>
             <a:prstGeom prst="rect">
@@ -16099,7 +16099,7 @@
           </p:blipFill>
           <p:spPr>
             <a:xfrm>
-              <a:off x="4804833" y="2480733"/>
+              <a:off x="4804833" y="2417233"/>
               <a:ext cx="254000" cy="254000"/>
             </a:xfrm>
             <a:prstGeom prst="rect">
@@ -16115,7 +16115,7 @@
           </p:nvSpPr>
           <p:spPr>
             <a:xfrm>
-              <a:off x="5143500" y="2530475"/>
+              <a:off x="5143500" y="2466975"/>
               <a:ext cx="1166813" cy="192617"/>
             </a:xfrm>
             <a:prstGeom prst="rect">
@@ -16156,7 +16156,7 @@
           </p:nvSpPr>
           <p:spPr>
             <a:xfrm>
-              <a:off x="6371167" y="2480733"/>
+              <a:off x="6371167" y="2417233"/>
               <a:ext cx="1608667" cy="1121833"/>
             </a:xfrm>
             <a:prstGeom prst="rect">
@@ -16201,7 +16201,7 @@
           </p:blipFill>
           <p:spPr>
             <a:xfrm>
-              <a:off x="6371167" y="2480733"/>
+              <a:off x="6371167" y="2417233"/>
               <a:ext cx="254000" cy="254000"/>
             </a:xfrm>
             <a:prstGeom prst="rect">
@@ -16217,7 +16217,7 @@
           </p:nvSpPr>
           <p:spPr>
             <a:xfrm>
-              <a:off x="6709833" y="2530475"/>
+              <a:off x="6709833" y="2466975"/>
               <a:ext cx="1676135" cy="192617"/>
             </a:xfrm>
             <a:prstGeom prst="rect">
@@ -16258,7 +16258,7 @@
           </p:nvSpPr>
           <p:spPr>
             <a:xfrm>
-              <a:off x="8106833" y="2480733"/>
+              <a:off x="8106833" y="2417233"/>
               <a:ext cx="1481667" cy="1121833"/>
             </a:xfrm>
             <a:prstGeom prst="rect">
@@ -16303,7 +16303,7 @@
           </p:blipFill>
           <p:spPr>
             <a:xfrm>
-              <a:off x="8106833" y="2480733"/>
+              <a:off x="8106833" y="2417233"/>
               <a:ext cx="254000" cy="254000"/>
             </a:xfrm>
             <a:prstGeom prst="rect">
@@ -16319,7 +16319,7 @@
           </p:nvSpPr>
           <p:spPr>
             <a:xfrm>
-              <a:off x="8445500" y="2530475"/>
+              <a:off x="8445500" y="2466975"/>
               <a:ext cx="1472406" cy="192617"/>
             </a:xfrm>
             <a:prstGeom prst="rect">
@@ -16360,7 +16360,7 @@
           </p:nvSpPr>
           <p:spPr>
             <a:xfrm>
-              <a:off x="4804833" y="4914900"/>
+              <a:off x="4804833" y="4851400"/>
               <a:ext cx="1439333" cy="1121833"/>
             </a:xfrm>
             <a:prstGeom prst="rect">
@@ -16405,7 +16405,7 @@
           </p:blipFill>
           <p:spPr>
             <a:xfrm>
-              <a:off x="4804833" y="4914900"/>
+              <a:off x="4804833" y="4851400"/>
               <a:ext cx="254000" cy="254000"/>
             </a:xfrm>
             <a:prstGeom prst="rect">
@@ -16421,7 +16421,7 @@
           </p:nvSpPr>
           <p:spPr>
             <a:xfrm>
-              <a:off x="5143500" y="4964642"/>
+              <a:off x="5143500" y="4901142"/>
               <a:ext cx="1166813" cy="192617"/>
             </a:xfrm>
             <a:prstGeom prst="rect">
@@ -16462,7 +16462,7 @@
           </p:nvSpPr>
           <p:spPr>
             <a:xfrm>
-              <a:off x="6371167" y="4914900"/>
+              <a:off x="6371167" y="4851400"/>
               <a:ext cx="1608667" cy="1121833"/>
             </a:xfrm>
             <a:prstGeom prst="rect">
@@ -16507,7 +16507,7 @@
           </p:blipFill>
           <p:spPr>
             <a:xfrm>
-              <a:off x="6371167" y="4914900"/>
+              <a:off x="6371167" y="4851400"/>
               <a:ext cx="254000" cy="254000"/>
             </a:xfrm>
             <a:prstGeom prst="rect">
@@ -16523,7 +16523,7 @@
           </p:nvSpPr>
           <p:spPr>
             <a:xfrm>
-              <a:off x="6709833" y="4964642"/>
+              <a:off x="6709833" y="4901142"/>
               <a:ext cx="1676135" cy="192617"/>
             </a:xfrm>
             <a:prstGeom prst="rect">
@@ -16564,7 +16564,7 @@
           </p:nvSpPr>
           <p:spPr>
             <a:xfrm>
-              <a:off x="8106833" y="4914900"/>
+              <a:off x="8106833" y="4851400"/>
               <a:ext cx="1481667" cy="1121833"/>
             </a:xfrm>
             <a:prstGeom prst="rect">
@@ -16609,7 +16609,7 @@
           </p:blipFill>
           <p:spPr>
             <a:xfrm>
-              <a:off x="8106833" y="4914900"/>
+              <a:off x="8106833" y="4851400"/>
               <a:ext cx="254000" cy="254000"/>
             </a:xfrm>
             <a:prstGeom prst="rect">
@@ -16625,7 +16625,7 @@
           </p:nvSpPr>
           <p:spPr>
             <a:xfrm>
-              <a:off x="8445500" y="4964642"/>
+              <a:off x="8445500" y="4901142"/>
               <a:ext cx="1472406" cy="192617"/>
             </a:xfrm>
             <a:prstGeom prst="rect">
@@ -16680,7 +16680,7 @@
           </p:blipFill>
           <p:spPr>
             <a:xfrm>
-              <a:off x="5270500" y="2777067"/>
+              <a:off x="5270500" y="2713567"/>
               <a:ext cx="508000" cy="508000"/>
             </a:xfrm>
             <a:prstGeom prst="rect">
@@ -16696,7 +16696,7 @@
           </p:nvSpPr>
           <p:spPr>
             <a:xfrm>
-              <a:off x="5093891" y="3334808"/>
+              <a:off x="5093891" y="3271308"/>
               <a:ext cx="861219" cy="192617"/>
             </a:xfrm>
             <a:prstGeom prst="rect">
@@ -16751,7 +16751,7 @@
           </p:blipFill>
           <p:spPr>
             <a:xfrm>
-              <a:off x="6921500" y="2777067"/>
+              <a:off x="6921500" y="2713567"/>
               <a:ext cx="508000" cy="508000"/>
             </a:xfrm>
             <a:prstGeom prst="rect">
@@ -16767,7 +16767,7 @@
           </p:nvSpPr>
           <p:spPr>
             <a:xfrm>
-              <a:off x="6235568" y="3334808"/>
+              <a:off x="6235568" y="3271308"/>
               <a:ext cx="1879865" cy="192617"/>
             </a:xfrm>
             <a:prstGeom prst="rect">
@@ -16822,7 +16822,7 @@
           </p:blipFill>
           <p:spPr>
             <a:xfrm>
-              <a:off x="8593667" y="2777067"/>
+              <a:off x="8593667" y="2713567"/>
               <a:ext cx="508000" cy="508000"/>
             </a:xfrm>
             <a:prstGeom prst="rect">
@@ -16838,7 +16838,7 @@
           </p:nvSpPr>
           <p:spPr>
             <a:xfrm>
-              <a:off x="8213328" y="3334808"/>
+              <a:off x="8213328" y="3271308"/>
               <a:ext cx="1268677" cy="192617"/>
             </a:xfrm>
             <a:prstGeom prst="rect">
@@ -16893,7 +16893,7 @@
           </p:blipFill>
           <p:spPr>
             <a:xfrm>
-              <a:off x="5270500" y="5211233"/>
+              <a:off x="5270500" y="5147733"/>
               <a:ext cx="508000" cy="508000"/>
             </a:xfrm>
             <a:prstGeom prst="rect">
@@ -16909,7 +16909,7 @@
           </p:nvSpPr>
           <p:spPr>
             <a:xfrm>
-              <a:off x="5093891" y="5768975"/>
+              <a:off x="5093891" y="5705475"/>
               <a:ext cx="861219" cy="192617"/>
             </a:xfrm>
             <a:prstGeom prst="rect">
@@ -16964,7 +16964,7 @@
           </p:blipFill>
           <p:spPr>
             <a:xfrm>
-              <a:off x="6921500" y="5211233"/>
+              <a:off x="6921500" y="5147733"/>
               <a:ext cx="508000" cy="508000"/>
             </a:xfrm>
             <a:prstGeom prst="rect">
@@ -16980,7 +16980,7 @@
           </p:nvSpPr>
           <p:spPr>
             <a:xfrm>
-              <a:off x="6235568" y="5768975"/>
+              <a:off x="6235568" y="5705475"/>
               <a:ext cx="1879865" cy="192617"/>
             </a:xfrm>
             <a:prstGeom prst="rect">
@@ -17035,7 +17035,7 @@
           </p:blipFill>
           <p:spPr>
             <a:xfrm>
-              <a:off x="8593667" y="5211233"/>
+              <a:off x="8593667" y="5147733"/>
               <a:ext cx="508000" cy="508000"/>
             </a:xfrm>
             <a:prstGeom prst="rect">
@@ -17051,7 +17051,7 @@
           </p:nvSpPr>
           <p:spPr>
             <a:xfrm>
-              <a:off x="8213328" y="5768975"/>
+              <a:off x="8213328" y="5705475"/>
               <a:ext cx="1268677" cy="192617"/>
             </a:xfrm>
             <a:prstGeom prst="rect">
@@ -17106,7 +17106,7 @@
           </p:blipFill>
           <p:spPr>
             <a:xfrm>
-              <a:off x="6921500" y="3771900"/>
+              <a:off x="6921500" y="3708400"/>
               <a:ext cx="508000" cy="508000"/>
             </a:xfrm>
             <a:prstGeom prst="rect">
@@ -17122,7 +17122,7 @@
           </p:nvSpPr>
           <p:spPr>
             <a:xfrm>
-              <a:off x="6082771" y="4329642"/>
+              <a:off x="6082771" y="4266142"/>
               <a:ext cx="2185458" cy="192617"/>
             </a:xfrm>
             <a:prstGeom prst="rect">
@@ -17163,7 +17163,7 @@
           </p:nvSpPr>
           <p:spPr>
             <a:xfrm>
-              <a:off x="10181167" y="3771900"/>
+              <a:off x="10181167" y="3708400"/>
               <a:ext cx="508000" cy="740833"/>
             </a:xfrm>
             <a:prstGeom prst="rect">
@@ -17206,7 +17206,7 @@
           </p:blipFill>
           <p:spPr>
             <a:xfrm>
-              <a:off x="10181167" y="3771900"/>
+              <a:off x="10181167" y="3708400"/>
               <a:ext cx="508000" cy="508000"/>
             </a:xfrm>
             <a:prstGeom prst="rect">
@@ -17222,7 +17222,7 @@
           </p:nvSpPr>
           <p:spPr>
             <a:xfrm>
-              <a:off x="10208286" y="4329642"/>
+              <a:off x="10208286" y="4266142"/>
               <a:ext cx="453760" cy="192617"/>
             </a:xfrm>
             <a:prstGeom prst="rect">
@@ -17263,7 +17263,7 @@
           </p:nvSpPr>
           <p:spPr>
             <a:xfrm>
-              <a:off x="3979333" y="3031067"/>
+              <a:off x="3979333" y="2967567"/>
               <a:ext cx="1248834" cy="910166"/>
             </a:xfrm>
             <a:custGeom>
@@ -17316,7 +17316,7 @@
           </p:nvSpPr>
           <p:spPr>
             <a:xfrm>
-              <a:off x="3979333" y="4110567"/>
+              <a:off x="3979333" y="4047067"/>
               <a:ext cx="1248834" cy="1354666"/>
             </a:xfrm>
             <a:custGeom>
@@ -17369,7 +17369,7 @@
           </p:nvCxnSpPr>
           <p:spPr>
             <a:xfrm>
-              <a:off x="5820833" y="3031067"/>
+              <a:off x="5820833" y="2967567"/>
               <a:ext cx="1058334" cy="0"/>
             </a:xfrm>
             <a:prstGeom prst="line">
@@ -17394,7 +17394,7 @@
           </p:nvCxnSpPr>
           <p:spPr>
             <a:xfrm>
-              <a:off x="5820833" y="5465233"/>
+              <a:off x="5820833" y="5401733"/>
               <a:ext cx="1058334" cy="0"/>
             </a:xfrm>
             <a:prstGeom prst="line">
@@ -17419,7 +17419,7 @@
           </p:nvCxnSpPr>
           <p:spPr>
             <a:xfrm>
-              <a:off x="7471833" y="3031067"/>
+              <a:off x="7471833" y="2967567"/>
               <a:ext cx="1079500" cy="0"/>
             </a:xfrm>
             <a:prstGeom prst="line">
@@ -17443,7 +17443,7 @@
           </p:nvCxnSpPr>
           <p:spPr>
             <a:xfrm>
-              <a:off x="7471833" y="5465233"/>
+              <a:off x="7471833" y="5401733"/>
               <a:ext cx="1079500" cy="0"/>
             </a:xfrm>
             <a:prstGeom prst="line">
@@ -17467,7 +17467,7 @@
           </p:nvSpPr>
           <p:spPr>
             <a:xfrm>
-              <a:off x="9144000" y="3031067"/>
+              <a:off x="9144000" y="2967567"/>
               <a:ext cx="994833" cy="994833"/>
             </a:xfrm>
             <a:custGeom>
@@ -17519,7 +17519,7 @@
           </p:nvSpPr>
           <p:spPr>
             <a:xfrm>
-              <a:off x="9144000" y="4025900"/>
+              <a:off x="9144000" y="3962400"/>
               <a:ext cx="698500" cy="1439333"/>
             </a:xfrm>
             <a:custGeom>
@@ -17581,7 +17581,7 @@
           </p:blipFill>
           <p:spPr>
             <a:xfrm>
-              <a:off x="11366500" y="3771900"/>
+              <a:off x="11366500" y="3708400"/>
               <a:ext cx="508000" cy="508000"/>
             </a:xfrm>
             <a:prstGeom prst="rect">
@@ -17597,7 +17597,7 @@
           </p:nvSpPr>
           <p:spPr>
             <a:xfrm>
-              <a:off x="11138958" y="4329642"/>
+              <a:off x="11138958" y="4266142"/>
               <a:ext cx="963083" cy="192617"/>
             </a:xfrm>
             <a:prstGeom prst="rect">
@@ -17638,7 +17638,7 @@
           </p:nvCxnSpPr>
           <p:spPr>
             <a:xfrm>
-              <a:off x="10731500" y="4025900"/>
+              <a:off x="10731500" y="3962400"/>
               <a:ext cx="592667" cy="0"/>
             </a:xfrm>
             <a:prstGeom prst="line">
@@ -17662,7 +17662,7 @@
           </p:nvSpPr>
           <p:spPr>
             <a:xfrm>
-              <a:off x="3164417" y="3687233"/>
+              <a:off x="3143250" y="3623733"/>
               <a:ext cx="211667" cy="211667"/>
             </a:xfrm>
             <a:prstGeom prst="ellipse">
@@ -17691,7 +17691,7 @@
           </p:nvSpPr>
           <p:spPr>
             <a:xfrm>
-              <a:off x="3163094" y="3714750"/>
+              <a:off x="3141927" y="3651250"/>
               <a:ext cx="214312" cy="165100"/>
             </a:xfrm>
             <a:prstGeom prst="rect">
@@ -17732,7 +17732,7 @@
           </p:nvSpPr>
           <p:spPr>
             <a:xfrm>
-              <a:off x="4053417" y="3687233"/>
+              <a:off x="4053417" y="3623733"/>
               <a:ext cx="211667" cy="211667"/>
             </a:xfrm>
             <a:prstGeom prst="ellipse">
@@ -17761,7 +17761,7 @@
           </p:nvSpPr>
           <p:spPr>
             <a:xfrm>
-              <a:off x="4052094" y="3714750"/>
+              <a:off x="4052094" y="3651250"/>
               <a:ext cx="214312" cy="165100"/>
             </a:xfrm>
             <a:prstGeom prst="rect">
@@ -17802,7 +17802,7 @@
           </p:nvSpPr>
           <p:spPr>
             <a:xfrm>
-              <a:off x="6519333" y="2777067"/>
+              <a:off x="6519333" y="2713567"/>
               <a:ext cx="211667" cy="211667"/>
             </a:xfrm>
             <a:prstGeom prst="ellipse">
@@ -17831,7 +17831,7 @@
           </p:nvSpPr>
           <p:spPr>
             <a:xfrm>
-              <a:off x="6518010" y="2804583"/>
+              <a:off x="6518010" y="2741083"/>
               <a:ext cx="214312" cy="165100"/>
             </a:xfrm>
             <a:prstGeom prst="rect">
@@ -17872,7 +17872,7 @@
           </p:nvSpPr>
           <p:spPr>
             <a:xfrm>
-              <a:off x="7620000" y="2777067"/>
+              <a:off x="7620000" y="2713567"/>
               <a:ext cx="211667" cy="211667"/>
             </a:xfrm>
             <a:prstGeom prst="ellipse">
@@ -17901,7 +17901,7 @@
           </p:nvSpPr>
           <p:spPr>
             <a:xfrm>
-              <a:off x="7618677" y="2804583"/>
+              <a:off x="7618677" y="2741083"/>
               <a:ext cx="214312" cy="165100"/>
             </a:xfrm>
             <a:prstGeom prst="rect">
@@ -17942,7 +17942,7 @@
           </p:nvSpPr>
           <p:spPr>
             <a:xfrm>
-              <a:off x="9260417" y="2777067"/>
+              <a:off x="9260417" y="2713567"/>
               <a:ext cx="211667" cy="211667"/>
             </a:xfrm>
             <a:prstGeom prst="ellipse">
@@ -17971,7 +17971,7 @@
           </p:nvSpPr>
           <p:spPr>
             <a:xfrm>
-              <a:off x="9259094" y="2804583"/>
+              <a:off x="9259094" y="2741083"/>
               <a:ext cx="214312" cy="165100"/>
             </a:xfrm>
             <a:prstGeom prst="rect">
@@ -18012,7 +18012,7 @@
           </p:nvSpPr>
           <p:spPr>
             <a:xfrm>
-              <a:off x="317500" y="6407150"/>
+              <a:off x="317500" y="6438900"/>
               <a:ext cx="211667" cy="211667"/>
             </a:xfrm>
             <a:prstGeom prst="ellipse">
@@ -18041,7 +18041,7 @@
           </p:nvSpPr>
           <p:spPr>
             <a:xfrm>
-              <a:off x="316177" y="6434667"/>
+              <a:off x="316177" y="6466417"/>
               <a:ext cx="214312" cy="165100"/>
             </a:xfrm>
             <a:prstGeom prst="rect">
@@ -18082,8 +18082,8 @@
           </p:nvSpPr>
           <p:spPr>
             <a:xfrm>
-              <a:off x="613833" y="6434667"/>
-              <a:ext cx="912812" cy="165100"/>
+              <a:off x="613833" y="6466417"/>
+              <a:ext cx="984250" cy="165100"/>
             </a:xfrm>
             <a:prstGeom prst="rect">
               <a:avLst/>
@@ -18123,7 +18123,7 @@
           </p:nvSpPr>
           <p:spPr>
             <a:xfrm>
-              <a:off x="1534583" y="6407150"/>
+              <a:off x="1511300" y="6438900"/>
               <a:ext cx="211667" cy="211667"/>
             </a:xfrm>
             <a:prstGeom prst="ellipse">
@@ -18152,7 +18152,7 @@
           </p:nvSpPr>
           <p:spPr>
             <a:xfrm>
-              <a:off x="1533260" y="6434667"/>
+              <a:off x="1509977" y="6466417"/>
               <a:ext cx="214312" cy="165100"/>
             </a:xfrm>
             <a:prstGeom prst="rect">
@@ -18193,8 +18193,8 @@
           </p:nvSpPr>
           <p:spPr>
             <a:xfrm>
-              <a:off x="1830917" y="6434667"/>
-              <a:ext cx="4111625" cy="165100"/>
+              <a:off x="1807633" y="6466417"/>
+              <a:ext cx="4183063" cy="165100"/>
             </a:xfrm>
             <a:prstGeom prst="rect">
               <a:avLst/>
@@ -18234,7 +18234,7 @@
           </p:nvSpPr>
           <p:spPr>
             <a:xfrm>
-              <a:off x="5139267" y="6407150"/>
+              <a:off x="5264150" y="6438900"/>
               <a:ext cx="211667" cy="211667"/>
             </a:xfrm>
             <a:prstGeom prst="ellipse">
@@ -18263,7 +18263,7 @@
           </p:nvSpPr>
           <p:spPr>
             <a:xfrm>
-              <a:off x="5137944" y="6434667"/>
+              <a:off x="5262827" y="6466417"/>
               <a:ext cx="214312" cy="165100"/>
             </a:xfrm>
             <a:prstGeom prst="rect">
@@ -18304,7 +18304,7 @@
           </p:nvSpPr>
           <p:spPr>
             <a:xfrm>
-              <a:off x="5435600" y="6434667"/>
+              <a:off x="5560483" y="6466417"/>
               <a:ext cx="3833812" cy="165100"/>
             </a:xfrm>
             <a:prstGeom prst="rect">
@@ -18345,7 +18345,7 @@
           </p:nvSpPr>
           <p:spPr>
             <a:xfrm>
-              <a:off x="8464550" y="6407150"/>
+              <a:off x="8737600" y="6438900"/>
               <a:ext cx="211667" cy="211667"/>
             </a:xfrm>
             <a:prstGeom prst="ellipse">
@@ -18374,7 +18374,7 @@
           </p:nvSpPr>
           <p:spPr>
             <a:xfrm>
-              <a:off x="8463227" y="6434667"/>
+              <a:off x="8736277" y="6466417"/>
               <a:ext cx="214312" cy="165100"/>
             </a:xfrm>
             <a:prstGeom prst="rect">
@@ -18415,8 +18415,8 @@
           </p:nvSpPr>
           <p:spPr>
             <a:xfrm>
-              <a:off x="8760883" y="6434667"/>
-              <a:ext cx="2024062" cy="165100"/>
+              <a:off x="9033933" y="6466417"/>
+              <a:ext cx="2095500" cy="165100"/>
             </a:xfrm>
             <a:prstGeom prst="rect">
               <a:avLst/>
@@ -18456,7 +18456,7 @@
           </p:nvSpPr>
           <p:spPr>
             <a:xfrm>
-              <a:off x="10399183" y="6407150"/>
+              <a:off x="10820400" y="6438900"/>
               <a:ext cx="211667" cy="211667"/>
             </a:xfrm>
             <a:prstGeom prst="ellipse">
@@ -18485,7 +18485,7 @@
           </p:nvSpPr>
           <p:spPr>
             <a:xfrm>
-              <a:off x="10397860" y="6434667"/>
+              <a:off x="10819077" y="6466417"/>
               <a:ext cx="214312" cy="165100"/>
             </a:xfrm>
             <a:prstGeom prst="rect">
@@ -18526,8 +18526,8 @@
           </p:nvSpPr>
           <p:spPr>
             <a:xfrm>
-              <a:off x="10695517" y="6434667"/>
-              <a:ext cx="912812" cy="165100"/>
+              <a:off x="11116733" y="6466417"/>
+              <a:ext cx="984250" cy="165100"/>
             </a:xfrm>
             <a:prstGeom prst="rect">
               <a:avLst/>

</xml_diff>

<commit_message>
Show TGW connections and one flow on the attachment lines: label attachment types, draw each TGW route table as a node, number the on-premises to DR VPC path, and label the VPC attachment in the Network Firewall examples
Co-Authored-By: Claude Opus 5.5 <noreply@anthropic.com>
</commit_message>
<xml_diff>
--- a/docs/examples/reference-architectures.pptx
+++ b/docs/examples/reference-architectures.pptx
@@ -12320,10 +12320,10 @@
         </p:nvGrpSpPr>
         <p:grpSpPr>
           <a:xfrm>
-            <a:off x="592667" y="1083733"/>
-            <a:ext cx="12472458" cy="5547784"/>
-            <a:chOff x="592667" y="1083733"/>
-            <a:chExt cx="12472458" cy="5547784"/>
+            <a:off x="398670" y="1157080"/>
+            <a:ext cx="11590772" cy="5420968"/>
+            <a:chOff x="398670" y="1157080"/>
+            <a:chExt cx="11590772" cy="5420968"/>
           </a:xfrm>
         </p:grpSpPr>
         <p:sp>
@@ -12334,14 +12334,14 @@
           </p:nvSpPr>
           <p:spPr>
             <a:xfrm>
-              <a:off x="592667" y="2988733"/>
-              <a:ext cx="1820333" cy="1397000"/>
-            </a:xfrm>
-            <a:prstGeom prst="rect">
-              <a:avLst/>
-            </a:prstGeom>
-            <a:noFill/>
-            <a:ln w="21167">
+              <a:off x="398670" y="3070363"/>
+              <a:ext cx="1658178" cy="1403074"/>
+            </a:xfrm>
+            <a:prstGeom prst="rect">
+              <a:avLst/>
+            </a:prstGeom>
+            <a:noFill/>
+            <a:ln w="21259">
               <a:solidFill>
                 <a:srgbClr val="7D8998"/>
               </a:solidFill>
@@ -12379,8 +12379,8 @@
           </p:blipFill>
           <p:spPr>
             <a:xfrm>
-              <a:off x="592667" y="2988733"/>
-              <a:ext cx="254000" cy="254000"/>
+              <a:off x="398670" y="3070363"/>
+              <a:ext cx="255104" cy="255104"/>
             </a:xfrm>
             <a:prstGeom prst="rect">
               <a:avLst/>
@@ -12395,8 +12395,8 @@
           </p:nvSpPr>
           <p:spPr>
             <a:xfrm>
-              <a:off x="931333" y="3038475"/>
-              <a:ext cx="1268677" cy="192617"/>
+              <a:off x="738809" y="3120321"/>
+              <a:ext cx="1274193" cy="193454"/>
             </a:xfrm>
             <a:prstGeom prst="rect">
               <a:avLst/>
@@ -12415,7 +12415,7 @@
                 </a:lnSpc>
               </a:pPr>
               <a:r>
-                <a:rPr sz="1166" b="1" lang="ko-KR">
+                <a:rPr sz="1171" b="1" lang="ko-KR">
                   <a:solidFill>
                     <a:srgbClr val="7D8998"/>
                   </a:solidFill>
@@ -12450,8 +12450,8 @@
           </p:blipFill>
           <p:spPr>
             <a:xfrm>
-              <a:off x="1248833" y="3348567"/>
-              <a:ext cx="508000" cy="508000"/>
+              <a:off x="1057689" y="3431761"/>
+              <a:ext cx="510209" cy="510209"/>
             </a:xfrm>
             <a:prstGeom prst="rect">
               <a:avLst/>
@@ -12466,8 +12466,8 @@
           </p:nvSpPr>
           <p:spPr>
             <a:xfrm>
-              <a:off x="613833" y="3906308"/>
-              <a:ext cx="1778000" cy="192617"/>
+              <a:off x="419928" y="3991927"/>
+              <a:ext cx="1785730" cy="193454"/>
             </a:xfrm>
             <a:prstGeom prst="rect">
               <a:avLst/>
@@ -12486,7 +12486,7 @@
                 </a:lnSpc>
               </a:pPr>
               <a:r>
-                <a:rPr sz="1166" b="0" lang="ko-KR">
+                <a:rPr sz="1171" b="0" lang="ko-KR">
                   <a:solidFill>
                     <a:srgbClr val="232F3E"/>
                   </a:solidFill>
@@ -12507,8 +12507,8 @@
           </p:nvSpPr>
           <p:spPr>
             <a:xfrm>
-              <a:off x="828146" y="4095750"/>
-              <a:ext cx="1349375" cy="165100"/>
+              <a:off x="635173" y="4182193"/>
+              <a:ext cx="1355242" cy="165818"/>
             </a:xfrm>
             <a:prstGeom prst="rect">
               <a:avLst/>
@@ -12527,7 +12527,7 @@
                 </a:lnSpc>
               </a:pPr>
               <a:r>
-                <a:rPr sz="1000" b="0" lang="ko-KR">
+                <a:rPr sz="1004" b="0" lang="ko-KR">
                   <a:solidFill>
                     <a:srgbClr val="545B64"/>
                   </a:solidFill>
@@ -12562,8 +12562,8 @@
           </p:blipFill>
           <p:spPr>
             <a:xfrm>
-              <a:off x="2772833" y="3348567"/>
-              <a:ext cx="508000" cy="508000"/>
+              <a:off x="2418246" y="3431761"/>
+              <a:ext cx="510209" cy="510209"/>
             </a:xfrm>
             <a:prstGeom prst="rect">
               <a:avLst/>
@@ -12578,8 +12578,8 @@
           </p:nvSpPr>
           <p:spPr>
             <a:xfrm>
-              <a:off x="2545292" y="3906308"/>
-              <a:ext cx="963083" cy="192617"/>
+              <a:off x="2189715" y="3991927"/>
+              <a:ext cx="967271" cy="193454"/>
             </a:xfrm>
             <a:prstGeom prst="rect">
               <a:avLst/>
@@ -12598,7 +12598,7 @@
                 </a:lnSpc>
               </a:pPr>
               <a:r>
-                <a:rPr sz="1166" b="0" lang="ko-KR">
+                <a:rPr sz="1171" b="0" lang="ko-KR">
                   <a:solidFill>
                     <a:srgbClr val="232F3E"/>
                   </a:solidFill>
@@ -12619,13 +12619,13 @@
           </p:nvCxnSpPr>
           <p:spPr>
             <a:xfrm>
-              <a:off x="1799167" y="3602567"/>
-              <a:ext cx="931333" cy="0"/>
+              <a:off x="1610415" y="3686865"/>
+              <a:ext cx="765313" cy="0"/>
             </a:xfrm>
             <a:prstGeom prst="line">
               <a:avLst/>
             </a:prstGeom>
-            <a:ln w="15875">
+            <a:ln w="15944">
               <a:solidFill>
                 <a:srgbClr val="232F3E"/>
               </a:solidFill>
@@ -12642,13 +12642,13 @@
           </p:nvCxnSpPr>
           <p:spPr>
             <a:xfrm>
-              <a:off x="3323167" y="3602567"/>
-              <a:ext cx="529166" cy="0"/>
+              <a:off x="2970972" y="3686865"/>
+              <a:ext cx="531467" cy="0"/>
             </a:xfrm>
             <a:prstGeom prst="line">
               <a:avLst/>
             </a:prstGeom>
-            <a:ln w="15875">
+            <a:ln w="15944">
               <a:solidFill>
                 <a:srgbClr val="232F3E"/>
               </a:solidFill>
@@ -12665,8 +12665,8 @@
           </p:nvSpPr>
           <p:spPr>
             <a:xfrm>
-              <a:off x="3305969" y="3386667"/>
-              <a:ext cx="563562" cy="165100"/>
+              <a:off x="2953699" y="3735760"/>
+              <a:ext cx="566013" cy="165818"/>
             </a:xfrm>
             <a:prstGeom prst="rect">
               <a:avLst/>
@@ -12685,7 +12685,7 @@
                 </a:lnSpc>
               </a:pPr>
               <a:r>
-                <a:rPr sz="1000" b="0" lang="ko-KR">
+                <a:rPr sz="1004" b="0" lang="ko-KR">
                   <a:solidFill>
                     <a:srgbClr val="232F3E"/>
                   </a:solidFill>
@@ -12720,8 +12720,8 @@
           </p:blipFill>
           <p:spPr>
             <a:xfrm>
-              <a:off x="3894667" y="3348567"/>
-              <a:ext cx="508000" cy="508000"/>
+              <a:off x="3544957" y="3431761"/>
+              <a:ext cx="510209" cy="510209"/>
             </a:xfrm>
             <a:prstGeom prst="rect">
               <a:avLst/>
@@ -12736,8 +12736,8 @@
           </p:nvSpPr>
           <p:spPr>
             <a:xfrm>
-              <a:off x="3259667" y="3906308"/>
-              <a:ext cx="1778000" cy="192617"/>
+              <a:off x="2907196" y="3991927"/>
+              <a:ext cx="1785730" cy="193454"/>
             </a:xfrm>
             <a:prstGeom prst="rect">
               <a:avLst/>
@@ -12756,7 +12756,7 @@
                 </a:lnSpc>
               </a:pPr>
               <a:r>
-                <a:rPr sz="1166" b="0" lang="ko-KR">
+                <a:rPr sz="1171" b="0" lang="ko-KR">
                   <a:solidFill>
                     <a:srgbClr val="232F3E"/>
                   </a:solidFill>
@@ -12777,13 +12777,13 @@
           </p:nvCxnSpPr>
           <p:spPr>
             <a:xfrm>
-              <a:off x="4445000" y="3602567"/>
-              <a:ext cx="1820333" cy="0"/>
+              <a:off x="4097683" y="3686865"/>
+              <a:ext cx="1892024" cy="0"/>
             </a:xfrm>
             <a:prstGeom prst="line">
               <a:avLst/>
             </a:prstGeom>
-            <a:ln w="15875">
+            <a:ln w="15944">
               <a:solidFill>
                 <a:srgbClr val="232F3E"/>
               </a:solidFill>
@@ -12794,20 +12794,61 @@
         </p:cxnSp>
         <p:sp>
           <p:nvSpPr>
-            <p:cNvPr id="18" name="Rectangle 17"/>
+            <p:cNvPr id="18" name="TextBox 17"/>
+            <p:cNvSpPr txBox="1"/>
+            <p:nvPr/>
+          </p:nvSpPr>
+          <p:spPr>
+            <a:xfrm>
+              <a:off x="4631807" y="3714502"/>
+              <a:ext cx="1355242" cy="165818"/>
+            </a:xfrm>
+            <a:prstGeom prst="rect">
+              <a:avLst/>
+            </a:prstGeom>
+            <a:noFill/>
+          </p:spPr>
+          <p:txBody>
+            <a:bodyPr wrap="none" lIns="0" rIns="0" tIns="0" bIns="0" anchor="t">
+              <a:noAutofit/>
+            </a:bodyPr>
+            <a:lstStyle/>
+            <a:p>
+              <a:pPr algn="ctr">
+                <a:lnSpc>
+                  <a:spcPct val="100000"/>
+                </a:lnSpc>
+              </a:pPr>
+              <a:r>
+                <a:rPr sz="1004" b="0" lang="ko-KR">
+                  <a:solidFill>
+                    <a:srgbClr val="545B64"/>
+                  </a:solidFill>
+                  <a:latin typeface="Arial"/>
+                  <a:ea typeface="Malgun Gothic"/>
+                  <a:cs typeface="Malgun Gothic"/>
+                </a:rPr>
+                <a:t>VPN attachment</a:t>
+              </a:r>
+            </a:p>
+          </p:txBody>
+        </p:sp>
+        <p:sp>
+          <p:nvSpPr>
+            <p:cNvPr id="19" name="Rectangle 18"/>
             <p:cNvSpPr/>
             <p:nvPr/>
           </p:nvSpPr>
           <p:spPr>
             <a:xfrm>
-              <a:off x="4953000" y="1083733"/>
-              <a:ext cx="6646333" cy="4931833"/>
-            </a:xfrm>
-            <a:prstGeom prst="rect">
-              <a:avLst/>
-            </a:prstGeom>
-            <a:noFill/>
-            <a:ln w="21167">
+              <a:off x="4544115" y="1157080"/>
+              <a:ext cx="7249215" cy="5123346"/>
+            </a:xfrm>
+            <a:prstGeom prst="rect">
+              <a:avLst/>
+            </a:prstGeom>
+            <a:noFill/>
+            <a:ln w="21259">
               <a:solidFill>
                 <a:srgbClr val="232F3E"/>
               </a:solidFill>
@@ -12825,7 +12866,7 @@
         </p:sp>
         <p:pic>
           <p:nvPicPr>
-            <p:cNvPr id="19" name="AWS-Cloud-logo_32" descr="AWS Cloud logo_32"/>
+            <p:cNvPr id="20" name="AWS-Cloud-logo_32" descr="AWS Cloud logo_32"/>
             <p:cNvPicPr>
               <a:picLocks noChangeAspect="1"/>
             </p:cNvPicPr>
@@ -12845,8 +12886,8 @@
           </p:blipFill>
           <p:spPr>
             <a:xfrm>
-              <a:off x="4953000" y="1083733"/>
-              <a:ext cx="338667" cy="338667"/>
+              <a:off x="4544115" y="1157080"/>
+              <a:ext cx="340139" cy="340139"/>
             </a:xfrm>
             <a:prstGeom prst="rect">
               <a:avLst/>
@@ -12855,14 +12896,14 @@
         </p:pic>
         <p:sp>
           <p:nvSpPr>
-            <p:cNvPr id="20" name="TextBox 19"/>
-            <p:cNvSpPr txBox="1"/>
-            <p:nvPr/>
-          </p:nvSpPr>
-          <p:spPr>
-            <a:xfrm>
-              <a:off x="5397500" y="1165754"/>
-              <a:ext cx="1141016" cy="206375"/>
+            <p:cNvPr id="21" name="TextBox 20"/>
+            <p:cNvSpPr txBox="1"/>
+            <p:nvPr/>
+          </p:nvSpPr>
+          <p:spPr>
+            <a:xfrm>
+              <a:off x="4990548" y="1239458"/>
+              <a:ext cx="1145977" cy="207272"/>
             </a:xfrm>
             <a:prstGeom prst="rect">
               <a:avLst/>
@@ -12881,7 +12922,7 @@
                 </a:lnSpc>
               </a:pPr>
               <a:r>
-                <a:rPr sz="1250" b="1" lang="ko-KR">
+                <a:rPr sz="1255" b="1" lang="ko-KR">
                   <a:solidFill>
                     <a:srgbClr val="232F3E"/>
                   </a:solidFill>
@@ -12896,20 +12937,20 @@
         </p:sp>
         <p:sp>
           <p:nvSpPr>
-            <p:cNvPr id="21" name="Rectangle 20"/>
+            <p:cNvPr id="22" name="Rectangle 21"/>
             <p:cNvSpPr/>
             <p:nvPr/>
           </p:nvSpPr>
           <p:spPr>
             <a:xfrm>
-              <a:off x="5164667" y="1507067"/>
-              <a:ext cx="2667000" cy="4296833"/>
-            </a:xfrm>
-            <a:prstGeom prst="rect">
-              <a:avLst/>
-            </a:prstGeom>
-            <a:noFill/>
-            <a:ln w="21167">
+              <a:off x="4629150" y="1582254"/>
+              <a:ext cx="3210063" cy="4613137"/>
+            </a:xfrm>
+            <a:prstGeom prst="rect">
+              <a:avLst/>
+            </a:prstGeom>
+            <a:noFill/>
+            <a:ln w="21259">
               <a:solidFill>
                 <a:srgbClr val="00A4A6"/>
               </a:solidFill>
@@ -12929,7 +12970,7 @@
         </p:sp>
         <p:pic>
           <p:nvPicPr>
-            <p:cNvPr id="22" name="Region_32" descr="Region_32"/>
+            <p:cNvPr id="23" name="Region_32" descr="Region_32"/>
             <p:cNvPicPr>
               <a:picLocks noChangeAspect="1"/>
             </p:cNvPicPr>
@@ -12949,8 +12990,8 @@
           </p:blipFill>
           <p:spPr>
             <a:xfrm>
-              <a:off x="5164667" y="1507067"/>
-              <a:ext cx="254000" cy="254000"/>
+              <a:off x="4629150" y="1582254"/>
+              <a:ext cx="255104" cy="255104"/>
             </a:xfrm>
             <a:prstGeom prst="rect">
               <a:avLst/>
@@ -12959,14 +13000,14 @@
         </p:pic>
         <p:sp>
           <p:nvSpPr>
-            <p:cNvPr id="23" name="TextBox 22"/>
-            <p:cNvSpPr txBox="1"/>
-            <p:nvPr/>
-          </p:nvSpPr>
-          <p:spPr>
-            <a:xfrm>
-              <a:off x="5503333" y="1556808"/>
-              <a:ext cx="2287323" cy="192617"/>
+            <p:cNvPr id="24" name="TextBox 23"/>
+            <p:cNvSpPr txBox="1"/>
+            <p:nvPr/>
+          </p:nvSpPr>
+          <p:spPr>
+            <a:xfrm>
+              <a:off x="4969289" y="1632212"/>
+              <a:ext cx="2297268" cy="193454"/>
             </a:xfrm>
             <a:prstGeom prst="rect">
               <a:avLst/>
@@ -12985,7 +13026,7 @@
                 </a:lnSpc>
               </a:pPr>
               <a:r>
-                <a:rPr sz="1166" b="1" lang="ko-KR">
+                <a:rPr sz="1171" b="1" lang="ko-KR">
                   <a:solidFill>
                     <a:srgbClr val="00A4A6"/>
                   </a:solidFill>
@@ -13000,7 +13041,7 @@
         </p:sp>
         <p:pic>
           <p:nvPicPr>
-            <p:cNvPr id="24" name="AWS-Transit-Gateway" descr="AWS Transit Gateway"/>
+            <p:cNvPr id="25" name="AWS-Transit-Gateway" descr="AWS Transit Gateway"/>
             <p:cNvPicPr>
               <a:picLocks noChangeAspect="1"/>
             </p:cNvPicPr>
@@ -13020,8 +13061,8 @@
           </p:blipFill>
           <p:spPr>
             <a:xfrm>
-              <a:off x="6307667" y="3348567"/>
-              <a:ext cx="508000" cy="508000"/>
+              <a:off x="6032224" y="3431761"/>
+              <a:ext cx="510209" cy="510209"/>
             </a:xfrm>
             <a:prstGeom prst="rect">
               <a:avLst/>
@@ -13030,14 +13071,14 @@
         </p:pic>
         <p:sp>
           <p:nvSpPr>
-            <p:cNvPr id="25" name="TextBox 24"/>
-            <p:cNvSpPr txBox="1"/>
-            <p:nvPr/>
-          </p:nvSpPr>
-          <p:spPr>
-            <a:xfrm>
-              <a:off x="5621734" y="3906308"/>
-              <a:ext cx="1879865" cy="192617"/>
+            <p:cNvPr id="26" name="TextBox 25"/>
+            <p:cNvSpPr txBox="1"/>
+            <p:nvPr/>
+          </p:nvSpPr>
+          <p:spPr>
+            <a:xfrm>
+              <a:off x="5343309" y="3991927"/>
+              <a:ext cx="1888038" cy="193454"/>
             </a:xfrm>
             <a:prstGeom prst="rect">
               <a:avLst/>
@@ -13056,7 +13097,7 @@
                 </a:lnSpc>
               </a:pPr>
               <a:r>
-                <a:rPr sz="1166" b="0" lang="ko-KR">
+                <a:rPr sz="1171" b="0" lang="ko-KR">
                   <a:solidFill>
                     <a:srgbClr val="232F3E"/>
                   </a:solidFill>
@@ -13071,7 +13112,7 @@
         </p:sp>
         <p:pic>
           <p:nvPicPr>
-            <p:cNvPr id="26" name="Amazon-Virtual-Private-Cloud" descr="Amazon Virtual Private Cloud"/>
+            <p:cNvPr id="27" name="Amazon-Virtual-Private-Cloud" descr="Amazon Virtual Private Cloud"/>
             <p:cNvPicPr>
               <a:picLocks noChangeAspect="1"/>
             </p:cNvPicPr>
@@ -13091,8 +13132,8 @@
           </p:blipFill>
           <p:spPr>
             <a:xfrm>
-              <a:off x="5672667" y="1930400"/>
-              <a:ext cx="508000" cy="508000"/>
+              <a:off x="4969289" y="2007428"/>
+              <a:ext cx="510209" cy="510209"/>
             </a:xfrm>
             <a:prstGeom prst="rect">
               <a:avLst/>
@@ -13101,14 +13142,14 @@
         </p:pic>
         <p:sp>
           <p:nvSpPr>
-            <p:cNvPr id="27" name="TextBox 26"/>
-            <p:cNvSpPr txBox="1"/>
-            <p:nvPr/>
-          </p:nvSpPr>
-          <p:spPr>
-            <a:xfrm>
-              <a:off x="5241396" y="2488142"/>
-              <a:ext cx="1370542" cy="192617"/>
+            <p:cNvPr id="28" name="TextBox 27"/>
+            <p:cNvSpPr txBox="1"/>
+            <p:nvPr/>
+          </p:nvSpPr>
+          <p:spPr>
+            <a:xfrm>
+              <a:off x="4536143" y="2567595"/>
+              <a:ext cx="1376501" cy="193454"/>
             </a:xfrm>
             <a:prstGeom prst="rect">
               <a:avLst/>
@@ -13127,7 +13168,7 @@
                 </a:lnSpc>
               </a:pPr>
               <a:r>
-                <a:rPr sz="1166" b="0" lang="ko-KR">
+                <a:rPr sz="1171" b="0" lang="ko-KR">
                   <a:solidFill>
                     <a:srgbClr val="232F3E"/>
                   </a:solidFill>
@@ -13142,14 +13183,14 @@
         </p:sp>
         <p:sp>
           <p:nvSpPr>
-            <p:cNvPr id="28" name="TextBox 27"/>
-            <p:cNvSpPr txBox="1"/>
-            <p:nvPr/>
-          </p:nvSpPr>
-          <p:spPr>
-            <a:xfrm>
-              <a:off x="5382948" y="2677583"/>
-              <a:ext cx="1087438" cy="165100"/>
+            <p:cNvPr id="29" name="TextBox 28"/>
+            <p:cNvSpPr txBox="1"/>
+            <p:nvPr/>
+          </p:nvSpPr>
+          <p:spPr>
+            <a:xfrm>
+              <a:off x="4678311" y="2757860"/>
+              <a:ext cx="1092165" cy="165818"/>
             </a:xfrm>
             <a:prstGeom prst="rect">
               <a:avLst/>
@@ -13168,7 +13209,7 @@
                 </a:lnSpc>
               </a:pPr>
               <a:r>
-                <a:rPr sz="1000" b="0" lang="ko-KR">
+                <a:rPr sz="1004" b="0" lang="ko-KR">
                   <a:solidFill>
                     <a:srgbClr val="545B64"/>
                   </a:solidFill>
@@ -13183,7 +13224,7 @@
         </p:sp>
         <p:pic>
           <p:nvPicPr>
-            <p:cNvPr id="29" name="Amazon-Virtual-Private-Cloud" descr="Amazon Virtual Private Cloud"/>
+            <p:cNvPr id="30" name="Amazon-Virtual-Private-Cloud" descr="Amazon Virtual Private Cloud"/>
             <p:cNvPicPr>
               <a:picLocks noChangeAspect="1"/>
             </p:cNvPicPr>
@@ -13203,8 +13244,8 @@
           </p:blipFill>
           <p:spPr>
             <a:xfrm>
-              <a:off x="6942667" y="1930400"/>
-              <a:ext cx="508000" cy="508000"/>
+              <a:off x="7095159" y="2007428"/>
+              <a:ext cx="510209" cy="510209"/>
             </a:xfrm>
             <a:prstGeom prst="rect">
               <a:avLst/>
@@ -13213,14 +13254,14 @@
         </p:pic>
         <p:sp>
           <p:nvSpPr>
-            <p:cNvPr id="30" name="TextBox 29"/>
-            <p:cNvSpPr txBox="1"/>
-            <p:nvPr/>
-          </p:nvSpPr>
-          <p:spPr>
-            <a:xfrm>
-              <a:off x="6715125" y="2488142"/>
-              <a:ext cx="963083" cy="192617"/>
+            <p:cNvPr id="31" name="TextBox 30"/>
+            <p:cNvSpPr txBox="1"/>
+            <p:nvPr/>
+          </p:nvSpPr>
+          <p:spPr>
+            <a:xfrm>
+              <a:off x="6866628" y="2567595"/>
+              <a:ext cx="967271" cy="193454"/>
             </a:xfrm>
             <a:prstGeom prst="rect">
               <a:avLst/>
@@ -13239,7 +13280,7 @@
                 </a:lnSpc>
               </a:pPr>
               <a:r>
-                <a:rPr sz="1166" b="0" lang="ko-KR">
+                <a:rPr sz="1171" b="0" lang="ko-KR">
                   <a:solidFill>
                     <a:srgbClr val="232F3E"/>
                   </a:solidFill>
@@ -13254,14 +13295,14 @@
         </p:sp>
         <p:sp>
           <p:nvSpPr>
-            <p:cNvPr id="31" name="TextBox 30"/>
-            <p:cNvSpPr txBox="1"/>
-            <p:nvPr/>
-          </p:nvSpPr>
-          <p:spPr>
-            <a:xfrm>
-              <a:off x="6652948" y="2677583"/>
-              <a:ext cx="1087438" cy="165100"/>
+            <p:cNvPr id="32" name="TextBox 31"/>
+            <p:cNvSpPr txBox="1"/>
+            <p:nvPr/>
+          </p:nvSpPr>
+          <p:spPr>
+            <a:xfrm>
+              <a:off x="6804180" y="2757860"/>
+              <a:ext cx="1092165" cy="165818"/>
             </a:xfrm>
             <a:prstGeom prst="rect">
               <a:avLst/>
@@ -13280,7 +13321,7 @@
                 </a:lnSpc>
               </a:pPr>
               <a:r>
-                <a:rPr sz="1000" b="0" lang="ko-KR">
+                <a:rPr sz="1004" b="0" lang="ko-KR">
                   <a:solidFill>
                     <a:srgbClr val="545B64"/>
                   </a:solidFill>
@@ -13295,7 +13336,7 @@
         </p:sp>
         <p:pic>
           <p:nvPicPr>
-            <p:cNvPr id="32" name="Amazon-Virtual-Private-Cloud" descr="Amazon Virtual Private Cloud"/>
+            <p:cNvPr id="33" name="Amazon-Virtual-Private-Cloud" descr="Amazon Virtual Private Cloud"/>
             <p:cNvPicPr>
               <a:picLocks noChangeAspect="1"/>
             </p:cNvPicPr>
@@ -13315,8 +13356,8 @@
           </p:blipFill>
           <p:spPr>
             <a:xfrm>
-              <a:off x="5672667" y="4766733"/>
-              <a:ext cx="508000" cy="508000"/>
+              <a:off x="4969289" y="4856093"/>
+              <a:ext cx="510209" cy="510209"/>
             </a:xfrm>
             <a:prstGeom prst="rect">
               <a:avLst/>
@@ -13325,14 +13366,14 @@
         </p:pic>
         <p:sp>
           <p:nvSpPr>
-            <p:cNvPr id="33" name="TextBox 32"/>
-            <p:cNvSpPr txBox="1"/>
-            <p:nvPr/>
-          </p:nvSpPr>
-          <p:spPr>
-            <a:xfrm>
-              <a:off x="5496057" y="5324475"/>
-              <a:ext cx="861219" cy="192617"/>
+            <p:cNvPr id="34" name="TextBox 33"/>
+            <p:cNvSpPr txBox="1"/>
+            <p:nvPr/>
+          </p:nvSpPr>
+          <p:spPr>
+            <a:xfrm>
+              <a:off x="4791912" y="5416260"/>
+              <a:ext cx="864963" cy="193454"/>
             </a:xfrm>
             <a:prstGeom prst="rect">
               <a:avLst/>
@@ -13351,7 +13392,7 @@
                 </a:lnSpc>
               </a:pPr>
               <a:r>
-                <a:rPr sz="1166" b="0" lang="ko-KR">
+                <a:rPr sz="1171" b="0" lang="ko-KR">
                   <a:solidFill>
                     <a:srgbClr val="232F3E"/>
                   </a:solidFill>
@@ -13366,14 +13407,14 @@
         </p:sp>
         <p:sp>
           <p:nvSpPr>
-            <p:cNvPr id="34" name="TextBox 33"/>
-            <p:cNvSpPr txBox="1"/>
-            <p:nvPr/>
-          </p:nvSpPr>
-          <p:spPr>
-            <a:xfrm>
-              <a:off x="5382948" y="5513917"/>
-              <a:ext cx="1087438" cy="165100"/>
+            <p:cNvPr id="35" name="TextBox 34"/>
+            <p:cNvSpPr txBox="1"/>
+            <p:nvPr/>
+          </p:nvSpPr>
+          <p:spPr>
+            <a:xfrm>
+              <a:off x="4678311" y="5606525"/>
+              <a:ext cx="1092165" cy="165818"/>
             </a:xfrm>
             <a:prstGeom prst="rect">
               <a:avLst/>
@@ -13392,7 +13433,7 @@
                 </a:lnSpc>
               </a:pPr>
               <a:r>
-                <a:rPr sz="1000" b="0" lang="ko-KR">
+                <a:rPr sz="1004" b="0" lang="ko-KR">
                   <a:solidFill>
                     <a:srgbClr val="545B64"/>
                   </a:solidFill>
@@ -13407,7 +13448,7 @@
         </p:sp>
         <p:pic>
           <p:nvPicPr>
-            <p:cNvPr id="35" name="Amazon-Virtual-Private-Cloud" descr="Amazon Virtual Private Cloud"/>
+            <p:cNvPr id="36" name="Amazon-Virtual-Private-Cloud" descr="Amazon Virtual Private Cloud"/>
             <p:cNvPicPr>
               <a:picLocks noChangeAspect="1"/>
             </p:cNvPicPr>
@@ -13427,8 +13468,8 @@
           </p:blipFill>
           <p:spPr>
             <a:xfrm>
-              <a:off x="6942667" y="4766733"/>
-              <a:ext cx="508000" cy="508000"/>
+              <a:off x="7095159" y="4856093"/>
+              <a:ext cx="510209" cy="510209"/>
             </a:xfrm>
             <a:prstGeom prst="rect">
               <a:avLst/>
@@ -13437,14 +13478,14 @@
         </p:pic>
         <p:sp>
           <p:nvSpPr>
-            <p:cNvPr id="36" name="TextBox 35"/>
-            <p:cNvSpPr txBox="1"/>
-            <p:nvPr/>
-          </p:nvSpPr>
-          <p:spPr>
-            <a:xfrm>
-              <a:off x="6715125" y="5324475"/>
-              <a:ext cx="963083" cy="192617"/>
+            <p:cNvPr id="37" name="TextBox 36"/>
+            <p:cNvSpPr txBox="1"/>
+            <p:nvPr/>
+          </p:nvSpPr>
+          <p:spPr>
+            <a:xfrm>
+              <a:off x="6866628" y="5416260"/>
+              <a:ext cx="967271" cy="193454"/>
             </a:xfrm>
             <a:prstGeom prst="rect">
               <a:avLst/>
@@ -13463,7 +13504,7 @@
                 </a:lnSpc>
               </a:pPr>
               <a:r>
-                <a:rPr sz="1166" b="0" lang="ko-KR">
+                <a:rPr sz="1171" b="0" lang="ko-KR">
                   <a:solidFill>
                     <a:srgbClr val="232F3E"/>
                   </a:solidFill>
@@ -13478,14 +13519,14 @@
         </p:sp>
         <p:sp>
           <p:nvSpPr>
-            <p:cNvPr id="37" name="TextBox 36"/>
-            <p:cNvSpPr txBox="1"/>
-            <p:nvPr/>
-          </p:nvSpPr>
-          <p:spPr>
-            <a:xfrm>
-              <a:off x="6652948" y="5513917"/>
-              <a:ext cx="1087438" cy="165100"/>
+            <p:cNvPr id="38" name="TextBox 37"/>
+            <p:cNvSpPr txBox="1"/>
+            <p:nvPr/>
+          </p:nvSpPr>
+          <p:spPr>
+            <a:xfrm>
+              <a:off x="6804180" y="5606525"/>
+              <a:ext cx="1092165" cy="165818"/>
             </a:xfrm>
             <a:prstGeom prst="rect">
               <a:avLst/>
@@ -13504,7 +13545,7 @@
                 </a:lnSpc>
               </a:pPr>
               <a:r>
-                <a:rPr sz="1000" b="0" lang="ko-KR">
+                <a:rPr sz="1004" b="0" lang="ko-KR">
                   <a:solidFill>
                     <a:srgbClr val="545B64"/>
                   </a:solidFill>
@@ -13517,16 +13558,169 @@
             </a:p>
           </p:txBody>
         </p:sp>
-        <p:sp>
-          <p:nvSpPr>
-            <p:cNvPr id="38" name="Freeform 37"/>
+        <p:pic>
+          <p:nvPicPr>
+            <p:cNvPr id="39" name="Amazon-Route-53_Route-Table" descr="Amazon Route 53_Route Table"/>
+            <p:cNvPicPr>
+              <a:picLocks noChangeAspect="1"/>
+            </p:cNvPicPr>
+            <p:nvPr/>
+          </p:nvPicPr>
+          <p:blipFill>
+            <a:blip r:embed="rId18">
+              <a:extLst>
+                <a:ext uri="{96DAC541-7B7A-43D3-8B79-37D633B846F1}">
+                  <asvg:svgBlip xmlns:asvg="http://schemas.microsoft.com/office/drawing/2016/SVG/main" r:embed="rId19"/>
+                </a:ext>
+              </a:extLst>
+            </a:blip>
+            <a:stretch>
+              <a:fillRect/>
+            </a:stretch>
+          </p:blipFill>
+          <p:spPr>
+            <a:xfrm>
+              <a:off x="6032224" y="4856093"/>
+              <a:ext cx="510209" cy="510209"/>
+            </a:xfrm>
+            <a:prstGeom prst="rect">
+              <a:avLst/>
+            </a:prstGeom>
+          </p:spPr>
+        </p:pic>
+        <p:sp>
+          <p:nvSpPr>
+            <p:cNvPr id="40" name="TextBox 39"/>
+            <p:cNvSpPr txBox="1"/>
+            <p:nvPr/>
+          </p:nvSpPr>
+          <p:spPr>
+            <a:xfrm>
+              <a:off x="5803693" y="5416260"/>
+              <a:ext cx="967271" cy="193454"/>
+            </a:xfrm>
+            <a:prstGeom prst="rect">
+              <a:avLst/>
+            </a:prstGeom>
+            <a:noFill/>
+          </p:spPr>
+          <p:txBody>
+            <a:bodyPr wrap="none" lIns="0" rIns="0" tIns="0" bIns="0" anchor="t">
+              <a:noAutofit/>
+            </a:bodyPr>
+            <a:lstStyle/>
+            <a:p>
+              <a:pPr algn="ctr">
+                <a:lnSpc>
+                  <a:spcPct val="100000"/>
+                </a:lnSpc>
+              </a:pPr>
+              <a:r>
+                <a:rPr sz="1171" b="0" lang="ko-KR">
+                  <a:solidFill>
+                    <a:srgbClr val="232F3E"/>
+                  </a:solidFill>
+                  <a:latin typeface="Arial"/>
+                  <a:ea typeface="Malgun Gothic"/>
+                  <a:cs typeface="Malgun Gothic"/>
+                </a:rPr>
+                <a:t>TGW A RT</a:t>
+              </a:r>
+            </a:p>
+          </p:txBody>
+        </p:sp>
+        <p:sp>
+          <p:nvSpPr>
+            <p:cNvPr id="41" name="TextBox 40"/>
+            <p:cNvSpPr txBox="1"/>
+            <p:nvPr/>
+          </p:nvSpPr>
+          <p:spPr>
+            <a:xfrm>
+              <a:off x="5510057" y="5606525"/>
+              <a:ext cx="1554542" cy="165818"/>
+            </a:xfrm>
+            <a:prstGeom prst="rect">
+              <a:avLst/>
+            </a:prstGeom>
+            <a:noFill/>
+          </p:spPr>
+          <p:txBody>
+            <a:bodyPr wrap="none" lIns="0" rIns="0" tIns="0" bIns="0" anchor="t">
+              <a:noAutofit/>
+            </a:bodyPr>
+            <a:lstStyle/>
+            <a:p>
+              <a:pPr algn="ctr">
+                <a:lnSpc>
+                  <a:spcPct val="100000"/>
+                </a:lnSpc>
+              </a:pPr>
+              <a:r>
+                <a:rPr sz="1004" b="0" lang="ko-KR">
+                  <a:solidFill>
+                    <a:srgbClr val="545B64"/>
+                  </a:solidFill>
+                  <a:latin typeface="Arial"/>
+                  <a:ea typeface="Malgun Gothic"/>
+                  <a:cs typeface="Malgun Gothic"/>
+                </a:rPr>
+                <a:t>VPC·VPN 경로 전파</a:t>
+              </a:r>
+            </a:p>
+          </p:txBody>
+        </p:sp>
+        <p:sp>
+          <p:nvSpPr>
+            <p:cNvPr id="42" name="TextBox 41"/>
+            <p:cNvSpPr txBox="1"/>
+            <p:nvPr/>
+          </p:nvSpPr>
+          <p:spPr>
+            <a:xfrm>
+              <a:off x="5223065" y="5776595"/>
+              <a:ext cx="2128527" cy="165818"/>
+            </a:xfrm>
+            <a:prstGeom prst="rect">
+              <a:avLst/>
+            </a:prstGeom>
+            <a:noFill/>
+          </p:spPr>
+          <p:txBody>
+            <a:bodyPr wrap="none" lIns="0" rIns="0" tIns="0" bIns="0" anchor="t">
+              <a:noAutofit/>
+            </a:bodyPr>
+            <a:lstStyle/>
+            <a:p>
+              <a:pPr algn="ctr">
+                <a:lnSpc>
+                  <a:spcPct val="100000"/>
+                </a:lnSpc>
+              </a:pPr>
+              <a:r>
+                <a:rPr sz="1004" b="0" lang="ko-KR">
+                  <a:solidFill>
+                    <a:srgbClr val="545B64"/>
+                  </a:solidFill>
+                  <a:latin typeface="Arial"/>
+                  <a:ea typeface="Malgun Gothic"/>
+                  <a:cs typeface="Malgun Gothic"/>
+                </a:rPr>
+                <a:t>10.16.0.0/13 → peering</a:t>
+              </a:r>
+            </a:p>
+          </p:txBody>
+        </p:sp>
+        <p:sp>
+          <p:nvSpPr>
+            <p:cNvPr id="43" name="Freeform 42"/>
             <p:cNvSpPr/>
             <p:nvPr/>
           </p:nvSpPr>
           <p:spPr>
             <a:xfrm>
-              <a:off x="5926667" y="2882900"/>
-              <a:ext cx="529166" cy="423333"/>
+              <a:off x="5224393" y="2964070"/>
+              <a:ext cx="956642" cy="425173"/>
             </a:xfrm>
             <a:custGeom>
               <a:avLst/>
@@ -13535,15 +13729,15 @@
               <a:cxnLst/>
               <a:rect l="l" t="t" r="r" b="b"/>
               <a:pathLst>
-                <a:path w="529166" h="423333">
+                <a:path w="956642" h="425173">
                   <a:moveTo>
-                    <a:pt x="529166" y="423333"/>
+                    <a:pt x="956642" y="425173"/>
                   </a:moveTo>
                   <a:lnTo>
-                    <a:pt x="529166" y="211667"/>
+                    <a:pt x="956642" y="297621"/>
                   </a:lnTo>
                   <a:lnTo>
-                    <a:pt x="0" y="211667"/>
+                    <a:pt x="0" y="297621"/>
                   </a:lnTo>
                   <a:lnTo>
                     <a:pt x="0" y="0"/>
@@ -13552,7 +13746,7 @@
               </a:pathLst>
             </a:custGeom>
             <a:noFill/>
-            <a:ln w="15875">
+            <a:ln w="15944">
               <a:solidFill>
                 <a:srgbClr val="232F3E"/>
               </a:solidFill>
@@ -13570,14 +13764,14 @@
         </p:sp>
         <p:sp>
           <p:nvSpPr>
-            <p:cNvPr id="39" name="Freeform 38"/>
+            <p:cNvPr id="44" name="Freeform 43"/>
             <p:cNvSpPr/>
             <p:nvPr/>
           </p:nvSpPr>
           <p:spPr>
             <a:xfrm>
-              <a:off x="6667500" y="2882900"/>
-              <a:ext cx="529167" cy="423333"/>
+              <a:off x="6393622" y="2964070"/>
+              <a:ext cx="956641" cy="425173"/>
             </a:xfrm>
             <a:custGeom>
               <a:avLst/>
@@ -13586,24 +13780,24 @@
               <a:cxnLst/>
               <a:rect l="l" t="t" r="r" b="b"/>
               <a:pathLst>
-                <a:path w="529167" h="423333">
+                <a:path w="956641" h="425173">
                   <a:moveTo>
-                    <a:pt x="0" y="423333"/>
+                    <a:pt x="0" y="425173"/>
                   </a:moveTo>
                   <a:lnTo>
-                    <a:pt x="0" y="211667"/>
+                    <a:pt x="0" y="297621"/>
                   </a:lnTo>
                   <a:lnTo>
-                    <a:pt x="529167" y="211667"/>
+                    <a:pt x="956641" y="297621"/>
                   </a:lnTo>
                   <a:lnTo>
-                    <a:pt x="529167" y="0"/>
+                    <a:pt x="956641" y="0"/>
                   </a:lnTo>
                 </a:path>
               </a:pathLst>
             </a:custGeom>
             <a:noFill/>
-            <a:ln w="15875">
+            <a:ln w="15944">
               <a:solidFill>
                 <a:srgbClr val="232F3E"/>
               </a:solidFill>
@@ -13621,14 +13815,14 @@
         </p:sp>
         <p:sp>
           <p:nvSpPr>
-            <p:cNvPr id="40" name="Freeform 39"/>
+            <p:cNvPr id="45" name="Freeform 44"/>
             <p:cNvSpPr/>
             <p:nvPr/>
           </p:nvSpPr>
           <p:spPr>
             <a:xfrm>
-              <a:off x="5926667" y="4131733"/>
-              <a:ext cx="529166" cy="592667"/>
+              <a:off x="5224393" y="4218333"/>
+              <a:ext cx="956642" cy="595243"/>
             </a:xfrm>
             <a:custGeom>
               <a:avLst/>
@@ -13637,24 +13831,24 @@
               <a:cxnLst/>
               <a:rect l="l" t="t" r="r" b="b"/>
               <a:pathLst>
-                <a:path w="529166" h="592667">
+                <a:path w="956642" h="595243">
                   <a:moveTo>
-                    <a:pt x="529166" y="0"/>
+                    <a:pt x="956642" y="0"/>
                   </a:moveTo>
                   <a:lnTo>
-                    <a:pt x="529166" y="296334"/>
+                    <a:pt x="956642" y="297621"/>
                   </a:lnTo>
                   <a:lnTo>
-                    <a:pt x="0" y="296334"/>
+                    <a:pt x="0" y="297621"/>
                   </a:lnTo>
                   <a:lnTo>
-                    <a:pt x="0" y="592667"/>
+                    <a:pt x="0" y="595243"/>
                   </a:lnTo>
                 </a:path>
               </a:pathLst>
             </a:custGeom>
             <a:noFill/>
-            <a:ln w="15875">
+            <a:ln w="15944">
               <a:solidFill>
                 <a:srgbClr val="232F3E"/>
               </a:solidFill>
@@ -13672,14 +13866,14 @@
         </p:sp>
         <p:sp>
           <p:nvSpPr>
-            <p:cNvPr id="41" name="Freeform 40"/>
+            <p:cNvPr id="46" name="Freeform 45"/>
             <p:cNvSpPr/>
             <p:nvPr/>
           </p:nvSpPr>
           <p:spPr>
             <a:xfrm>
-              <a:off x="6667500" y="4131733"/>
-              <a:ext cx="529167" cy="592667"/>
+              <a:off x="6393622" y="4218333"/>
+              <a:ext cx="956641" cy="595243"/>
             </a:xfrm>
             <a:custGeom>
               <a:avLst/>
@@ -13688,24 +13882,24 @@
               <a:cxnLst/>
               <a:rect l="l" t="t" r="r" b="b"/>
               <a:pathLst>
-                <a:path w="529167" h="592667">
+                <a:path w="956641" h="595243">
                   <a:moveTo>
                     <a:pt x="0" y="0"/>
                   </a:moveTo>
                   <a:lnTo>
-                    <a:pt x="0" y="296334"/>
+                    <a:pt x="0" y="297621"/>
                   </a:lnTo>
                   <a:lnTo>
-                    <a:pt x="529167" y="296334"/>
+                    <a:pt x="956641" y="297621"/>
                   </a:lnTo>
                   <a:lnTo>
-                    <a:pt x="529167" y="592667"/>
+                    <a:pt x="956641" y="595243"/>
                   </a:lnTo>
                 </a:path>
               </a:pathLst>
             </a:custGeom>
             <a:noFill/>
-            <a:ln w="15875">
+            <a:ln w="15944">
               <a:solidFill>
                 <a:srgbClr val="232F3E"/>
               </a:solidFill>
@@ -13723,20 +13917,219 @@
         </p:sp>
         <p:sp>
           <p:nvSpPr>
-            <p:cNvPr id="42" name="Rectangle 41"/>
+            <p:cNvPr id="47" name="TextBox 46"/>
+            <p:cNvSpPr txBox="1"/>
+            <p:nvPr/>
+          </p:nvSpPr>
+          <p:spPr>
+            <a:xfrm>
+              <a:off x="5099499" y="3055482"/>
+              <a:ext cx="1355242" cy="165818"/>
+            </a:xfrm>
+            <a:prstGeom prst="rect">
+              <a:avLst/>
+            </a:prstGeom>
+            <a:noFill/>
+          </p:spPr>
+          <p:txBody>
+            <a:bodyPr wrap="none" lIns="0" rIns="0" tIns="0" bIns="0" anchor="t">
+              <a:noAutofit/>
+            </a:bodyPr>
+            <a:lstStyle/>
+            <a:p>
+              <a:pPr algn="ctr">
+                <a:lnSpc>
+                  <a:spcPct val="100000"/>
+                </a:lnSpc>
+              </a:pPr>
+              <a:r>
+                <a:rPr sz="1004" b="0" lang="ko-KR">
+                  <a:solidFill>
+                    <a:srgbClr val="545B64"/>
+                  </a:solidFill>
+                  <a:latin typeface="Arial"/>
+                  <a:ea typeface="Malgun Gothic"/>
+                  <a:cs typeface="Malgun Gothic"/>
+                </a:rPr>
+                <a:t>VPC attachment</a:t>
+              </a:r>
+            </a:p>
+          </p:txBody>
+        </p:sp>
+        <p:cxnSp>
+          <p:nvCxnSpPr>
+            <p:cNvPr id="48" name="Connector 47"/>
+            <p:cNvCxnSpPr/>
+            <p:nvPr/>
+          </p:nvCxnSpPr>
+          <p:spPr>
+            <a:xfrm>
+              <a:off x="6584950" y="3686865"/>
+              <a:ext cx="1679437" cy="0"/>
+            </a:xfrm>
+            <a:prstGeom prst="line">
+              <a:avLst/>
+            </a:prstGeom>
+            <a:ln w="15944">
+              <a:solidFill>
+                <a:srgbClr val="232F3E"/>
+              </a:solidFill>
+              <a:prstDash val="solid"/>
+              <a:miter lim="800000"/>
+            </a:ln>
+          </p:spPr>
+        </p:cxnSp>
+        <p:cxnSp>
+          <p:nvCxnSpPr>
+            <p:cNvPr id="49" name="Connector 48"/>
+            <p:cNvCxnSpPr/>
+            <p:nvPr/>
+          </p:nvCxnSpPr>
+          <p:spPr>
+            <a:xfrm>
+              <a:off x="8859630" y="3686865"/>
+              <a:ext cx="1275522" cy="0"/>
+            </a:xfrm>
+            <a:prstGeom prst="line">
+              <a:avLst/>
+            </a:prstGeom>
+            <a:ln w="15944">
+              <a:solidFill>
+                <a:srgbClr val="232F3E"/>
+              </a:solidFill>
+              <a:prstDash val="solid"/>
+              <a:miter lim="800000"/>
+            </a:ln>
+          </p:spPr>
+        </p:cxnSp>
+        <p:pic>
+          <p:nvPicPr>
+            <p:cNvPr id="50" name="Amazon-VPC_Peering-Connection" descr="Amazon VPC_Peering Connection"/>
+            <p:cNvPicPr>
+              <a:picLocks noChangeAspect="1"/>
+            </p:cNvPicPr>
+            <p:nvPr/>
+          </p:nvPicPr>
+          <p:blipFill>
+            <a:blip r:embed="rId20">
+              <a:extLst>
+                <a:ext uri="{96DAC541-7B7A-43D3-8B79-37D633B846F1}">
+                  <asvg:svgBlip xmlns:asvg="http://schemas.microsoft.com/office/drawing/2016/SVG/main" r:embed="rId21"/>
+                </a:ext>
+              </a:extLst>
+            </a:blip>
+            <a:stretch>
+              <a:fillRect/>
+            </a:stretch>
+          </p:blipFill>
+          <p:spPr>
+            <a:xfrm>
+              <a:off x="8306904" y="3431761"/>
+              <a:ext cx="510209" cy="510209"/>
+            </a:xfrm>
+            <a:prstGeom prst="rect">
+              <a:avLst/>
+            </a:prstGeom>
+          </p:spPr>
+        </p:pic>
+        <p:sp>
+          <p:nvSpPr>
+            <p:cNvPr id="51" name="TextBox 50"/>
+            <p:cNvSpPr txBox="1"/>
+            <p:nvPr/>
+          </p:nvSpPr>
+          <p:spPr>
+            <a:xfrm>
+              <a:off x="7924912" y="3991927"/>
+              <a:ext cx="1274193" cy="193454"/>
+            </a:xfrm>
+            <a:prstGeom prst="rect">
+              <a:avLst/>
+            </a:prstGeom>
+            <a:noFill/>
+          </p:spPr>
+          <p:txBody>
+            <a:bodyPr wrap="none" lIns="0" rIns="0" tIns="0" bIns="0" anchor="t">
+              <a:noAutofit/>
+            </a:bodyPr>
+            <a:lstStyle/>
+            <a:p>
+              <a:pPr algn="ctr">
+                <a:lnSpc>
+                  <a:spcPct val="100000"/>
+                </a:lnSpc>
+              </a:pPr>
+              <a:r>
+                <a:rPr sz="1171" b="0" lang="ko-KR">
+                  <a:solidFill>
+                    <a:srgbClr val="232F3E"/>
+                  </a:solidFill>
+                  <a:latin typeface="Arial"/>
+                  <a:ea typeface="Malgun Gothic"/>
+                  <a:cs typeface="Malgun Gothic"/>
+                </a:rPr>
+                <a:t>TGW peering</a:t>
+              </a:r>
+            </a:p>
+          </p:txBody>
+        </p:sp>
+        <p:sp>
+          <p:nvSpPr>
+            <p:cNvPr id="52" name="TextBox 51"/>
+            <p:cNvSpPr txBox="1"/>
+            <p:nvPr/>
+          </p:nvSpPr>
+          <p:spPr>
+            <a:xfrm>
+              <a:off x="7709004" y="4182193"/>
+              <a:ext cx="1706010" cy="165818"/>
+            </a:xfrm>
+            <a:prstGeom prst="rect">
+              <a:avLst/>
+            </a:prstGeom>
+            <a:noFill/>
+          </p:spPr>
+          <p:txBody>
+            <a:bodyPr wrap="none" lIns="0" rIns="0" tIns="0" bIns="0" anchor="t">
+              <a:noAutofit/>
+            </a:bodyPr>
+            <a:lstStyle/>
+            <a:p>
+              <a:pPr algn="ctr">
+                <a:lnSpc>
+                  <a:spcPct val="100000"/>
+                </a:lnSpc>
+              </a:pPr>
+              <a:r>
+                <a:rPr sz="1004" b="0" lang="ko-KR">
+                  <a:solidFill>
+                    <a:srgbClr val="545B64"/>
+                  </a:solidFill>
+                  <a:latin typeface="Arial"/>
+                  <a:ea typeface="Malgun Gothic"/>
+                  <a:cs typeface="Malgun Gothic"/>
+                </a:rPr>
+                <a:t>peering attachment</a:t>
+              </a:r>
+            </a:p>
+          </p:txBody>
+        </p:sp>
+        <p:sp>
+          <p:nvSpPr>
+            <p:cNvPr id="53" name="Rectangle 52"/>
             <p:cNvSpPr/>
             <p:nvPr/>
           </p:nvSpPr>
           <p:spPr>
             <a:xfrm>
-              <a:off x="8932333" y="1507067"/>
-              <a:ext cx="2455333" cy="4296833"/>
-            </a:xfrm>
-            <a:prstGeom prst="rect">
-              <a:avLst/>
-            </a:prstGeom>
-            <a:noFill/>
-            <a:ln w="21167">
+              <a:off x="9284804" y="1582254"/>
+              <a:ext cx="2423491" cy="4613137"/>
+            </a:xfrm>
+            <a:prstGeom prst="rect">
+              <a:avLst/>
+            </a:prstGeom>
+            <a:noFill/>
+            <a:ln w="21259">
               <a:solidFill>
                 <a:srgbClr val="00A4A6"/>
               </a:solidFill>
@@ -13756,7 +14149,7 @@
         </p:sp>
         <p:pic>
           <p:nvPicPr>
-            <p:cNvPr id="43" name="Region_32" descr="Region_32"/>
+            <p:cNvPr id="54" name="Region_32" descr="Region_32"/>
             <p:cNvPicPr>
               <a:picLocks noChangeAspect="1"/>
             </p:cNvPicPr>
@@ -13776,8 +14169,8 @@
           </p:blipFill>
           <p:spPr>
             <a:xfrm>
-              <a:off x="8932333" y="1507067"/>
-              <a:ext cx="254000" cy="254000"/>
+              <a:off x="9284804" y="1582254"/>
+              <a:ext cx="255104" cy="255104"/>
             </a:xfrm>
             <a:prstGeom prst="rect">
               <a:avLst/>
@@ -13786,14 +14179,14 @@
         </p:pic>
         <p:sp>
           <p:nvSpPr>
-            <p:cNvPr id="44" name="TextBox 43"/>
-            <p:cNvSpPr txBox="1"/>
-            <p:nvPr/>
-          </p:nvSpPr>
-          <p:spPr>
-            <a:xfrm>
-              <a:off x="9271000" y="1556808"/>
-              <a:ext cx="2287323" cy="192617"/>
+            <p:cNvPr id="55" name="TextBox 54"/>
+            <p:cNvSpPr txBox="1"/>
+            <p:nvPr/>
+          </p:nvSpPr>
+          <p:spPr>
+            <a:xfrm>
+              <a:off x="9624943" y="1632212"/>
+              <a:ext cx="2297268" cy="193454"/>
             </a:xfrm>
             <a:prstGeom prst="rect">
               <a:avLst/>
@@ -13812,7 +14205,7 @@
                 </a:lnSpc>
               </a:pPr>
               <a:r>
-                <a:rPr sz="1166" b="1" lang="ko-KR">
+                <a:rPr sz="1171" b="1" lang="ko-KR">
                   <a:solidFill>
                     <a:srgbClr val="00A4A6"/>
                   </a:solidFill>
@@ -13827,7 +14220,7 @@
         </p:sp>
         <p:pic>
           <p:nvPicPr>
-            <p:cNvPr id="45" name="AWS-Transit-Gateway" descr="AWS Transit Gateway"/>
+            <p:cNvPr id="56" name="AWS-Transit-Gateway" descr="AWS Transit Gateway"/>
             <p:cNvPicPr>
               <a:picLocks noChangeAspect="1"/>
             </p:cNvPicPr>
@@ -13847,8 +14240,8 @@
           </p:blipFill>
           <p:spPr>
             <a:xfrm>
-              <a:off x="9863667" y="3348567"/>
-              <a:ext cx="508000" cy="508000"/>
+              <a:off x="10177670" y="3431761"/>
+              <a:ext cx="510209" cy="510209"/>
             </a:xfrm>
             <a:prstGeom prst="rect">
               <a:avLst/>
@@ -13857,14 +14250,14 @@
         </p:pic>
         <p:sp>
           <p:nvSpPr>
-            <p:cNvPr id="46" name="TextBox 45"/>
-            <p:cNvSpPr txBox="1"/>
-            <p:nvPr/>
-          </p:nvSpPr>
-          <p:spPr>
-            <a:xfrm>
-              <a:off x="9177734" y="3906308"/>
-              <a:ext cx="1879865" cy="192617"/>
+            <p:cNvPr id="57" name="TextBox 56"/>
+            <p:cNvSpPr txBox="1"/>
+            <p:nvPr/>
+          </p:nvSpPr>
+          <p:spPr>
+            <a:xfrm>
+              <a:off x="9488755" y="3991927"/>
+              <a:ext cx="1888038" cy="193454"/>
             </a:xfrm>
             <a:prstGeom prst="rect">
               <a:avLst/>
@@ -13883,7 +14276,7 @@
                 </a:lnSpc>
               </a:pPr>
               <a:r>
-                <a:rPr sz="1166" b="0" lang="ko-KR">
+                <a:rPr sz="1171" b="0" lang="ko-KR">
                   <a:solidFill>
                     <a:srgbClr val="232F3E"/>
                   </a:solidFill>
@@ -13898,7 +14291,7 @@
         </p:sp>
         <p:pic>
           <p:nvPicPr>
-            <p:cNvPr id="47" name="Amazon-Virtual-Private-Cloud" descr="Amazon Virtual Private Cloud"/>
+            <p:cNvPr id="58" name="Amazon-Virtual-Private-Cloud" descr="Amazon Virtual Private Cloud"/>
             <p:cNvPicPr>
               <a:picLocks noChangeAspect="1"/>
             </p:cNvPicPr>
@@ -13918,8 +14311,8 @@
           </p:blipFill>
           <p:spPr>
             <a:xfrm>
-              <a:off x="9863667" y="1930400"/>
-              <a:ext cx="508000" cy="508000"/>
+              <a:off x="9539909" y="2007428"/>
+              <a:ext cx="510209" cy="510209"/>
             </a:xfrm>
             <a:prstGeom prst="rect">
               <a:avLst/>
@@ -13928,14 +14321,14 @@
         </p:pic>
         <p:sp>
           <p:nvSpPr>
-            <p:cNvPr id="48" name="TextBox 47"/>
-            <p:cNvSpPr txBox="1"/>
-            <p:nvPr/>
-          </p:nvSpPr>
-          <p:spPr>
-            <a:xfrm>
-              <a:off x="9737990" y="2488142"/>
-              <a:ext cx="759354" cy="192617"/>
+            <p:cNvPr id="59" name="TextBox 58"/>
+            <p:cNvSpPr txBox="1"/>
+            <p:nvPr/>
+          </p:nvSpPr>
+          <p:spPr>
+            <a:xfrm>
+              <a:off x="9413685" y="2567595"/>
+              <a:ext cx="762656" cy="193454"/>
             </a:xfrm>
             <a:prstGeom prst="rect">
               <a:avLst/>
@@ -13954,7 +14347,7 @@
                 </a:lnSpc>
               </a:pPr>
               <a:r>
-                <a:rPr sz="1166" b="0" lang="ko-KR">
+                <a:rPr sz="1171" b="0" lang="ko-KR">
                   <a:solidFill>
                     <a:srgbClr val="232F3E"/>
                   </a:solidFill>
@@ -13969,14 +14362,14 @@
         </p:sp>
         <p:sp>
           <p:nvSpPr>
-            <p:cNvPr id="49" name="TextBox 48"/>
-            <p:cNvSpPr txBox="1"/>
-            <p:nvPr/>
-          </p:nvSpPr>
-          <p:spPr>
-            <a:xfrm>
-              <a:off x="9530292" y="2677583"/>
-              <a:ext cx="1174750" cy="165100"/>
+            <p:cNvPr id="60" name="TextBox 59"/>
+            <p:cNvSpPr txBox="1"/>
+            <p:nvPr/>
+          </p:nvSpPr>
+          <p:spPr>
+            <a:xfrm>
+              <a:off x="9205084" y="2757860"/>
+              <a:ext cx="1179858" cy="165818"/>
             </a:xfrm>
             <a:prstGeom prst="rect">
               <a:avLst/>
@@ -13995,7 +14388,7 @@
                 </a:lnSpc>
               </a:pPr>
               <a:r>
-                <a:rPr sz="1000" b="0" lang="ko-KR">
+                <a:rPr sz="1004" b="0" lang="ko-KR">
                   <a:solidFill>
                     <a:srgbClr val="545B64"/>
                   </a:solidFill>
@@ -14010,7 +14403,7 @@
         </p:sp>
         <p:pic>
           <p:nvPicPr>
-            <p:cNvPr id="50" name="Amazon-Virtual-Private-Cloud" descr="Amazon Virtual Private Cloud"/>
+            <p:cNvPr id="61" name="Amazon-Virtual-Private-Cloud" descr="Amazon Virtual Private Cloud"/>
             <p:cNvPicPr>
               <a:picLocks noChangeAspect="1"/>
             </p:cNvPicPr>
@@ -14030,8 +14423,8 @@
           </p:blipFill>
           <p:spPr>
             <a:xfrm>
-              <a:off x="9863667" y="4766733"/>
-              <a:ext cx="508000" cy="508000"/>
+              <a:off x="10815430" y="2007428"/>
+              <a:ext cx="510209" cy="510209"/>
             </a:xfrm>
             <a:prstGeom prst="rect">
               <a:avLst/>
@@ -14040,14 +14433,14 @@
         </p:pic>
         <p:sp>
           <p:nvSpPr>
-            <p:cNvPr id="51" name="TextBox 50"/>
-            <p:cNvSpPr txBox="1"/>
-            <p:nvPr/>
-          </p:nvSpPr>
-          <p:spPr>
-            <a:xfrm>
-              <a:off x="9381464" y="5324475"/>
-              <a:ext cx="1472406" cy="192617"/>
+            <p:cNvPr id="62" name="TextBox 61"/>
+            <p:cNvSpPr txBox="1"/>
+            <p:nvPr/>
+          </p:nvSpPr>
+          <p:spPr>
+            <a:xfrm>
+              <a:off x="10331131" y="2567595"/>
+              <a:ext cx="1478808" cy="193454"/>
             </a:xfrm>
             <a:prstGeom prst="rect">
               <a:avLst/>
@@ -14066,7 +14459,7 @@
                 </a:lnSpc>
               </a:pPr>
               <a:r>
-                <a:rPr sz="1166" b="0" lang="ko-KR">
+                <a:rPr sz="1171" b="0" lang="ko-KR">
                   <a:solidFill>
                     <a:srgbClr val="232F3E"/>
                   </a:solidFill>
@@ -14081,14 +14474,14 @@
         </p:sp>
         <p:sp>
           <p:nvSpPr>
-            <p:cNvPr id="52" name="TextBox 51"/>
-            <p:cNvSpPr txBox="1"/>
-            <p:nvPr/>
-          </p:nvSpPr>
-          <p:spPr>
-            <a:xfrm>
-              <a:off x="9530292" y="5513917"/>
-              <a:ext cx="1174750" cy="165100"/>
+            <p:cNvPr id="63" name="TextBox 62"/>
+            <p:cNvSpPr txBox="1"/>
+            <p:nvPr/>
+          </p:nvSpPr>
+          <p:spPr>
+            <a:xfrm>
+              <a:off x="10480606" y="2757860"/>
+              <a:ext cx="1179858" cy="165818"/>
             </a:xfrm>
             <a:prstGeom prst="rect">
               <a:avLst/>
@@ -14107,7 +14500,7 @@
                 </a:lnSpc>
               </a:pPr>
               <a:r>
-                <a:rPr sz="1000" b="0" lang="ko-KR">
+                <a:rPr sz="1004" b="0" lang="ko-KR">
                   <a:solidFill>
                     <a:srgbClr val="545B64"/>
                   </a:solidFill>
@@ -14120,101 +14513,9 @@
             </a:p>
           </p:txBody>
         </p:sp>
-        <p:cxnSp>
-          <p:nvCxnSpPr>
-            <p:cNvPr id="53" name="Connector 52"/>
-            <p:cNvCxnSpPr/>
-            <p:nvPr/>
-          </p:nvCxnSpPr>
-          <p:spPr>
-            <a:xfrm flipV="1">
-              <a:off x="10117667" y="2882900"/>
-              <a:ext cx="0" cy="423333"/>
-            </a:xfrm>
-            <a:prstGeom prst="line">
-              <a:avLst/>
-            </a:prstGeom>
-            <a:ln w="15875">
-              <a:solidFill>
-                <a:srgbClr val="232F3E"/>
-              </a:solidFill>
-              <a:prstDash val="solid"/>
-              <a:miter lim="800000"/>
-            </a:ln>
-          </p:spPr>
-        </p:cxnSp>
-        <p:cxnSp>
-          <p:nvCxnSpPr>
-            <p:cNvPr id="54" name="Connector 53"/>
-            <p:cNvCxnSpPr/>
-            <p:nvPr/>
-          </p:nvCxnSpPr>
-          <p:spPr>
-            <a:xfrm>
-              <a:off x="10117667" y="4131733"/>
-              <a:ext cx="0" cy="592667"/>
-            </a:xfrm>
-            <a:prstGeom prst="line">
-              <a:avLst/>
-            </a:prstGeom>
-            <a:ln w="15875">
-              <a:solidFill>
-                <a:srgbClr val="232F3E"/>
-              </a:solidFill>
-              <a:prstDash val="solid"/>
-              <a:miter lim="800000"/>
-            </a:ln>
-          </p:spPr>
-        </p:cxnSp>
-        <p:cxnSp>
-          <p:nvCxnSpPr>
-            <p:cNvPr id="55" name="Connector 54"/>
-            <p:cNvCxnSpPr/>
-            <p:nvPr/>
-          </p:nvCxnSpPr>
-          <p:spPr>
-            <a:xfrm>
-              <a:off x="6858000" y="3602567"/>
-              <a:ext cx="1227667" cy="0"/>
-            </a:xfrm>
-            <a:prstGeom prst="line">
-              <a:avLst/>
-            </a:prstGeom>
-            <a:ln w="15875">
-              <a:solidFill>
-                <a:srgbClr val="232F3E"/>
-              </a:solidFill>
-              <a:prstDash val="solid"/>
-              <a:miter lim="800000"/>
-            </a:ln>
-          </p:spPr>
-        </p:cxnSp>
-        <p:cxnSp>
-          <p:nvCxnSpPr>
-            <p:cNvPr id="56" name="Connector 55"/>
-            <p:cNvCxnSpPr/>
-            <p:nvPr/>
-          </p:nvCxnSpPr>
-          <p:spPr>
-            <a:xfrm>
-              <a:off x="8678333" y="3602567"/>
-              <a:ext cx="1143000" cy="0"/>
-            </a:xfrm>
-            <a:prstGeom prst="line">
-              <a:avLst/>
-            </a:prstGeom>
-            <a:ln w="15875">
-              <a:solidFill>
-                <a:srgbClr val="232F3E"/>
-              </a:solidFill>
-              <a:prstDash val="solid"/>
-              <a:miter lim="800000"/>
-            </a:ln>
-          </p:spPr>
-        </p:cxnSp>
         <p:pic>
           <p:nvPicPr>
-            <p:cNvPr id="57" name="Amazon-VPC_Peering-Connection" descr="Amazon VPC_Peering Connection"/>
+            <p:cNvPr id="64" name="Amazon-Route-53_Route-Table" descr="Amazon Route 53_Route Table"/>
             <p:cNvPicPr>
               <a:picLocks noChangeAspect="1"/>
             </p:cNvPicPr>
@@ -14234,8 +14535,8 @@
           </p:blipFill>
           <p:spPr>
             <a:xfrm>
-              <a:off x="8128000" y="3348567"/>
-              <a:ext cx="508000" cy="508000"/>
+              <a:off x="10177670" y="4856093"/>
+              <a:ext cx="510209" cy="510209"/>
             </a:xfrm>
             <a:prstGeom prst="rect">
               <a:avLst/>
@@ -14244,14 +14545,14 @@
         </p:pic>
         <p:sp>
           <p:nvSpPr>
-            <p:cNvPr id="58" name="TextBox 57"/>
-            <p:cNvSpPr txBox="1"/>
-            <p:nvPr/>
-          </p:nvSpPr>
-          <p:spPr>
-            <a:xfrm>
-              <a:off x="7747661" y="3906308"/>
-              <a:ext cx="1268677" cy="192617"/>
+            <p:cNvPr id="65" name="TextBox 64"/>
+            <p:cNvSpPr txBox="1"/>
+            <p:nvPr/>
+          </p:nvSpPr>
+          <p:spPr>
+            <a:xfrm>
+              <a:off x="9949139" y="5416260"/>
+              <a:ext cx="967271" cy="193454"/>
             </a:xfrm>
             <a:prstGeom prst="rect">
               <a:avLst/>
@@ -14270,7 +14571,7 @@
                 </a:lnSpc>
               </a:pPr>
               <a:r>
-                <a:rPr sz="1166" b="0" lang="ko-KR">
+                <a:rPr sz="1171" b="0" lang="ko-KR">
                   <a:solidFill>
                     <a:srgbClr val="232F3E"/>
                   </a:solidFill>
@@ -14278,21 +14579,21 @@
                   <a:ea typeface="Malgun Gothic"/>
                   <a:cs typeface="Malgun Gothic"/>
                 </a:rPr>
-                <a:t>TGW peering</a:t>
-              </a:r>
-            </a:p>
-          </p:txBody>
-        </p:sp>
-        <p:sp>
-          <p:nvSpPr>
-            <p:cNvPr id="59" name="TextBox 58"/>
-            <p:cNvSpPr txBox="1"/>
-            <p:nvPr/>
-          </p:nvSpPr>
-          <p:spPr>
-            <a:xfrm>
-              <a:off x="7985125" y="4095750"/>
-              <a:ext cx="793750" cy="165100"/>
+                <a:t>TGW B RT</a:t>
+              </a:r>
+            </a:p>
+          </p:txBody>
+        </p:sp>
+        <p:sp>
+          <p:nvSpPr>
+            <p:cNvPr id="66" name="TextBox 65"/>
+            <p:cNvSpPr txBox="1"/>
+            <p:nvPr/>
+          </p:nvSpPr>
+          <p:spPr>
+            <a:xfrm>
+              <a:off x="9830887" y="5606525"/>
+              <a:ext cx="1203774" cy="165818"/>
             </a:xfrm>
             <a:prstGeom prst="rect">
               <a:avLst/>
@@ -14311,7 +14612,7 @@
                 </a:lnSpc>
               </a:pPr>
               <a:r>
-                <a:rPr sz="1000" b="0" lang="ko-KR">
+                <a:rPr sz="1004" b="0" lang="ko-KR">
                   <a:solidFill>
                     <a:srgbClr val="545B64"/>
                   </a:solidFill>
@@ -14319,21 +14620,555 @@
                   <a:ea typeface="Malgun Gothic"/>
                   <a:cs typeface="Malgun Gothic"/>
                 </a:rPr>
-                <a:t>AWS 백본</a:t>
-              </a:r>
-            </a:p>
-          </p:txBody>
-        </p:sp>
-        <p:sp>
-          <p:nvSpPr>
-            <p:cNvPr id="60" name="TextBox 59"/>
-            <p:cNvSpPr txBox="1"/>
-            <p:nvPr/>
-          </p:nvSpPr>
-          <p:spPr>
-            <a:xfrm>
-              <a:off x="4953000" y="6127750"/>
-              <a:ext cx="8112125" cy="165100"/>
+                <a:t>VPC 경로 전파</a:t>
+              </a:r>
+            </a:p>
+          </p:txBody>
+        </p:sp>
+        <p:sp>
+          <p:nvSpPr>
+            <p:cNvPr id="67" name="TextBox 66"/>
+            <p:cNvSpPr txBox="1"/>
+            <p:nvPr/>
+          </p:nvSpPr>
+          <p:spPr>
+            <a:xfrm>
+              <a:off x="9141308" y="5776595"/>
+              <a:ext cx="2582932" cy="165818"/>
+            </a:xfrm>
+            <a:prstGeom prst="rect">
+              <a:avLst/>
+            </a:prstGeom>
+            <a:noFill/>
+          </p:spPr>
+          <p:txBody>
+            <a:bodyPr wrap="none" lIns="0" rIns="0" tIns="0" bIns="0" anchor="t">
+              <a:noAutofit/>
+            </a:bodyPr>
+            <a:lstStyle/>
+            <a:p>
+              <a:pPr algn="ctr">
+                <a:lnSpc>
+                  <a:spcPct val="100000"/>
+                </a:lnSpc>
+              </a:pPr>
+              <a:r>
+                <a:rPr sz="1004" b="0" lang="ko-KR">
+                  <a:solidFill>
+                    <a:srgbClr val="545B64"/>
+                  </a:solidFill>
+                  <a:latin typeface="Arial"/>
+                  <a:ea typeface="Malgun Gothic"/>
+                  <a:cs typeface="Malgun Gothic"/>
+                </a:rPr>
+                <a:t>10.0.0.0/13 · 192.168.0.0/16</a:t>
+              </a:r>
+            </a:p>
+          </p:txBody>
+        </p:sp>
+        <p:sp>
+          <p:nvSpPr>
+            <p:cNvPr id="68" name="TextBox 67"/>
+            <p:cNvSpPr txBox="1"/>
+            <p:nvPr/>
+          </p:nvSpPr>
+          <p:spPr>
+            <a:xfrm>
+              <a:off x="9938509" y="5946665"/>
+              <a:ext cx="988529" cy="165818"/>
+            </a:xfrm>
+            <a:prstGeom prst="rect">
+              <a:avLst/>
+            </a:prstGeom>
+            <a:noFill/>
+          </p:spPr>
+          <p:txBody>
+            <a:bodyPr wrap="none" lIns="0" rIns="0" tIns="0" bIns="0" anchor="t">
+              <a:noAutofit/>
+            </a:bodyPr>
+            <a:lstStyle/>
+            <a:p>
+              <a:pPr algn="ctr">
+                <a:lnSpc>
+                  <a:spcPct val="100000"/>
+                </a:lnSpc>
+              </a:pPr>
+              <a:r>
+                <a:rPr sz="1004" b="0" lang="ko-KR">
+                  <a:solidFill>
+                    <a:srgbClr val="545B64"/>
+                  </a:solidFill>
+                  <a:latin typeface="Arial"/>
+                  <a:ea typeface="Malgun Gothic"/>
+                  <a:cs typeface="Malgun Gothic"/>
+                </a:rPr>
+                <a:t>→ peering</a:t>
+              </a:r>
+            </a:p>
+          </p:txBody>
+        </p:sp>
+        <p:sp>
+          <p:nvSpPr>
+            <p:cNvPr id="69" name="Freeform 68"/>
+            <p:cNvSpPr/>
+            <p:nvPr/>
+          </p:nvSpPr>
+          <p:spPr>
+            <a:xfrm>
+              <a:off x="9795013" y="2964070"/>
+              <a:ext cx="531467" cy="425173"/>
+            </a:xfrm>
+            <a:custGeom>
+              <a:avLst/>
+              <a:gdLst/>
+              <a:ahLst/>
+              <a:cxnLst/>
+              <a:rect l="l" t="t" r="r" b="b"/>
+              <a:pathLst>
+                <a:path w="531467" h="425173">
+                  <a:moveTo>
+                    <a:pt x="531467" y="425173"/>
+                  </a:moveTo>
+                  <a:lnTo>
+                    <a:pt x="531467" y="297621"/>
+                  </a:lnTo>
+                  <a:lnTo>
+                    <a:pt x="0" y="297621"/>
+                  </a:lnTo>
+                  <a:lnTo>
+                    <a:pt x="0" y="0"/>
+                  </a:lnTo>
+                </a:path>
+              </a:pathLst>
+            </a:custGeom>
+            <a:noFill/>
+            <a:ln w="15944">
+              <a:solidFill>
+                <a:srgbClr val="232F3E"/>
+              </a:solidFill>
+              <a:prstDash val="solid"/>
+              <a:miter lim="800000"/>
+            </a:ln>
+          </p:spPr>
+          <p:txBody>
+            <a:bodyPr rtlCol="0" anchor="ctr"/>
+            <a:lstStyle/>
+            <a:p>
+              <a:pPr algn="ctr"/>
+            </a:p>
+          </p:txBody>
+        </p:sp>
+        <p:sp>
+          <p:nvSpPr>
+            <p:cNvPr id="70" name="Freeform 69"/>
+            <p:cNvSpPr/>
+            <p:nvPr/>
+          </p:nvSpPr>
+          <p:spPr>
+            <a:xfrm>
+              <a:off x="10539067" y="2964070"/>
+              <a:ext cx="531468" cy="425173"/>
+            </a:xfrm>
+            <a:custGeom>
+              <a:avLst/>
+              <a:gdLst/>
+              <a:ahLst/>
+              <a:cxnLst/>
+              <a:rect l="l" t="t" r="r" b="b"/>
+              <a:pathLst>
+                <a:path w="531468" h="425173">
+                  <a:moveTo>
+                    <a:pt x="0" y="425173"/>
+                  </a:moveTo>
+                  <a:lnTo>
+                    <a:pt x="0" y="297621"/>
+                  </a:lnTo>
+                  <a:lnTo>
+                    <a:pt x="531468" y="297621"/>
+                  </a:lnTo>
+                  <a:lnTo>
+                    <a:pt x="531468" y="0"/>
+                  </a:lnTo>
+                </a:path>
+              </a:pathLst>
+            </a:custGeom>
+            <a:noFill/>
+            <a:ln w="15944">
+              <a:solidFill>
+                <a:srgbClr val="232F3E"/>
+              </a:solidFill>
+              <a:prstDash val="solid"/>
+              <a:miter lim="800000"/>
+            </a:ln>
+          </p:spPr>
+          <p:txBody>
+            <a:bodyPr rtlCol="0" anchor="ctr"/>
+            <a:lstStyle/>
+            <a:p>
+              <a:pPr algn="ctr"/>
+            </a:p>
+          </p:txBody>
+        </p:sp>
+        <p:sp>
+          <p:nvSpPr>
+            <p:cNvPr id="71" name="Oval 70"/>
+            <p:cNvSpPr/>
+            <p:nvPr/>
+          </p:nvSpPr>
+          <p:spPr>
+            <a:xfrm>
+              <a:off x="3130412" y="3431761"/>
+              <a:ext cx="212587" cy="212587"/>
+            </a:xfrm>
+            <a:prstGeom prst="ellipse">
+              <a:avLst/>
+            </a:prstGeom>
+            <a:solidFill>
+              <a:srgbClr val="232F3E"/>
+            </a:solidFill>
+            <a:ln>
+              <a:noFill/>
+            </a:ln>
+          </p:spPr>
+          <p:txBody>
+            <a:bodyPr rtlCol="0" anchor="ctr"/>
+            <a:lstStyle/>
+            <a:p>
+              <a:pPr algn="ctr"/>
+            </a:p>
+          </p:txBody>
+        </p:sp>
+        <p:sp>
+          <p:nvSpPr>
+            <p:cNvPr id="72" name="TextBox 71"/>
+            <p:cNvSpPr txBox="1"/>
+            <p:nvPr/>
+          </p:nvSpPr>
+          <p:spPr>
+            <a:xfrm>
+              <a:off x="3129083" y="3459397"/>
+              <a:ext cx="215244" cy="165818"/>
+            </a:xfrm>
+            <a:prstGeom prst="rect">
+              <a:avLst/>
+            </a:prstGeom>
+            <a:noFill/>
+          </p:spPr>
+          <p:txBody>
+            <a:bodyPr wrap="none" lIns="0" rIns="0" tIns="0" bIns="0" anchor="t">
+              <a:noAutofit/>
+            </a:bodyPr>
+            <a:lstStyle/>
+            <a:p>
+              <a:pPr algn="ctr">
+                <a:lnSpc>
+                  <a:spcPct val="100000"/>
+                </a:lnSpc>
+              </a:pPr>
+              <a:r>
+                <a:rPr sz="1004" b="1" lang="ko-KR">
+                  <a:solidFill>
+                    <a:srgbClr val="FFFFFF"/>
+                  </a:solidFill>
+                  <a:latin typeface="Arial"/>
+                  <a:ea typeface="Malgun Gothic"/>
+                  <a:cs typeface="Malgun Gothic"/>
+                </a:rPr>
+                <a:t>1</a:t>
+              </a:r>
+            </a:p>
+          </p:txBody>
+        </p:sp>
+        <p:sp>
+          <p:nvSpPr>
+            <p:cNvPr id="73" name="Oval 72"/>
+            <p:cNvSpPr/>
+            <p:nvPr/>
+          </p:nvSpPr>
+          <p:spPr>
+            <a:xfrm>
+              <a:off x="5203135" y="3431761"/>
+              <a:ext cx="212587" cy="212587"/>
+            </a:xfrm>
+            <a:prstGeom prst="ellipse">
+              <a:avLst/>
+            </a:prstGeom>
+            <a:solidFill>
+              <a:srgbClr val="232F3E"/>
+            </a:solidFill>
+            <a:ln>
+              <a:noFill/>
+            </a:ln>
+          </p:spPr>
+          <p:txBody>
+            <a:bodyPr rtlCol="0" anchor="ctr"/>
+            <a:lstStyle/>
+            <a:p>
+              <a:pPr algn="ctr"/>
+            </a:p>
+          </p:txBody>
+        </p:sp>
+        <p:sp>
+          <p:nvSpPr>
+            <p:cNvPr id="74" name="TextBox 73"/>
+            <p:cNvSpPr txBox="1"/>
+            <p:nvPr/>
+          </p:nvSpPr>
+          <p:spPr>
+            <a:xfrm>
+              <a:off x="5201806" y="3459397"/>
+              <a:ext cx="215244" cy="165818"/>
+            </a:xfrm>
+            <a:prstGeom prst="rect">
+              <a:avLst/>
+            </a:prstGeom>
+            <a:noFill/>
+          </p:spPr>
+          <p:txBody>
+            <a:bodyPr wrap="none" lIns="0" rIns="0" tIns="0" bIns="0" anchor="t">
+              <a:noAutofit/>
+            </a:bodyPr>
+            <a:lstStyle/>
+            <a:p>
+              <a:pPr algn="ctr">
+                <a:lnSpc>
+                  <a:spcPct val="100000"/>
+                </a:lnSpc>
+              </a:pPr>
+              <a:r>
+                <a:rPr sz="1004" b="1" lang="ko-KR">
+                  <a:solidFill>
+                    <a:srgbClr val="FFFFFF"/>
+                  </a:solidFill>
+                  <a:latin typeface="Arial"/>
+                  <a:ea typeface="Malgun Gothic"/>
+                  <a:cs typeface="Malgun Gothic"/>
+                </a:rPr>
+                <a:t>2</a:t>
+              </a:r>
+            </a:p>
+          </p:txBody>
+        </p:sp>
+        <p:sp>
+          <p:nvSpPr>
+            <p:cNvPr id="75" name="Oval 74"/>
+            <p:cNvSpPr/>
+            <p:nvPr/>
+          </p:nvSpPr>
+          <p:spPr>
+            <a:xfrm>
+              <a:off x="7966765" y="3431761"/>
+              <a:ext cx="212587" cy="212587"/>
+            </a:xfrm>
+            <a:prstGeom prst="ellipse">
+              <a:avLst/>
+            </a:prstGeom>
+            <a:solidFill>
+              <a:srgbClr val="232F3E"/>
+            </a:solidFill>
+            <a:ln>
+              <a:noFill/>
+            </a:ln>
+          </p:spPr>
+          <p:txBody>
+            <a:bodyPr rtlCol="0" anchor="ctr"/>
+            <a:lstStyle/>
+            <a:p>
+              <a:pPr algn="ctr"/>
+            </a:p>
+          </p:txBody>
+        </p:sp>
+        <p:sp>
+          <p:nvSpPr>
+            <p:cNvPr id="76" name="TextBox 75"/>
+            <p:cNvSpPr txBox="1"/>
+            <p:nvPr/>
+          </p:nvSpPr>
+          <p:spPr>
+            <a:xfrm>
+              <a:off x="7965437" y="3459397"/>
+              <a:ext cx="215244" cy="165818"/>
+            </a:xfrm>
+            <a:prstGeom prst="rect">
+              <a:avLst/>
+            </a:prstGeom>
+            <a:noFill/>
+          </p:spPr>
+          <p:txBody>
+            <a:bodyPr wrap="none" lIns="0" rIns="0" tIns="0" bIns="0" anchor="t">
+              <a:noAutofit/>
+            </a:bodyPr>
+            <a:lstStyle/>
+            <a:p>
+              <a:pPr algn="ctr">
+                <a:lnSpc>
+                  <a:spcPct val="100000"/>
+                </a:lnSpc>
+              </a:pPr>
+              <a:r>
+                <a:rPr sz="1004" b="1" lang="ko-KR">
+                  <a:solidFill>
+                    <a:srgbClr val="FFFFFF"/>
+                  </a:solidFill>
+                  <a:latin typeface="Arial"/>
+                  <a:ea typeface="Malgun Gothic"/>
+                  <a:cs typeface="Malgun Gothic"/>
+                </a:rPr>
+                <a:t>3</a:t>
+              </a:r>
+            </a:p>
+          </p:txBody>
+        </p:sp>
+        <p:sp>
+          <p:nvSpPr>
+            <p:cNvPr id="77" name="Oval 76"/>
+            <p:cNvSpPr/>
+            <p:nvPr/>
+          </p:nvSpPr>
+          <p:spPr>
+            <a:xfrm>
+              <a:off x="9954453" y="3006587"/>
+              <a:ext cx="212587" cy="212587"/>
+            </a:xfrm>
+            <a:prstGeom prst="ellipse">
+              <a:avLst/>
+            </a:prstGeom>
+            <a:solidFill>
+              <a:srgbClr val="232F3E"/>
+            </a:solidFill>
+            <a:ln>
+              <a:noFill/>
+            </a:ln>
+          </p:spPr>
+          <p:txBody>
+            <a:bodyPr rtlCol="0" anchor="ctr"/>
+            <a:lstStyle/>
+            <a:p>
+              <a:pPr algn="ctr"/>
+            </a:p>
+          </p:txBody>
+        </p:sp>
+        <p:sp>
+          <p:nvSpPr>
+            <p:cNvPr id="78" name="TextBox 77"/>
+            <p:cNvSpPr txBox="1"/>
+            <p:nvPr/>
+          </p:nvSpPr>
+          <p:spPr>
+            <a:xfrm>
+              <a:off x="9953125" y="3034223"/>
+              <a:ext cx="215244" cy="165818"/>
+            </a:xfrm>
+            <a:prstGeom prst="rect">
+              <a:avLst/>
+            </a:prstGeom>
+            <a:noFill/>
+          </p:spPr>
+          <p:txBody>
+            <a:bodyPr wrap="none" lIns="0" rIns="0" tIns="0" bIns="0" anchor="t">
+              <a:noAutofit/>
+            </a:bodyPr>
+            <a:lstStyle/>
+            <a:p>
+              <a:pPr algn="ctr">
+                <a:lnSpc>
+                  <a:spcPct val="100000"/>
+                </a:lnSpc>
+              </a:pPr>
+              <a:r>
+                <a:rPr sz="1004" b="1" lang="ko-KR">
+                  <a:solidFill>
+                    <a:srgbClr val="FFFFFF"/>
+                  </a:solidFill>
+                  <a:latin typeface="Arial"/>
+                  <a:ea typeface="Malgun Gothic"/>
+                  <a:cs typeface="Malgun Gothic"/>
+                </a:rPr>
+                <a:t>4</a:t>
+              </a:r>
+            </a:p>
+          </p:txBody>
+        </p:sp>
+        <p:sp>
+          <p:nvSpPr>
+            <p:cNvPr id="79" name="Oval 78"/>
+            <p:cNvSpPr/>
+            <p:nvPr/>
+          </p:nvSpPr>
+          <p:spPr>
+            <a:xfrm>
+              <a:off x="4544115" y="6365461"/>
+              <a:ext cx="212587" cy="212587"/>
+            </a:xfrm>
+            <a:prstGeom prst="ellipse">
+              <a:avLst/>
+            </a:prstGeom>
+            <a:solidFill>
+              <a:srgbClr val="232F3E"/>
+            </a:solidFill>
+            <a:ln>
+              <a:noFill/>
+            </a:ln>
+          </p:spPr>
+          <p:txBody>
+            <a:bodyPr rtlCol="0" anchor="ctr"/>
+            <a:lstStyle/>
+            <a:p>
+              <a:pPr algn="ctr"/>
+            </a:p>
+          </p:txBody>
+        </p:sp>
+        <p:sp>
+          <p:nvSpPr>
+            <p:cNvPr id="80" name="TextBox 79"/>
+            <p:cNvSpPr txBox="1"/>
+            <p:nvPr/>
+          </p:nvSpPr>
+          <p:spPr>
+            <a:xfrm>
+              <a:off x="4542787" y="6393097"/>
+              <a:ext cx="215244" cy="165818"/>
+            </a:xfrm>
+            <a:prstGeom prst="rect">
+              <a:avLst/>
+            </a:prstGeom>
+            <a:noFill/>
+          </p:spPr>
+          <p:txBody>
+            <a:bodyPr wrap="none" lIns="0" rIns="0" tIns="0" bIns="0" anchor="t">
+              <a:noAutofit/>
+            </a:bodyPr>
+            <a:lstStyle/>
+            <a:p>
+              <a:pPr algn="ctr">
+                <a:lnSpc>
+                  <a:spcPct val="100000"/>
+                </a:lnSpc>
+              </a:pPr>
+              <a:r>
+                <a:rPr sz="1004" b="1" lang="ko-KR">
+                  <a:solidFill>
+                    <a:srgbClr val="FFFFFF"/>
+                  </a:solidFill>
+                  <a:latin typeface="Arial"/>
+                  <a:ea typeface="Malgun Gothic"/>
+                  <a:cs typeface="Malgun Gothic"/>
+                </a:rPr>
+                <a:t>1</a:t>
+              </a:r>
+            </a:p>
+          </p:txBody>
+        </p:sp>
+        <p:sp>
+          <p:nvSpPr>
+            <p:cNvPr id="81" name="TextBox 80"/>
+            <p:cNvSpPr txBox="1"/>
+            <p:nvPr/>
+          </p:nvSpPr>
+          <p:spPr>
+            <a:xfrm>
+              <a:off x="4841737" y="6393097"/>
+              <a:ext cx="2128527" cy="165818"/>
             </a:xfrm>
             <a:prstGeom prst="rect">
               <a:avLst/>
@@ -14352,7 +15187,7 @@
                 </a:lnSpc>
               </a:pPr>
               <a:r>
-                <a:rPr sz="1000" b="0" lang="ko-KR">
+                <a:rPr sz="1004" b="0" lang="ko-KR">
                   <a:solidFill>
                     <a:srgbClr val="545B64"/>
                   </a:solidFill>
@@ -14360,21 +15195,91 @@
                   <a:ea typeface="Malgun Gothic"/>
                   <a:cs typeface="Malgun Gothic"/>
                 </a:rPr>
-                <a:t>Hub &amp; spoke: VPC·VPN은 리전 TGW에 attachment로 연결 · VPC CIDR과 VPN(BGP) 경로는 TGW RT에 전파</a:t>
-              </a:r>
-            </a:p>
-          </p:txBody>
-        </p:sp>
-        <p:sp>
-          <p:nvSpPr>
-            <p:cNvPr id="61" name="TextBox 60"/>
-            <p:cNvSpPr txBox="1"/>
-            <p:nvPr/>
-          </p:nvSpPr>
-          <p:spPr>
-            <a:xfrm>
-              <a:off x="4953000" y="6297083"/>
-              <a:ext cx="4643438" cy="165100"/>
+                <a:t>CGW → VPN (IPsec, BGP)</a:t>
+              </a:r>
+            </a:p>
+          </p:txBody>
+        </p:sp>
+        <p:sp>
+          <p:nvSpPr>
+            <p:cNvPr id="82" name="Oval 81"/>
+            <p:cNvSpPr/>
+            <p:nvPr/>
+          </p:nvSpPr>
+          <p:spPr>
+            <a:xfrm>
+              <a:off x="6655104" y="6365461"/>
+              <a:ext cx="212587" cy="212587"/>
+            </a:xfrm>
+            <a:prstGeom prst="ellipse">
+              <a:avLst/>
+            </a:prstGeom>
+            <a:solidFill>
+              <a:srgbClr val="232F3E"/>
+            </a:solidFill>
+            <a:ln>
+              <a:noFill/>
+            </a:ln>
+          </p:spPr>
+          <p:txBody>
+            <a:bodyPr rtlCol="0" anchor="ctr"/>
+            <a:lstStyle/>
+            <a:p>
+              <a:pPr algn="ctr"/>
+            </a:p>
+          </p:txBody>
+        </p:sp>
+        <p:sp>
+          <p:nvSpPr>
+            <p:cNvPr id="83" name="TextBox 82"/>
+            <p:cNvSpPr txBox="1"/>
+            <p:nvPr/>
+          </p:nvSpPr>
+          <p:spPr>
+            <a:xfrm>
+              <a:off x="6653775" y="6393097"/>
+              <a:ext cx="215244" cy="165818"/>
+            </a:xfrm>
+            <a:prstGeom prst="rect">
+              <a:avLst/>
+            </a:prstGeom>
+            <a:noFill/>
+          </p:spPr>
+          <p:txBody>
+            <a:bodyPr wrap="none" lIns="0" rIns="0" tIns="0" bIns="0" anchor="t">
+              <a:noAutofit/>
+            </a:bodyPr>
+            <a:lstStyle/>
+            <a:p>
+              <a:pPr algn="ctr">
+                <a:lnSpc>
+                  <a:spcPct val="100000"/>
+                </a:lnSpc>
+              </a:pPr>
+              <a:r>
+                <a:rPr sz="1004" b="1" lang="ko-KR">
+                  <a:solidFill>
+                    <a:srgbClr val="FFFFFF"/>
+                  </a:solidFill>
+                  <a:latin typeface="Arial"/>
+                  <a:ea typeface="Malgun Gothic"/>
+                  <a:cs typeface="Malgun Gothic"/>
+                </a:rPr>
+                <a:t>2</a:t>
+              </a:r>
+            </a:p>
+          </p:txBody>
+        </p:sp>
+        <p:sp>
+          <p:nvSpPr>
+            <p:cNvPr id="84" name="TextBox 83"/>
+            <p:cNvSpPr txBox="1"/>
+            <p:nvPr/>
+          </p:nvSpPr>
+          <p:spPr>
+            <a:xfrm>
+              <a:off x="6952725" y="6393097"/>
+              <a:ext cx="1163914" cy="165818"/>
             </a:xfrm>
             <a:prstGeom prst="rect">
               <a:avLst/>
@@ -14393,7 +15298,7 @@
                 </a:lnSpc>
               </a:pPr>
               <a:r>
-                <a:rPr sz="1000" b="0" lang="ko-KR">
+                <a:rPr sz="1004" b="0" lang="ko-KR">
                   <a:solidFill>
                     <a:srgbClr val="545B64"/>
                   </a:solidFill>
@@ -14401,21 +15306,91 @@
                   <a:ea typeface="Malgun Gothic"/>
                   <a:cs typeface="Malgun Gothic"/>
                 </a:rPr>
-                <a:t>라우팅: VPC 서브넷 10.0.0.0/8 · 192.168.0.0/16 → TGW</a:t>
-              </a:r>
-            </a:p>
-          </p:txBody>
-        </p:sp>
-        <p:sp>
-          <p:nvSpPr>
-            <p:cNvPr id="62" name="TextBox 61"/>
-            <p:cNvSpPr txBox="1"/>
-            <p:nvPr/>
-          </p:nvSpPr>
-          <p:spPr>
-            <a:xfrm>
-              <a:off x="4953000" y="6466417"/>
-              <a:ext cx="7802563" cy="165100"/>
+                <a:t>VPN → TGW A</a:t>
+              </a:r>
+            </a:p>
+          </p:txBody>
+        </p:sp>
+        <p:sp>
+          <p:nvSpPr>
+            <p:cNvPr id="85" name="Oval 84"/>
+            <p:cNvSpPr/>
+            <p:nvPr/>
+          </p:nvSpPr>
+          <p:spPr>
+            <a:xfrm>
+              <a:off x="7994402" y="6365461"/>
+              <a:ext cx="212587" cy="212587"/>
+            </a:xfrm>
+            <a:prstGeom prst="ellipse">
+              <a:avLst/>
+            </a:prstGeom>
+            <a:solidFill>
+              <a:srgbClr val="232F3E"/>
+            </a:solidFill>
+            <a:ln>
+              <a:noFill/>
+            </a:ln>
+          </p:spPr>
+          <p:txBody>
+            <a:bodyPr rtlCol="0" anchor="ctr"/>
+            <a:lstStyle/>
+            <a:p>
+              <a:pPr algn="ctr"/>
+            </a:p>
+          </p:txBody>
+        </p:sp>
+        <p:sp>
+          <p:nvSpPr>
+            <p:cNvPr id="86" name="TextBox 85"/>
+            <p:cNvSpPr txBox="1"/>
+            <p:nvPr/>
+          </p:nvSpPr>
+          <p:spPr>
+            <a:xfrm>
+              <a:off x="7993073" y="6393097"/>
+              <a:ext cx="215244" cy="165818"/>
+            </a:xfrm>
+            <a:prstGeom prst="rect">
+              <a:avLst/>
+            </a:prstGeom>
+            <a:noFill/>
+          </p:spPr>
+          <p:txBody>
+            <a:bodyPr wrap="none" lIns="0" rIns="0" tIns="0" bIns="0" anchor="t">
+              <a:noAutofit/>
+            </a:bodyPr>
+            <a:lstStyle/>
+            <a:p>
+              <a:pPr algn="ctr">
+                <a:lnSpc>
+                  <a:spcPct val="100000"/>
+                </a:lnSpc>
+              </a:pPr>
+              <a:r>
+                <a:rPr sz="1004" b="1" lang="ko-KR">
+                  <a:solidFill>
+                    <a:srgbClr val="FFFFFF"/>
+                  </a:solidFill>
+                  <a:latin typeface="Arial"/>
+                  <a:ea typeface="Malgun Gothic"/>
+                  <a:cs typeface="Malgun Gothic"/>
+                </a:rPr>
+                <a:t>3</a:t>
+              </a:r>
+            </a:p>
+          </p:txBody>
+        </p:sp>
+        <p:sp>
+          <p:nvSpPr>
+            <p:cNvPr id="87" name="TextBox 86"/>
+            <p:cNvSpPr txBox="1"/>
+            <p:nvPr/>
+          </p:nvSpPr>
+          <p:spPr>
+            <a:xfrm>
+              <a:off x="8292023" y="6393097"/>
+              <a:ext cx="2327827" cy="165818"/>
             </a:xfrm>
             <a:prstGeom prst="rect">
               <a:avLst/>
@@ -14434,7 +15409,7 @@
                 </a:lnSpc>
               </a:pPr>
               <a:r>
-                <a:rPr sz="1000" b="0" lang="ko-KR">
+                <a:rPr sz="1004" b="0" lang="ko-KR">
                   <a:solidFill>
                     <a:srgbClr val="545B64"/>
                   </a:solidFill>
@@ -14442,7 +15417,118 @@
                   <a:ea typeface="Malgun Gothic"/>
                   <a:cs typeface="Malgun Gothic"/>
                 </a:rPr>
-                <a:t>TGW RT: A 10.16.0.0/13 → peering · B 10.0.0.0/13 · 192.168.0.0/16 → peering (정적 경로)</a:t>
+                <a:t>TGW A → TGW B (정적 경로)</a:t>
+              </a:r>
+            </a:p>
+          </p:txBody>
+        </p:sp>
+        <p:sp>
+          <p:nvSpPr>
+            <p:cNvPr id="88" name="Oval 87"/>
+            <p:cNvSpPr/>
+            <p:nvPr/>
+          </p:nvSpPr>
+          <p:spPr>
+            <a:xfrm>
+              <a:off x="10264830" y="6365461"/>
+              <a:ext cx="212587" cy="212587"/>
+            </a:xfrm>
+            <a:prstGeom prst="ellipse">
+              <a:avLst/>
+            </a:prstGeom>
+            <a:solidFill>
+              <a:srgbClr val="232F3E"/>
+            </a:solidFill>
+            <a:ln>
+              <a:noFill/>
+            </a:ln>
+          </p:spPr>
+          <p:txBody>
+            <a:bodyPr rtlCol="0" anchor="ctr"/>
+            <a:lstStyle/>
+            <a:p>
+              <a:pPr algn="ctr"/>
+            </a:p>
+          </p:txBody>
+        </p:sp>
+        <p:sp>
+          <p:nvSpPr>
+            <p:cNvPr id="89" name="TextBox 88"/>
+            <p:cNvSpPr txBox="1"/>
+            <p:nvPr/>
+          </p:nvSpPr>
+          <p:spPr>
+            <a:xfrm>
+              <a:off x="10263502" y="6393097"/>
+              <a:ext cx="215244" cy="165818"/>
+            </a:xfrm>
+            <a:prstGeom prst="rect">
+              <a:avLst/>
+            </a:prstGeom>
+            <a:noFill/>
+          </p:spPr>
+          <p:txBody>
+            <a:bodyPr wrap="none" lIns="0" rIns="0" tIns="0" bIns="0" anchor="t">
+              <a:noAutofit/>
+            </a:bodyPr>
+            <a:lstStyle/>
+            <a:p>
+              <a:pPr algn="ctr">
+                <a:lnSpc>
+                  <a:spcPct val="100000"/>
+                </a:lnSpc>
+              </a:pPr>
+              <a:r>
+                <a:rPr sz="1004" b="1" lang="ko-KR">
+                  <a:solidFill>
+                    <a:srgbClr val="FFFFFF"/>
+                  </a:solidFill>
+                  <a:latin typeface="Arial"/>
+                  <a:ea typeface="Malgun Gothic"/>
+                  <a:cs typeface="Malgun Gothic"/>
+                </a:rPr>
+                <a:t>4</a:t>
+              </a:r>
+            </a:p>
+          </p:txBody>
+        </p:sp>
+        <p:sp>
+          <p:nvSpPr>
+            <p:cNvPr id="90" name="TextBox 89"/>
+            <p:cNvSpPr txBox="1"/>
+            <p:nvPr/>
+          </p:nvSpPr>
+          <p:spPr>
+            <a:xfrm>
+              <a:off x="10562452" y="6393097"/>
+              <a:ext cx="1426990" cy="165818"/>
+            </a:xfrm>
+            <a:prstGeom prst="rect">
+              <a:avLst/>
+            </a:prstGeom>
+            <a:noFill/>
+          </p:spPr>
+          <p:txBody>
+            <a:bodyPr wrap="none" lIns="0" rIns="0" tIns="0" bIns="0" anchor="t">
+              <a:noAutofit/>
+            </a:bodyPr>
+            <a:lstStyle/>
+            <a:p>
+              <a:pPr algn="l">
+                <a:lnSpc>
+                  <a:spcPct val="100000"/>
+                </a:lnSpc>
+              </a:pPr>
+              <a:r>
+                <a:rPr sz="1004" b="0" lang="ko-KR">
+                  <a:solidFill>
+                    <a:srgbClr val="545B64"/>
+                  </a:solidFill>
+                  <a:latin typeface="Arial"/>
+                  <a:ea typeface="Malgun Gothic"/>
+                  <a:cs typeface="Malgun Gothic"/>
+                </a:rPr>
+                <a:t>TGW B → DR VPC</a:t>
               </a:r>
             </a:p>
           </p:txBody>
@@ -14731,7 +15817,7 @@
           <p:spPr>
             <a:xfrm>
               <a:off x="698500" y="1930400"/>
-              <a:ext cx="1735667" cy="1693333"/>
+              <a:ext cx="1481667" cy="1693333"/>
             </a:xfrm>
             <a:prstGeom prst="rect">
               <a:avLst/>
@@ -14874,7 +15960,7 @@
           <p:spPr>
             <a:xfrm>
               <a:off x="825500" y="2417233"/>
-              <a:ext cx="1481667" cy="1121833"/>
+              <a:ext cx="1227667" cy="1121833"/>
             </a:xfrm>
             <a:prstGeom prst="rect">
               <a:avLst/>
@@ -14989,7 +16075,7 @@
           </p:blipFill>
           <p:spPr>
             <a:xfrm>
-              <a:off x="1312333" y="2713567"/>
+              <a:off x="1185333" y="2713567"/>
               <a:ext cx="508000" cy="508000"/>
             </a:xfrm>
             <a:prstGeom prst="rect">
@@ -15005,7 +16091,7 @@
           </p:nvSpPr>
           <p:spPr>
             <a:xfrm>
-              <a:off x="1339453" y="3271308"/>
+              <a:off x="1212453" y="3271308"/>
               <a:ext cx="453760" cy="192617"/>
             </a:xfrm>
             <a:prstGeom prst="rect">
@@ -15047,7 +16133,7 @@
           <p:spPr>
             <a:xfrm>
               <a:off x="698500" y="4364567"/>
-              <a:ext cx="1735667" cy="1693333"/>
+              <a:ext cx="1481667" cy="1693333"/>
             </a:xfrm>
             <a:prstGeom prst="rect">
               <a:avLst/>
@@ -15190,7 +16276,7 @@
           <p:spPr>
             <a:xfrm>
               <a:off x="825500" y="4851400"/>
-              <a:ext cx="1481667" cy="1121833"/>
+              <a:ext cx="1227667" cy="1121833"/>
             </a:xfrm>
             <a:prstGeom prst="rect">
               <a:avLst/>
@@ -15305,7 +16391,7 @@
           </p:blipFill>
           <p:spPr>
             <a:xfrm>
-              <a:off x="1312333" y="5147733"/>
+              <a:off x="1185333" y="5147733"/>
               <a:ext cx="508000" cy="508000"/>
             </a:xfrm>
             <a:prstGeom prst="rect">
@@ -15321,7 +16407,7 @@
           </p:nvSpPr>
           <p:spPr>
             <a:xfrm>
-              <a:off x="1339453" y="5705475"/>
+              <a:off x="1212453" y="5705475"/>
               <a:ext cx="453760" cy="192617"/>
             </a:xfrm>
             <a:prstGeom prst="rect">
@@ -15657,8 +16743,8 @@
           </p:nvSpPr>
           <p:spPr>
             <a:xfrm>
-              <a:off x="2476500" y="2967567"/>
-              <a:ext cx="910167" cy="910166"/>
+              <a:off x="2222500" y="2967567"/>
+              <a:ext cx="1164167" cy="910166"/>
             </a:xfrm>
             <a:custGeom>
               <a:avLst/>
@@ -15667,18 +16753,18 @@
               <a:cxnLst/>
               <a:rect l="l" t="t" r="r" b="b"/>
               <a:pathLst>
-                <a:path w="910167" h="910166">
+                <a:path w="1164167" h="910166">
                   <a:moveTo>
                     <a:pt x="0" y="0"/>
                   </a:moveTo>
                   <a:lnTo>
-                    <a:pt x="635000" y="0"/>
+                    <a:pt x="931333" y="0"/>
                   </a:lnTo>
                   <a:lnTo>
-                    <a:pt x="635000" y="910166"/>
+                    <a:pt x="931333" y="910166"/>
                   </a:lnTo>
                   <a:lnTo>
-                    <a:pt x="910167" y="910166"/>
+                    <a:pt x="1164167" y="910166"/>
                   </a:lnTo>
                 </a:path>
               </a:pathLst>
@@ -15710,8 +16796,8 @@
           </p:nvSpPr>
           <p:spPr>
             <a:xfrm>
-              <a:off x="2476500" y="4047067"/>
-              <a:ext cx="910167" cy="1354666"/>
+              <a:off x="2222500" y="4047067"/>
+              <a:ext cx="1164167" cy="1354666"/>
             </a:xfrm>
             <a:custGeom>
               <a:avLst/>
@@ -15720,18 +16806,18 @@
               <a:cxnLst/>
               <a:rect l="l" t="t" r="r" b="b"/>
               <a:pathLst>
-                <a:path w="910167" h="1354666">
+                <a:path w="1164167" h="1354666">
                   <a:moveTo>
                     <a:pt x="0" y="1354666"/>
                   </a:moveTo>
                   <a:lnTo>
-                    <a:pt x="635000" y="1354666"/>
+                    <a:pt x="931333" y="1354666"/>
                   </a:lnTo>
                   <a:lnTo>
-                    <a:pt x="635000" y="0"/>
+                    <a:pt x="931333" y="0"/>
                   </a:lnTo>
                   <a:lnTo>
-                    <a:pt x="910167" y="0"/>
+                    <a:pt x="1164167" y="0"/>
                   </a:lnTo>
                 </a:path>
               </a:pathLst>
@@ -15757,7 +16843,48 @@
         </p:sp>
         <p:sp>
           <p:nvSpPr>
-            <p:cNvPr id="38" name="Rectangle 37"/>
+            <p:cNvPr id="38" name="TextBox 37"/>
+            <p:cNvSpPr txBox="1"/>
+            <p:nvPr/>
+          </p:nvSpPr>
+          <p:spPr>
+            <a:xfrm>
+              <a:off x="2098146" y="2762250"/>
+              <a:ext cx="1349375" cy="165100"/>
+            </a:xfrm>
+            <a:prstGeom prst="rect">
+              <a:avLst/>
+            </a:prstGeom>
+            <a:noFill/>
+          </p:spPr>
+          <p:txBody>
+            <a:bodyPr wrap="none" lIns="0" rIns="0" tIns="0" bIns="0" anchor="t">
+              <a:noAutofit/>
+            </a:bodyPr>
+            <a:lstStyle/>
+            <a:p>
+              <a:pPr algn="ctr">
+                <a:lnSpc>
+                  <a:spcPct val="100000"/>
+                </a:lnSpc>
+              </a:pPr>
+              <a:r>
+                <a:rPr sz="1000" b="0" lang="ko-KR">
+                  <a:solidFill>
+                    <a:srgbClr val="545B64"/>
+                  </a:solidFill>
+                  <a:latin typeface="Arial"/>
+                  <a:ea typeface="Malgun Gothic"/>
+                  <a:cs typeface="Malgun Gothic"/>
+                </a:rPr>
+                <a:t>VPC attachment</a:t>
+              </a:r>
+            </a:p>
+          </p:txBody>
+        </p:sp>
+        <p:sp>
+          <p:nvSpPr>
+            <p:cNvPr id="39" name="Rectangle 38"/>
             <p:cNvSpPr/>
             <p:nvPr/>
           </p:nvSpPr>
@@ -15788,7 +16915,7 @@
         </p:sp>
         <p:pic>
           <p:nvPicPr>
-            <p:cNvPr id="39" name="Virtual-private-cloud-VPC_32" descr="Virtual private cloud VPC_32"/>
+            <p:cNvPr id="40" name="Virtual-private-cloud-VPC_32" descr="Virtual private cloud VPC_32"/>
             <p:cNvPicPr>
               <a:picLocks noChangeAspect="1"/>
             </p:cNvPicPr>
@@ -15818,7 +16945,7 @@
         </p:pic>
         <p:sp>
           <p:nvSpPr>
-            <p:cNvPr id="40" name="TextBox 39"/>
+            <p:cNvPr id="41" name="TextBox 40"/>
             <p:cNvSpPr txBox="1"/>
             <p:nvPr/>
           </p:nvSpPr>
@@ -15859,7 +16986,7 @@
         </p:sp>
         <p:sp>
           <p:nvSpPr>
-            <p:cNvPr id="41" name="TextBox 40"/>
+            <p:cNvPr id="42" name="TextBox 41"/>
             <p:cNvSpPr txBox="1"/>
             <p:nvPr/>
           </p:nvSpPr>
@@ -15900,7 +17027,7 @@
         </p:sp>
         <p:sp>
           <p:nvSpPr>
-            <p:cNvPr id="42" name="Rectangle 41"/>
+            <p:cNvPr id="43" name="Rectangle 42"/>
             <p:cNvSpPr/>
             <p:nvPr/>
           </p:nvSpPr>
@@ -15933,7 +17060,7 @@
         </p:sp>
         <p:sp>
           <p:nvSpPr>
-            <p:cNvPr id="43" name="TextBox 42"/>
+            <p:cNvPr id="44" name="TextBox 43"/>
             <p:cNvSpPr txBox="1"/>
             <p:nvPr/>
           </p:nvSpPr>
@@ -15974,7 +17101,7 @@
         </p:sp>
         <p:sp>
           <p:nvSpPr>
-            <p:cNvPr id="44" name="Rectangle 43"/>
+            <p:cNvPr id="45" name="Rectangle 44"/>
             <p:cNvSpPr/>
             <p:nvPr/>
           </p:nvSpPr>
@@ -16007,7 +17134,7 @@
         </p:sp>
         <p:sp>
           <p:nvSpPr>
-            <p:cNvPr id="45" name="TextBox 44"/>
+            <p:cNvPr id="46" name="TextBox 45"/>
             <p:cNvSpPr txBox="1"/>
             <p:nvPr/>
           </p:nvSpPr>
@@ -16048,7 +17175,7 @@
         </p:sp>
         <p:sp>
           <p:nvSpPr>
-            <p:cNvPr id="46" name="Rectangle 45"/>
+            <p:cNvPr id="47" name="Rectangle 46"/>
             <p:cNvSpPr/>
             <p:nvPr/>
           </p:nvSpPr>
@@ -16079,7 +17206,7 @@
         </p:sp>
         <p:pic>
           <p:nvPicPr>
-            <p:cNvPr id="47" name="Private-subnet_32" descr="Private subnet_32"/>
+            <p:cNvPr id="48" name="Private-subnet_32" descr="Private subnet_32"/>
             <p:cNvPicPr>
               <a:picLocks noChangeAspect="1"/>
             </p:cNvPicPr>
@@ -16109,7 +17236,7 @@
         </p:pic>
         <p:sp>
           <p:nvSpPr>
-            <p:cNvPr id="48" name="TextBox 47"/>
+            <p:cNvPr id="49" name="TextBox 48"/>
             <p:cNvSpPr txBox="1"/>
             <p:nvPr/>
           </p:nvSpPr>
@@ -16150,7 +17277,7 @@
         </p:sp>
         <p:sp>
           <p:nvSpPr>
-            <p:cNvPr id="49" name="Rectangle 48"/>
+            <p:cNvPr id="50" name="Rectangle 49"/>
             <p:cNvSpPr/>
             <p:nvPr/>
           </p:nvSpPr>
@@ -16181,7 +17308,7 @@
         </p:sp>
         <p:pic>
           <p:nvPicPr>
-            <p:cNvPr id="50" name="Private-subnet_32" descr="Private subnet_32"/>
+            <p:cNvPr id="51" name="Private-subnet_32" descr="Private subnet_32"/>
             <p:cNvPicPr>
               <a:picLocks noChangeAspect="1"/>
             </p:cNvPicPr>
@@ -16211,7 +17338,7 @@
         </p:pic>
         <p:sp>
           <p:nvSpPr>
-            <p:cNvPr id="51" name="TextBox 50"/>
+            <p:cNvPr id="52" name="TextBox 51"/>
             <p:cNvSpPr txBox="1"/>
             <p:nvPr/>
           </p:nvSpPr>
@@ -16252,7 +17379,7 @@
         </p:sp>
         <p:sp>
           <p:nvSpPr>
-            <p:cNvPr id="52" name="Rectangle 51"/>
+            <p:cNvPr id="53" name="Rectangle 52"/>
             <p:cNvSpPr/>
             <p:nvPr/>
           </p:nvSpPr>
@@ -16283,7 +17410,7 @@
         </p:sp>
         <p:pic>
           <p:nvPicPr>
-            <p:cNvPr id="53" name="Public-subnet_32" descr="Public subnet_32"/>
+            <p:cNvPr id="54" name="Public-subnet_32" descr="Public subnet_32"/>
             <p:cNvPicPr>
               <a:picLocks noChangeAspect="1"/>
             </p:cNvPicPr>
@@ -16313,7 +17440,7 @@
         </p:pic>
         <p:sp>
           <p:nvSpPr>
-            <p:cNvPr id="54" name="TextBox 53"/>
+            <p:cNvPr id="55" name="TextBox 54"/>
             <p:cNvSpPr txBox="1"/>
             <p:nvPr/>
           </p:nvSpPr>
@@ -16354,7 +17481,7 @@
         </p:sp>
         <p:sp>
           <p:nvSpPr>
-            <p:cNvPr id="55" name="Rectangle 54"/>
+            <p:cNvPr id="56" name="Rectangle 55"/>
             <p:cNvSpPr/>
             <p:nvPr/>
           </p:nvSpPr>
@@ -16385,7 +17512,7 @@
         </p:sp>
         <p:pic>
           <p:nvPicPr>
-            <p:cNvPr id="56" name="Private-subnet_32" descr="Private subnet_32"/>
+            <p:cNvPr id="57" name="Private-subnet_32" descr="Private subnet_32"/>
             <p:cNvPicPr>
               <a:picLocks noChangeAspect="1"/>
             </p:cNvPicPr>
@@ -16415,7 +17542,7 @@
         </p:pic>
         <p:sp>
           <p:nvSpPr>
-            <p:cNvPr id="57" name="TextBox 56"/>
+            <p:cNvPr id="58" name="TextBox 57"/>
             <p:cNvSpPr txBox="1"/>
             <p:nvPr/>
           </p:nvSpPr>
@@ -16456,7 +17583,7 @@
         </p:sp>
         <p:sp>
           <p:nvSpPr>
-            <p:cNvPr id="58" name="Rectangle 57"/>
+            <p:cNvPr id="59" name="Rectangle 58"/>
             <p:cNvSpPr/>
             <p:nvPr/>
           </p:nvSpPr>
@@ -16487,7 +17614,7 @@
         </p:sp>
         <p:pic>
           <p:nvPicPr>
-            <p:cNvPr id="59" name="Private-subnet_32" descr="Private subnet_32"/>
+            <p:cNvPr id="60" name="Private-subnet_32" descr="Private subnet_32"/>
             <p:cNvPicPr>
               <a:picLocks noChangeAspect="1"/>
             </p:cNvPicPr>
@@ -16517,7 +17644,7 @@
         </p:pic>
         <p:sp>
           <p:nvSpPr>
-            <p:cNvPr id="60" name="TextBox 59"/>
+            <p:cNvPr id="61" name="TextBox 60"/>
             <p:cNvSpPr txBox="1"/>
             <p:nvPr/>
           </p:nvSpPr>
@@ -16558,7 +17685,7 @@
         </p:sp>
         <p:sp>
           <p:nvSpPr>
-            <p:cNvPr id="61" name="Rectangle 60"/>
+            <p:cNvPr id="62" name="Rectangle 61"/>
             <p:cNvSpPr/>
             <p:nvPr/>
           </p:nvSpPr>
@@ -16589,7 +17716,7 @@
         </p:sp>
         <p:pic>
           <p:nvPicPr>
-            <p:cNvPr id="62" name="Public-subnet_32" descr="Public subnet_32"/>
+            <p:cNvPr id="63" name="Public-subnet_32" descr="Public subnet_32"/>
             <p:cNvPicPr>
               <a:picLocks noChangeAspect="1"/>
             </p:cNvPicPr>
@@ -16619,7 +17746,7 @@
         </p:pic>
         <p:sp>
           <p:nvSpPr>
-            <p:cNvPr id="63" name="TextBox 62"/>
+            <p:cNvPr id="64" name="TextBox 63"/>
             <p:cNvSpPr txBox="1"/>
             <p:nvPr/>
           </p:nvSpPr>
@@ -16660,7 +17787,7 @@
         </p:sp>
         <p:pic>
           <p:nvPicPr>
-            <p:cNvPr id="64" name="AWS-Transit-Gateway_Attachment" descr="AWS Transit Gateway_Attachment"/>
+            <p:cNvPr id="65" name="AWS-Transit-Gateway_Attachment" descr="AWS Transit Gateway_Attachment"/>
             <p:cNvPicPr>
               <a:picLocks noChangeAspect="1"/>
             </p:cNvPicPr>
@@ -16690,7 +17817,7 @@
         </p:pic>
         <p:sp>
           <p:nvSpPr>
-            <p:cNvPr id="65" name="TextBox 64"/>
+            <p:cNvPr id="66" name="TextBox 65"/>
             <p:cNvSpPr txBox="1"/>
             <p:nvPr/>
           </p:nvSpPr>
@@ -16731,7 +17858,7 @@
         </p:sp>
         <p:pic>
           <p:nvPicPr>
-            <p:cNvPr id="66" name="AWS-Network-Firewall_Endpoints" descr="AWS Network Firewall_Endpoints"/>
+            <p:cNvPr id="67" name="AWS-Network-Firewall_Endpoints" descr="AWS Network Firewall_Endpoints"/>
             <p:cNvPicPr>
               <a:picLocks noChangeAspect="1"/>
             </p:cNvPicPr>
@@ -16761,7 +17888,7 @@
         </p:pic>
         <p:sp>
           <p:nvSpPr>
-            <p:cNvPr id="67" name="TextBox 66"/>
+            <p:cNvPr id="68" name="TextBox 67"/>
             <p:cNvSpPr txBox="1"/>
             <p:nvPr/>
           </p:nvSpPr>
@@ -16802,7 +17929,7 @@
         </p:sp>
         <p:pic>
           <p:nvPicPr>
-            <p:cNvPr id="68" name="Amazon-VPC_NAT-Gateway" descr="Amazon VPC_NAT Gateway"/>
+            <p:cNvPr id="69" name="Amazon-VPC_NAT-Gateway" descr="Amazon VPC_NAT Gateway"/>
             <p:cNvPicPr>
               <a:picLocks noChangeAspect="1"/>
             </p:cNvPicPr>
@@ -16832,7 +17959,7 @@
         </p:pic>
         <p:sp>
           <p:nvSpPr>
-            <p:cNvPr id="69" name="TextBox 68"/>
+            <p:cNvPr id="70" name="TextBox 69"/>
             <p:cNvSpPr txBox="1"/>
             <p:nvPr/>
           </p:nvSpPr>
@@ -16873,7 +18000,7 @@
         </p:sp>
         <p:pic>
           <p:nvPicPr>
-            <p:cNvPr id="70" name="AWS-Transit-Gateway_Attachment" descr="AWS Transit Gateway_Attachment"/>
+            <p:cNvPr id="71" name="AWS-Transit-Gateway_Attachment" descr="AWS Transit Gateway_Attachment"/>
             <p:cNvPicPr>
               <a:picLocks noChangeAspect="1"/>
             </p:cNvPicPr>
@@ -16903,7 +18030,7 @@
         </p:pic>
         <p:sp>
           <p:nvSpPr>
-            <p:cNvPr id="71" name="TextBox 70"/>
+            <p:cNvPr id="72" name="TextBox 71"/>
             <p:cNvSpPr txBox="1"/>
             <p:nvPr/>
           </p:nvSpPr>
@@ -16944,7 +18071,7 @@
         </p:sp>
         <p:pic>
           <p:nvPicPr>
-            <p:cNvPr id="72" name="AWS-Network-Firewall_Endpoints" descr="AWS Network Firewall_Endpoints"/>
+            <p:cNvPr id="73" name="AWS-Network-Firewall_Endpoints" descr="AWS Network Firewall_Endpoints"/>
             <p:cNvPicPr>
               <a:picLocks noChangeAspect="1"/>
             </p:cNvPicPr>
@@ -16974,7 +18101,7 @@
         </p:pic>
         <p:sp>
           <p:nvSpPr>
-            <p:cNvPr id="73" name="TextBox 72"/>
+            <p:cNvPr id="74" name="TextBox 73"/>
             <p:cNvSpPr txBox="1"/>
             <p:nvPr/>
           </p:nvSpPr>
@@ -17015,7 +18142,7 @@
         </p:sp>
         <p:pic>
           <p:nvPicPr>
-            <p:cNvPr id="74" name="Amazon-VPC_NAT-Gateway" descr="Amazon VPC_NAT Gateway"/>
+            <p:cNvPr id="75" name="Amazon-VPC_NAT-Gateway" descr="Amazon VPC_NAT Gateway"/>
             <p:cNvPicPr>
               <a:picLocks noChangeAspect="1"/>
             </p:cNvPicPr>
@@ -17045,7 +18172,7 @@
         </p:pic>
         <p:sp>
           <p:nvSpPr>
-            <p:cNvPr id="75" name="TextBox 74"/>
+            <p:cNvPr id="76" name="TextBox 75"/>
             <p:cNvSpPr txBox="1"/>
             <p:nvPr/>
           </p:nvSpPr>
@@ -17086,7 +18213,7 @@
         </p:sp>
         <p:pic>
           <p:nvPicPr>
-            <p:cNvPr id="76" name="AWS-Network-Firewall" descr="AWS Network Firewall"/>
+            <p:cNvPr id="77" name="AWS-Network-Firewall" descr="AWS Network Firewall"/>
             <p:cNvPicPr>
               <a:picLocks noChangeAspect="1"/>
             </p:cNvPicPr>
@@ -17116,7 +18243,7 @@
         </p:pic>
         <p:sp>
           <p:nvSpPr>
-            <p:cNvPr id="77" name="TextBox 76"/>
+            <p:cNvPr id="78" name="TextBox 77"/>
             <p:cNvSpPr txBox="1"/>
             <p:nvPr/>
           </p:nvSpPr>
@@ -17157,7 +18284,7 @@
         </p:sp>
         <p:sp>
           <p:nvSpPr>
-            <p:cNvPr id="78" name="Rectangle 77"/>
+            <p:cNvPr id="79" name="Rectangle 78"/>
             <p:cNvSpPr/>
             <p:nvPr/>
           </p:nvSpPr>
@@ -17186,7 +18313,7 @@
         </p:sp>
         <p:pic>
           <p:nvPicPr>
-            <p:cNvPr id="79" name="Amazon-VPC_Internet-Gateway" descr="Amazon VPC_Internet Gateway"/>
+            <p:cNvPr id="80" name="Amazon-VPC_Internet-Gateway" descr="Amazon VPC_Internet Gateway"/>
             <p:cNvPicPr>
               <a:picLocks noChangeAspect="1"/>
             </p:cNvPicPr>
@@ -17216,7 +18343,7 @@
         </p:pic>
         <p:sp>
           <p:nvSpPr>
-            <p:cNvPr id="80" name="TextBox 79"/>
+            <p:cNvPr id="81" name="TextBox 80"/>
             <p:cNvSpPr txBox="1"/>
             <p:nvPr/>
           </p:nvSpPr>
@@ -17257,7 +18384,7 @@
         </p:sp>
         <p:sp>
           <p:nvSpPr>
-            <p:cNvPr id="81" name="Freeform 80"/>
+            <p:cNvPr id="82" name="Freeform 81"/>
             <p:cNvSpPr/>
             <p:nvPr/>
           </p:nvSpPr>
@@ -17310,7 +18437,7 @@
         </p:sp>
         <p:sp>
           <p:nvSpPr>
-            <p:cNvPr id="82" name="Freeform 81"/>
+            <p:cNvPr id="83" name="Freeform 82"/>
             <p:cNvSpPr/>
             <p:nvPr/>
           </p:nvSpPr>
@@ -17363,7 +18490,7 @@
         </p:sp>
         <p:cxnSp>
           <p:nvCxnSpPr>
-            <p:cNvPr id="83" name="Connector 82"/>
+            <p:cNvPr id="84" name="Connector 83"/>
             <p:cNvCxnSpPr/>
             <p:nvPr/>
           </p:nvCxnSpPr>
@@ -17388,7 +18515,7 @@
         </p:cxnSp>
         <p:cxnSp>
           <p:nvCxnSpPr>
-            <p:cNvPr id="84" name="Connector 83"/>
+            <p:cNvPr id="85" name="Connector 84"/>
             <p:cNvCxnSpPr/>
             <p:nvPr/>
           </p:nvCxnSpPr>
@@ -17413,7 +18540,7 @@
         </p:cxnSp>
         <p:cxnSp>
           <p:nvCxnSpPr>
-            <p:cNvPr id="85" name="Connector 84"/>
+            <p:cNvPr id="86" name="Connector 85"/>
             <p:cNvCxnSpPr/>
             <p:nvPr/>
           </p:nvCxnSpPr>
@@ -17437,7 +18564,7 @@
         </p:cxnSp>
         <p:cxnSp>
           <p:nvCxnSpPr>
-            <p:cNvPr id="86" name="Connector 85"/>
+            <p:cNvPr id="87" name="Connector 86"/>
             <p:cNvCxnSpPr/>
             <p:nvPr/>
           </p:nvCxnSpPr>
@@ -17461,7 +18588,7 @@
         </p:cxnSp>
         <p:sp>
           <p:nvSpPr>
-            <p:cNvPr id="87" name="Freeform 86"/>
+            <p:cNvPr id="88" name="Freeform 87"/>
             <p:cNvSpPr/>
             <p:nvPr/>
           </p:nvSpPr>
@@ -17513,7 +18640,7 @@
         </p:sp>
         <p:sp>
           <p:nvSpPr>
-            <p:cNvPr id="88" name="Freeform 87"/>
+            <p:cNvPr id="89" name="Freeform 88"/>
             <p:cNvSpPr/>
             <p:nvPr/>
           </p:nvSpPr>
@@ -17561,7 +18688,7 @@
         </p:sp>
         <p:pic>
           <p:nvPicPr>
-            <p:cNvPr id="89" name="Internet" descr="Internet"/>
+            <p:cNvPr id="90" name="Internet" descr="Internet"/>
             <p:cNvPicPr>
               <a:picLocks noChangeAspect="1"/>
             </p:cNvPicPr>
@@ -17591,7 +18718,7 @@
         </p:pic>
         <p:sp>
           <p:nvSpPr>
-            <p:cNvPr id="90" name="TextBox 89"/>
+            <p:cNvPr id="91" name="TextBox 90"/>
             <p:cNvSpPr txBox="1"/>
             <p:nvPr/>
           </p:nvSpPr>
@@ -17632,7 +18759,7 @@
         </p:sp>
         <p:cxnSp>
           <p:nvCxnSpPr>
-            <p:cNvPr id="91" name="Connector 90"/>
+            <p:cNvPr id="92" name="Connector 91"/>
             <p:cNvCxnSpPr/>
             <p:nvPr/>
           </p:nvCxnSpPr>
@@ -17656,13 +18783,13 @@
         </p:cxnSp>
         <p:sp>
           <p:nvSpPr>
-            <p:cNvPr id="92" name="Oval 91"/>
+            <p:cNvPr id="93" name="Oval 92"/>
             <p:cNvSpPr/>
             <p:nvPr/>
           </p:nvSpPr>
           <p:spPr>
             <a:xfrm>
-              <a:off x="3143250" y="3623733"/>
+              <a:off x="3164417" y="3623733"/>
               <a:ext cx="211667" cy="211667"/>
             </a:xfrm>
             <a:prstGeom prst="ellipse">
@@ -17685,13 +18812,13 @@
         </p:sp>
         <p:sp>
           <p:nvSpPr>
-            <p:cNvPr id="93" name="TextBox 92"/>
-            <p:cNvSpPr txBox="1"/>
-            <p:nvPr/>
-          </p:nvSpPr>
-          <p:spPr>
-            <a:xfrm>
-              <a:off x="3141927" y="3651250"/>
+            <p:cNvPr id="94" name="TextBox 93"/>
+            <p:cNvSpPr txBox="1"/>
+            <p:nvPr/>
+          </p:nvSpPr>
+          <p:spPr>
+            <a:xfrm>
+              <a:off x="3163094" y="3651250"/>
               <a:ext cx="214312" cy="165100"/>
             </a:xfrm>
             <a:prstGeom prst="rect">
@@ -17726,7 +18853,7 @@
         </p:sp>
         <p:sp>
           <p:nvSpPr>
-            <p:cNvPr id="94" name="Oval 93"/>
+            <p:cNvPr id="95" name="Oval 94"/>
             <p:cNvSpPr/>
             <p:nvPr/>
           </p:nvSpPr>
@@ -17755,7 +18882,7 @@
         </p:sp>
         <p:sp>
           <p:nvSpPr>
-            <p:cNvPr id="95" name="TextBox 94"/>
+            <p:cNvPr id="96" name="TextBox 95"/>
             <p:cNvSpPr txBox="1"/>
             <p:nvPr/>
           </p:nvSpPr>
@@ -17796,7 +18923,7 @@
         </p:sp>
         <p:sp>
           <p:nvSpPr>
-            <p:cNvPr id="96" name="Oval 95"/>
+            <p:cNvPr id="97" name="Oval 96"/>
             <p:cNvSpPr/>
             <p:nvPr/>
           </p:nvSpPr>
@@ -17825,7 +18952,7 @@
         </p:sp>
         <p:sp>
           <p:nvSpPr>
-            <p:cNvPr id="97" name="TextBox 96"/>
+            <p:cNvPr id="98" name="TextBox 97"/>
             <p:cNvSpPr txBox="1"/>
             <p:nvPr/>
           </p:nvSpPr>
@@ -17866,7 +18993,7 @@
         </p:sp>
         <p:sp>
           <p:nvSpPr>
-            <p:cNvPr id="98" name="Oval 97"/>
+            <p:cNvPr id="99" name="Oval 98"/>
             <p:cNvSpPr/>
             <p:nvPr/>
           </p:nvSpPr>
@@ -17895,7 +19022,7 @@
         </p:sp>
         <p:sp>
           <p:nvSpPr>
-            <p:cNvPr id="99" name="TextBox 98"/>
+            <p:cNvPr id="100" name="TextBox 99"/>
             <p:cNvSpPr txBox="1"/>
             <p:nvPr/>
           </p:nvSpPr>
@@ -17936,7 +19063,7 @@
         </p:sp>
         <p:sp>
           <p:nvSpPr>
-            <p:cNvPr id="100" name="Oval 99"/>
+            <p:cNvPr id="101" name="Oval 100"/>
             <p:cNvSpPr/>
             <p:nvPr/>
           </p:nvSpPr>
@@ -17965,7 +19092,7 @@
         </p:sp>
         <p:sp>
           <p:nvSpPr>
-            <p:cNvPr id="101" name="TextBox 100"/>
+            <p:cNvPr id="102" name="TextBox 101"/>
             <p:cNvSpPr txBox="1"/>
             <p:nvPr/>
           </p:nvSpPr>
@@ -18006,7 +19133,7 @@
         </p:sp>
         <p:sp>
           <p:nvSpPr>
-            <p:cNvPr id="102" name="Oval 101"/>
+            <p:cNvPr id="103" name="Oval 102"/>
             <p:cNvSpPr/>
             <p:nvPr/>
           </p:nvSpPr>
@@ -18035,7 +19162,7 @@
         </p:sp>
         <p:sp>
           <p:nvSpPr>
-            <p:cNvPr id="103" name="TextBox 102"/>
+            <p:cNvPr id="104" name="TextBox 103"/>
             <p:cNvSpPr txBox="1"/>
             <p:nvPr/>
           </p:nvSpPr>
@@ -18076,7 +19203,7 @@
         </p:sp>
         <p:sp>
           <p:nvSpPr>
-            <p:cNvPr id="104" name="TextBox 103"/>
+            <p:cNvPr id="105" name="TextBox 104"/>
             <p:cNvSpPr txBox="1"/>
             <p:nvPr/>
           </p:nvSpPr>
@@ -18117,7 +19244,7 @@
         </p:sp>
         <p:sp>
           <p:nvSpPr>
-            <p:cNvPr id="105" name="Oval 104"/>
+            <p:cNvPr id="106" name="Oval 105"/>
             <p:cNvSpPr/>
             <p:nvPr/>
           </p:nvSpPr>
@@ -18146,7 +19273,7 @@
         </p:sp>
         <p:sp>
           <p:nvSpPr>
-            <p:cNvPr id="106" name="TextBox 105"/>
+            <p:cNvPr id="107" name="TextBox 106"/>
             <p:cNvSpPr txBox="1"/>
             <p:nvPr/>
           </p:nvSpPr>
@@ -18187,7 +19314,7 @@
         </p:sp>
         <p:sp>
           <p:nvSpPr>
-            <p:cNvPr id="107" name="TextBox 106"/>
+            <p:cNvPr id="108" name="TextBox 107"/>
             <p:cNvSpPr txBox="1"/>
             <p:nvPr/>
           </p:nvSpPr>
@@ -18228,7 +19355,7 @@
         </p:sp>
         <p:sp>
           <p:nvSpPr>
-            <p:cNvPr id="108" name="Oval 107"/>
+            <p:cNvPr id="109" name="Oval 108"/>
             <p:cNvSpPr/>
             <p:nvPr/>
           </p:nvSpPr>
@@ -18257,7 +19384,7 @@
         </p:sp>
         <p:sp>
           <p:nvSpPr>
-            <p:cNvPr id="109" name="TextBox 108"/>
+            <p:cNvPr id="110" name="TextBox 109"/>
             <p:cNvSpPr txBox="1"/>
             <p:nvPr/>
           </p:nvSpPr>
@@ -18298,7 +19425,7 @@
         </p:sp>
         <p:sp>
           <p:nvSpPr>
-            <p:cNvPr id="110" name="TextBox 109"/>
+            <p:cNvPr id="111" name="TextBox 110"/>
             <p:cNvSpPr txBox="1"/>
             <p:nvPr/>
           </p:nvSpPr>
@@ -18339,7 +19466,7 @@
         </p:sp>
         <p:sp>
           <p:nvSpPr>
-            <p:cNvPr id="111" name="Oval 110"/>
+            <p:cNvPr id="112" name="Oval 111"/>
             <p:cNvSpPr/>
             <p:nvPr/>
           </p:nvSpPr>
@@ -18368,7 +19495,7 @@
         </p:sp>
         <p:sp>
           <p:nvSpPr>
-            <p:cNvPr id="112" name="TextBox 111"/>
+            <p:cNvPr id="113" name="TextBox 112"/>
             <p:cNvSpPr txBox="1"/>
             <p:nvPr/>
           </p:nvSpPr>
@@ -18409,7 +19536,7 @@
         </p:sp>
         <p:sp>
           <p:nvSpPr>
-            <p:cNvPr id="113" name="TextBox 112"/>
+            <p:cNvPr id="114" name="TextBox 113"/>
             <p:cNvSpPr txBox="1"/>
             <p:nvPr/>
           </p:nvSpPr>
@@ -18450,7 +19577,7 @@
         </p:sp>
         <p:sp>
           <p:nvSpPr>
-            <p:cNvPr id="114" name="Oval 113"/>
+            <p:cNvPr id="115" name="Oval 114"/>
             <p:cNvSpPr/>
             <p:nvPr/>
           </p:nvSpPr>
@@ -18479,7 +19606,7 @@
         </p:sp>
         <p:sp>
           <p:nvSpPr>
-            <p:cNvPr id="115" name="TextBox 114"/>
+            <p:cNvPr id="116" name="TextBox 115"/>
             <p:cNvSpPr txBox="1"/>
             <p:nvPr/>
           </p:nvSpPr>
@@ -18520,7 +19647,7 @@
         </p:sp>
         <p:sp>
           <p:nvSpPr>
-            <p:cNvPr id="116" name="TextBox 115"/>
+            <p:cNvPr id="117" name="TextBox 116"/>
             <p:cNvSpPr txBox="1"/>
             <p:nvPr/>
           </p:nvSpPr>

</xml_diff>